<commit_message>
feat(presentation): add "Take it with you" scan-to-explore QR slide to GraphQL decks
Mirrors the slide already shipped in the REST decks: left QR -> the GraphQL
site, right QR -> the Workshops & Tutorials hub. Added to deck.js source for
all three decks (100, python, quarkus) and rebuilt the pptx. New QR assets
qr-graphql-site.png and qr-hub.png added to _shared/assets.
</commit_message>
<xml_diff>
--- a/presentation/api-patterns-graphql-100/api-patterns-graphql-100.pptx
+++ b/presentation/api-patterns-graphql-100/api-patterns-graphql-100.pptx
@@ -83,9 +83,10 @@
     <p:sldId id="331" r:id="rId77"/>
     <p:sldId id="332" r:id="rId78"/>
     <p:sldId id="333" r:id="rId79"/>
+    <p:sldId id="334" r:id="rId80"/>
   </p:sldIdLst>
   <p:notesMasterIdLst>
-    <p:notesMasterId r:id="rId80"/>
+    <p:notesMasterId r:id="rId81"/>
   </p:notesMasterIdLst>
   <p:sldSz cx="12192000" cy="6858000"/>
   <p:notesSz cx="6858000" cy="12192000"/>
@@ -7203,6 +7204,94 @@
             <a:fld id="{F7021451-1387-4CA6-816F-3879F97B5CBC}" type="slidenum">
               <a:rPr lang="en-US"/>
               <a:t>78</a:t>
+            </a:fld>
+            <a:endParaRPr lang="en-US"/>
+          </a:p>
+        </p:txBody>
+      </p:sp>
+    </p:spTree>
+    <p:extLst>
+      <p:ext uri="{BB962C8B-B14F-4D97-AF65-F5344CB8AC3E}">
+        <p14:creationId xmlns:p14="http://schemas.microsoft.com/office/powerpoint/2010/main" val="1024086991"/>
+      </p:ext>
+    </p:extLst>
+  </p:cSld>
+  <p:clrMapOvr>
+    <a:masterClrMapping/>
+  </p:clrMapOvr>
+</p:notes>
+</file>
+
+<file path=ppt/notesSlides/notesSlide79.xml><?xml version="1.0" encoding="utf-8"?>
+<p:notes xmlns:a="http://schemas.openxmlformats.org/drawingml/2006/main" xmlns:r="http://schemas.openxmlformats.org/officeDocument/2006/relationships" xmlns:p="http://schemas.openxmlformats.org/presentationml/2006/main">
+  <p:cSld>
+    <p:spTree>
+      <p:nvGrpSpPr>
+        <p:cNvPr id="1" name=""/>
+        <p:cNvGrpSpPr/>
+        <p:nvPr/>
+      </p:nvGrpSpPr>
+      <p:grpSpPr>
+        <a:xfrm>
+          <a:off x="0" y="0"/>
+          <a:ext cx="0" cy="0"/>
+          <a:chOff x="0" y="0"/>
+          <a:chExt cx="0" cy="0"/>
+        </a:xfrm>
+      </p:grpSpPr>
+      <p:sp>
+        <p:nvSpPr>
+          <p:cNvPr id="2" name="Slide Image Placeholder 1"/>
+          <p:cNvSpPr>
+            <a:spLocks noGrp="1" noRot="1" noChangeAspect="1"/>
+          </p:cNvSpPr>
+          <p:nvPr>
+            <p:ph type="sldImg"/>
+          </p:nvPr>
+        </p:nvSpPr>
+        <p:spPr/>
+      </p:sp>
+      <p:sp>
+        <p:nvSpPr>
+          <p:cNvPr id="3" name="Notes Placeholder 2"/>
+          <p:cNvSpPr>
+            <a:spLocks noGrp="1"/>
+          </p:cNvSpPr>
+          <p:nvPr>
+            <p:ph type="body" idx="1"/>
+          </p:nvPr>
+        </p:nvSpPr>
+        <p:spPr/>
+        <p:txBody>
+          <a:bodyPr/>
+          <a:lstStyle/>
+          <a:p>
+            <a:r>
+              <a:rPr lang="en-US" dirty="0"/>
+              <a:t>This is the 100-level concepts deck, so the two codes point where the ideas live and where the whole series lives. On the left, the site: the chapters, the GraphQL schema and contracts, and the runnable both-stack examples, all public. On the right, the Workshops and Tutorials hub: every workshop, tutorial, and deck in the series in one place, including the REST, gRPC, and WebSockets siblings. Scan whichever is useful; both are on the Pattern Catalyst GitHub organization.</a:t>
+            </a:r>
+            <a:endParaRPr lang="en-US" dirty="0"/>
+          </a:p>
+        </p:txBody>
+      </p:sp>
+      <p:sp>
+        <p:nvSpPr>
+          <p:cNvPr id="4" name="Slide Number Placeholder 3"/>
+          <p:cNvSpPr>
+            <a:spLocks noGrp="1"/>
+          </p:cNvSpPr>
+          <p:nvPr>
+            <p:ph type="sldNum" sz="quarter" idx="10"/>
+          </p:nvPr>
+        </p:nvSpPr>
+        <p:spPr/>
+        <p:txBody>
+          <a:bodyPr/>
+          <a:lstStyle/>
+          <a:p>
+            <a:fld id="{F7021451-1387-4CA6-816F-3879F97B5CBC}" type="slidenum">
+              <a:rPr lang="en-US"/>
+              <a:t>79</a:t>
             </a:fld>
             <a:endParaRPr lang="en-US"/>
           </a:p>
@@ -7770,7 +7859,7 @@
       </p:grpSpPr>
       <p:pic>
         <p:nvPicPr>
-          <p:cNvPr id="2" name="Image 0" descr="/work/_shared/assets/cover-panel.png">    </p:cNvPr>
+          <p:cNvPr id="2" name="Image 0" descr="/tmp/pcwork/api-patterns-and-practices-graphql/presentation/_shared/assets/cover-panel.png">    </p:cNvPr>
           <p:cNvPicPr>
             <a:picLocks noChangeAspect="1"/>
           </p:cNvPicPr>
@@ -7984,7 +8073,7 @@
       </p:sp>
       <p:pic>
         <p:nvPicPr>
-          <p:cNvPr id="7" name="Image 1" descr="/work/_shared/assets/logo-candidate-2.png">    </p:cNvPr>
+          <p:cNvPr id="7" name="Image 1" descr="/tmp/pcwork/api-patterns-and-practices-graphql/presentation/_shared/assets/logo-candidate-2.png">    </p:cNvPr>
           <p:cNvPicPr>
             <a:picLocks noChangeAspect="1"/>
           </p:cNvPicPr>
@@ -8150,7 +8239,7 @@
       </p:sp>
       <p:pic>
         <p:nvPicPr>
-          <p:cNvPr id="5" name="Image 0" descr="/work/_shared/assets/redhat-logo-white.png">    </p:cNvPr>
+          <p:cNvPr id="5" name="Image 0" descr="/tmp/pcwork/api-patterns-and-practices-graphql/presentation/_shared/assets/redhat-logo-white.png">    </p:cNvPr>
           <p:cNvPicPr>
             <a:picLocks noChangeAspect="1"/>
           </p:cNvPicPr>
@@ -8238,7 +8327,7 @@
       </p:sp>
       <p:pic>
         <p:nvPicPr>
-          <p:cNvPr id="3" name="Image 0" descr="/work/_shared/assets/logo-candidate-2.png">    </p:cNvPr>
+          <p:cNvPr id="3" name="Image 0" descr="/tmp/pcwork/api-patterns-and-practices-graphql/presentation/_shared/assets/logo-candidate-2.png">    </p:cNvPr>
           <p:cNvPicPr>
             <a:picLocks noChangeAspect="1"/>
           </p:cNvPicPr>
@@ -8340,7 +8429,7 @@
       </p:sp>
       <p:pic>
         <p:nvPicPr>
-          <p:cNvPr id="6" name="Image 1" descr="/work/_shared/png/03-type-system-map.png">    </p:cNvPr>
+          <p:cNvPr id="6" name="Image 1" descr="/tmp/pcwork/api-patterns-and-practices-graphql/presentation/_shared/png/03-type-system-map.png">    </p:cNvPr>
           <p:cNvPicPr>
             <a:picLocks noChangeAspect="1"/>
           </p:cNvPicPr>
@@ -8466,7 +8555,7 @@
       </p:sp>
       <p:pic>
         <p:nvPicPr>
-          <p:cNvPr id="3" name="Image 0" descr="/work/_shared/assets/logo-candidate-2.png">    </p:cNvPr>
+          <p:cNvPr id="3" name="Image 0" descr="/tmp/pcwork/api-patterns-and-practices-graphql/presentation/_shared/assets/logo-candidate-2.png">    </p:cNvPr>
           <p:cNvPicPr>
             <a:picLocks noChangeAspect="1"/>
           </p:cNvPicPr>
@@ -9174,7 +9263,7 @@
       </p:sp>
       <p:pic>
         <p:nvPicPr>
-          <p:cNvPr id="3" name="Image 0" descr="/work/_shared/assets/logo-candidate-2.png">    </p:cNvPr>
+          <p:cNvPr id="3" name="Image 0" descr="/tmp/pcwork/api-patterns-and-practices-graphql/presentation/_shared/assets/logo-candidate-2.png">    </p:cNvPr>
           <p:cNvPicPr>
             <a:picLocks noChangeAspect="1"/>
           </p:cNvPicPr>
@@ -9276,7 +9365,7 @@
       </p:sp>
       <p:pic>
         <p:nvPicPr>
-          <p:cNvPr id="6" name="Image 1" descr="/work/_shared/png/03-scalar-coercion.png">    </p:cNvPr>
+          <p:cNvPr id="6" name="Image 1" descr="/tmp/pcwork/api-patterns-and-practices-graphql/presentation/_shared/png/03-scalar-coercion.png">    </p:cNvPr>
           <p:cNvPicPr>
             <a:picLocks noChangeAspect="1"/>
           </p:cNvPicPr>
@@ -9402,7 +9491,7 @@
       </p:sp>
       <p:pic>
         <p:nvPicPr>
-          <p:cNvPr id="3" name="Image 0" descr="/work/_shared/assets/logo-candidate-2.png">    </p:cNvPr>
+          <p:cNvPr id="3" name="Image 0" descr="/tmp/pcwork/api-patterns-and-practices-graphql/presentation/_shared/assets/logo-candidate-2.png">    </p:cNvPr>
           <p:cNvPicPr>
             <a:picLocks noChangeAspect="1"/>
           </p:cNvPicPr>
@@ -9504,7 +9593,7 @@
       </p:sp>
       <p:pic>
         <p:nvPicPr>
-          <p:cNvPr id="6" name="Image 1" descr="/work/_shared/png/04-wrapper-matrix.png">    </p:cNvPr>
+          <p:cNvPr id="6" name="Image 1" descr="/tmp/pcwork/api-patterns-and-practices-graphql/presentation/_shared/png/04-wrapper-matrix.png">    </p:cNvPr>
           <p:cNvPicPr>
             <a:picLocks noChangeAspect="1"/>
           </p:cNvPicPr>
@@ -9630,7 +9719,7 @@
       </p:sp>
       <p:pic>
         <p:nvPicPr>
-          <p:cNvPr id="3" name="Image 0" descr="/work/_shared/assets/logo-candidate-2.png">    </p:cNvPr>
+          <p:cNvPr id="3" name="Image 0" descr="/tmp/pcwork/api-patterns-and-practices-graphql/presentation/_shared/assets/logo-candidate-2.png">    </p:cNvPr>
           <p:cNvPicPr>
             <a:picLocks noChangeAspect="1"/>
           </p:cNvPicPr>
@@ -9732,7 +9821,7 @@
       </p:sp>
       <p:pic>
         <p:nvPicPr>
-          <p:cNvPr id="6" name="Image 1" descr="/work/_shared/png/04-null-bubbling-walk.png">    </p:cNvPr>
+          <p:cNvPr id="6" name="Image 1" descr="/tmp/pcwork/api-patterns-and-practices-graphql/presentation/_shared/png/04-null-bubbling-walk.png">    </p:cNvPr>
           <p:cNvPicPr>
             <a:picLocks noChangeAspect="1"/>
           </p:cNvPicPr>
@@ -9858,7 +9947,7 @@
       </p:sp>
       <p:pic>
         <p:nvPicPr>
-          <p:cNvPr id="3" name="Image 0" descr="/work/_shared/assets/logo-candidate-2.png">    </p:cNvPr>
+          <p:cNvPr id="3" name="Image 0" descr="/tmp/pcwork/api-patterns-and-practices-graphql/presentation/_shared/assets/logo-candidate-2.png">    </p:cNvPr>
           <p:cNvPicPr>
             <a:picLocks noChangeAspect="1"/>
           </p:cNvPicPr>
@@ -9960,7 +10049,7 @@
       </p:sp>
       <p:pic>
         <p:nvPicPr>
-          <p:cNvPr id="6" name="Image 1" descr="/work/_shared/png/05-contract-loop.png">    </p:cNvPr>
+          <p:cNvPr id="6" name="Image 1" descr="/tmp/pcwork/api-patterns-and-practices-graphql/presentation/_shared/png/05-contract-loop.png">    </p:cNvPr>
           <p:cNvPicPr>
             <a:picLocks noChangeAspect="1"/>
           </p:cNvPicPr>
@@ -10164,7 +10253,7 @@
       </p:sp>
       <p:pic>
         <p:nvPicPr>
-          <p:cNvPr id="5" name="Image 0" descr="/work/_shared/assets/redhat-logo-white.png">    </p:cNvPr>
+          <p:cNvPr id="5" name="Image 0" descr="/tmp/pcwork/api-patterns-and-practices-graphql/presentation/_shared/assets/redhat-logo-white.png">    </p:cNvPr>
           <p:cNvPicPr>
             <a:picLocks noChangeAspect="1"/>
           </p:cNvPicPr>
@@ -10252,7 +10341,7 @@
       </p:sp>
       <p:pic>
         <p:nvPicPr>
-          <p:cNvPr id="3" name="Image 0" descr="/work/_shared/assets/logo-candidate-2.png">    </p:cNvPr>
+          <p:cNvPr id="3" name="Image 0" descr="/tmp/pcwork/api-patterns-and-practices-graphql/presentation/_shared/assets/logo-candidate-2.png">    </p:cNvPr>
           <p:cNvPicPr>
             <a:picLocks noChangeAspect="1"/>
           </p:cNvPicPr>
@@ -10354,7 +10443,7 @@
       </p:sp>
       <p:pic>
         <p:nvPicPr>
-          <p:cNvPr id="6" name="Image 1" descr="/work/_shared/png/06-request-phases.png">    </p:cNvPr>
+          <p:cNvPr id="6" name="Image 1" descr="/tmp/pcwork/api-patterns-and-practices-graphql/presentation/_shared/png/06-request-phases.png">    </p:cNvPr>
           <p:cNvPicPr>
             <a:picLocks noChangeAspect="1"/>
           </p:cNvPicPr>
@@ -10480,7 +10569,7 @@
       </p:sp>
       <p:pic>
         <p:nvPicPr>
-          <p:cNvPr id="3" name="Image 0" descr="/work/_shared/assets/logo-candidate-2.png">    </p:cNvPr>
+          <p:cNvPr id="3" name="Image 0" descr="/tmp/pcwork/api-patterns-and-practices-graphql/presentation/_shared/assets/logo-candidate-2.png">    </p:cNvPr>
           <p:cNvPicPr>
             <a:picLocks noChangeAspect="1"/>
           </p:cNvPicPr>
@@ -10582,7 +10671,7 @@
       </p:sp>
       <p:pic>
         <p:nvPicPr>
-          <p:cNvPr id="6" name="Image 1" descr="/work/_shared/png/07-resolver-chain.png">    </p:cNvPr>
+          <p:cNvPr id="6" name="Image 1" descr="/tmp/pcwork/api-patterns-and-practices-graphql/presentation/_shared/png/07-resolver-chain.png">    </p:cNvPr>
           <p:cNvPicPr>
             <a:picLocks noChangeAspect="1"/>
           </p:cNvPicPr>
@@ -10708,7 +10797,7 @@
       </p:sp>
       <p:pic>
         <p:nvPicPr>
-          <p:cNvPr id="3" name="Image 0" descr="/work/_shared/assets/logo-candidate-2.png">    </p:cNvPr>
+          <p:cNvPr id="3" name="Image 0" descr="/tmp/pcwork/api-patterns-and-practices-graphql/presentation/_shared/assets/logo-candidate-2.png">    </p:cNvPr>
           <p:cNvPicPr>
             <a:picLocks noChangeAspect="1"/>
           </p:cNvPicPr>
@@ -11245,7 +11334,7 @@
       </p:sp>
       <p:pic>
         <p:nvPicPr>
-          <p:cNvPr id="3" name="Image 0" descr="/work/_shared/assets/logo-candidate-2.png">    </p:cNvPr>
+          <p:cNvPr id="3" name="Image 0" descr="/tmp/pcwork/api-patterns-and-practices-graphql/presentation/_shared/assets/logo-candidate-2.png">    </p:cNvPr>
           <p:cNvPicPr>
             <a:picLocks noChangeAspect="1"/>
           </p:cNvPicPr>
@@ -11463,7 +11552,7 @@
                 <a:ea typeface="Red Hat Mono" pitchFamily="34" charset="-122"/>
                 <a:cs typeface="Red Hat Mono" pitchFamily="34" charset="-120"/>
               </a:rPr>
-              <a:t>query($t: TrackingId! = "ABC123") { cargo(trackingId: $t) { trackingId } }
+              <a:t>    return info.context.derivation.derive(self, itinerary, events)
 </a:t>
             </a:r>
             <a:pPr algn="l" indent="0" marL="0">
@@ -11499,7 +11588,7 @@
                 <a:ea typeface="Red Hat Mono" pitchFamily="34" charset="-122"/>
                 <a:cs typeface="Red Hat Mono" pitchFamily="34" charset="-120"/>
               </a:rPr>
-              <a:t>{ ny: location(unLocode: "USNYC") { name } rtm: location(unLocode: "NLRTM") { name } }
+              <a:t>
 </a:t>
             </a:r>
             <a:pPr algn="l" indent="0" marL="0">
@@ -11535,7 +11624,7 @@
                 <a:ea typeface="Red Hat Mono" pitchFamily="34" charset="-122"/>
                 <a:cs typeface="Red Hat Mono" pitchFamily="34" charset="-120"/>
               </a:rPr>
-              <a:t>{ cargo(trackingId: "ABC123") { origin { ...Place } destination { ...Place } } }
+              <a:t>
 </a:t>
             </a:r>
             <a:pPr algn="l" indent="0" marL="0">
@@ -11553,7 +11642,7 @@
                 <a:ea typeface="Red Hat Mono" pitchFamily="34" charset="-122"/>
                 <a:cs typeface="Red Hat Mono" pitchFamily="34" charset="-120"/>
               </a:rPr>
-              <a:t>fragment Place on Location { unLocode name country }
+              <a:t>```graphql
 </a:t>
             </a:r>
             <a:pPr algn="l" indent="0" marL="0">
@@ -11589,7 +11678,7 @@
                 <a:ea typeface="Red Hat Mono" pitchFamily="34" charset="-122"/>
                 <a:cs typeface="Red Hat Mono" pitchFamily="34" charset="-120"/>
               </a:rPr>
-              <a:t>query($full: Boolean!) {
+              <a:t>
 </a:t>
             </a:r>
             <a:pPr algn="l" indent="0" marL="0">
@@ -11607,7 +11696,7 @@
                 <a:ea typeface="Red Hat Mono" pitchFamily="34" charset="-122"/>
                 <a:cs typeface="Red Hat Mono" pitchFamily="34" charset="-120"/>
               </a:rPr>
-              <a:t>  cargo(trackingId: "ABC123") {
+              <a:t>```graphql
 </a:t>
             </a:r>
             <a:pPr algn="l" indent="0" marL="0">
@@ -11625,7 +11714,7 @@
                 <a:ea typeface="Red Hat Mono" pitchFamily="34" charset="-122"/>
                 <a:cs typeface="Red Hat Mono" pitchFamily="34" charset="-120"/>
               </a:rPr>
-              <a:t>    trackingId
+              <a:t>{ node(id: "loc_NLRTM") { __typename ... on Location { name } } }
 </a:t>
             </a:r>
             <a:pPr algn="l" indent="0" marL="0">
@@ -11643,7 +11732,7 @@
                 <a:ea typeface="Red Hat Mono" pitchFamily="34" charset="-122"/>
                 <a:cs typeface="Red Hat Mono" pitchFamily="34" charset="-120"/>
               </a:rPr>
-              <a:t>    itinerary @include(if: $full) { legs { loadTime } }
+              <a:t>```
 </a:t>
             </a:r>
             <a:pPr algn="l" indent="0" marL="0">
@@ -11661,7 +11750,7 @@
                 <a:ea typeface="Red Hat Mono" pitchFamily="34" charset="-122"/>
                 <a:cs typeface="Red Hat Mono" pitchFamily="34" charset="-120"/>
               </a:rPr>
-              <a:t>    delivery @skip(if: $full) { transportStatus }
+              <a:t>
 </a:t>
             </a:r>
             <a:pPr algn="l" indent="0" marL="0">
@@ -11679,7 +11768,7 @@
                 <a:ea typeface="Red Hat Mono" pitchFamily="34" charset="-122"/>
                 <a:cs typeface="Red Hat Mono" pitchFamily="34" charset="-120"/>
               </a:rPr>
-              <a:t>  }
+              <a:t>returns `{"__typename":"Location","name":"Rotterdam"}`, and a `... on Cargo` fragment in the same selection would contribute nothing, as Chapter 3 showed. The spec covers both in "Fragments" and "Inline Fragments".
 </a:t>
             </a:r>
             <a:pPr algn="l" indent="0" marL="0">
@@ -11697,7 +11786,7 @@
                 <a:ea typeface="Red Hat Mono" pitchFamily="34" charset="-122"/>
                 <a:cs typeface="Red Hat Mono" pitchFamily="34" charset="-120"/>
               </a:rPr>
-              <a:t>}
+              <a:t>
 </a:t>
             </a:r>
             <a:endParaRPr lang="en-US" sz="1300" dirty="0"/>
@@ -11809,7 +11898,7 @@
       </p:sp>
       <p:pic>
         <p:nvPicPr>
-          <p:cNvPr id="3" name="Image 0" descr="/work/_shared/assets/logo-candidate-2.png">    </p:cNvPr>
+          <p:cNvPr id="3" name="Image 0" descr="/tmp/pcwork/api-patterns-and-practices-graphql/presentation/_shared/assets/logo-candidate-2.png">    </p:cNvPr>
           <p:cNvPicPr>
             <a:picLocks noChangeAspect="1"/>
           </p:cNvPicPr>
@@ -11911,7 +12000,7 @@
       </p:sp>
       <p:pic>
         <p:nvPicPr>
-          <p:cNvPr id="6" name="Image 1" descr="/work/_shared/png/08-mutation-flow.png">    </p:cNvPr>
+          <p:cNvPr id="6" name="Image 1" descr="/tmp/pcwork/api-patterns-and-practices-graphql/presentation/_shared/png/08-mutation-flow.png">    </p:cNvPr>
           <p:cNvPicPr>
             <a:picLocks noChangeAspect="1"/>
           </p:cNvPicPr>
@@ -12037,7 +12126,7 @@
       </p:sp>
       <p:pic>
         <p:nvPicPr>
-          <p:cNvPr id="3" name="Image 0" descr="/work/_shared/assets/logo-candidate-2.png">    </p:cNvPr>
+          <p:cNvPr id="3" name="Image 0" descr="/tmp/pcwork/api-patterns-and-practices-graphql/presentation/_shared/assets/logo-candidate-2.png">    </p:cNvPr>
           <p:cNvPicPr>
             <a:picLocks noChangeAspect="1"/>
           </p:cNvPicPr>
@@ -12139,7 +12228,7 @@
       </p:sp>
       <p:pic>
         <p:nvPicPr>
-          <p:cNvPr id="6" name="Image 1" descr="/work/_shared/png/08-idempotent-replay.png">    </p:cNvPr>
+          <p:cNvPr id="6" name="Image 1" descr="/tmp/pcwork/api-patterns-and-practices-graphql/presentation/_shared/png/08-idempotent-replay.png">    </p:cNvPr>
           <p:cNvPicPr>
             <a:picLocks noChangeAspect="1"/>
           </p:cNvPicPr>
@@ -12343,7 +12432,7 @@
       </p:sp>
       <p:pic>
         <p:nvPicPr>
-          <p:cNvPr id="5" name="Image 0" descr="/work/_shared/assets/redhat-logo-white.png">    </p:cNvPr>
+          <p:cNvPr id="5" name="Image 0" descr="/tmp/pcwork/api-patterns-and-practices-graphql/presentation/_shared/assets/redhat-logo-white.png">    </p:cNvPr>
           <p:cNvPicPr>
             <a:picLocks noChangeAspect="1"/>
           </p:cNvPicPr>
@@ -12431,7 +12520,7 @@
       </p:sp>
       <p:pic>
         <p:nvPicPr>
-          <p:cNvPr id="3" name="Image 0" descr="/work/_shared/assets/logo-candidate-2.png">    </p:cNvPr>
+          <p:cNvPr id="3" name="Image 0" descr="/tmp/pcwork/api-patterns-and-practices-graphql/presentation/_shared/assets/logo-candidate-2.png">    </p:cNvPr>
           <p:cNvPicPr>
             <a:picLocks noChangeAspect="1"/>
           </p:cNvPicPr>
@@ -12533,7 +12622,7 @@
       </p:sp>
       <p:pic>
         <p:nvPicPr>
-          <p:cNvPr id="6" name="Image 1" descr="/work/_shared/png/09-error-taxonomy.png">    </p:cNvPr>
+          <p:cNvPr id="6" name="Image 1" descr="/tmp/pcwork/api-patterns-and-practices-graphql/presentation/_shared/png/09-error-taxonomy.png">    </p:cNvPr>
           <p:cNvPicPr>
             <a:picLocks noChangeAspect="1"/>
           </p:cNvPicPr>
@@ -12659,7 +12748,7 @@
       </p:sp>
       <p:pic>
         <p:nvPicPr>
-          <p:cNvPr id="3" name="Image 0" descr="/work/_shared/assets/logo-candidate-2.png">    </p:cNvPr>
+          <p:cNvPr id="3" name="Image 0" descr="/tmp/pcwork/api-patterns-and-practices-graphql/presentation/_shared/assets/logo-candidate-2.png">    </p:cNvPr>
           <p:cNvPicPr>
             <a:picLocks noChangeAspect="1"/>
           </p:cNvPicPr>
@@ -12761,7 +12850,7 @@
       </p:sp>
       <p:pic>
         <p:nvPicPr>
-          <p:cNvPr id="6" name="Image 1" descr="/work/_shared/png/09-partial-data-errors.png">    </p:cNvPr>
+          <p:cNvPr id="6" name="Image 1" descr="/tmp/pcwork/api-patterns-and-practices-graphql/presentation/_shared/png/09-partial-data-errors.png">    </p:cNvPr>
           <p:cNvPicPr>
             <a:picLocks noChangeAspect="1"/>
           </p:cNvPicPr>
@@ -12887,7 +12976,7 @@
       </p:sp>
       <p:pic>
         <p:nvPicPr>
-          <p:cNvPr id="3" name="Image 0" descr="/work/_shared/assets/logo-candidate-2.png">    </p:cNvPr>
+          <p:cNvPr id="3" name="Image 0" descr="/tmp/pcwork/api-patterns-and-practices-graphql/presentation/_shared/assets/logo-candidate-2.png">    </p:cNvPr>
           <p:cNvPicPr>
             <a:picLocks noChangeAspect="1"/>
           </p:cNvPicPr>
@@ -13099,13 +13188,13 @@
             <a:r>
               <a:rPr lang="en-US" sz="1100" dirty="0">
                 <a:solidFill>
-                  <a:srgbClr val="E6E6E6"/>
+                  <a:srgbClr val="8FB98F"/>
                 </a:solidFill>
                 <a:latin typeface="Red Hat Mono" pitchFamily="34" charset="0"/>
                 <a:ea typeface="Red Hat Mono" pitchFamily="34" charset="-122"/>
                 <a:cs typeface="Red Hat Mono" pitchFamily="34" charset="-120"/>
               </a:rPr>
-              <a:t>Q '{ cargo(trackingId: "JKL567") { trackingId itinerary { legs { loadLocation { unLocode } voyage { number } } } } }'
+              <a:t>## On the wire
 </a:t>
             </a:r>
             <a:pPr algn="l" indent="0" marL="0">
@@ -13141,7 +13230,7 @@
                 <a:ea typeface="Red Hat Mono" pitchFamily="34" charset="-122"/>
                 <a:cs typeface="Red Hat Mono" pitchFamily="34" charset="-120"/>
               </a:rPr>
-              <a:t>{"errors":[{"message":"voyage service unavailable","locations":[{"line":1,"column":89}],"path":["cargo","itinerary","legs",0,"voyage"],"extensions":{"code":"SERVICE_UNAVAILABLE"}}],"data":{"cargo":{"trackingId":"JKL567","itinerary":{"legs":[{"loadLocation":{"unLocode":"USNYC"},"voyage":null}]}}}}
+              <a:t>```bash
 </a:t>
             </a:r>
             <a:pPr algn="l" indent="0" marL="0">
@@ -13177,7 +13266,7 @@
                 <a:ea typeface="Red Hat Mono" pitchFamily="34" charset="-122"/>
                 <a:cs typeface="Red Hat Mono" pitchFamily="34" charset="-120"/>
               </a:rPr>
-              <a:t>Q '{ cargo(trackingId: "PQR234") { trackingId delivery { transportStatus } } }'
+              <a:t>
 </a:t>
             </a:r>
             <a:pPr algn="l" indent="0" marL="0">
@@ -13213,7 +13302,7 @@
                 <a:ea typeface="Red Hat Mono" pitchFamily="34" charset="-122"/>
                 <a:cs typeface="Red Hat Mono" pitchFamily="34" charset="-120"/>
               </a:rPr>
-              <a:t>{"errors":[{"message":"Internal server error.","locations":[{"line":1,"column":44}],"path":["cargo","delivery"],"extensions":{"code":null}}],"data":{"cargo":null}}
+              <a:t>```json
 </a:t>
             </a:r>
             <a:endParaRPr lang="en-US" sz="1100" dirty="0"/>
@@ -13325,7 +13414,7 @@
       </p:sp>
       <p:pic>
         <p:nvPicPr>
-          <p:cNvPr id="3" name="Image 0" descr="/work/_shared/assets/logo-candidate-2.png">    </p:cNvPr>
+          <p:cNvPr id="3" name="Image 0" descr="/tmp/pcwork/api-patterns-and-practices-graphql/presentation/_shared/assets/logo-candidate-2.png">    </p:cNvPr>
           <p:cNvPicPr>
             <a:picLocks noChangeAspect="1"/>
           </p:cNvPicPr>
@@ -13427,7 +13516,7 @@
       </p:sp>
       <p:pic>
         <p:nvPicPr>
-          <p:cNvPr id="6" name="Image 1" descr="/work/_shared/png/09-error-masking.png">    </p:cNvPr>
+          <p:cNvPr id="6" name="Image 1" descr="/tmp/pcwork/api-patterns-and-practices-graphql/presentation/_shared/png/09-error-masking.png">    </p:cNvPr>
           <p:cNvPicPr>
             <a:picLocks noChangeAspect="1"/>
           </p:cNvPicPr>
@@ -13631,7 +13720,7 @@
       </p:sp>
       <p:pic>
         <p:nvPicPr>
-          <p:cNvPr id="5" name="Image 0" descr="/work/_shared/assets/redhat-logo-white.png">    </p:cNvPr>
+          <p:cNvPr id="5" name="Image 0" descr="/tmp/pcwork/api-patterns-and-practices-graphql/presentation/_shared/assets/redhat-logo-white.png">    </p:cNvPr>
           <p:cNvPicPr>
             <a:picLocks noChangeAspect="1"/>
           </p:cNvPicPr>
@@ -13719,7 +13808,7 @@
       </p:sp>
       <p:pic>
         <p:nvPicPr>
-          <p:cNvPr id="3" name="Image 0" descr="/work/_shared/assets/logo-candidate-2.png">    </p:cNvPr>
+          <p:cNvPr id="3" name="Image 0" descr="/tmp/pcwork/api-patterns-and-practices-graphql/presentation/_shared/assets/logo-candidate-2.png">    </p:cNvPr>
           <p:cNvPicPr>
             <a:picLocks noChangeAspect="1"/>
           </p:cNvPicPr>
@@ -13821,7 +13910,7 @@
       </p:sp>
       <p:pic>
         <p:nvPicPr>
-          <p:cNvPr id="6" name="Image 1" descr="/work/_shared/png/10-demand-oriented-schema.png">    </p:cNvPr>
+          <p:cNvPr id="6" name="Image 1" descr="/tmp/pcwork/api-patterns-and-practices-graphql/presentation/_shared/png/10-demand-oriented-schema.png">    </p:cNvPr>
           <p:cNvPicPr>
             <a:picLocks noChangeAspect="1"/>
           </p:cNvPicPr>
@@ -14025,7 +14114,7 @@
       </p:sp>
       <p:pic>
         <p:nvPicPr>
-          <p:cNvPr id="5" name="Image 0" descr="/work/_shared/assets/redhat-logo-white.png">    </p:cNvPr>
+          <p:cNvPr id="5" name="Image 0" descr="/tmp/pcwork/api-patterns-and-practices-graphql/presentation/_shared/assets/redhat-logo-white.png">    </p:cNvPr>
           <p:cNvPicPr>
             <a:picLocks noChangeAspect="1"/>
           </p:cNvPicPr>
@@ -14113,7 +14202,7 @@
       </p:sp>
       <p:pic>
         <p:nvPicPr>
-          <p:cNvPr id="3" name="Image 0" descr="/work/_shared/assets/logo-candidate-2.png">    </p:cNvPr>
+          <p:cNvPr id="3" name="Image 0" descr="/tmp/pcwork/api-patterns-and-practices-graphql/presentation/_shared/assets/logo-candidate-2.png">    </p:cNvPr>
           <p:cNvPicPr>
             <a:picLocks noChangeAspect="1"/>
           </p:cNvPicPr>
@@ -14215,7 +14304,7 @@
       </p:sp>
       <p:pic>
         <p:nvPicPr>
-          <p:cNvPr id="6" name="Image 1" descr="/work/_shared/png/10-node-identity.png">    </p:cNvPr>
+          <p:cNvPr id="6" name="Image 1" descr="/tmp/pcwork/api-patterns-and-practices-graphql/presentation/_shared/png/10-node-identity.png">    </p:cNvPr>
           <p:cNvPicPr>
             <a:picLocks noChangeAspect="1"/>
           </p:cNvPicPr>
@@ -14341,7 +14430,7 @@
       </p:sp>
       <p:pic>
         <p:nvPicPr>
-          <p:cNvPr id="3" name="Image 0" descr="/work/_shared/assets/logo-candidate-2.png">    </p:cNvPr>
+          <p:cNvPr id="3" name="Image 0" descr="/tmp/pcwork/api-patterns-and-practices-graphql/presentation/_shared/assets/logo-candidate-2.png">    </p:cNvPr>
           <p:cNvPicPr>
             <a:picLocks noChangeAspect="1"/>
           </p:cNvPicPr>
@@ -14443,7 +14532,7 @@
       </p:sp>
       <p:pic>
         <p:nvPicPr>
-          <p:cNvPr id="6" name="Image 1" descr="/work/_shared/png/11-change-classes.png">    </p:cNvPr>
+          <p:cNvPr id="6" name="Image 1" descr="/tmp/pcwork/api-patterns-and-practices-graphql/presentation/_shared/png/11-change-classes.png">    </p:cNvPr>
           <p:cNvPicPr>
             <a:picLocks noChangeAspect="1"/>
           </p:cNvPicPr>
@@ -14569,7 +14658,7 @@
       </p:sp>
       <p:pic>
         <p:nvPicPr>
-          <p:cNvPr id="3" name="Image 0" descr="/work/_shared/assets/logo-candidate-2.png">    </p:cNvPr>
+          <p:cNvPr id="3" name="Image 0" descr="/tmp/pcwork/api-patterns-and-practices-graphql/presentation/_shared/assets/logo-candidate-2.png">    </p:cNvPr>
           <p:cNvPicPr>
             <a:picLocks noChangeAspect="1"/>
           </p:cNvPicPr>
@@ -15025,7 +15114,7 @@
       </p:sp>
       <p:pic>
         <p:nvPicPr>
-          <p:cNvPr id="3" name="Image 0" descr="/work/_shared/assets/logo-candidate-2.png">    </p:cNvPr>
+          <p:cNvPr id="3" name="Image 0" descr="/tmp/pcwork/api-patterns-and-practices-graphql/presentation/_shared/assets/logo-candidate-2.png">    </p:cNvPr>
           <p:cNvPicPr>
             <a:picLocks noChangeAspect="1"/>
           </p:cNvPicPr>
@@ -15127,7 +15216,7 @@
       </p:sp>
       <p:pic>
         <p:nvPicPr>
-          <p:cNvPr id="6" name="Image 1" descr="/work/_shared/png/11-deprecation-lifecycle.png">    </p:cNvPr>
+          <p:cNvPr id="6" name="Image 1" descr="/tmp/pcwork/api-patterns-and-practices-graphql/presentation/_shared/png/11-deprecation-lifecycle.png">    </p:cNvPr>
           <p:cNvPicPr>
             <a:picLocks noChangeAspect="1"/>
           </p:cNvPicPr>
@@ -15331,7 +15420,7 @@
       </p:sp>
       <p:pic>
         <p:nvPicPr>
-          <p:cNvPr id="5" name="Image 0" descr="/work/_shared/assets/redhat-logo-white.png">    </p:cNvPr>
+          <p:cNvPr id="5" name="Image 0" descr="/tmp/pcwork/api-patterns-and-practices-graphql/presentation/_shared/assets/redhat-logo-white.png">    </p:cNvPr>
           <p:cNvPicPr>
             <a:picLocks noChangeAspect="1"/>
           </p:cNvPicPr>
@@ -15419,7 +15508,7 @@
       </p:sp>
       <p:pic>
         <p:nvPicPr>
-          <p:cNvPr id="3" name="Image 0" descr="/work/_shared/assets/logo-candidate-2.png">    </p:cNvPr>
+          <p:cNvPr id="3" name="Image 0" descr="/tmp/pcwork/api-patterns-and-practices-graphql/presentation/_shared/assets/logo-candidate-2.png">    </p:cNvPr>
           <p:cNvPicPr>
             <a:picLocks noChangeAspect="1"/>
           </p:cNvPicPr>
@@ -15521,7 +15610,7 @@
       </p:sp>
       <p:pic>
         <p:nvPicPr>
-          <p:cNvPr id="6" name="Image 1" descr="/work/_shared/png/12-connection-anatomy.png">    </p:cNvPr>
+          <p:cNvPr id="6" name="Image 1" descr="/tmp/pcwork/api-patterns-and-practices-graphql/presentation/_shared/png/12-connection-anatomy.png">    </p:cNvPr>
           <p:cNvPicPr>
             <a:picLocks noChangeAspect="1"/>
           </p:cNvPicPr>
@@ -15647,7 +15736,7 @@
       </p:sp>
       <p:pic>
         <p:nvPicPr>
-          <p:cNvPr id="3" name="Image 0" descr="/work/_shared/assets/logo-candidate-2.png">    </p:cNvPr>
+          <p:cNvPr id="3" name="Image 0" descr="/tmp/pcwork/api-patterns-and-practices-graphql/presentation/_shared/assets/logo-candidate-2.png">    </p:cNvPr>
           <p:cNvPicPr>
             <a:picLocks noChangeAspect="1"/>
           </p:cNvPicPr>
@@ -15749,7 +15838,7 @@
       </p:sp>
       <p:pic>
         <p:nvPicPr>
-          <p:cNvPr id="6" name="Image 1" descr="/work/_shared/png/12-offset-vs-keyset.png">    </p:cNvPr>
+          <p:cNvPr id="6" name="Image 1" descr="/tmp/pcwork/api-patterns-and-practices-graphql/presentation/_shared/png/12-offset-vs-keyset.png">    </p:cNvPr>
           <p:cNvPicPr>
             <a:picLocks noChangeAspect="1"/>
           </p:cNvPicPr>
@@ -15875,7 +15964,7 @@
       </p:sp>
       <p:pic>
         <p:nvPicPr>
-          <p:cNvPr id="3" name="Image 0" descr="/work/_shared/assets/logo-candidate-2.png">    </p:cNvPr>
+          <p:cNvPr id="3" name="Image 0" descr="/tmp/pcwork/api-patterns-and-practices-graphql/presentation/_shared/assets/logo-candidate-2.png">    </p:cNvPr>
           <p:cNvPicPr>
             <a:picLocks noChangeAspect="1"/>
           </p:cNvPicPr>
@@ -16093,7 +16182,7 @@
                 <a:ea typeface="Red Hat Mono" pitchFamily="34" charset="-122"/>
                 <a:cs typeface="Red Hat Mono" pitchFamily="34" charset="-120"/>
               </a:rPr>
-              <a:t>Q 'query($f: Int, $a: String) { cargos(first: $f, after: $a) { edges { cursor node { trackingId } } pageInfo { hasNextPage hasPreviousPage startCursor endCursor } totalCount } }' '{"f":2}'
+              <a:t>```bash
 </a:t>
             </a:r>
             <a:pPr algn="l" indent="0" marL="0">
@@ -16111,7 +16200,7 @@
                 <a:ea typeface="Red Hat Mono" pitchFamily="34" charset="-122"/>
                 <a:cs typeface="Red Hat Mono" pitchFamily="34" charset="-120"/>
               </a:rPr>
-              <a:t>...
+              <a:t>  ...
 </a:t>
             </a:r>
             <a:pPr algn="l" indent="0" marL="0">
@@ -16129,7 +16218,7 @@
                 <a:ea typeface="Red Hat Mono" pitchFamily="34" charset="-122"/>
                 <a:cs typeface="Red Hat Mono" pitchFamily="34" charset="-120"/>
               </a:rPr>
-              <a:t>{"data":{"cargos":{"edges":[{"cursor":"Y2FyZ298djF8MjAyNi0wOS0yOVQwOTowMDowMFp8VldYOTAx","node":{"trackingId":"VWX901"}},{"cursor":"Y2FyZ298djF8MjAyNi0wOS0yOFQwOTowMDowMFp8WFlaNzg5","node":{"trackingId":"XYZ789"}}],"pageInfo":{"hasNextPage":true,"hasPreviousPage":false,"startCursor":"Y2FyZ298djF8MjAyNi0wOS0yOVQwOTowMDowMFp8VldYOTAx","endCursor":"Y2FyZ298djF8MjAyNi0wOS0yOFQwOTowMDowMFp8WFlaNzg5"},"totalCount":6}}}
+              <a:t>  curl -s localhost:${3:-8220}/graphql -H 'Content-Type: application/json' \
 </a:t>
             </a:r>
             <a:pPr algn="l" indent="0" marL="0">
@@ -16165,7 +16254,7 @@
                 <a:ea typeface="Red Hat Mono" pitchFamily="34" charset="-122"/>
                 <a:cs typeface="Red Hat Mono" pitchFamily="34" charset="-120"/>
               </a:rPr>
-              <a:t>Q '{ cargos(first: 51) { totalCount } }'
+              <a:t>
 </a:t>
             </a:r>
             <a:pPr algn="l" indent="0" marL="0">
@@ -16201,7 +16290,7 @@
                 <a:ea typeface="Red Hat Mono" pitchFamily="34" charset="-122"/>
                 <a:cs typeface="Red Hat Mono" pitchFamily="34" charset="-120"/>
               </a:rPr>
-              <a:t>{"errors":[{"message":"first must be between 0 and 50","locations":[{"line":1,"column":3}],"path":["cargos"],"extensions":{"code":"BAD_USER_INPUT"}}],"data":null}
+              <a:t>```
 </a:t>
             </a:r>
             <a:endParaRPr lang="en-US" sz="900" dirty="0"/>
@@ -16313,7 +16402,7 @@
       </p:sp>
       <p:pic>
         <p:nvPicPr>
-          <p:cNvPr id="3" name="Image 0" descr="/work/_shared/assets/logo-candidate-2.png">    </p:cNvPr>
+          <p:cNvPr id="3" name="Image 0" descr="/tmp/pcwork/api-patterns-and-practices-graphql/presentation/_shared/assets/logo-candidate-2.png">    </p:cNvPr>
           <p:cNvPicPr>
             <a:picLocks noChangeAspect="1"/>
           </p:cNvPicPr>
@@ -16415,7 +16504,7 @@
       </p:sp>
       <p:pic>
         <p:nvPicPr>
-          <p:cNvPr id="6" name="Image 1" descr="/work/_shared/png/13-n-plus-one-fanout.png">    </p:cNvPr>
+          <p:cNvPr id="6" name="Image 1" descr="/tmp/pcwork/api-patterns-and-practices-graphql/presentation/_shared/png/13-n-plus-one-fanout.png">    </p:cNvPr>
           <p:cNvPicPr>
             <a:picLocks noChangeAspect="1"/>
           </p:cNvPicPr>
@@ -16541,7 +16630,7 @@
       </p:sp>
       <p:pic>
         <p:nvPicPr>
-          <p:cNvPr id="3" name="Image 0" descr="/work/_shared/assets/logo-candidate-2.png">    </p:cNvPr>
+          <p:cNvPr id="3" name="Image 0" descr="/tmp/pcwork/api-patterns-and-practices-graphql/presentation/_shared/assets/logo-candidate-2.png">    </p:cNvPr>
           <p:cNvPicPr>
             <a:picLocks noChangeAspect="1"/>
           </p:cNvPicPr>
@@ -16643,7 +16732,7 @@
       </p:sp>
       <p:pic>
         <p:nvPicPr>
-          <p:cNvPr id="6" name="Image 1" descr="/work/_shared/png/13-batched-load.png">    </p:cNvPr>
+          <p:cNvPr id="6" name="Image 1" descr="/tmp/pcwork/api-patterns-and-practices-graphql/presentation/_shared/png/13-batched-load.png">    </p:cNvPr>
           <p:cNvPicPr>
             <a:picLocks noChangeAspect="1"/>
           </p:cNvPicPr>
@@ -16769,7 +16858,7 @@
       </p:sp>
       <p:pic>
         <p:nvPicPr>
-          <p:cNvPr id="3" name="Image 0" descr="/work/_shared/assets/logo-candidate-2.png">    </p:cNvPr>
+          <p:cNvPr id="3" name="Image 0" descr="/tmp/pcwork/api-patterns-and-practices-graphql/presentation/_shared/assets/logo-candidate-2.png">    </p:cNvPr>
           <p:cNvPicPr>
             <a:picLocks noChangeAspect="1"/>
           </p:cNvPicPr>
@@ -16871,7 +16960,7 @@
       </p:sp>
       <p:pic>
         <p:nvPicPr>
-          <p:cNvPr id="6" name="Image 1" descr="/work/_shared/png/01-three-paradigms.png">    </p:cNvPr>
+          <p:cNvPr id="6" name="Image 1" descr="/tmp/pcwork/api-patterns-and-practices-graphql/presentation/_shared/png/01-three-paradigms.png">    </p:cNvPr>
           <p:cNvPicPr>
             <a:picLocks noChangeAspect="1"/>
           </p:cNvPicPr>
@@ -16997,7 +17086,7 @@
       </p:sp>
       <p:pic>
         <p:nvPicPr>
-          <p:cNvPr id="3" name="Image 0" descr="/work/_shared/assets/logo-candidate-2.png">    </p:cNvPr>
+          <p:cNvPr id="3" name="Image 0" descr="/tmp/pcwork/api-patterns-and-practices-graphql/presentation/_shared/assets/logo-candidate-2.png">    </p:cNvPr>
           <p:cNvPicPr>
             <a:picLocks noChangeAspect="1"/>
           </p:cNvPicPr>
@@ -17099,7 +17188,7 @@
       </p:sp>
       <p:pic>
         <p:nvPicPr>
-          <p:cNvPr id="6" name="Image 1" descr="/work/_shared/png/13-dataloader-tick.png">    </p:cNvPr>
+          <p:cNvPr id="6" name="Image 1" descr="/tmp/pcwork/api-patterns-and-practices-graphql/presentation/_shared/png/13-dataloader-tick.png">    </p:cNvPr>
           <p:cNvPicPr>
             <a:picLocks noChangeAspect="1"/>
           </p:cNvPicPr>
@@ -17303,7 +17392,7 @@
       </p:sp>
       <p:pic>
         <p:nvPicPr>
-          <p:cNvPr id="5" name="Image 0" descr="/work/_shared/assets/redhat-logo-white.png">    </p:cNvPr>
+          <p:cNvPr id="5" name="Image 0" descr="/tmp/pcwork/api-patterns-and-practices-graphql/presentation/_shared/assets/redhat-logo-white.png">    </p:cNvPr>
           <p:cNvPicPr>
             <a:picLocks noChangeAspect="1"/>
           </p:cNvPicPr>
@@ -17391,7 +17480,7 @@
       </p:sp>
       <p:pic>
         <p:nvPicPr>
-          <p:cNvPr id="3" name="Image 0" descr="/work/_shared/assets/logo-candidate-2.png">    </p:cNvPr>
+          <p:cNvPr id="3" name="Image 0" descr="/tmp/pcwork/api-patterns-and-practices-graphql/presentation/_shared/assets/logo-candidate-2.png">    </p:cNvPr>
           <p:cNvPicPr>
             <a:picLocks noChangeAspect="1"/>
           </p:cNvPicPr>
@@ -17493,7 +17582,7 @@
       </p:sp>
       <p:pic>
         <p:nvPicPr>
-          <p:cNvPr id="6" name="Image 1" descr="/work/_shared/png/14-limit-pipeline.png">    </p:cNvPr>
+          <p:cNvPr id="6" name="Image 1" descr="/tmp/pcwork/api-patterns-and-practices-graphql/presentation/_shared/png/14-limit-pipeline.png">    </p:cNvPr>
           <p:cNvPicPr>
             <a:picLocks noChangeAspect="1"/>
           </p:cNvPicPr>
@@ -17619,7 +17708,7 @@
       </p:sp>
       <p:pic>
         <p:nvPicPr>
-          <p:cNvPr id="3" name="Image 0" descr="/work/_shared/assets/logo-candidate-2.png">    </p:cNvPr>
+          <p:cNvPr id="3" name="Image 0" descr="/tmp/pcwork/api-patterns-and-practices-graphql/presentation/_shared/assets/logo-candidate-2.png">    </p:cNvPr>
           <p:cNvPicPr>
             <a:picLocks noChangeAspect="1"/>
           </p:cNvPicPr>
@@ -17721,7 +17810,7 @@
       </p:sp>
       <p:pic>
         <p:nvPicPr>
-          <p:cNvPr id="6" name="Image 1" descr="/work/_shared/png/14-cost-accumulation.png">    </p:cNvPr>
+          <p:cNvPr id="6" name="Image 1" descr="/tmp/pcwork/api-patterns-and-practices-graphql/presentation/_shared/png/14-cost-accumulation.png">    </p:cNvPr>
           <p:cNvPicPr>
             <a:picLocks noChangeAspect="1"/>
           </p:cNvPicPr>
@@ -17847,7 +17936,7 @@
       </p:sp>
       <p:pic>
         <p:nvPicPr>
-          <p:cNvPr id="3" name="Image 0" descr="/work/_shared/assets/logo-candidate-2.png">    </p:cNvPr>
+          <p:cNvPr id="3" name="Image 0" descr="/tmp/pcwork/api-patterns-and-practices-graphql/presentation/_shared/assets/logo-candidate-2.png">    </p:cNvPr>
           <p:cNvPicPr>
             <a:picLocks noChangeAspect="1"/>
           </p:cNvPicPr>
@@ -17949,7 +18038,7 @@
       </p:sp>
       <p:pic>
         <p:nvPicPr>
-          <p:cNvPr id="6" name="Image 1" descr="/work/_shared/png/15-apq-handshake.png">    </p:cNvPr>
+          <p:cNvPr id="6" name="Image 1" descr="/tmp/pcwork/api-patterns-and-practices-graphql/presentation/_shared/png/15-apq-handshake.png">    </p:cNvPr>
           <p:cNvPicPr>
             <a:picLocks noChangeAspect="1"/>
           </p:cNvPicPr>
@@ -18075,7 +18164,7 @@
       </p:sp>
       <p:pic>
         <p:nvPicPr>
-          <p:cNvPr id="3" name="Image 0" descr="/work/_shared/assets/logo-candidate-2.png">    </p:cNvPr>
+          <p:cNvPr id="3" name="Image 0" descr="/tmp/pcwork/api-patterns-and-practices-graphql/presentation/_shared/assets/logo-candidate-2.png">    </p:cNvPr>
           <p:cNvPicPr>
             <a:picLocks noChangeAspect="1"/>
           </p:cNvPicPr>
@@ -18177,7 +18266,7 @@
       </p:sp>
       <p:pic>
         <p:nvPicPr>
-          <p:cNvPr id="6" name="Image 1" descr="/work/_shared/png/15-apq-vs-trusted.png">    </p:cNvPr>
+          <p:cNvPr id="6" name="Image 1" descr="/tmp/pcwork/api-patterns-and-practices-graphql/presentation/_shared/png/15-apq-vs-trusted.png">    </p:cNvPr>
           <p:cNvPicPr>
             <a:picLocks noChangeAspect="1"/>
           </p:cNvPicPr>
@@ -18303,7 +18392,7 @@
       </p:sp>
       <p:pic>
         <p:nvPicPr>
-          <p:cNvPr id="3" name="Image 0" descr="/work/_shared/assets/logo-candidate-2.png">    </p:cNvPr>
+          <p:cNvPr id="3" name="Image 0" descr="/tmp/pcwork/api-patterns-and-practices-graphql/presentation/_shared/assets/logo-candidate-2.png">    </p:cNvPr>
           <p:cNvPicPr>
             <a:picLocks noChangeAspect="1"/>
           </p:cNvPicPr>
@@ -18405,7 +18494,7 @@
       </p:sp>
       <p:pic>
         <p:nvPicPr>
-          <p:cNvPr id="6" name="Image 1" descr="/work/_shared/png/16-cache-layers.png">    </p:cNvPr>
+          <p:cNvPr id="6" name="Image 1" descr="/tmp/pcwork/api-patterns-and-practices-graphql/presentation/_shared/png/16-cache-layers.png">    </p:cNvPr>
           <p:cNvPicPr>
             <a:picLocks noChangeAspect="1"/>
           </p:cNvPicPr>
@@ -18531,7 +18620,7 @@
       </p:sp>
       <p:pic>
         <p:nvPicPr>
-          <p:cNvPr id="3" name="Image 0" descr="/work/_shared/assets/logo-candidate-2.png">    </p:cNvPr>
+          <p:cNvPr id="3" name="Image 0" descr="/tmp/pcwork/api-patterns-and-practices-graphql/presentation/_shared/assets/logo-candidate-2.png">    </p:cNvPr>
           <p:cNvPicPr>
             <a:picLocks noChangeAspect="1"/>
           </p:cNvPicPr>
@@ -18633,7 +18722,7 @@
       </p:sp>
       <p:pic>
         <p:nvPicPr>
-          <p:cNvPr id="6" name="Image 1" descr="/work/_shared/png/16-cache-policy-decision.png">    </p:cNvPr>
+          <p:cNvPr id="6" name="Image 1" descr="/tmp/pcwork/api-patterns-and-practices-graphql/presentation/_shared/png/16-cache-policy-decision.png">    </p:cNvPr>
           <p:cNvPicPr>
             <a:picLocks noChangeAspect="1"/>
           </p:cNvPicPr>
@@ -18837,7 +18926,7 @@
       </p:sp>
       <p:pic>
         <p:nvPicPr>
-          <p:cNvPr id="5" name="Image 0" descr="/work/_shared/assets/redhat-logo-white.png">    </p:cNvPr>
+          <p:cNvPr id="5" name="Image 0" descr="/tmp/pcwork/api-patterns-and-practices-graphql/presentation/_shared/assets/redhat-logo-white.png">    </p:cNvPr>
           <p:cNvPicPr>
             <a:picLocks noChangeAspect="1"/>
           </p:cNvPicPr>
@@ -18925,7 +19014,7 @@
       </p:sp>
       <p:pic>
         <p:nvPicPr>
-          <p:cNvPr id="3" name="Image 0" descr="/work/_shared/assets/logo-candidate-2.png">    </p:cNvPr>
+          <p:cNvPr id="3" name="Image 0" descr="/tmp/pcwork/api-patterns-and-practices-graphql/presentation/_shared/assets/logo-candidate-2.png">    </p:cNvPr>
           <p:cNvPicPr>
             <a:picLocks noChangeAspect="1"/>
           </p:cNvPicPr>
@@ -19027,7 +19116,7 @@
       </p:sp>
       <p:pic>
         <p:nvPicPr>
-          <p:cNvPr id="6" name="Image 1" descr="/work/_shared/png/17-hardened-request-path.png">    </p:cNvPr>
+          <p:cNvPr id="6" name="Image 1" descr="/tmp/pcwork/api-patterns-and-practices-graphql/presentation/_shared/png/17-hardened-request-path.png">    </p:cNvPr>
           <p:cNvPicPr>
             <a:picLocks noChangeAspect="1"/>
           </p:cNvPicPr>
@@ -19153,7 +19242,7 @@
       </p:sp>
       <p:pic>
         <p:nvPicPr>
-          <p:cNvPr id="3" name="Image 0" descr="/work/_shared/assets/logo-candidate-2.png">    </p:cNvPr>
+          <p:cNvPr id="3" name="Image 0" descr="/tmp/pcwork/api-patterns-and-practices-graphql/presentation/_shared/assets/logo-candidate-2.png">    </p:cNvPr>
           <p:cNvPicPr>
             <a:picLocks noChangeAspect="1"/>
           </p:cNvPicPr>
@@ -19255,7 +19344,7 @@
       </p:sp>
       <p:pic>
         <p:nvPicPr>
-          <p:cNvPr id="6" name="Image 1" descr="/work/_shared/png/01-request-path.png">    </p:cNvPr>
+          <p:cNvPr id="6" name="Image 1" descr="/tmp/pcwork/api-patterns-and-practices-graphql/presentation/_shared/png/01-request-path.png">    </p:cNvPr>
           <p:cNvPicPr>
             <a:picLocks noChangeAspect="1"/>
           </p:cNvPicPr>
@@ -19381,7 +19470,7 @@
       </p:sp>
       <p:pic>
         <p:nvPicPr>
-          <p:cNvPr id="3" name="Image 0" descr="/work/_shared/assets/logo-candidate-2.png">    </p:cNvPr>
+          <p:cNvPr id="3" name="Image 0" descr="/tmp/pcwork/api-patterns-and-practices-graphql/presentation/_shared/assets/logo-candidate-2.png">    </p:cNvPr>
           <p:cNvPicPr>
             <a:picLocks noChangeAspect="1"/>
           </p:cNvPicPr>
@@ -19483,7 +19572,7 @@
       </p:sp>
       <p:pic>
         <p:nvPicPr>
-          <p:cNvPr id="6" name="Image 1" descr="/work/_shared/png/17-public-vs-internal-endpoints.png">    </p:cNvPr>
+          <p:cNvPr id="6" name="Image 1" descr="/tmp/pcwork/api-patterns-and-practices-graphql/presentation/_shared/png/17-public-vs-internal-endpoints.png">    </p:cNvPr>
           <p:cNvPicPr>
             <a:picLocks noChangeAspect="1"/>
           </p:cNvPicPr>
@@ -19609,7 +19698,7 @@
       </p:sp>
       <p:pic>
         <p:nvPicPr>
-          <p:cNvPr id="3" name="Image 0" descr="/work/_shared/assets/logo-candidate-2.png">    </p:cNvPr>
+          <p:cNvPr id="3" name="Image 0" descr="/tmp/pcwork/api-patterns-and-practices-graphql/presentation/_shared/assets/logo-candidate-2.png">    </p:cNvPr>
           <p:cNvPicPr>
             <a:picLocks noChangeAspect="1"/>
           </p:cNvPicPr>
@@ -19711,7 +19800,7 @@
       </p:sp>
       <p:pic>
         <p:nvPicPr>
-          <p:cNvPr id="6" name="Image 1" descr="/work/_shared/png/18-authorization-layers.png">    </p:cNvPr>
+          <p:cNvPr id="6" name="Image 1" descr="/tmp/pcwork/api-patterns-and-practices-graphql/presentation/_shared/png/18-authorization-layers.png">    </p:cNvPr>
           <p:cNvPicPr>
             <a:picLocks noChangeAspect="1"/>
           </p:cNvPicPr>
@@ -19837,7 +19926,7 @@
       </p:sp>
       <p:pic>
         <p:nvPicPr>
-          <p:cNvPr id="3" name="Image 0" descr="/work/_shared/assets/logo-candidate-2.png">    </p:cNvPr>
+          <p:cNvPr id="3" name="Image 0" descr="/tmp/pcwork/api-patterns-and-practices-graphql/presentation/_shared/assets/logo-candidate-2.png">    </p:cNvPr>
           <p:cNvPicPr>
             <a:picLocks noChangeAspect="1"/>
           </p:cNvPicPr>
@@ -19939,7 +20028,7 @@
       </p:sp>
       <p:pic>
         <p:nvPicPr>
-          <p:cNvPr id="6" name="Image 1" descr="/work/_shared/png/18-errors-vs-nulls.png">    </p:cNvPr>
+          <p:cNvPr id="6" name="Image 1" descr="/tmp/pcwork/api-patterns-and-practices-graphql/presentation/_shared/png/18-errors-vs-nulls.png">    </p:cNvPr>
           <p:cNvPicPr>
             <a:picLocks noChangeAspect="1"/>
           </p:cNvPicPr>
@@ -20143,7 +20232,7 @@
       </p:sp>
       <p:pic>
         <p:nvPicPr>
-          <p:cNvPr id="5" name="Image 0" descr="/work/_shared/assets/redhat-logo-white.png">    </p:cNvPr>
+          <p:cNvPr id="5" name="Image 0" descr="/tmp/pcwork/api-patterns-and-practices-graphql/presentation/_shared/assets/redhat-logo-white.png">    </p:cNvPr>
           <p:cNvPicPr>
             <a:picLocks noChangeAspect="1"/>
           </p:cNvPicPr>
@@ -20231,7 +20320,7 @@
       </p:sp>
       <p:pic>
         <p:nvPicPr>
-          <p:cNvPr id="3" name="Image 0" descr="/work/_shared/assets/logo-candidate-2.png">    </p:cNvPr>
+          <p:cNvPr id="3" name="Image 0" descr="/tmp/pcwork/api-patterns-and-practices-graphql/presentation/_shared/assets/logo-candidate-2.png">    </p:cNvPr>
           <p:cNvPicPr>
             <a:picLocks noChangeAspect="1"/>
           </p:cNvPicPr>
@@ -20333,7 +20422,7 @@
       </p:sp>
       <p:pic>
         <p:nvPicPr>
-          <p:cNvPr id="6" name="Image 1" descr="/work/_shared/png/19-one-endpoint-blind-spot.png">    </p:cNvPr>
+          <p:cNvPr id="6" name="Image 1" descr="/tmp/pcwork/api-patterns-and-practices-graphql/presentation/_shared/png/19-one-endpoint-blind-spot.png">    </p:cNvPr>
           <p:cNvPicPr>
             <a:picLocks noChangeAspect="1"/>
           </p:cNvPicPr>
@@ -20459,7 +20548,7 @@
       </p:sp>
       <p:pic>
         <p:nvPicPr>
-          <p:cNvPr id="3" name="Image 0" descr="/work/_shared/assets/logo-candidate-2.png">    </p:cNvPr>
+          <p:cNvPr id="3" name="Image 0" descr="/tmp/pcwork/api-patterns-and-practices-graphql/presentation/_shared/assets/logo-candidate-2.png">    </p:cNvPr>
           <p:cNvPicPr>
             <a:picLocks noChangeAspect="1"/>
           </p:cNvPicPr>
@@ -20561,7 +20650,7 @@
       </p:sp>
       <p:pic>
         <p:nvPicPr>
-          <p:cNvPr id="6" name="Image 1" descr="/work/_shared/png/19-span-per-resolver.png">    </p:cNvPr>
+          <p:cNvPr id="6" name="Image 1" descr="/tmp/pcwork/api-patterns-and-practices-graphql/presentation/_shared/png/19-span-per-resolver.png">    </p:cNvPr>
           <p:cNvPicPr>
             <a:picLocks noChangeAspect="1"/>
           </p:cNvPicPr>
@@ -20687,7 +20776,7 @@
       </p:sp>
       <p:pic>
         <p:nvPicPr>
-          <p:cNvPr id="3" name="Image 0" descr="/work/_shared/assets/logo-candidate-2.png">    </p:cNvPr>
+          <p:cNvPr id="3" name="Image 0" descr="/tmp/pcwork/api-patterns-and-practices-graphql/presentation/_shared/assets/logo-candidate-2.png">    </p:cNvPr>
           <p:cNvPicPr>
             <a:picLocks noChangeAspect="1"/>
           </p:cNvPicPr>
@@ -20789,7 +20878,7 @@
       </p:sp>
       <p:pic>
         <p:nvPicPr>
-          <p:cNvPr id="6" name="Image 1" descr="/work/_shared/png/20-subgraph-ownership.png">    </p:cNvPr>
+          <p:cNvPr id="6" name="Image 1" descr="/tmp/pcwork/api-patterns-and-practices-graphql/presentation/_shared/png/20-subgraph-ownership.png">    </p:cNvPr>
           <p:cNvPicPr>
             <a:picLocks noChangeAspect="1"/>
           </p:cNvPicPr>
@@ -20915,7 +21004,7 @@
       </p:sp>
       <p:pic>
         <p:nvPicPr>
-          <p:cNvPr id="3" name="Image 0" descr="/work/_shared/assets/logo-candidate-2.png">    </p:cNvPr>
+          <p:cNvPr id="3" name="Image 0" descr="/tmp/pcwork/api-patterns-and-practices-graphql/presentation/_shared/assets/logo-candidate-2.png">    </p:cNvPr>
           <p:cNvPicPr>
             <a:picLocks noChangeAspect="1"/>
           </p:cNvPicPr>
@@ -21017,7 +21106,7 @@
       </p:sp>
       <p:pic>
         <p:nvPicPr>
-          <p:cNvPr id="6" name="Image 1" descr="/work/_shared/png/20-query-plan.png">    </p:cNvPr>
+          <p:cNvPr id="6" name="Image 1" descr="/tmp/pcwork/api-patterns-and-practices-graphql/presentation/_shared/png/20-query-plan.png">    </p:cNvPr>
           <p:cNvPicPr>
             <a:picLocks noChangeAspect="1"/>
           </p:cNvPicPr>
@@ -21221,7 +21310,7 @@
       </p:sp>
       <p:pic>
         <p:nvPicPr>
-          <p:cNvPr id="5" name="Image 0" descr="/work/_shared/assets/redhat-logo-white.png">    </p:cNvPr>
+          <p:cNvPr id="5" name="Image 0" descr="/tmp/pcwork/api-patterns-and-practices-graphql/presentation/_shared/assets/redhat-logo-white.png">    </p:cNvPr>
           <p:cNvPicPr>
             <a:picLocks noChangeAspect="1"/>
           </p:cNvPicPr>
@@ -21309,7 +21398,7 @@
       </p:sp>
       <p:pic>
         <p:nvPicPr>
-          <p:cNvPr id="3" name="Image 0" descr="/work/_shared/assets/logo-candidate-2.png">    </p:cNvPr>
+          <p:cNvPr id="3" name="Image 0" descr="/tmp/pcwork/api-patterns-and-practices-graphql/presentation/_shared/assets/logo-candidate-2.png">    </p:cNvPr>
           <p:cNvPicPr>
             <a:picLocks noChangeAspect="1"/>
           </p:cNvPicPr>
@@ -21411,7 +21500,7 @@
       </p:sp>
       <p:pic>
         <p:nvPicPr>
-          <p:cNvPr id="6" name="Image 1" descr="/work/_shared/png/21-three-ways-to-push.png">    </p:cNvPr>
+          <p:cNvPr id="6" name="Image 1" descr="/tmp/pcwork/api-patterns-and-practices-graphql/presentation/_shared/png/21-three-ways-to-push.png">    </p:cNvPr>
           <p:cNvPicPr>
             <a:picLocks noChangeAspect="1"/>
           </p:cNvPicPr>
@@ -21537,7 +21626,7 @@
       </p:sp>
       <p:pic>
         <p:nvPicPr>
-          <p:cNvPr id="3" name="Image 0" descr="/work/_shared/assets/logo-candidate-2.png">    </p:cNvPr>
+          <p:cNvPr id="3" name="Image 0" descr="/tmp/pcwork/api-patterns-and-practices-graphql/presentation/_shared/assets/logo-candidate-2.png">    </p:cNvPr>
           <p:cNvPicPr>
             <a:picLocks noChangeAspect="1"/>
           </p:cNvPicPr>
@@ -21755,7 +21844,7 @@
                 <a:ea typeface="Red Hat Mono" pitchFamily="34" charset="-122"/>
                 <a:cs typeface="Red Hat Mono" pitchFamily="34" charset="-120"/>
               </a:rPr>
-              <a:t>query TrackCargo($id: TrackingId!) {
+              <a:t>
 </a:t>
             </a:r>
             <a:pPr algn="l" indent="0" marL="0">
@@ -21773,7 +21862,7 @@
                 <a:ea typeface="Red Hat Mono" pitchFamily="34" charset="-122"/>
                 <a:cs typeface="Red Hat Mono" pitchFamily="34" charset="-120"/>
               </a:rPr>
-              <a:t>  cargo(trackingId: $id) {
+              <a:t>The services behind the tracking view own the data and the rules. The cargo service decides what a booking is. The routing service decides which itinerary satisfies a route specification. The handling service records what physically happened. The delivery state is derived from those events and the itinerary, and Chapter 7 puts that derivation in the tracking view. Each of them may speak REST or gRPC, exactly as the sibling books describe, and none of them needs to know GraphQL exists. The tracking view owns no business data. It owns a schema, a set of resolvers that know which service to ask for which field, and the logic that stitches the answers into a graph and derives the delivery state.
 </a:t>
             </a:r>
             <a:pPr algn="l" indent="0" marL="0">
@@ -21791,7 +21880,7 @@
                 <a:ea typeface="Red Hat Mono" pitchFamily="34" charset="-122"/>
                 <a:cs typeface="Red Hat Mono" pitchFamily="34" charset="-120"/>
               </a:rPr>
-              <a:t>    trackingId
+              <a:t>
 </a:t>
             </a:r>
             <a:pPr algn="l" indent="0" marL="0">
@@ -21809,7 +21898,7 @@
                 <a:ea typeface="Red Hat Mono" pitchFamily="34" charset="-122"/>
                 <a:cs typeface="Red Hat Mono" pitchFamily="34" charset="-120"/>
               </a:rPr>
-              <a:t>    origin { unLocode name }
+              <a:t>This division keeps the strengths of each paradigm where they belong. Writes go through the owning services with the validation, idempotency and transactional rules those services already enforce. Internal calls keep the speed and typing of gRPC. Clients get one place to ask questions, one schema to learn and one round trip per screen. The schema is the contract between the tracking view and every client, and it lives in the repository as SDL under `contracts/schema/`. Both implementation stacks in this book, Quarkus with SmallRye GraphQL and Python with Strawberry, are checked against that same schema, so the contract does not depend on a language.
 </a:t>
             </a:r>
             <a:pPr algn="l" indent="0" marL="0">
@@ -21827,7 +21916,7 @@
                 <a:ea typeface="Red Hat Mono" pitchFamily="34" charset="-122"/>
                 <a:cs typeface="Red Hat Mono" pitchFamily="34" charset="-120"/>
               </a:rPr>
-              <a:t>    destination { unLocode name }
+              <a:t>
 </a:t>
             </a:r>
             <a:pPr algn="l" indent="0" marL="0">
@@ -21845,7 +21934,7 @@
                 <a:ea typeface="Red Hat Mono" pitchFamily="34" charset="-122"/>
                 <a:cs typeface="Red Hat Mono" pitchFamily="34" charset="-120"/>
               </a:rPr>
-              <a:t>    delivery {
+              <a:t>The read-oriented emphasis is a design choice. The schema does contain one mutation, `registerHandlingEvent`, because recording a handling event is the one write a tracking client legitimately initiates, and Chapter 8 treats mutations in detail. Booking a cargo and assigning its route remain REST and gRPC operations in the owning services. Chapter 2 gives the criteria that put each interaction on its side of that line.
 </a:t>
             </a:r>
             <a:pPr algn="l" indent="0" marL="0">
@@ -21863,7 +21952,7 @@
                 <a:ea typeface="Red Hat Mono" pitchFamily="34" charset="-122"/>
                 <a:cs typeface="Red Hat Mono" pitchFamily="34" charset="-120"/>
               </a:rPr>
-              <a:t>      transportStatus
+              <a:t>
 </a:t>
             </a:r>
             <a:pPr algn="l" indent="0" marL="0">
@@ -21875,13 +21964,13 @@
             <a:r>
               <a:rPr lang="en-US" sz="1000" dirty="0">
                 <a:solidFill>
-                  <a:srgbClr val="E6E6E6"/>
+                  <a:srgbClr val="8FB98F"/>
                 </a:solidFill>
                 <a:latin typeface="Red Hat Mono" pitchFamily="34" charset="0"/>
                 <a:ea typeface="Red Hat Mono" pitchFamily="34" charset="-122"/>
                 <a:cs typeface="Red Hat Mono" pitchFamily="34" charset="-120"/>
               </a:rPr>
-              <a:t>      lastKnownLocation { name }
+              <a:t>## What a query looks like
 </a:t>
             </a:r>
             <a:pPr algn="l" indent="0" marL="0">
@@ -21899,7 +21988,7 @@
                 <a:ea typeface="Red Hat Mono" pitchFamily="34" charset="-122"/>
                 <a:cs typeface="Red Hat Mono" pitchFamily="34" charset="-120"/>
               </a:rPr>
-              <a:t>      estimatedTimeOfArrival
+              <a:t>
 </a:t>
             </a:r>
             <a:pPr algn="l" indent="0" marL="0">
@@ -21917,7 +22006,7 @@
                 <a:ea typeface="Red Hat Mono" pitchFamily="34" charset="-122"/>
                 <a:cs typeface="Red Hat Mono" pitchFamily="34" charset="-120"/>
               </a:rPr>
-              <a:t>  ...
+              <a:t>      ...
 </a:t>
             </a:r>
             <a:pPr algn="l" indent="0" marL="0">
@@ -21935,7 +22024,7 @@
                 <a:ea typeface="Red Hat Mono" pitchFamily="34" charset="-122"/>
                 <a:cs typeface="Red Hat Mono" pitchFamily="34" charset="-120"/>
               </a:rPr>
-              <a:t>  }
+              <a:t>      legs {
 </a:t>
             </a:r>
             <a:pPr algn="l" indent="0" marL="0">
@@ -21953,7 +22042,7 @@
                 <a:ea typeface="Red Hat Mono" pitchFamily="34" charset="-122"/>
                 <a:cs typeface="Red Hat Mono" pitchFamily="34" charset="-120"/>
               </a:rPr>
-              <a:t>}
+              <a:t>        voyage { number }
 </a:t>
             </a:r>
             <a:pPr algn="l" indent="0" marL="0">
@@ -21971,7 +22060,7 @@
                 <a:ea typeface="Red Hat Mono" pitchFamily="34" charset="-122"/>
                 <a:cs typeface="Red Hat Mono" pitchFamily="34" charset="-120"/>
               </a:rPr>
-              <a:t>...
+              <a:t>        ...
 </a:t>
             </a:r>
             <a:pPr algn="l" indent="0" marL="0">
@@ -21989,7 +22078,7 @@
                 <a:ea typeface="Red Hat Mono" pitchFamily="34" charset="-122"/>
                 <a:cs typeface="Red Hat Mono" pitchFamily="34" charset="-120"/>
               </a:rPr>
-              <a:t>{
+              <a:t>        node { type location { unLocode } completionTime }
 </a:t>
             </a:r>
             <a:pPr algn="l" indent="0" marL="0">
@@ -22007,7 +22096,7 @@
                 <a:ea typeface="Red Hat Mono" pitchFamily="34" charset="-122"/>
                 <a:cs typeface="Red Hat Mono" pitchFamily="34" charset="-120"/>
               </a:rPr>
-              <a:t>  "data": {
+              <a:t>      }
 </a:t>
             </a:r>
             <a:pPr algn="l" indent="0" marL="0">
@@ -22025,7 +22114,7 @@
                 <a:ea typeface="Red Hat Mono" pitchFamily="34" charset="-122"/>
                 <a:cs typeface="Red Hat Mono" pitchFamily="34" charset="-120"/>
               </a:rPr>
-              <a:t>    "cargo": {
+              <a:t>    }
 </a:t>
             </a:r>
             <a:pPr algn="l" indent="0" marL="0">
@@ -22043,7 +22132,7 @@
                 <a:ea typeface="Red Hat Mono" pitchFamily="34" charset="-122"/>
                 <a:cs typeface="Red Hat Mono" pitchFamily="34" charset="-120"/>
               </a:rPr>
-              <a:t>      "trackingId": "ABC123",
+              <a:t>  }
 </a:t>
             </a:r>
             <a:pPr algn="l" indent="0" marL="0">
@@ -22061,7 +22150,7 @@
                 <a:ea typeface="Red Hat Mono" pitchFamily="34" charset="-122"/>
                 <a:cs typeface="Red Hat Mono" pitchFamily="34" charset="-120"/>
               </a:rPr>
-              <a:t>      "origin": { "unLocode": "USNYC", "name": "New York" },
+              <a:t>}
 </a:t>
             </a:r>
             <a:pPr algn="l" indent="0" marL="0">
@@ -22079,7 +22168,7 @@
                 <a:ea typeface="Red Hat Mono" pitchFamily="34" charset="-122"/>
                 <a:cs typeface="Red Hat Mono" pitchFamily="34" charset="-120"/>
               </a:rPr>
-              <a:t>      "destination": { "unLocode": "NLRTM", "name": "Rotterdam" },
+              <a:t>```
 </a:t>
             </a:r>
             <a:pPr algn="l" indent="0" marL="0">
@@ -22097,7 +22186,7 @@
                 <a:ea typeface="Red Hat Mono" pitchFamily="34" charset="-122"/>
                 <a:cs typeface="Red Hat Mono" pitchFamily="34" charset="-120"/>
               </a:rPr>
-              <a:t>      "delivery": {
+              <a:t>
 </a:t>
             </a:r>
             <a:pPr algn="l" indent="0" marL="0">
@@ -22115,7 +22204,7 @@
                 <a:ea typeface="Red Hat Mono" pitchFamily="34" charset="-122"/>
                 <a:cs typeface="Red Hat Mono" pitchFamily="34" charset="-120"/>
               </a:rPr>
-              <a:t>        "transportStatus": "ONBOARD_CARRIER",
+              <a:t>The operation takes one variable, `$id`, typed with the schema's `TrackingId` scalar and marked non-null with `!`. The root field `cargo` resolves one `Cargo` by tracking id. Inside it, `origin`, `destination` and `lastKnownLocation` are `Location` objects of which the client asks only for the UN/LOCODE and the name. `itinerary` is nullable in the schema because a cargo that has not been routed has none, and `handlingHistory(first: 2)` uses the Relay connection pattern that Chapter 12 covers: edges that wrap nodes, so the client can page through events newest first.
 </a:t>
             </a:r>
             <a:pPr algn="l" indent="0" marL="0">
@@ -22133,7 +22222,7 @@
                 <a:ea typeface="Red Hat Mono" pitchFamily="34" charset="-122"/>
                 <a:cs typeface="Red Hat Mono" pitchFamily="34" charset="-120"/>
               </a:rPr>
-              <a:t>        "lastKnownLocation": { "name": "New York" },
+              <a:t>
 </a:t>
             </a:r>
             <a:pPr algn="l" indent="0" marL="0">
@@ -22151,7 +22240,7 @@
                 <a:ea typeface="Red Hat Mono" pitchFamily="34" charset="-122"/>
                 <a:cs typeface="Red Hat Mono" pitchFamily="34" charset="-120"/>
               </a:rPr>
-              <a:t>        "estimatedTimeOfArrival": "2026-10-11T18:00:00Z",
+              <a:t>The response mirrors the selection field for field:
 </a:t>
             </a:r>
             <a:pPr algn="l" indent="0" marL="0">
@@ -22281,7 +22370,7 @@
       </p:sp>
       <p:pic>
         <p:nvPicPr>
-          <p:cNvPr id="3" name="Image 0" descr="/work/_shared/assets/logo-candidate-2.png">    </p:cNvPr>
+          <p:cNvPr id="3" name="Image 0" descr="/tmp/pcwork/api-patterns-and-practices-graphql/presentation/_shared/assets/logo-candidate-2.png">    </p:cNvPr>
           <p:cNvPicPr>
             <a:picLocks noChangeAspect="1"/>
           </p:cNvPicPr>
@@ -23305,7 +23394,7 @@
       </p:sp>
       <p:pic>
         <p:nvPicPr>
-          <p:cNvPr id="3" name="Image 0" descr="/work/_shared/assets/logo-candidate-2.png">    </p:cNvPr>
+          <p:cNvPr id="3" name="Image 0" descr="/tmp/pcwork/api-patterns-and-practices-graphql/presentation/_shared/assets/logo-candidate-2.png">    </p:cNvPr>
           <p:cNvPicPr>
             <a:picLocks noChangeAspect="1"/>
           </p:cNvPicPr>
@@ -23407,7 +23496,7 @@
       </p:sp>
       <p:pic>
         <p:nvPicPr>
-          <p:cNvPr id="6" name="Image 1" descr="/work/_shared/png/22-normalized-cache-update.png">    </p:cNvPr>
+          <p:cNvPr id="6" name="Image 1" descr="/tmp/pcwork/api-patterns-and-practices-graphql/presentation/_shared/png/22-normalized-cache-update.png">    </p:cNvPr>
           <p:cNvPicPr>
             <a:picLocks noChangeAspect="1"/>
           </p:cNvPicPr>
@@ -23611,7 +23700,7 @@
       </p:sp>
       <p:pic>
         <p:nvPicPr>
-          <p:cNvPr id="5" name="Image 0" descr="/work/_shared/assets/redhat-logo-white.png">    </p:cNvPr>
+          <p:cNvPr id="5" name="Image 0" descr="/tmp/pcwork/api-patterns-and-practices-graphql/presentation/_shared/assets/redhat-logo-white.png">    </p:cNvPr>
           <p:cNvPicPr>
             <a:picLocks noChangeAspect="1"/>
           </p:cNvPicPr>
@@ -23699,7 +23788,7 @@
       </p:sp>
       <p:pic>
         <p:nvPicPr>
-          <p:cNvPr id="3" name="Image 0" descr="/work/_shared/assets/logo-candidate-2.png">    </p:cNvPr>
+          <p:cNvPr id="3" name="Image 0" descr="/tmp/pcwork/api-patterns-and-practices-graphql/presentation/_shared/assets/logo-candidate-2.png">    </p:cNvPr>
           <p:cNvPicPr>
             <a:picLocks noChangeAspect="1"/>
           </p:cNvPicPr>
@@ -23801,7 +23890,7 @@
       </p:sp>
       <p:pic>
         <p:nvPicPr>
-          <p:cNvPr id="6" name="Image 1" descr="/work/_shared/png/23-test-layers.png">    </p:cNvPr>
+          <p:cNvPr id="6" name="Image 1" descr="/tmp/pcwork/api-patterns-and-practices-graphql/presentation/_shared/png/23-test-layers.png">    </p:cNvPr>
           <p:cNvPicPr>
             <a:picLocks noChangeAspect="1"/>
           </p:cNvPicPr>
@@ -23927,7 +24016,7 @@
       </p:sp>
       <p:pic>
         <p:nvPicPr>
-          <p:cNvPr id="3" name="Image 0" descr="/work/_shared/assets/logo-candidate-2.png">    </p:cNvPr>
+          <p:cNvPr id="3" name="Image 0" descr="/tmp/pcwork/api-patterns-and-practices-graphql/presentation/_shared/assets/logo-candidate-2.png">    </p:cNvPr>
           <p:cNvPicPr>
             <a:picLocks noChangeAspect="1"/>
           </p:cNvPicPr>
@@ -24029,7 +24118,7 @@
       </p:sp>
       <p:pic>
         <p:nvPicPr>
-          <p:cNvPr id="6" name="Image 1" descr="/work/_shared/png/24-diagnosis-path.png">    </p:cNvPr>
+          <p:cNvPr id="6" name="Image 1" descr="/tmp/pcwork/api-patterns-and-practices-graphql/presentation/_shared/png/24-diagnosis-path.png">    </p:cNvPr>
           <p:cNvPicPr>
             <a:picLocks noChangeAspect="1"/>
           </p:cNvPicPr>
@@ -24233,7 +24322,7 @@
       </p:sp>
       <p:pic>
         <p:nvPicPr>
-          <p:cNvPr id="5" name="Image 0" descr="/work/_shared/assets/redhat-logo-white.png">    </p:cNvPr>
+          <p:cNvPr id="5" name="Image 0" descr="/tmp/pcwork/api-patterns-and-practices-graphql/presentation/_shared/assets/redhat-logo-white.png">    </p:cNvPr>
           <p:cNvPicPr>
             <a:picLocks noChangeAspect="1"/>
           </p:cNvPicPr>
@@ -24321,7 +24410,7 @@
       </p:sp>
       <p:pic>
         <p:nvPicPr>
-          <p:cNvPr id="3" name="Image 0" descr="/work/_shared/assets/logo-candidate-2.png">    </p:cNvPr>
+          <p:cNvPr id="3" name="Image 0" descr="/tmp/pcwork/api-patterns-and-practices-graphql/presentation/_shared/assets/logo-candidate-2.png">    </p:cNvPr>
           <p:cNvPicPr>
             <a:picLocks noChangeAspect="1"/>
           </p:cNvPicPr>
@@ -24423,7 +24512,7 @@
       </p:sp>
       <p:pic>
         <p:nvPicPr>
-          <p:cNvPr id="6" name="Image 1" descr="/work/_shared/png/26-compose-to-kubernetes.png">    </p:cNvPr>
+          <p:cNvPr id="6" name="Image 1" descr="/tmp/pcwork/api-patterns-and-practices-graphql/presentation/_shared/png/26-compose-to-kubernetes.png">    </p:cNvPr>
           <p:cNvPicPr>
             <a:picLocks noChangeAspect="1"/>
           </p:cNvPicPr>
@@ -24549,7 +24638,7 @@
       </p:sp>
       <p:pic>
         <p:nvPicPr>
-          <p:cNvPr id="3" name="Image 0" descr="/work/_shared/assets/logo-candidate-2.png">    </p:cNvPr>
+          <p:cNvPr id="3" name="Image 0" descr="/tmp/pcwork/api-patterns-and-practices-graphql/presentation/_shared/assets/logo-candidate-2.png">    </p:cNvPr>
           <p:cNvPicPr>
             <a:picLocks noChangeAspect="1"/>
           </p:cNvPicPr>
@@ -24651,7 +24740,7 @@
       </p:sp>
       <p:pic>
         <p:nvPicPr>
-          <p:cNvPr id="6" name="Image 1" descr="/work/_shared/png/27-final-architecture.png">    </p:cNvPr>
+          <p:cNvPr id="6" name="Image 1" descr="/tmp/pcwork/api-patterns-and-practices-graphql/presentation/_shared/png/27-final-architecture.png">    </p:cNvPr>
           <p:cNvPicPr>
             <a:picLocks noChangeAspect="1"/>
           </p:cNvPicPr>
@@ -24777,7 +24866,7 @@
       </p:sp>
       <p:pic>
         <p:nvPicPr>
-          <p:cNvPr id="3" name="Image 0" descr="/work/_shared/assets/logo-candidate-2.png">    </p:cNvPr>
+          <p:cNvPr id="3" name="Image 0" descr="/tmp/pcwork/api-patterns-and-practices-graphql/presentation/_shared/assets/logo-candidate-2.png">    </p:cNvPr>
           <p:cNvPicPr>
             <a:picLocks noChangeAspect="1"/>
           </p:cNvPicPr>
@@ -24879,7 +24968,7 @@
       </p:sp>
       <p:pic>
         <p:nvPicPr>
-          <p:cNvPr id="6" name="Image 1" descr="/work/_shared/png/27-request-defences.png">    </p:cNvPr>
+          <p:cNvPr id="6" name="Image 1" descr="/tmp/pcwork/api-patterns-and-practices-graphql/presentation/_shared/png/27-request-defences.png">    </p:cNvPr>
           <p:cNvPicPr>
             <a:picLocks noChangeAspect="1"/>
           </p:cNvPicPr>
@@ -25005,7 +25094,7 @@
       </p:sp>
       <p:pic>
         <p:nvPicPr>
-          <p:cNvPr id="3" name="Image 0" descr="/work/_shared/assets/logo-candidate-2.png">    </p:cNvPr>
+          <p:cNvPr id="3" name="Image 0" descr="/tmp/pcwork/api-patterns-and-practices-graphql/presentation/_shared/assets/logo-candidate-2.png">    </p:cNvPr>
           <p:cNvPicPr>
             <a:picLocks noChangeAspect="1"/>
           </p:cNvPicPr>
@@ -26620,7 +26709,7 @@
       </p:sp>
       <p:pic>
         <p:nvPicPr>
-          <p:cNvPr id="3" name="Image 0" descr="/work/_shared/assets/logo-candidate-2.png">    </p:cNvPr>
+          <p:cNvPr id="3" name="Image 0" descr="/tmp/pcwork/api-patterns-and-practices-graphql/presentation/_shared/assets/logo-candidate-2.png">    </p:cNvPr>
           <p:cNvPicPr>
             <a:picLocks noChangeAspect="1"/>
           </p:cNvPicPr>
@@ -28510,7 +28599,7 @@
       </p:sp>
       <p:pic>
         <p:nvPicPr>
-          <p:cNvPr id="5" name="Image 0" descr="/work/_shared/assets/redhat-logo-white.png">    </p:cNvPr>
+          <p:cNvPr id="5" name="Image 0" descr="/tmp/pcwork/api-patterns-and-practices-graphql/presentation/_shared/assets/redhat-logo-white.png">    </p:cNvPr>
           <p:cNvPicPr>
             <a:picLocks noChangeAspect="1"/>
           </p:cNvPicPr>
@@ -28598,7 +28687,7 @@
       </p:sp>
       <p:pic>
         <p:nvPicPr>
-          <p:cNvPr id="3" name="Image 0" descr="/work/_shared/assets/logo-candidate-2.png">    </p:cNvPr>
+          <p:cNvPr id="3" name="Image 0" descr="/tmp/pcwork/api-patterns-and-practices-graphql/presentation/_shared/assets/logo-candidate-2.png">    </p:cNvPr>
           <p:cNvPicPr>
             <a:picLocks noChangeAspect="1"/>
           </p:cNvPicPr>
@@ -29288,7 +29377,7 @@
       </p:sp>
       <p:pic>
         <p:nvPicPr>
-          <p:cNvPr id="3" name="Image 0" descr="/work/_shared/assets/logo-candidate-2.png">    </p:cNvPr>
+          <p:cNvPr id="3" name="Image 0" descr="/tmp/pcwork/api-patterns-and-practices-graphql/presentation/_shared/assets/logo-candidate-2.png">    </p:cNvPr>
           <p:cNvPicPr>
             <a:picLocks noChangeAspect="1"/>
           </p:cNvPicPr>
@@ -29978,7 +30067,7 @@
       </p:sp>
       <p:pic>
         <p:nvPicPr>
-          <p:cNvPr id="3" name="Image 0" descr="/work/_shared/assets/logo-candidate-2.png">    </p:cNvPr>
+          <p:cNvPr id="3" name="Image 0" descr="/tmp/pcwork/api-patterns-and-practices-graphql/presentation/_shared/assets/logo-candidate-2.png">    </p:cNvPr>
           <p:cNvPicPr>
             <a:picLocks noChangeAspect="1"/>
           </p:cNvPicPr>
@@ -30704,7 +30793,7 @@
       </p:sp>
       <p:pic>
         <p:nvPicPr>
-          <p:cNvPr id="3" name="Image 0" descr="/work/_shared/assets/logo-candidate-2.png">    </p:cNvPr>
+          <p:cNvPr id="3" name="Image 0" descr="/tmp/pcwork/api-patterns-and-practices-graphql/presentation/_shared/assets/logo-candidate-2.png">    </p:cNvPr>
           <p:cNvPicPr>
             <a:picLocks noChangeAspect="1"/>
           </p:cNvPicPr>
@@ -31304,7 +31393,7 @@
       </p:sp>
       <p:pic>
         <p:nvPicPr>
-          <p:cNvPr id="3" name="Image 0" descr="/work/_shared/assets/logo-candidate-2.png">    </p:cNvPr>
+          <p:cNvPr id="3" name="Image 0" descr="/tmp/pcwork/api-patterns-and-practices-graphql/presentation/_shared/assets/logo-candidate-2.png">    </p:cNvPr>
           <p:cNvPicPr>
             <a:picLocks noChangeAspect="1"/>
           </p:cNvPicPr>
@@ -32919,7 +33008,7 @@
       </p:sp>
       <p:pic>
         <p:nvPicPr>
-          <p:cNvPr id="3" name="Image 0" descr="/work/_shared/assets/logo-candidate-2.png">    </p:cNvPr>
+          <p:cNvPr id="3" name="Image 0" descr="/tmp/pcwork/api-patterns-and-practices-graphql/presentation/_shared/assets/logo-candidate-2.png">    </p:cNvPr>
           <p:cNvPicPr>
             <a:picLocks noChangeAspect="1"/>
           </p:cNvPicPr>
@@ -33693,7 +33782,7 @@
       </p:sp>
       <p:pic>
         <p:nvPicPr>
-          <p:cNvPr id="3" name="Image 0" descr="/work/_shared/assets/logo-candidate-2.png">    </p:cNvPr>
+          <p:cNvPr id="3" name="Image 0" descr="/tmp/pcwork/api-patterns-and-practices-graphql/presentation/_shared/assets/logo-candidate-2.png">    </p:cNvPr>
           <p:cNvPicPr>
             <a:picLocks noChangeAspect="1"/>
           </p:cNvPicPr>
@@ -34064,7 +34153,7 @@
       </p:sp>
       <p:pic>
         <p:nvPicPr>
-          <p:cNvPr id="3" name="Image 0" descr="/work/_shared/assets/logo-candidate-2.png">    </p:cNvPr>
+          <p:cNvPr id="3" name="Image 0" descr="/tmp/pcwork/api-patterns-and-practices-graphql/presentation/_shared/assets/logo-candidate-2.png">    </p:cNvPr>
           <p:cNvPicPr>
             <a:picLocks noChangeAspect="1"/>
           </p:cNvPicPr>
@@ -34270,6 +34359,454 @@
               <a:t>Red Hat is the world's leading provider of enterprise open source software solutions.</a:t>
             </a:r>
             <a:endParaRPr lang="en-US" sz="1300" dirty="0"/>
+          </a:p>
+        </p:txBody>
+      </p:sp>
+    </p:spTree>
+  </p:cSld>
+  <p:clrMapOvr>
+    <a:masterClrMapping/>
+  </p:clrMapOvr>
+</p:sld>
+</file>
+
+<file path=ppt/slides/slide79.xml><?xml version="1.0" encoding="utf-8"?>
+<p:sld xmlns:a="http://schemas.openxmlformats.org/drawingml/2006/main" xmlns:r="http://schemas.openxmlformats.org/officeDocument/2006/relationships" xmlns:p="http://schemas.openxmlformats.org/presentationml/2006/main">
+  <p:cSld name="Slide 79">
+    <p:spTree>
+      <p:nvGrpSpPr>
+        <p:cNvPr id="1" name=""/>
+        <p:cNvGrpSpPr/>
+        <p:nvPr/>
+      </p:nvGrpSpPr>
+      <p:grpSpPr>
+        <a:xfrm>
+          <a:off x="0" y="0"/>
+          <a:ext cx="0" cy="0"/>
+          <a:chOff x="0" y="0"/>
+          <a:chExt cx="0" cy="0"/>
+        </a:xfrm>
+      </p:grpSpPr>
+      <p:sp>
+        <p:nvSpPr>
+          <p:cNvPr id="2" name="Text 0"/>
+          <p:cNvSpPr/>
+          <p:nvPr/>
+        </p:nvSpPr>
+        <p:spPr>
+          <a:xfrm>
+            <a:off x="566928" y="6364224"/>
+            <a:ext cx="914400" cy="274320"/>
+          </a:xfrm>
+          <a:prstGeom prst="rect">
+            <a:avLst/>
+          </a:prstGeom>
+          <a:noFill/>
+          <a:ln/>
+        </p:spPr>
+        <p:txBody>
+          <a:bodyPr wrap="square" rtlCol="0" anchor="ctr"/>
+          <a:lstStyle/>
+          <a:p>
+            <a:pPr algn="l" indent="0" marL="0">
+              <a:buNone/>
+            </a:pPr>
+            <a:r>
+              <a:rPr lang="en-US" sz="1000" dirty="0">
+                <a:solidFill>
+                  <a:srgbClr val="8A8A8A"/>
+                </a:solidFill>
+                <a:latin typeface="Red Hat Text" pitchFamily="34" charset="0"/>
+                <a:ea typeface="Red Hat Text" pitchFamily="34" charset="-122"/>
+                <a:cs typeface="Red Hat Text" pitchFamily="34" charset="-120"/>
+              </a:rPr>
+              <a:t>79</a:t>
+            </a:r>
+            <a:endParaRPr lang="en-US" sz="1000" dirty="0"/>
+          </a:p>
+        </p:txBody>
+      </p:sp>
+      <p:pic>
+        <p:nvPicPr>
+          <p:cNvPr id="3" name="Image 0" descr="/tmp/pcwork/api-patterns-and-practices-graphql/presentation/_shared/assets/logo-candidate-2.png">    </p:cNvPr>
+          <p:cNvPicPr>
+            <a:picLocks noChangeAspect="1"/>
+          </p:cNvPicPr>
+          <p:nvPr/>
+        </p:nvPicPr>
+        <p:blipFill>
+          <a:blip r:embed="rId1"/>
+          <a:stretch>
+            <a:fillRect/>
+          </a:stretch>
+        </p:blipFill>
+        <p:spPr>
+          <a:xfrm>
+            <a:off x="10561320" y="6355080"/>
+            <a:ext cx="1033272" cy="246888"/>
+          </a:xfrm>
+          <a:prstGeom prst="rect">
+            <a:avLst/>
+          </a:prstGeom>
+        </p:spPr>
+      </p:pic>
+      <p:sp>
+        <p:nvSpPr>
+          <p:cNvPr id="4" name="Text 1"/>
+          <p:cNvSpPr/>
+          <p:nvPr/>
+        </p:nvSpPr>
+        <p:spPr>
+          <a:xfrm>
+            <a:off x="566928" y="384048"/>
+            <a:ext cx="11055096" cy="292608"/>
+          </a:xfrm>
+          <a:prstGeom prst="rect">
+            <a:avLst/>
+          </a:prstGeom>
+          <a:noFill/>
+          <a:ln/>
+        </p:spPr>
+        <p:txBody>
+          <a:bodyPr wrap="square" rtlCol="0" anchor="ctr"/>
+          <a:lstStyle/>
+          <a:p>
+            <a:pPr algn="l" indent="0" marL="0">
+              <a:buNone/>
+            </a:pPr>
+            <a:r>
+              <a:rPr lang="en-US" sz="1200" b="1" spc="400" kern="0" dirty="0">
+                <a:solidFill>
+                  <a:srgbClr val="EE0000"/>
+                </a:solidFill>
+                <a:latin typeface="Red Hat Display" pitchFamily="34" charset="0"/>
+                <a:ea typeface="Red Hat Display" pitchFamily="34" charset="-122"/>
+                <a:cs typeface="Red Hat Display" pitchFamily="34" charset="-120"/>
+              </a:rPr>
+              <a:t>SCAN TO EXPLORE</a:t>
+            </a:r>
+            <a:endParaRPr lang="en-US" sz="1200" dirty="0"/>
+          </a:p>
+        </p:txBody>
+      </p:sp>
+      <p:sp>
+        <p:nvSpPr>
+          <p:cNvPr id="5" name="Text 2"/>
+          <p:cNvSpPr/>
+          <p:nvPr/>
+        </p:nvSpPr>
+        <p:spPr>
+          <a:xfrm>
+            <a:off x="566928" y="676656"/>
+            <a:ext cx="11055096" cy="1005840"/>
+          </a:xfrm>
+          <a:prstGeom prst="rect">
+            <a:avLst/>
+          </a:prstGeom>
+          <a:noFill/>
+          <a:ln/>
+        </p:spPr>
+        <p:txBody>
+          <a:bodyPr wrap="square" rtlCol="0" anchor="t"/>
+          <a:lstStyle/>
+          <a:p>
+            <a:pPr algn="l" indent="0" marL="0">
+              <a:buNone/>
+            </a:pPr>
+            <a:r>
+              <a:rPr lang="en-US" sz="3000" b="1" dirty="0">
+                <a:solidFill>
+                  <a:srgbClr val="151515"/>
+                </a:solidFill>
+                <a:latin typeface="Red Hat Display" pitchFamily="34" charset="0"/>
+                <a:ea typeface="Red Hat Display" pitchFamily="34" charset="-122"/>
+                <a:cs typeface="Red Hat Display" pitchFamily="34" charset="-120"/>
+              </a:rPr>
+              <a:t>Take it with you</a:t>
+            </a:r>
+            <a:endParaRPr lang="en-US" sz="3000" dirty="0"/>
+          </a:p>
+        </p:txBody>
+      </p:sp>
+      <p:pic>
+        <p:nvPicPr>
+          <p:cNvPr id="6" name="Image 1" descr="/tmp/pcwork/api-patterns-and-practices-graphql/presentation/_shared/assets/qr-graphql-site.png">    </p:cNvPr>
+          <p:cNvPicPr>
+            <a:picLocks noChangeAspect="1"/>
+          </p:cNvPicPr>
+          <p:nvPr/>
+        </p:nvPicPr>
+        <p:blipFill>
+          <a:blip r:embed="rId2"/>
+          <a:stretch>
+            <a:fillRect/>
+          </a:stretch>
+        </p:blipFill>
+        <p:spPr>
+          <a:xfrm>
+            <a:off x="2103120" y="1627632"/>
+            <a:ext cx="2834640" cy="2834640"/>
+          </a:xfrm>
+          <a:prstGeom prst="rect">
+            <a:avLst/>
+          </a:prstGeom>
+        </p:spPr>
+      </p:pic>
+      <p:sp>
+        <p:nvSpPr>
+          <p:cNvPr id="7" name="Text 3"/>
+          <p:cNvSpPr/>
+          <p:nvPr/>
+        </p:nvSpPr>
+        <p:spPr>
+          <a:xfrm>
+            <a:off x="1417320" y="4553712"/>
+            <a:ext cx="4206240" cy="365760"/>
+          </a:xfrm>
+          <a:prstGeom prst="rect">
+            <a:avLst/>
+          </a:prstGeom>
+          <a:noFill/>
+          <a:ln/>
+        </p:spPr>
+        <p:txBody>
+          <a:bodyPr wrap="square" rtlCol="0" anchor="ctr"/>
+          <a:lstStyle/>
+          <a:p>
+            <a:pPr algn="ctr" indent="0" marL="0">
+              <a:buNone/>
+            </a:pPr>
+            <a:r>
+              <a:rPr lang="en-US" sz="1800" b="1" dirty="0">
+                <a:solidFill>
+                  <a:srgbClr val="151515"/>
+                </a:solidFill>
+                <a:latin typeface="Red Hat Display" pitchFamily="34" charset="0"/>
+                <a:ea typeface="Red Hat Display" pitchFamily="34" charset="-122"/>
+                <a:cs typeface="Red Hat Display" pitchFamily="34" charset="-120"/>
+              </a:rPr>
+              <a:t>The site</a:t>
+            </a:r>
+            <a:endParaRPr lang="en-US" sz="1800" dirty="0"/>
+          </a:p>
+        </p:txBody>
+      </p:sp>
+      <p:sp>
+        <p:nvSpPr>
+          <p:cNvPr id="8" name="Text 4"/>
+          <p:cNvSpPr/>
+          <p:nvPr/>
+        </p:nvSpPr>
+        <p:spPr>
+          <a:xfrm>
+            <a:off x="1325880" y="4937760"/>
+            <a:ext cx="4389120" cy="658368"/>
+          </a:xfrm>
+          <a:prstGeom prst="rect">
+            <a:avLst/>
+          </a:prstGeom>
+          <a:noFill/>
+          <a:ln/>
+        </p:spPr>
+        <p:txBody>
+          <a:bodyPr wrap="square" rtlCol="0" anchor="t"/>
+          <a:lstStyle/>
+          <a:p>
+            <a:pPr algn="ctr" indent="0" marL="0">
+              <a:buNone/>
+            </a:pPr>
+            <a:r>
+              <a:rPr lang="en-US" sz="1300" i="1" dirty="0">
+                <a:solidFill>
+                  <a:srgbClr val="5A5A5A"/>
+                </a:solidFill>
+                <a:latin typeface="Red Hat Text" pitchFamily="34" charset="0"/>
+                <a:ea typeface="Red Hat Text" pitchFamily="34" charset="-122"/>
+                <a:cs typeface="Red Hat Text" pitchFamily="34" charset="-120"/>
+              </a:rPr>
+              <a:t>Chapters, the GraphQL schema and contracts, and both-stack runnable examples</a:t>
+            </a:r>
+            <a:endParaRPr lang="en-US" sz="1300" dirty="0"/>
+          </a:p>
+        </p:txBody>
+      </p:sp>
+      <p:sp>
+        <p:nvSpPr>
+          <p:cNvPr id="9" name="Text 5"/>
+          <p:cNvSpPr/>
+          <p:nvPr/>
+        </p:nvSpPr>
+        <p:spPr>
+          <a:xfrm>
+            <a:off x="1325880" y="5596128"/>
+            <a:ext cx="4389120" cy="292608"/>
+          </a:xfrm>
+          <a:prstGeom prst="rect">
+            <a:avLst/>
+          </a:prstGeom>
+          <a:noFill/>
+          <a:ln/>
+        </p:spPr>
+        <p:txBody>
+          <a:bodyPr wrap="square" rtlCol="0" anchor="ctr"/>
+          <a:lstStyle/>
+          <a:p>
+            <a:pPr algn="ctr" indent="0" marL="0">
+              <a:buNone/>
+            </a:pPr>
+            <a:r>
+              <a:rPr lang="en-US" sz="1000" dirty="0">
+                <a:solidFill>
+                  <a:srgbClr val="EE0000"/>
+                </a:solidFill>
+                <a:latin typeface="Red Hat Mono" pitchFamily="34" charset="0"/>
+                <a:ea typeface="Red Hat Mono" pitchFamily="34" charset="-122"/>
+                <a:cs typeface="Red Hat Mono" pitchFamily="34" charset="-120"/>
+              </a:rPr>
+              <a:t>patterncatalyst.github.io/api-patterns-and-practices-graphql</a:t>
+            </a:r>
+            <a:endParaRPr lang="en-US" sz="1000" dirty="0"/>
+          </a:p>
+        </p:txBody>
+      </p:sp>
+      <p:pic>
+        <p:nvPicPr>
+          <p:cNvPr id="10" name="Image 2" descr="/tmp/pcwork/api-patterns-and-practices-graphql/presentation/_shared/assets/qr-hub.png">    </p:cNvPr>
+          <p:cNvPicPr>
+            <a:picLocks noChangeAspect="1"/>
+          </p:cNvPicPr>
+          <p:nvPr/>
+        </p:nvPicPr>
+        <p:blipFill>
+          <a:blip r:embed="rId3"/>
+          <a:stretch>
+            <a:fillRect/>
+          </a:stretch>
+        </p:blipFill>
+        <p:spPr>
+          <a:xfrm>
+            <a:off x="7251192" y="1627632"/>
+            <a:ext cx="2834640" cy="2834640"/>
+          </a:xfrm>
+          <a:prstGeom prst="rect">
+            <a:avLst/>
+          </a:prstGeom>
+        </p:spPr>
+      </p:pic>
+      <p:sp>
+        <p:nvSpPr>
+          <p:cNvPr id="11" name="Text 6"/>
+          <p:cNvSpPr/>
+          <p:nvPr/>
+        </p:nvSpPr>
+        <p:spPr>
+          <a:xfrm>
+            <a:off x="6565392" y="4553712"/>
+            <a:ext cx="4206240" cy="365760"/>
+          </a:xfrm>
+          <a:prstGeom prst="rect">
+            <a:avLst/>
+          </a:prstGeom>
+          <a:noFill/>
+          <a:ln/>
+        </p:spPr>
+        <p:txBody>
+          <a:bodyPr wrap="square" rtlCol="0" anchor="ctr"/>
+          <a:lstStyle/>
+          <a:p>
+            <a:pPr algn="ctr" indent="0" marL="0">
+              <a:buNone/>
+            </a:pPr>
+            <a:r>
+              <a:rPr lang="en-US" sz="1800" b="1" dirty="0">
+                <a:solidFill>
+                  <a:srgbClr val="151515"/>
+                </a:solidFill>
+                <a:latin typeface="Red Hat Display" pitchFamily="34" charset="0"/>
+                <a:ea typeface="Red Hat Display" pitchFamily="34" charset="-122"/>
+                <a:cs typeface="Red Hat Display" pitchFamily="34" charset="-120"/>
+              </a:rPr>
+              <a:t>Workshops &amp; Tutorials</a:t>
+            </a:r>
+            <a:endParaRPr lang="en-US" sz="1800" dirty="0"/>
+          </a:p>
+        </p:txBody>
+      </p:sp>
+      <p:sp>
+        <p:nvSpPr>
+          <p:cNvPr id="12" name="Text 7"/>
+          <p:cNvSpPr/>
+          <p:nvPr/>
+        </p:nvSpPr>
+        <p:spPr>
+          <a:xfrm>
+            <a:off x="6473952" y="4937760"/>
+            <a:ext cx="4389120" cy="658368"/>
+          </a:xfrm>
+          <a:prstGeom prst="rect">
+            <a:avLst/>
+          </a:prstGeom>
+          <a:noFill/>
+          <a:ln/>
+        </p:spPr>
+        <p:txBody>
+          <a:bodyPr wrap="square" rtlCol="0" anchor="t"/>
+          <a:lstStyle/>
+          <a:p>
+            <a:pPr algn="ctr" indent="0" marL="0">
+              <a:buNone/>
+            </a:pPr>
+            <a:r>
+              <a:rPr lang="en-US" sz="1300" i="1" dirty="0">
+                <a:solidFill>
+                  <a:srgbClr val="5A5A5A"/>
+                </a:solidFill>
+                <a:latin typeface="Red Hat Text" pitchFamily="34" charset="0"/>
+                <a:ea typeface="Red Hat Text" pitchFamily="34" charset="-122"/>
+                <a:cs typeface="Red Hat Text" pitchFamily="34" charset="-120"/>
+              </a:rPr>
+              <a:t>The whole series: every workshop, tutorial, and deck in one place</a:t>
+            </a:r>
+            <a:endParaRPr lang="en-US" sz="1300" dirty="0"/>
+          </a:p>
+        </p:txBody>
+      </p:sp>
+      <p:sp>
+        <p:nvSpPr>
+          <p:cNvPr id="13" name="Text 8"/>
+          <p:cNvSpPr/>
+          <p:nvPr/>
+        </p:nvSpPr>
+        <p:spPr>
+          <a:xfrm>
+            <a:off x="6473952" y="5596128"/>
+            <a:ext cx="4389120" cy="292608"/>
+          </a:xfrm>
+          <a:prstGeom prst="rect">
+            <a:avLst/>
+          </a:prstGeom>
+          <a:noFill/>
+          <a:ln/>
+        </p:spPr>
+        <p:txBody>
+          <a:bodyPr wrap="square" rtlCol="0" anchor="ctr"/>
+          <a:lstStyle/>
+          <a:p>
+            <a:pPr algn="ctr" indent="0" marL="0">
+              <a:buNone/>
+            </a:pPr>
+            <a:r>
+              <a:rPr lang="en-US" sz="900" dirty="0">
+                <a:solidFill>
+                  <a:srgbClr val="EE0000"/>
+                </a:solidFill>
+                <a:latin typeface="Red Hat Mono" pitchFamily="34" charset="0"/>
+                <a:ea typeface="Red Hat Mono" pitchFamily="34" charset="-122"/>
+                <a:cs typeface="Red Hat Mono" pitchFamily="34" charset="-120"/>
+              </a:rPr>
+              <a:t>patterncatalyst.github.io/patterncatalyst-workshops-tutorials-list</a:t>
+            </a:r>
+            <a:endParaRPr lang="en-US" sz="900" dirty="0"/>
           </a:p>
         </p:txBody>
       </p:sp>
@@ -34339,7 +34876,7 @@
       </p:sp>
       <p:pic>
         <p:nvPicPr>
-          <p:cNvPr id="3" name="Image 0" descr="/work/_shared/assets/logo-candidate-2.png">    </p:cNvPr>
+          <p:cNvPr id="3" name="Image 0" descr="/tmp/pcwork/api-patterns-and-practices-graphql/presentation/_shared/assets/logo-candidate-2.png">    </p:cNvPr>
           <p:cNvPicPr>
             <a:picLocks noChangeAspect="1"/>
           </p:cNvPicPr>
@@ -34441,7 +34978,7 @@
       </p:sp>
       <p:pic>
         <p:nvPicPr>
-          <p:cNvPr id="6" name="Image 1" descr="/work/_shared/png/02-decision-framework.png">    </p:cNvPr>
+          <p:cNvPr id="6" name="Image 1" descr="/tmp/pcwork/api-patterns-and-practices-graphql/presentation/_shared/png/02-decision-framework.png">    </p:cNvPr>
           <p:cNvPicPr>
             <a:picLocks noChangeAspect="1"/>
           </p:cNvPicPr>
@@ -34567,7 +35104,7 @@
       </p:sp>
       <p:pic>
         <p:nvPicPr>
-          <p:cNvPr id="3" name="Image 0" descr="/work/_shared/assets/logo-candidate-2.png">    </p:cNvPr>
+          <p:cNvPr id="3" name="Image 0" descr="/tmp/pcwork/api-patterns-and-practices-graphql/presentation/_shared/assets/logo-candidate-2.png">    </p:cNvPr>
           <p:cNvPicPr>
             <a:picLocks noChangeAspect="1"/>
           </p:cNvPicPr>
@@ -34669,7 +35206,7 @@
       </p:sp>
       <p:pic>
         <p:nvPicPr>
-          <p:cNvPr id="6" name="Image 1" descr="/work/_shared/png/02-tracking-view-topology.png">    </p:cNvPr>
+          <p:cNvPr id="6" name="Image 1" descr="/tmp/pcwork/api-patterns-and-practices-graphql/presentation/_shared/png/02-tracking-view-topology.png">    </p:cNvPr>
           <p:cNvPicPr>
             <a:picLocks noChangeAspect="1"/>
           </p:cNvPicPr>

</xml_diff>

<commit_message>
feat(presentation): add "Take it with you" scan-to-explore QR slide to GraphQL decks (#6)
Mirrors the slide already shipped in the REST decks: left QR -> the GraphQL
site, right QR -> the Workshops & Tutorials hub. Added to deck.js source for
all three decks (100, python, quarkus) and rebuilt the pptx. New QR assets
qr-graphql-site.png and qr-hub.png added to _shared/assets.
</commit_message>
<xml_diff>
--- a/presentation/api-patterns-graphql-100/api-patterns-graphql-100.pptx
+++ b/presentation/api-patterns-graphql-100/api-patterns-graphql-100.pptx
@@ -83,9 +83,10 @@
     <p:sldId id="331" r:id="rId77"/>
     <p:sldId id="332" r:id="rId78"/>
     <p:sldId id="333" r:id="rId79"/>
+    <p:sldId id="334" r:id="rId80"/>
   </p:sldIdLst>
   <p:notesMasterIdLst>
-    <p:notesMasterId r:id="rId80"/>
+    <p:notesMasterId r:id="rId81"/>
   </p:notesMasterIdLst>
   <p:sldSz cx="12192000" cy="6858000"/>
   <p:notesSz cx="6858000" cy="12192000"/>
@@ -7203,6 +7204,94 @@
             <a:fld id="{F7021451-1387-4CA6-816F-3879F97B5CBC}" type="slidenum">
               <a:rPr lang="en-US"/>
               <a:t>78</a:t>
+            </a:fld>
+            <a:endParaRPr lang="en-US"/>
+          </a:p>
+        </p:txBody>
+      </p:sp>
+    </p:spTree>
+    <p:extLst>
+      <p:ext uri="{BB962C8B-B14F-4D97-AF65-F5344CB8AC3E}">
+        <p14:creationId xmlns:p14="http://schemas.microsoft.com/office/powerpoint/2010/main" val="1024086991"/>
+      </p:ext>
+    </p:extLst>
+  </p:cSld>
+  <p:clrMapOvr>
+    <a:masterClrMapping/>
+  </p:clrMapOvr>
+</p:notes>
+</file>
+
+<file path=ppt/notesSlides/notesSlide79.xml><?xml version="1.0" encoding="utf-8"?>
+<p:notes xmlns:a="http://schemas.openxmlformats.org/drawingml/2006/main" xmlns:r="http://schemas.openxmlformats.org/officeDocument/2006/relationships" xmlns:p="http://schemas.openxmlformats.org/presentationml/2006/main">
+  <p:cSld>
+    <p:spTree>
+      <p:nvGrpSpPr>
+        <p:cNvPr id="1" name=""/>
+        <p:cNvGrpSpPr/>
+        <p:nvPr/>
+      </p:nvGrpSpPr>
+      <p:grpSpPr>
+        <a:xfrm>
+          <a:off x="0" y="0"/>
+          <a:ext cx="0" cy="0"/>
+          <a:chOff x="0" y="0"/>
+          <a:chExt cx="0" cy="0"/>
+        </a:xfrm>
+      </p:grpSpPr>
+      <p:sp>
+        <p:nvSpPr>
+          <p:cNvPr id="2" name="Slide Image Placeholder 1"/>
+          <p:cNvSpPr>
+            <a:spLocks noGrp="1" noRot="1" noChangeAspect="1"/>
+          </p:cNvSpPr>
+          <p:nvPr>
+            <p:ph type="sldImg"/>
+          </p:nvPr>
+        </p:nvSpPr>
+        <p:spPr/>
+      </p:sp>
+      <p:sp>
+        <p:nvSpPr>
+          <p:cNvPr id="3" name="Notes Placeholder 2"/>
+          <p:cNvSpPr>
+            <a:spLocks noGrp="1"/>
+          </p:cNvSpPr>
+          <p:nvPr>
+            <p:ph type="body" idx="1"/>
+          </p:nvPr>
+        </p:nvSpPr>
+        <p:spPr/>
+        <p:txBody>
+          <a:bodyPr/>
+          <a:lstStyle/>
+          <a:p>
+            <a:r>
+              <a:rPr lang="en-US" dirty="0"/>
+              <a:t>This is the 100-level concepts deck, so the two codes point where the ideas live and where the whole series lives. On the left, the site: the chapters, the GraphQL schema and contracts, and the runnable both-stack examples, all public. On the right, the Workshops and Tutorials hub: every workshop, tutorial, and deck in the series in one place, including the REST, gRPC, and WebSockets siblings. Scan whichever is useful; both are on the Pattern Catalyst GitHub organization.</a:t>
+            </a:r>
+            <a:endParaRPr lang="en-US" dirty="0"/>
+          </a:p>
+        </p:txBody>
+      </p:sp>
+      <p:sp>
+        <p:nvSpPr>
+          <p:cNvPr id="4" name="Slide Number Placeholder 3"/>
+          <p:cNvSpPr>
+            <a:spLocks noGrp="1"/>
+          </p:cNvSpPr>
+          <p:nvPr>
+            <p:ph type="sldNum" sz="quarter" idx="10"/>
+          </p:nvPr>
+        </p:nvSpPr>
+        <p:spPr/>
+        <p:txBody>
+          <a:bodyPr/>
+          <a:lstStyle/>
+          <a:p>
+            <a:fld id="{F7021451-1387-4CA6-816F-3879F97B5CBC}" type="slidenum">
+              <a:rPr lang="en-US"/>
+              <a:t>79</a:t>
             </a:fld>
             <a:endParaRPr lang="en-US"/>
           </a:p>
@@ -7770,7 +7859,7 @@
       </p:grpSpPr>
       <p:pic>
         <p:nvPicPr>
-          <p:cNvPr id="2" name="Image 0" descr="/work/_shared/assets/cover-panel.png">    </p:cNvPr>
+          <p:cNvPr id="2" name="Image 0" descr="/tmp/pcwork/api-patterns-and-practices-graphql/presentation/_shared/assets/cover-panel.png">    </p:cNvPr>
           <p:cNvPicPr>
             <a:picLocks noChangeAspect="1"/>
           </p:cNvPicPr>
@@ -7984,7 +8073,7 @@
       </p:sp>
       <p:pic>
         <p:nvPicPr>
-          <p:cNvPr id="7" name="Image 1" descr="/work/_shared/assets/logo-candidate-2.png">    </p:cNvPr>
+          <p:cNvPr id="7" name="Image 1" descr="/tmp/pcwork/api-patterns-and-practices-graphql/presentation/_shared/assets/logo-candidate-2.png">    </p:cNvPr>
           <p:cNvPicPr>
             <a:picLocks noChangeAspect="1"/>
           </p:cNvPicPr>
@@ -8150,7 +8239,7 @@
       </p:sp>
       <p:pic>
         <p:nvPicPr>
-          <p:cNvPr id="5" name="Image 0" descr="/work/_shared/assets/redhat-logo-white.png">    </p:cNvPr>
+          <p:cNvPr id="5" name="Image 0" descr="/tmp/pcwork/api-patterns-and-practices-graphql/presentation/_shared/assets/redhat-logo-white.png">    </p:cNvPr>
           <p:cNvPicPr>
             <a:picLocks noChangeAspect="1"/>
           </p:cNvPicPr>
@@ -8238,7 +8327,7 @@
       </p:sp>
       <p:pic>
         <p:nvPicPr>
-          <p:cNvPr id="3" name="Image 0" descr="/work/_shared/assets/logo-candidate-2.png">    </p:cNvPr>
+          <p:cNvPr id="3" name="Image 0" descr="/tmp/pcwork/api-patterns-and-practices-graphql/presentation/_shared/assets/logo-candidate-2.png">    </p:cNvPr>
           <p:cNvPicPr>
             <a:picLocks noChangeAspect="1"/>
           </p:cNvPicPr>
@@ -8340,7 +8429,7 @@
       </p:sp>
       <p:pic>
         <p:nvPicPr>
-          <p:cNvPr id="6" name="Image 1" descr="/work/_shared/png/03-type-system-map.png">    </p:cNvPr>
+          <p:cNvPr id="6" name="Image 1" descr="/tmp/pcwork/api-patterns-and-practices-graphql/presentation/_shared/png/03-type-system-map.png">    </p:cNvPr>
           <p:cNvPicPr>
             <a:picLocks noChangeAspect="1"/>
           </p:cNvPicPr>
@@ -8466,7 +8555,7 @@
       </p:sp>
       <p:pic>
         <p:nvPicPr>
-          <p:cNvPr id="3" name="Image 0" descr="/work/_shared/assets/logo-candidate-2.png">    </p:cNvPr>
+          <p:cNvPr id="3" name="Image 0" descr="/tmp/pcwork/api-patterns-and-practices-graphql/presentation/_shared/assets/logo-candidate-2.png">    </p:cNvPr>
           <p:cNvPicPr>
             <a:picLocks noChangeAspect="1"/>
           </p:cNvPicPr>
@@ -9174,7 +9263,7 @@
       </p:sp>
       <p:pic>
         <p:nvPicPr>
-          <p:cNvPr id="3" name="Image 0" descr="/work/_shared/assets/logo-candidate-2.png">    </p:cNvPr>
+          <p:cNvPr id="3" name="Image 0" descr="/tmp/pcwork/api-patterns-and-practices-graphql/presentation/_shared/assets/logo-candidate-2.png">    </p:cNvPr>
           <p:cNvPicPr>
             <a:picLocks noChangeAspect="1"/>
           </p:cNvPicPr>
@@ -9276,7 +9365,7 @@
       </p:sp>
       <p:pic>
         <p:nvPicPr>
-          <p:cNvPr id="6" name="Image 1" descr="/work/_shared/png/03-scalar-coercion.png">    </p:cNvPr>
+          <p:cNvPr id="6" name="Image 1" descr="/tmp/pcwork/api-patterns-and-practices-graphql/presentation/_shared/png/03-scalar-coercion.png">    </p:cNvPr>
           <p:cNvPicPr>
             <a:picLocks noChangeAspect="1"/>
           </p:cNvPicPr>
@@ -9402,7 +9491,7 @@
       </p:sp>
       <p:pic>
         <p:nvPicPr>
-          <p:cNvPr id="3" name="Image 0" descr="/work/_shared/assets/logo-candidate-2.png">    </p:cNvPr>
+          <p:cNvPr id="3" name="Image 0" descr="/tmp/pcwork/api-patterns-and-practices-graphql/presentation/_shared/assets/logo-candidate-2.png">    </p:cNvPr>
           <p:cNvPicPr>
             <a:picLocks noChangeAspect="1"/>
           </p:cNvPicPr>
@@ -9504,7 +9593,7 @@
       </p:sp>
       <p:pic>
         <p:nvPicPr>
-          <p:cNvPr id="6" name="Image 1" descr="/work/_shared/png/04-wrapper-matrix.png">    </p:cNvPr>
+          <p:cNvPr id="6" name="Image 1" descr="/tmp/pcwork/api-patterns-and-practices-graphql/presentation/_shared/png/04-wrapper-matrix.png">    </p:cNvPr>
           <p:cNvPicPr>
             <a:picLocks noChangeAspect="1"/>
           </p:cNvPicPr>
@@ -9630,7 +9719,7 @@
       </p:sp>
       <p:pic>
         <p:nvPicPr>
-          <p:cNvPr id="3" name="Image 0" descr="/work/_shared/assets/logo-candidate-2.png">    </p:cNvPr>
+          <p:cNvPr id="3" name="Image 0" descr="/tmp/pcwork/api-patterns-and-practices-graphql/presentation/_shared/assets/logo-candidate-2.png">    </p:cNvPr>
           <p:cNvPicPr>
             <a:picLocks noChangeAspect="1"/>
           </p:cNvPicPr>
@@ -9732,7 +9821,7 @@
       </p:sp>
       <p:pic>
         <p:nvPicPr>
-          <p:cNvPr id="6" name="Image 1" descr="/work/_shared/png/04-null-bubbling-walk.png">    </p:cNvPr>
+          <p:cNvPr id="6" name="Image 1" descr="/tmp/pcwork/api-patterns-and-practices-graphql/presentation/_shared/png/04-null-bubbling-walk.png">    </p:cNvPr>
           <p:cNvPicPr>
             <a:picLocks noChangeAspect="1"/>
           </p:cNvPicPr>
@@ -9858,7 +9947,7 @@
       </p:sp>
       <p:pic>
         <p:nvPicPr>
-          <p:cNvPr id="3" name="Image 0" descr="/work/_shared/assets/logo-candidate-2.png">    </p:cNvPr>
+          <p:cNvPr id="3" name="Image 0" descr="/tmp/pcwork/api-patterns-and-practices-graphql/presentation/_shared/assets/logo-candidate-2.png">    </p:cNvPr>
           <p:cNvPicPr>
             <a:picLocks noChangeAspect="1"/>
           </p:cNvPicPr>
@@ -9960,7 +10049,7 @@
       </p:sp>
       <p:pic>
         <p:nvPicPr>
-          <p:cNvPr id="6" name="Image 1" descr="/work/_shared/png/05-contract-loop.png">    </p:cNvPr>
+          <p:cNvPr id="6" name="Image 1" descr="/tmp/pcwork/api-patterns-and-practices-graphql/presentation/_shared/png/05-contract-loop.png">    </p:cNvPr>
           <p:cNvPicPr>
             <a:picLocks noChangeAspect="1"/>
           </p:cNvPicPr>
@@ -10164,7 +10253,7 @@
       </p:sp>
       <p:pic>
         <p:nvPicPr>
-          <p:cNvPr id="5" name="Image 0" descr="/work/_shared/assets/redhat-logo-white.png">    </p:cNvPr>
+          <p:cNvPr id="5" name="Image 0" descr="/tmp/pcwork/api-patterns-and-practices-graphql/presentation/_shared/assets/redhat-logo-white.png">    </p:cNvPr>
           <p:cNvPicPr>
             <a:picLocks noChangeAspect="1"/>
           </p:cNvPicPr>
@@ -10252,7 +10341,7 @@
       </p:sp>
       <p:pic>
         <p:nvPicPr>
-          <p:cNvPr id="3" name="Image 0" descr="/work/_shared/assets/logo-candidate-2.png">    </p:cNvPr>
+          <p:cNvPr id="3" name="Image 0" descr="/tmp/pcwork/api-patterns-and-practices-graphql/presentation/_shared/assets/logo-candidate-2.png">    </p:cNvPr>
           <p:cNvPicPr>
             <a:picLocks noChangeAspect="1"/>
           </p:cNvPicPr>
@@ -10354,7 +10443,7 @@
       </p:sp>
       <p:pic>
         <p:nvPicPr>
-          <p:cNvPr id="6" name="Image 1" descr="/work/_shared/png/06-request-phases.png">    </p:cNvPr>
+          <p:cNvPr id="6" name="Image 1" descr="/tmp/pcwork/api-patterns-and-practices-graphql/presentation/_shared/png/06-request-phases.png">    </p:cNvPr>
           <p:cNvPicPr>
             <a:picLocks noChangeAspect="1"/>
           </p:cNvPicPr>
@@ -10480,7 +10569,7 @@
       </p:sp>
       <p:pic>
         <p:nvPicPr>
-          <p:cNvPr id="3" name="Image 0" descr="/work/_shared/assets/logo-candidate-2.png">    </p:cNvPr>
+          <p:cNvPr id="3" name="Image 0" descr="/tmp/pcwork/api-patterns-and-practices-graphql/presentation/_shared/assets/logo-candidate-2.png">    </p:cNvPr>
           <p:cNvPicPr>
             <a:picLocks noChangeAspect="1"/>
           </p:cNvPicPr>
@@ -10582,7 +10671,7 @@
       </p:sp>
       <p:pic>
         <p:nvPicPr>
-          <p:cNvPr id="6" name="Image 1" descr="/work/_shared/png/07-resolver-chain.png">    </p:cNvPr>
+          <p:cNvPr id="6" name="Image 1" descr="/tmp/pcwork/api-patterns-and-practices-graphql/presentation/_shared/png/07-resolver-chain.png">    </p:cNvPr>
           <p:cNvPicPr>
             <a:picLocks noChangeAspect="1"/>
           </p:cNvPicPr>
@@ -10708,7 +10797,7 @@
       </p:sp>
       <p:pic>
         <p:nvPicPr>
-          <p:cNvPr id="3" name="Image 0" descr="/work/_shared/assets/logo-candidate-2.png">    </p:cNvPr>
+          <p:cNvPr id="3" name="Image 0" descr="/tmp/pcwork/api-patterns-and-practices-graphql/presentation/_shared/assets/logo-candidate-2.png">    </p:cNvPr>
           <p:cNvPicPr>
             <a:picLocks noChangeAspect="1"/>
           </p:cNvPicPr>
@@ -11245,7 +11334,7 @@
       </p:sp>
       <p:pic>
         <p:nvPicPr>
-          <p:cNvPr id="3" name="Image 0" descr="/work/_shared/assets/logo-candidate-2.png">    </p:cNvPr>
+          <p:cNvPr id="3" name="Image 0" descr="/tmp/pcwork/api-patterns-and-practices-graphql/presentation/_shared/assets/logo-candidate-2.png">    </p:cNvPr>
           <p:cNvPicPr>
             <a:picLocks noChangeAspect="1"/>
           </p:cNvPicPr>
@@ -11463,7 +11552,7 @@
                 <a:ea typeface="Red Hat Mono" pitchFamily="34" charset="-122"/>
                 <a:cs typeface="Red Hat Mono" pitchFamily="34" charset="-120"/>
               </a:rPr>
-              <a:t>query($t: TrackingId! = "ABC123") { cargo(trackingId: $t) { trackingId } }
+              <a:t>    return info.context.derivation.derive(self, itinerary, events)
 </a:t>
             </a:r>
             <a:pPr algn="l" indent="0" marL="0">
@@ -11499,7 +11588,7 @@
                 <a:ea typeface="Red Hat Mono" pitchFamily="34" charset="-122"/>
                 <a:cs typeface="Red Hat Mono" pitchFamily="34" charset="-120"/>
               </a:rPr>
-              <a:t>{ ny: location(unLocode: "USNYC") { name } rtm: location(unLocode: "NLRTM") { name } }
+              <a:t>
 </a:t>
             </a:r>
             <a:pPr algn="l" indent="0" marL="0">
@@ -11535,7 +11624,7 @@
                 <a:ea typeface="Red Hat Mono" pitchFamily="34" charset="-122"/>
                 <a:cs typeface="Red Hat Mono" pitchFamily="34" charset="-120"/>
               </a:rPr>
-              <a:t>{ cargo(trackingId: "ABC123") { origin { ...Place } destination { ...Place } } }
+              <a:t>
 </a:t>
             </a:r>
             <a:pPr algn="l" indent="0" marL="0">
@@ -11553,7 +11642,7 @@
                 <a:ea typeface="Red Hat Mono" pitchFamily="34" charset="-122"/>
                 <a:cs typeface="Red Hat Mono" pitchFamily="34" charset="-120"/>
               </a:rPr>
-              <a:t>fragment Place on Location { unLocode name country }
+              <a:t>```graphql
 </a:t>
             </a:r>
             <a:pPr algn="l" indent="0" marL="0">
@@ -11589,7 +11678,7 @@
                 <a:ea typeface="Red Hat Mono" pitchFamily="34" charset="-122"/>
                 <a:cs typeface="Red Hat Mono" pitchFamily="34" charset="-120"/>
               </a:rPr>
-              <a:t>query($full: Boolean!) {
+              <a:t>
 </a:t>
             </a:r>
             <a:pPr algn="l" indent="0" marL="0">
@@ -11607,7 +11696,7 @@
                 <a:ea typeface="Red Hat Mono" pitchFamily="34" charset="-122"/>
                 <a:cs typeface="Red Hat Mono" pitchFamily="34" charset="-120"/>
               </a:rPr>
-              <a:t>  cargo(trackingId: "ABC123") {
+              <a:t>```graphql
 </a:t>
             </a:r>
             <a:pPr algn="l" indent="0" marL="0">
@@ -11625,7 +11714,7 @@
                 <a:ea typeface="Red Hat Mono" pitchFamily="34" charset="-122"/>
                 <a:cs typeface="Red Hat Mono" pitchFamily="34" charset="-120"/>
               </a:rPr>
-              <a:t>    trackingId
+              <a:t>{ node(id: "loc_NLRTM") { __typename ... on Location { name } } }
 </a:t>
             </a:r>
             <a:pPr algn="l" indent="0" marL="0">
@@ -11643,7 +11732,7 @@
                 <a:ea typeface="Red Hat Mono" pitchFamily="34" charset="-122"/>
                 <a:cs typeface="Red Hat Mono" pitchFamily="34" charset="-120"/>
               </a:rPr>
-              <a:t>    itinerary @include(if: $full) { legs { loadTime } }
+              <a:t>```
 </a:t>
             </a:r>
             <a:pPr algn="l" indent="0" marL="0">
@@ -11661,7 +11750,7 @@
                 <a:ea typeface="Red Hat Mono" pitchFamily="34" charset="-122"/>
                 <a:cs typeface="Red Hat Mono" pitchFamily="34" charset="-120"/>
               </a:rPr>
-              <a:t>    delivery @skip(if: $full) { transportStatus }
+              <a:t>
 </a:t>
             </a:r>
             <a:pPr algn="l" indent="0" marL="0">
@@ -11679,7 +11768,7 @@
                 <a:ea typeface="Red Hat Mono" pitchFamily="34" charset="-122"/>
                 <a:cs typeface="Red Hat Mono" pitchFamily="34" charset="-120"/>
               </a:rPr>
-              <a:t>  }
+              <a:t>returns `{"__typename":"Location","name":"Rotterdam"}`, and a `... on Cargo` fragment in the same selection would contribute nothing, as Chapter 3 showed. The spec covers both in "Fragments" and "Inline Fragments".
 </a:t>
             </a:r>
             <a:pPr algn="l" indent="0" marL="0">
@@ -11697,7 +11786,7 @@
                 <a:ea typeface="Red Hat Mono" pitchFamily="34" charset="-122"/>
                 <a:cs typeface="Red Hat Mono" pitchFamily="34" charset="-120"/>
               </a:rPr>
-              <a:t>}
+              <a:t>
 </a:t>
             </a:r>
             <a:endParaRPr lang="en-US" sz="1300" dirty="0"/>
@@ -11809,7 +11898,7 @@
       </p:sp>
       <p:pic>
         <p:nvPicPr>
-          <p:cNvPr id="3" name="Image 0" descr="/work/_shared/assets/logo-candidate-2.png">    </p:cNvPr>
+          <p:cNvPr id="3" name="Image 0" descr="/tmp/pcwork/api-patterns-and-practices-graphql/presentation/_shared/assets/logo-candidate-2.png">    </p:cNvPr>
           <p:cNvPicPr>
             <a:picLocks noChangeAspect="1"/>
           </p:cNvPicPr>
@@ -11911,7 +12000,7 @@
       </p:sp>
       <p:pic>
         <p:nvPicPr>
-          <p:cNvPr id="6" name="Image 1" descr="/work/_shared/png/08-mutation-flow.png">    </p:cNvPr>
+          <p:cNvPr id="6" name="Image 1" descr="/tmp/pcwork/api-patterns-and-practices-graphql/presentation/_shared/png/08-mutation-flow.png">    </p:cNvPr>
           <p:cNvPicPr>
             <a:picLocks noChangeAspect="1"/>
           </p:cNvPicPr>
@@ -12037,7 +12126,7 @@
       </p:sp>
       <p:pic>
         <p:nvPicPr>
-          <p:cNvPr id="3" name="Image 0" descr="/work/_shared/assets/logo-candidate-2.png">    </p:cNvPr>
+          <p:cNvPr id="3" name="Image 0" descr="/tmp/pcwork/api-patterns-and-practices-graphql/presentation/_shared/assets/logo-candidate-2.png">    </p:cNvPr>
           <p:cNvPicPr>
             <a:picLocks noChangeAspect="1"/>
           </p:cNvPicPr>
@@ -12139,7 +12228,7 @@
       </p:sp>
       <p:pic>
         <p:nvPicPr>
-          <p:cNvPr id="6" name="Image 1" descr="/work/_shared/png/08-idempotent-replay.png">    </p:cNvPr>
+          <p:cNvPr id="6" name="Image 1" descr="/tmp/pcwork/api-patterns-and-practices-graphql/presentation/_shared/png/08-idempotent-replay.png">    </p:cNvPr>
           <p:cNvPicPr>
             <a:picLocks noChangeAspect="1"/>
           </p:cNvPicPr>
@@ -12343,7 +12432,7 @@
       </p:sp>
       <p:pic>
         <p:nvPicPr>
-          <p:cNvPr id="5" name="Image 0" descr="/work/_shared/assets/redhat-logo-white.png">    </p:cNvPr>
+          <p:cNvPr id="5" name="Image 0" descr="/tmp/pcwork/api-patterns-and-practices-graphql/presentation/_shared/assets/redhat-logo-white.png">    </p:cNvPr>
           <p:cNvPicPr>
             <a:picLocks noChangeAspect="1"/>
           </p:cNvPicPr>
@@ -12431,7 +12520,7 @@
       </p:sp>
       <p:pic>
         <p:nvPicPr>
-          <p:cNvPr id="3" name="Image 0" descr="/work/_shared/assets/logo-candidate-2.png">    </p:cNvPr>
+          <p:cNvPr id="3" name="Image 0" descr="/tmp/pcwork/api-patterns-and-practices-graphql/presentation/_shared/assets/logo-candidate-2.png">    </p:cNvPr>
           <p:cNvPicPr>
             <a:picLocks noChangeAspect="1"/>
           </p:cNvPicPr>
@@ -12533,7 +12622,7 @@
       </p:sp>
       <p:pic>
         <p:nvPicPr>
-          <p:cNvPr id="6" name="Image 1" descr="/work/_shared/png/09-error-taxonomy.png">    </p:cNvPr>
+          <p:cNvPr id="6" name="Image 1" descr="/tmp/pcwork/api-patterns-and-practices-graphql/presentation/_shared/png/09-error-taxonomy.png">    </p:cNvPr>
           <p:cNvPicPr>
             <a:picLocks noChangeAspect="1"/>
           </p:cNvPicPr>
@@ -12659,7 +12748,7 @@
       </p:sp>
       <p:pic>
         <p:nvPicPr>
-          <p:cNvPr id="3" name="Image 0" descr="/work/_shared/assets/logo-candidate-2.png">    </p:cNvPr>
+          <p:cNvPr id="3" name="Image 0" descr="/tmp/pcwork/api-patterns-and-practices-graphql/presentation/_shared/assets/logo-candidate-2.png">    </p:cNvPr>
           <p:cNvPicPr>
             <a:picLocks noChangeAspect="1"/>
           </p:cNvPicPr>
@@ -12761,7 +12850,7 @@
       </p:sp>
       <p:pic>
         <p:nvPicPr>
-          <p:cNvPr id="6" name="Image 1" descr="/work/_shared/png/09-partial-data-errors.png">    </p:cNvPr>
+          <p:cNvPr id="6" name="Image 1" descr="/tmp/pcwork/api-patterns-and-practices-graphql/presentation/_shared/png/09-partial-data-errors.png">    </p:cNvPr>
           <p:cNvPicPr>
             <a:picLocks noChangeAspect="1"/>
           </p:cNvPicPr>
@@ -12887,7 +12976,7 @@
       </p:sp>
       <p:pic>
         <p:nvPicPr>
-          <p:cNvPr id="3" name="Image 0" descr="/work/_shared/assets/logo-candidate-2.png">    </p:cNvPr>
+          <p:cNvPr id="3" name="Image 0" descr="/tmp/pcwork/api-patterns-and-practices-graphql/presentation/_shared/assets/logo-candidate-2.png">    </p:cNvPr>
           <p:cNvPicPr>
             <a:picLocks noChangeAspect="1"/>
           </p:cNvPicPr>
@@ -13099,13 +13188,13 @@
             <a:r>
               <a:rPr lang="en-US" sz="1100" dirty="0">
                 <a:solidFill>
-                  <a:srgbClr val="E6E6E6"/>
+                  <a:srgbClr val="8FB98F"/>
                 </a:solidFill>
                 <a:latin typeface="Red Hat Mono" pitchFamily="34" charset="0"/>
                 <a:ea typeface="Red Hat Mono" pitchFamily="34" charset="-122"/>
                 <a:cs typeface="Red Hat Mono" pitchFamily="34" charset="-120"/>
               </a:rPr>
-              <a:t>Q '{ cargo(trackingId: "JKL567") { trackingId itinerary { legs { loadLocation { unLocode } voyage { number } } } } }'
+              <a:t>## On the wire
 </a:t>
             </a:r>
             <a:pPr algn="l" indent="0" marL="0">
@@ -13141,7 +13230,7 @@
                 <a:ea typeface="Red Hat Mono" pitchFamily="34" charset="-122"/>
                 <a:cs typeface="Red Hat Mono" pitchFamily="34" charset="-120"/>
               </a:rPr>
-              <a:t>{"errors":[{"message":"voyage service unavailable","locations":[{"line":1,"column":89}],"path":["cargo","itinerary","legs",0,"voyage"],"extensions":{"code":"SERVICE_UNAVAILABLE"}}],"data":{"cargo":{"trackingId":"JKL567","itinerary":{"legs":[{"loadLocation":{"unLocode":"USNYC"},"voyage":null}]}}}}
+              <a:t>```bash
 </a:t>
             </a:r>
             <a:pPr algn="l" indent="0" marL="0">
@@ -13177,7 +13266,7 @@
                 <a:ea typeface="Red Hat Mono" pitchFamily="34" charset="-122"/>
                 <a:cs typeface="Red Hat Mono" pitchFamily="34" charset="-120"/>
               </a:rPr>
-              <a:t>Q '{ cargo(trackingId: "PQR234") { trackingId delivery { transportStatus } } }'
+              <a:t>
 </a:t>
             </a:r>
             <a:pPr algn="l" indent="0" marL="0">
@@ -13213,7 +13302,7 @@
                 <a:ea typeface="Red Hat Mono" pitchFamily="34" charset="-122"/>
                 <a:cs typeface="Red Hat Mono" pitchFamily="34" charset="-120"/>
               </a:rPr>
-              <a:t>{"errors":[{"message":"Internal server error.","locations":[{"line":1,"column":44}],"path":["cargo","delivery"],"extensions":{"code":null}}],"data":{"cargo":null}}
+              <a:t>```json
 </a:t>
             </a:r>
             <a:endParaRPr lang="en-US" sz="1100" dirty="0"/>
@@ -13325,7 +13414,7 @@
       </p:sp>
       <p:pic>
         <p:nvPicPr>
-          <p:cNvPr id="3" name="Image 0" descr="/work/_shared/assets/logo-candidate-2.png">    </p:cNvPr>
+          <p:cNvPr id="3" name="Image 0" descr="/tmp/pcwork/api-patterns-and-practices-graphql/presentation/_shared/assets/logo-candidate-2.png">    </p:cNvPr>
           <p:cNvPicPr>
             <a:picLocks noChangeAspect="1"/>
           </p:cNvPicPr>
@@ -13427,7 +13516,7 @@
       </p:sp>
       <p:pic>
         <p:nvPicPr>
-          <p:cNvPr id="6" name="Image 1" descr="/work/_shared/png/09-error-masking.png">    </p:cNvPr>
+          <p:cNvPr id="6" name="Image 1" descr="/tmp/pcwork/api-patterns-and-practices-graphql/presentation/_shared/png/09-error-masking.png">    </p:cNvPr>
           <p:cNvPicPr>
             <a:picLocks noChangeAspect="1"/>
           </p:cNvPicPr>
@@ -13631,7 +13720,7 @@
       </p:sp>
       <p:pic>
         <p:nvPicPr>
-          <p:cNvPr id="5" name="Image 0" descr="/work/_shared/assets/redhat-logo-white.png">    </p:cNvPr>
+          <p:cNvPr id="5" name="Image 0" descr="/tmp/pcwork/api-patterns-and-practices-graphql/presentation/_shared/assets/redhat-logo-white.png">    </p:cNvPr>
           <p:cNvPicPr>
             <a:picLocks noChangeAspect="1"/>
           </p:cNvPicPr>
@@ -13719,7 +13808,7 @@
       </p:sp>
       <p:pic>
         <p:nvPicPr>
-          <p:cNvPr id="3" name="Image 0" descr="/work/_shared/assets/logo-candidate-2.png">    </p:cNvPr>
+          <p:cNvPr id="3" name="Image 0" descr="/tmp/pcwork/api-patterns-and-practices-graphql/presentation/_shared/assets/logo-candidate-2.png">    </p:cNvPr>
           <p:cNvPicPr>
             <a:picLocks noChangeAspect="1"/>
           </p:cNvPicPr>
@@ -13821,7 +13910,7 @@
       </p:sp>
       <p:pic>
         <p:nvPicPr>
-          <p:cNvPr id="6" name="Image 1" descr="/work/_shared/png/10-demand-oriented-schema.png">    </p:cNvPr>
+          <p:cNvPr id="6" name="Image 1" descr="/tmp/pcwork/api-patterns-and-practices-graphql/presentation/_shared/png/10-demand-oriented-schema.png">    </p:cNvPr>
           <p:cNvPicPr>
             <a:picLocks noChangeAspect="1"/>
           </p:cNvPicPr>
@@ -14025,7 +14114,7 @@
       </p:sp>
       <p:pic>
         <p:nvPicPr>
-          <p:cNvPr id="5" name="Image 0" descr="/work/_shared/assets/redhat-logo-white.png">    </p:cNvPr>
+          <p:cNvPr id="5" name="Image 0" descr="/tmp/pcwork/api-patterns-and-practices-graphql/presentation/_shared/assets/redhat-logo-white.png">    </p:cNvPr>
           <p:cNvPicPr>
             <a:picLocks noChangeAspect="1"/>
           </p:cNvPicPr>
@@ -14113,7 +14202,7 @@
       </p:sp>
       <p:pic>
         <p:nvPicPr>
-          <p:cNvPr id="3" name="Image 0" descr="/work/_shared/assets/logo-candidate-2.png">    </p:cNvPr>
+          <p:cNvPr id="3" name="Image 0" descr="/tmp/pcwork/api-patterns-and-practices-graphql/presentation/_shared/assets/logo-candidate-2.png">    </p:cNvPr>
           <p:cNvPicPr>
             <a:picLocks noChangeAspect="1"/>
           </p:cNvPicPr>
@@ -14215,7 +14304,7 @@
       </p:sp>
       <p:pic>
         <p:nvPicPr>
-          <p:cNvPr id="6" name="Image 1" descr="/work/_shared/png/10-node-identity.png">    </p:cNvPr>
+          <p:cNvPr id="6" name="Image 1" descr="/tmp/pcwork/api-patterns-and-practices-graphql/presentation/_shared/png/10-node-identity.png">    </p:cNvPr>
           <p:cNvPicPr>
             <a:picLocks noChangeAspect="1"/>
           </p:cNvPicPr>
@@ -14341,7 +14430,7 @@
       </p:sp>
       <p:pic>
         <p:nvPicPr>
-          <p:cNvPr id="3" name="Image 0" descr="/work/_shared/assets/logo-candidate-2.png">    </p:cNvPr>
+          <p:cNvPr id="3" name="Image 0" descr="/tmp/pcwork/api-patterns-and-practices-graphql/presentation/_shared/assets/logo-candidate-2.png">    </p:cNvPr>
           <p:cNvPicPr>
             <a:picLocks noChangeAspect="1"/>
           </p:cNvPicPr>
@@ -14443,7 +14532,7 @@
       </p:sp>
       <p:pic>
         <p:nvPicPr>
-          <p:cNvPr id="6" name="Image 1" descr="/work/_shared/png/11-change-classes.png">    </p:cNvPr>
+          <p:cNvPr id="6" name="Image 1" descr="/tmp/pcwork/api-patterns-and-practices-graphql/presentation/_shared/png/11-change-classes.png">    </p:cNvPr>
           <p:cNvPicPr>
             <a:picLocks noChangeAspect="1"/>
           </p:cNvPicPr>
@@ -14569,7 +14658,7 @@
       </p:sp>
       <p:pic>
         <p:nvPicPr>
-          <p:cNvPr id="3" name="Image 0" descr="/work/_shared/assets/logo-candidate-2.png">    </p:cNvPr>
+          <p:cNvPr id="3" name="Image 0" descr="/tmp/pcwork/api-patterns-and-practices-graphql/presentation/_shared/assets/logo-candidate-2.png">    </p:cNvPr>
           <p:cNvPicPr>
             <a:picLocks noChangeAspect="1"/>
           </p:cNvPicPr>
@@ -15025,7 +15114,7 @@
       </p:sp>
       <p:pic>
         <p:nvPicPr>
-          <p:cNvPr id="3" name="Image 0" descr="/work/_shared/assets/logo-candidate-2.png">    </p:cNvPr>
+          <p:cNvPr id="3" name="Image 0" descr="/tmp/pcwork/api-patterns-and-practices-graphql/presentation/_shared/assets/logo-candidate-2.png">    </p:cNvPr>
           <p:cNvPicPr>
             <a:picLocks noChangeAspect="1"/>
           </p:cNvPicPr>
@@ -15127,7 +15216,7 @@
       </p:sp>
       <p:pic>
         <p:nvPicPr>
-          <p:cNvPr id="6" name="Image 1" descr="/work/_shared/png/11-deprecation-lifecycle.png">    </p:cNvPr>
+          <p:cNvPr id="6" name="Image 1" descr="/tmp/pcwork/api-patterns-and-practices-graphql/presentation/_shared/png/11-deprecation-lifecycle.png">    </p:cNvPr>
           <p:cNvPicPr>
             <a:picLocks noChangeAspect="1"/>
           </p:cNvPicPr>
@@ -15331,7 +15420,7 @@
       </p:sp>
       <p:pic>
         <p:nvPicPr>
-          <p:cNvPr id="5" name="Image 0" descr="/work/_shared/assets/redhat-logo-white.png">    </p:cNvPr>
+          <p:cNvPr id="5" name="Image 0" descr="/tmp/pcwork/api-patterns-and-practices-graphql/presentation/_shared/assets/redhat-logo-white.png">    </p:cNvPr>
           <p:cNvPicPr>
             <a:picLocks noChangeAspect="1"/>
           </p:cNvPicPr>
@@ -15419,7 +15508,7 @@
       </p:sp>
       <p:pic>
         <p:nvPicPr>
-          <p:cNvPr id="3" name="Image 0" descr="/work/_shared/assets/logo-candidate-2.png">    </p:cNvPr>
+          <p:cNvPr id="3" name="Image 0" descr="/tmp/pcwork/api-patterns-and-practices-graphql/presentation/_shared/assets/logo-candidate-2.png">    </p:cNvPr>
           <p:cNvPicPr>
             <a:picLocks noChangeAspect="1"/>
           </p:cNvPicPr>
@@ -15521,7 +15610,7 @@
       </p:sp>
       <p:pic>
         <p:nvPicPr>
-          <p:cNvPr id="6" name="Image 1" descr="/work/_shared/png/12-connection-anatomy.png">    </p:cNvPr>
+          <p:cNvPr id="6" name="Image 1" descr="/tmp/pcwork/api-patterns-and-practices-graphql/presentation/_shared/png/12-connection-anatomy.png">    </p:cNvPr>
           <p:cNvPicPr>
             <a:picLocks noChangeAspect="1"/>
           </p:cNvPicPr>
@@ -15647,7 +15736,7 @@
       </p:sp>
       <p:pic>
         <p:nvPicPr>
-          <p:cNvPr id="3" name="Image 0" descr="/work/_shared/assets/logo-candidate-2.png">    </p:cNvPr>
+          <p:cNvPr id="3" name="Image 0" descr="/tmp/pcwork/api-patterns-and-practices-graphql/presentation/_shared/assets/logo-candidate-2.png">    </p:cNvPr>
           <p:cNvPicPr>
             <a:picLocks noChangeAspect="1"/>
           </p:cNvPicPr>
@@ -15749,7 +15838,7 @@
       </p:sp>
       <p:pic>
         <p:nvPicPr>
-          <p:cNvPr id="6" name="Image 1" descr="/work/_shared/png/12-offset-vs-keyset.png">    </p:cNvPr>
+          <p:cNvPr id="6" name="Image 1" descr="/tmp/pcwork/api-patterns-and-practices-graphql/presentation/_shared/png/12-offset-vs-keyset.png">    </p:cNvPr>
           <p:cNvPicPr>
             <a:picLocks noChangeAspect="1"/>
           </p:cNvPicPr>
@@ -15875,7 +15964,7 @@
       </p:sp>
       <p:pic>
         <p:nvPicPr>
-          <p:cNvPr id="3" name="Image 0" descr="/work/_shared/assets/logo-candidate-2.png">    </p:cNvPr>
+          <p:cNvPr id="3" name="Image 0" descr="/tmp/pcwork/api-patterns-and-practices-graphql/presentation/_shared/assets/logo-candidate-2.png">    </p:cNvPr>
           <p:cNvPicPr>
             <a:picLocks noChangeAspect="1"/>
           </p:cNvPicPr>
@@ -16093,7 +16182,7 @@
                 <a:ea typeface="Red Hat Mono" pitchFamily="34" charset="-122"/>
                 <a:cs typeface="Red Hat Mono" pitchFamily="34" charset="-120"/>
               </a:rPr>
-              <a:t>Q 'query($f: Int, $a: String) { cargos(first: $f, after: $a) { edges { cursor node { trackingId } } pageInfo { hasNextPage hasPreviousPage startCursor endCursor } totalCount } }' '{"f":2}'
+              <a:t>```bash
 </a:t>
             </a:r>
             <a:pPr algn="l" indent="0" marL="0">
@@ -16111,7 +16200,7 @@
                 <a:ea typeface="Red Hat Mono" pitchFamily="34" charset="-122"/>
                 <a:cs typeface="Red Hat Mono" pitchFamily="34" charset="-120"/>
               </a:rPr>
-              <a:t>...
+              <a:t>  ...
 </a:t>
             </a:r>
             <a:pPr algn="l" indent="0" marL="0">
@@ -16129,7 +16218,7 @@
                 <a:ea typeface="Red Hat Mono" pitchFamily="34" charset="-122"/>
                 <a:cs typeface="Red Hat Mono" pitchFamily="34" charset="-120"/>
               </a:rPr>
-              <a:t>{"data":{"cargos":{"edges":[{"cursor":"Y2FyZ298djF8MjAyNi0wOS0yOVQwOTowMDowMFp8VldYOTAx","node":{"trackingId":"VWX901"}},{"cursor":"Y2FyZ298djF8MjAyNi0wOS0yOFQwOTowMDowMFp8WFlaNzg5","node":{"trackingId":"XYZ789"}}],"pageInfo":{"hasNextPage":true,"hasPreviousPage":false,"startCursor":"Y2FyZ298djF8MjAyNi0wOS0yOVQwOTowMDowMFp8VldYOTAx","endCursor":"Y2FyZ298djF8MjAyNi0wOS0yOFQwOTowMDowMFp8WFlaNzg5"},"totalCount":6}}}
+              <a:t>  curl -s localhost:${3:-8220}/graphql -H 'Content-Type: application/json' \
 </a:t>
             </a:r>
             <a:pPr algn="l" indent="0" marL="0">
@@ -16165,7 +16254,7 @@
                 <a:ea typeface="Red Hat Mono" pitchFamily="34" charset="-122"/>
                 <a:cs typeface="Red Hat Mono" pitchFamily="34" charset="-120"/>
               </a:rPr>
-              <a:t>Q '{ cargos(first: 51) { totalCount } }'
+              <a:t>
 </a:t>
             </a:r>
             <a:pPr algn="l" indent="0" marL="0">
@@ -16201,7 +16290,7 @@
                 <a:ea typeface="Red Hat Mono" pitchFamily="34" charset="-122"/>
                 <a:cs typeface="Red Hat Mono" pitchFamily="34" charset="-120"/>
               </a:rPr>
-              <a:t>{"errors":[{"message":"first must be between 0 and 50","locations":[{"line":1,"column":3}],"path":["cargos"],"extensions":{"code":"BAD_USER_INPUT"}}],"data":null}
+              <a:t>```
 </a:t>
             </a:r>
             <a:endParaRPr lang="en-US" sz="900" dirty="0"/>
@@ -16313,7 +16402,7 @@
       </p:sp>
       <p:pic>
         <p:nvPicPr>
-          <p:cNvPr id="3" name="Image 0" descr="/work/_shared/assets/logo-candidate-2.png">    </p:cNvPr>
+          <p:cNvPr id="3" name="Image 0" descr="/tmp/pcwork/api-patterns-and-practices-graphql/presentation/_shared/assets/logo-candidate-2.png">    </p:cNvPr>
           <p:cNvPicPr>
             <a:picLocks noChangeAspect="1"/>
           </p:cNvPicPr>
@@ -16415,7 +16504,7 @@
       </p:sp>
       <p:pic>
         <p:nvPicPr>
-          <p:cNvPr id="6" name="Image 1" descr="/work/_shared/png/13-n-plus-one-fanout.png">    </p:cNvPr>
+          <p:cNvPr id="6" name="Image 1" descr="/tmp/pcwork/api-patterns-and-practices-graphql/presentation/_shared/png/13-n-plus-one-fanout.png">    </p:cNvPr>
           <p:cNvPicPr>
             <a:picLocks noChangeAspect="1"/>
           </p:cNvPicPr>
@@ -16541,7 +16630,7 @@
       </p:sp>
       <p:pic>
         <p:nvPicPr>
-          <p:cNvPr id="3" name="Image 0" descr="/work/_shared/assets/logo-candidate-2.png">    </p:cNvPr>
+          <p:cNvPr id="3" name="Image 0" descr="/tmp/pcwork/api-patterns-and-practices-graphql/presentation/_shared/assets/logo-candidate-2.png">    </p:cNvPr>
           <p:cNvPicPr>
             <a:picLocks noChangeAspect="1"/>
           </p:cNvPicPr>
@@ -16643,7 +16732,7 @@
       </p:sp>
       <p:pic>
         <p:nvPicPr>
-          <p:cNvPr id="6" name="Image 1" descr="/work/_shared/png/13-batched-load.png">    </p:cNvPr>
+          <p:cNvPr id="6" name="Image 1" descr="/tmp/pcwork/api-patterns-and-practices-graphql/presentation/_shared/png/13-batched-load.png">    </p:cNvPr>
           <p:cNvPicPr>
             <a:picLocks noChangeAspect="1"/>
           </p:cNvPicPr>
@@ -16769,7 +16858,7 @@
       </p:sp>
       <p:pic>
         <p:nvPicPr>
-          <p:cNvPr id="3" name="Image 0" descr="/work/_shared/assets/logo-candidate-2.png">    </p:cNvPr>
+          <p:cNvPr id="3" name="Image 0" descr="/tmp/pcwork/api-patterns-and-practices-graphql/presentation/_shared/assets/logo-candidate-2.png">    </p:cNvPr>
           <p:cNvPicPr>
             <a:picLocks noChangeAspect="1"/>
           </p:cNvPicPr>
@@ -16871,7 +16960,7 @@
       </p:sp>
       <p:pic>
         <p:nvPicPr>
-          <p:cNvPr id="6" name="Image 1" descr="/work/_shared/png/01-three-paradigms.png">    </p:cNvPr>
+          <p:cNvPr id="6" name="Image 1" descr="/tmp/pcwork/api-patterns-and-practices-graphql/presentation/_shared/png/01-three-paradigms.png">    </p:cNvPr>
           <p:cNvPicPr>
             <a:picLocks noChangeAspect="1"/>
           </p:cNvPicPr>
@@ -16997,7 +17086,7 @@
       </p:sp>
       <p:pic>
         <p:nvPicPr>
-          <p:cNvPr id="3" name="Image 0" descr="/work/_shared/assets/logo-candidate-2.png">    </p:cNvPr>
+          <p:cNvPr id="3" name="Image 0" descr="/tmp/pcwork/api-patterns-and-practices-graphql/presentation/_shared/assets/logo-candidate-2.png">    </p:cNvPr>
           <p:cNvPicPr>
             <a:picLocks noChangeAspect="1"/>
           </p:cNvPicPr>
@@ -17099,7 +17188,7 @@
       </p:sp>
       <p:pic>
         <p:nvPicPr>
-          <p:cNvPr id="6" name="Image 1" descr="/work/_shared/png/13-dataloader-tick.png">    </p:cNvPr>
+          <p:cNvPr id="6" name="Image 1" descr="/tmp/pcwork/api-patterns-and-practices-graphql/presentation/_shared/png/13-dataloader-tick.png">    </p:cNvPr>
           <p:cNvPicPr>
             <a:picLocks noChangeAspect="1"/>
           </p:cNvPicPr>
@@ -17303,7 +17392,7 @@
       </p:sp>
       <p:pic>
         <p:nvPicPr>
-          <p:cNvPr id="5" name="Image 0" descr="/work/_shared/assets/redhat-logo-white.png">    </p:cNvPr>
+          <p:cNvPr id="5" name="Image 0" descr="/tmp/pcwork/api-patterns-and-practices-graphql/presentation/_shared/assets/redhat-logo-white.png">    </p:cNvPr>
           <p:cNvPicPr>
             <a:picLocks noChangeAspect="1"/>
           </p:cNvPicPr>
@@ -17391,7 +17480,7 @@
       </p:sp>
       <p:pic>
         <p:nvPicPr>
-          <p:cNvPr id="3" name="Image 0" descr="/work/_shared/assets/logo-candidate-2.png">    </p:cNvPr>
+          <p:cNvPr id="3" name="Image 0" descr="/tmp/pcwork/api-patterns-and-practices-graphql/presentation/_shared/assets/logo-candidate-2.png">    </p:cNvPr>
           <p:cNvPicPr>
             <a:picLocks noChangeAspect="1"/>
           </p:cNvPicPr>
@@ -17493,7 +17582,7 @@
       </p:sp>
       <p:pic>
         <p:nvPicPr>
-          <p:cNvPr id="6" name="Image 1" descr="/work/_shared/png/14-limit-pipeline.png">    </p:cNvPr>
+          <p:cNvPr id="6" name="Image 1" descr="/tmp/pcwork/api-patterns-and-practices-graphql/presentation/_shared/png/14-limit-pipeline.png">    </p:cNvPr>
           <p:cNvPicPr>
             <a:picLocks noChangeAspect="1"/>
           </p:cNvPicPr>
@@ -17619,7 +17708,7 @@
       </p:sp>
       <p:pic>
         <p:nvPicPr>
-          <p:cNvPr id="3" name="Image 0" descr="/work/_shared/assets/logo-candidate-2.png">    </p:cNvPr>
+          <p:cNvPr id="3" name="Image 0" descr="/tmp/pcwork/api-patterns-and-practices-graphql/presentation/_shared/assets/logo-candidate-2.png">    </p:cNvPr>
           <p:cNvPicPr>
             <a:picLocks noChangeAspect="1"/>
           </p:cNvPicPr>
@@ -17721,7 +17810,7 @@
       </p:sp>
       <p:pic>
         <p:nvPicPr>
-          <p:cNvPr id="6" name="Image 1" descr="/work/_shared/png/14-cost-accumulation.png">    </p:cNvPr>
+          <p:cNvPr id="6" name="Image 1" descr="/tmp/pcwork/api-patterns-and-practices-graphql/presentation/_shared/png/14-cost-accumulation.png">    </p:cNvPr>
           <p:cNvPicPr>
             <a:picLocks noChangeAspect="1"/>
           </p:cNvPicPr>
@@ -17847,7 +17936,7 @@
       </p:sp>
       <p:pic>
         <p:nvPicPr>
-          <p:cNvPr id="3" name="Image 0" descr="/work/_shared/assets/logo-candidate-2.png">    </p:cNvPr>
+          <p:cNvPr id="3" name="Image 0" descr="/tmp/pcwork/api-patterns-and-practices-graphql/presentation/_shared/assets/logo-candidate-2.png">    </p:cNvPr>
           <p:cNvPicPr>
             <a:picLocks noChangeAspect="1"/>
           </p:cNvPicPr>
@@ -17949,7 +18038,7 @@
       </p:sp>
       <p:pic>
         <p:nvPicPr>
-          <p:cNvPr id="6" name="Image 1" descr="/work/_shared/png/15-apq-handshake.png">    </p:cNvPr>
+          <p:cNvPr id="6" name="Image 1" descr="/tmp/pcwork/api-patterns-and-practices-graphql/presentation/_shared/png/15-apq-handshake.png">    </p:cNvPr>
           <p:cNvPicPr>
             <a:picLocks noChangeAspect="1"/>
           </p:cNvPicPr>
@@ -18075,7 +18164,7 @@
       </p:sp>
       <p:pic>
         <p:nvPicPr>
-          <p:cNvPr id="3" name="Image 0" descr="/work/_shared/assets/logo-candidate-2.png">    </p:cNvPr>
+          <p:cNvPr id="3" name="Image 0" descr="/tmp/pcwork/api-patterns-and-practices-graphql/presentation/_shared/assets/logo-candidate-2.png">    </p:cNvPr>
           <p:cNvPicPr>
             <a:picLocks noChangeAspect="1"/>
           </p:cNvPicPr>
@@ -18177,7 +18266,7 @@
       </p:sp>
       <p:pic>
         <p:nvPicPr>
-          <p:cNvPr id="6" name="Image 1" descr="/work/_shared/png/15-apq-vs-trusted.png">    </p:cNvPr>
+          <p:cNvPr id="6" name="Image 1" descr="/tmp/pcwork/api-patterns-and-practices-graphql/presentation/_shared/png/15-apq-vs-trusted.png">    </p:cNvPr>
           <p:cNvPicPr>
             <a:picLocks noChangeAspect="1"/>
           </p:cNvPicPr>
@@ -18303,7 +18392,7 @@
       </p:sp>
       <p:pic>
         <p:nvPicPr>
-          <p:cNvPr id="3" name="Image 0" descr="/work/_shared/assets/logo-candidate-2.png">    </p:cNvPr>
+          <p:cNvPr id="3" name="Image 0" descr="/tmp/pcwork/api-patterns-and-practices-graphql/presentation/_shared/assets/logo-candidate-2.png">    </p:cNvPr>
           <p:cNvPicPr>
             <a:picLocks noChangeAspect="1"/>
           </p:cNvPicPr>
@@ -18405,7 +18494,7 @@
       </p:sp>
       <p:pic>
         <p:nvPicPr>
-          <p:cNvPr id="6" name="Image 1" descr="/work/_shared/png/16-cache-layers.png">    </p:cNvPr>
+          <p:cNvPr id="6" name="Image 1" descr="/tmp/pcwork/api-patterns-and-practices-graphql/presentation/_shared/png/16-cache-layers.png">    </p:cNvPr>
           <p:cNvPicPr>
             <a:picLocks noChangeAspect="1"/>
           </p:cNvPicPr>
@@ -18531,7 +18620,7 @@
       </p:sp>
       <p:pic>
         <p:nvPicPr>
-          <p:cNvPr id="3" name="Image 0" descr="/work/_shared/assets/logo-candidate-2.png">    </p:cNvPr>
+          <p:cNvPr id="3" name="Image 0" descr="/tmp/pcwork/api-patterns-and-practices-graphql/presentation/_shared/assets/logo-candidate-2.png">    </p:cNvPr>
           <p:cNvPicPr>
             <a:picLocks noChangeAspect="1"/>
           </p:cNvPicPr>
@@ -18633,7 +18722,7 @@
       </p:sp>
       <p:pic>
         <p:nvPicPr>
-          <p:cNvPr id="6" name="Image 1" descr="/work/_shared/png/16-cache-policy-decision.png">    </p:cNvPr>
+          <p:cNvPr id="6" name="Image 1" descr="/tmp/pcwork/api-patterns-and-practices-graphql/presentation/_shared/png/16-cache-policy-decision.png">    </p:cNvPr>
           <p:cNvPicPr>
             <a:picLocks noChangeAspect="1"/>
           </p:cNvPicPr>
@@ -18837,7 +18926,7 @@
       </p:sp>
       <p:pic>
         <p:nvPicPr>
-          <p:cNvPr id="5" name="Image 0" descr="/work/_shared/assets/redhat-logo-white.png">    </p:cNvPr>
+          <p:cNvPr id="5" name="Image 0" descr="/tmp/pcwork/api-patterns-and-practices-graphql/presentation/_shared/assets/redhat-logo-white.png">    </p:cNvPr>
           <p:cNvPicPr>
             <a:picLocks noChangeAspect="1"/>
           </p:cNvPicPr>
@@ -18925,7 +19014,7 @@
       </p:sp>
       <p:pic>
         <p:nvPicPr>
-          <p:cNvPr id="3" name="Image 0" descr="/work/_shared/assets/logo-candidate-2.png">    </p:cNvPr>
+          <p:cNvPr id="3" name="Image 0" descr="/tmp/pcwork/api-patterns-and-practices-graphql/presentation/_shared/assets/logo-candidate-2.png">    </p:cNvPr>
           <p:cNvPicPr>
             <a:picLocks noChangeAspect="1"/>
           </p:cNvPicPr>
@@ -19027,7 +19116,7 @@
       </p:sp>
       <p:pic>
         <p:nvPicPr>
-          <p:cNvPr id="6" name="Image 1" descr="/work/_shared/png/17-hardened-request-path.png">    </p:cNvPr>
+          <p:cNvPr id="6" name="Image 1" descr="/tmp/pcwork/api-patterns-and-practices-graphql/presentation/_shared/png/17-hardened-request-path.png">    </p:cNvPr>
           <p:cNvPicPr>
             <a:picLocks noChangeAspect="1"/>
           </p:cNvPicPr>
@@ -19153,7 +19242,7 @@
       </p:sp>
       <p:pic>
         <p:nvPicPr>
-          <p:cNvPr id="3" name="Image 0" descr="/work/_shared/assets/logo-candidate-2.png">    </p:cNvPr>
+          <p:cNvPr id="3" name="Image 0" descr="/tmp/pcwork/api-patterns-and-practices-graphql/presentation/_shared/assets/logo-candidate-2.png">    </p:cNvPr>
           <p:cNvPicPr>
             <a:picLocks noChangeAspect="1"/>
           </p:cNvPicPr>
@@ -19255,7 +19344,7 @@
       </p:sp>
       <p:pic>
         <p:nvPicPr>
-          <p:cNvPr id="6" name="Image 1" descr="/work/_shared/png/01-request-path.png">    </p:cNvPr>
+          <p:cNvPr id="6" name="Image 1" descr="/tmp/pcwork/api-patterns-and-practices-graphql/presentation/_shared/png/01-request-path.png">    </p:cNvPr>
           <p:cNvPicPr>
             <a:picLocks noChangeAspect="1"/>
           </p:cNvPicPr>
@@ -19381,7 +19470,7 @@
       </p:sp>
       <p:pic>
         <p:nvPicPr>
-          <p:cNvPr id="3" name="Image 0" descr="/work/_shared/assets/logo-candidate-2.png">    </p:cNvPr>
+          <p:cNvPr id="3" name="Image 0" descr="/tmp/pcwork/api-patterns-and-practices-graphql/presentation/_shared/assets/logo-candidate-2.png">    </p:cNvPr>
           <p:cNvPicPr>
             <a:picLocks noChangeAspect="1"/>
           </p:cNvPicPr>
@@ -19483,7 +19572,7 @@
       </p:sp>
       <p:pic>
         <p:nvPicPr>
-          <p:cNvPr id="6" name="Image 1" descr="/work/_shared/png/17-public-vs-internal-endpoints.png">    </p:cNvPr>
+          <p:cNvPr id="6" name="Image 1" descr="/tmp/pcwork/api-patterns-and-practices-graphql/presentation/_shared/png/17-public-vs-internal-endpoints.png">    </p:cNvPr>
           <p:cNvPicPr>
             <a:picLocks noChangeAspect="1"/>
           </p:cNvPicPr>
@@ -19609,7 +19698,7 @@
       </p:sp>
       <p:pic>
         <p:nvPicPr>
-          <p:cNvPr id="3" name="Image 0" descr="/work/_shared/assets/logo-candidate-2.png">    </p:cNvPr>
+          <p:cNvPr id="3" name="Image 0" descr="/tmp/pcwork/api-patterns-and-practices-graphql/presentation/_shared/assets/logo-candidate-2.png">    </p:cNvPr>
           <p:cNvPicPr>
             <a:picLocks noChangeAspect="1"/>
           </p:cNvPicPr>
@@ -19711,7 +19800,7 @@
       </p:sp>
       <p:pic>
         <p:nvPicPr>
-          <p:cNvPr id="6" name="Image 1" descr="/work/_shared/png/18-authorization-layers.png">    </p:cNvPr>
+          <p:cNvPr id="6" name="Image 1" descr="/tmp/pcwork/api-patterns-and-practices-graphql/presentation/_shared/png/18-authorization-layers.png">    </p:cNvPr>
           <p:cNvPicPr>
             <a:picLocks noChangeAspect="1"/>
           </p:cNvPicPr>
@@ -19837,7 +19926,7 @@
       </p:sp>
       <p:pic>
         <p:nvPicPr>
-          <p:cNvPr id="3" name="Image 0" descr="/work/_shared/assets/logo-candidate-2.png">    </p:cNvPr>
+          <p:cNvPr id="3" name="Image 0" descr="/tmp/pcwork/api-patterns-and-practices-graphql/presentation/_shared/assets/logo-candidate-2.png">    </p:cNvPr>
           <p:cNvPicPr>
             <a:picLocks noChangeAspect="1"/>
           </p:cNvPicPr>
@@ -19939,7 +20028,7 @@
       </p:sp>
       <p:pic>
         <p:nvPicPr>
-          <p:cNvPr id="6" name="Image 1" descr="/work/_shared/png/18-errors-vs-nulls.png">    </p:cNvPr>
+          <p:cNvPr id="6" name="Image 1" descr="/tmp/pcwork/api-patterns-and-practices-graphql/presentation/_shared/png/18-errors-vs-nulls.png">    </p:cNvPr>
           <p:cNvPicPr>
             <a:picLocks noChangeAspect="1"/>
           </p:cNvPicPr>
@@ -20143,7 +20232,7 @@
       </p:sp>
       <p:pic>
         <p:nvPicPr>
-          <p:cNvPr id="5" name="Image 0" descr="/work/_shared/assets/redhat-logo-white.png">    </p:cNvPr>
+          <p:cNvPr id="5" name="Image 0" descr="/tmp/pcwork/api-patterns-and-practices-graphql/presentation/_shared/assets/redhat-logo-white.png">    </p:cNvPr>
           <p:cNvPicPr>
             <a:picLocks noChangeAspect="1"/>
           </p:cNvPicPr>
@@ -20231,7 +20320,7 @@
       </p:sp>
       <p:pic>
         <p:nvPicPr>
-          <p:cNvPr id="3" name="Image 0" descr="/work/_shared/assets/logo-candidate-2.png">    </p:cNvPr>
+          <p:cNvPr id="3" name="Image 0" descr="/tmp/pcwork/api-patterns-and-practices-graphql/presentation/_shared/assets/logo-candidate-2.png">    </p:cNvPr>
           <p:cNvPicPr>
             <a:picLocks noChangeAspect="1"/>
           </p:cNvPicPr>
@@ -20333,7 +20422,7 @@
       </p:sp>
       <p:pic>
         <p:nvPicPr>
-          <p:cNvPr id="6" name="Image 1" descr="/work/_shared/png/19-one-endpoint-blind-spot.png">    </p:cNvPr>
+          <p:cNvPr id="6" name="Image 1" descr="/tmp/pcwork/api-patterns-and-practices-graphql/presentation/_shared/png/19-one-endpoint-blind-spot.png">    </p:cNvPr>
           <p:cNvPicPr>
             <a:picLocks noChangeAspect="1"/>
           </p:cNvPicPr>
@@ -20459,7 +20548,7 @@
       </p:sp>
       <p:pic>
         <p:nvPicPr>
-          <p:cNvPr id="3" name="Image 0" descr="/work/_shared/assets/logo-candidate-2.png">    </p:cNvPr>
+          <p:cNvPr id="3" name="Image 0" descr="/tmp/pcwork/api-patterns-and-practices-graphql/presentation/_shared/assets/logo-candidate-2.png">    </p:cNvPr>
           <p:cNvPicPr>
             <a:picLocks noChangeAspect="1"/>
           </p:cNvPicPr>
@@ -20561,7 +20650,7 @@
       </p:sp>
       <p:pic>
         <p:nvPicPr>
-          <p:cNvPr id="6" name="Image 1" descr="/work/_shared/png/19-span-per-resolver.png">    </p:cNvPr>
+          <p:cNvPr id="6" name="Image 1" descr="/tmp/pcwork/api-patterns-and-practices-graphql/presentation/_shared/png/19-span-per-resolver.png">    </p:cNvPr>
           <p:cNvPicPr>
             <a:picLocks noChangeAspect="1"/>
           </p:cNvPicPr>
@@ -20687,7 +20776,7 @@
       </p:sp>
       <p:pic>
         <p:nvPicPr>
-          <p:cNvPr id="3" name="Image 0" descr="/work/_shared/assets/logo-candidate-2.png">    </p:cNvPr>
+          <p:cNvPr id="3" name="Image 0" descr="/tmp/pcwork/api-patterns-and-practices-graphql/presentation/_shared/assets/logo-candidate-2.png">    </p:cNvPr>
           <p:cNvPicPr>
             <a:picLocks noChangeAspect="1"/>
           </p:cNvPicPr>
@@ -20789,7 +20878,7 @@
       </p:sp>
       <p:pic>
         <p:nvPicPr>
-          <p:cNvPr id="6" name="Image 1" descr="/work/_shared/png/20-subgraph-ownership.png">    </p:cNvPr>
+          <p:cNvPr id="6" name="Image 1" descr="/tmp/pcwork/api-patterns-and-practices-graphql/presentation/_shared/png/20-subgraph-ownership.png">    </p:cNvPr>
           <p:cNvPicPr>
             <a:picLocks noChangeAspect="1"/>
           </p:cNvPicPr>
@@ -20915,7 +21004,7 @@
       </p:sp>
       <p:pic>
         <p:nvPicPr>
-          <p:cNvPr id="3" name="Image 0" descr="/work/_shared/assets/logo-candidate-2.png">    </p:cNvPr>
+          <p:cNvPr id="3" name="Image 0" descr="/tmp/pcwork/api-patterns-and-practices-graphql/presentation/_shared/assets/logo-candidate-2.png">    </p:cNvPr>
           <p:cNvPicPr>
             <a:picLocks noChangeAspect="1"/>
           </p:cNvPicPr>
@@ -21017,7 +21106,7 @@
       </p:sp>
       <p:pic>
         <p:nvPicPr>
-          <p:cNvPr id="6" name="Image 1" descr="/work/_shared/png/20-query-plan.png">    </p:cNvPr>
+          <p:cNvPr id="6" name="Image 1" descr="/tmp/pcwork/api-patterns-and-practices-graphql/presentation/_shared/png/20-query-plan.png">    </p:cNvPr>
           <p:cNvPicPr>
             <a:picLocks noChangeAspect="1"/>
           </p:cNvPicPr>
@@ -21221,7 +21310,7 @@
       </p:sp>
       <p:pic>
         <p:nvPicPr>
-          <p:cNvPr id="5" name="Image 0" descr="/work/_shared/assets/redhat-logo-white.png">    </p:cNvPr>
+          <p:cNvPr id="5" name="Image 0" descr="/tmp/pcwork/api-patterns-and-practices-graphql/presentation/_shared/assets/redhat-logo-white.png">    </p:cNvPr>
           <p:cNvPicPr>
             <a:picLocks noChangeAspect="1"/>
           </p:cNvPicPr>
@@ -21309,7 +21398,7 @@
       </p:sp>
       <p:pic>
         <p:nvPicPr>
-          <p:cNvPr id="3" name="Image 0" descr="/work/_shared/assets/logo-candidate-2.png">    </p:cNvPr>
+          <p:cNvPr id="3" name="Image 0" descr="/tmp/pcwork/api-patterns-and-practices-graphql/presentation/_shared/assets/logo-candidate-2.png">    </p:cNvPr>
           <p:cNvPicPr>
             <a:picLocks noChangeAspect="1"/>
           </p:cNvPicPr>
@@ -21411,7 +21500,7 @@
       </p:sp>
       <p:pic>
         <p:nvPicPr>
-          <p:cNvPr id="6" name="Image 1" descr="/work/_shared/png/21-three-ways-to-push.png">    </p:cNvPr>
+          <p:cNvPr id="6" name="Image 1" descr="/tmp/pcwork/api-patterns-and-practices-graphql/presentation/_shared/png/21-three-ways-to-push.png">    </p:cNvPr>
           <p:cNvPicPr>
             <a:picLocks noChangeAspect="1"/>
           </p:cNvPicPr>
@@ -21537,7 +21626,7 @@
       </p:sp>
       <p:pic>
         <p:nvPicPr>
-          <p:cNvPr id="3" name="Image 0" descr="/work/_shared/assets/logo-candidate-2.png">    </p:cNvPr>
+          <p:cNvPr id="3" name="Image 0" descr="/tmp/pcwork/api-patterns-and-practices-graphql/presentation/_shared/assets/logo-candidate-2.png">    </p:cNvPr>
           <p:cNvPicPr>
             <a:picLocks noChangeAspect="1"/>
           </p:cNvPicPr>
@@ -21755,7 +21844,7 @@
                 <a:ea typeface="Red Hat Mono" pitchFamily="34" charset="-122"/>
                 <a:cs typeface="Red Hat Mono" pitchFamily="34" charset="-120"/>
               </a:rPr>
-              <a:t>query TrackCargo($id: TrackingId!) {
+              <a:t>
 </a:t>
             </a:r>
             <a:pPr algn="l" indent="0" marL="0">
@@ -21773,7 +21862,7 @@
                 <a:ea typeface="Red Hat Mono" pitchFamily="34" charset="-122"/>
                 <a:cs typeface="Red Hat Mono" pitchFamily="34" charset="-120"/>
               </a:rPr>
-              <a:t>  cargo(trackingId: $id) {
+              <a:t>The services behind the tracking view own the data and the rules. The cargo service decides what a booking is. The routing service decides which itinerary satisfies a route specification. The handling service records what physically happened. The delivery state is derived from those events and the itinerary, and Chapter 7 puts that derivation in the tracking view. Each of them may speak REST or gRPC, exactly as the sibling books describe, and none of them needs to know GraphQL exists. The tracking view owns no business data. It owns a schema, a set of resolvers that know which service to ask for which field, and the logic that stitches the answers into a graph and derives the delivery state.
 </a:t>
             </a:r>
             <a:pPr algn="l" indent="0" marL="0">
@@ -21791,7 +21880,7 @@
                 <a:ea typeface="Red Hat Mono" pitchFamily="34" charset="-122"/>
                 <a:cs typeface="Red Hat Mono" pitchFamily="34" charset="-120"/>
               </a:rPr>
-              <a:t>    trackingId
+              <a:t>
 </a:t>
             </a:r>
             <a:pPr algn="l" indent="0" marL="0">
@@ -21809,7 +21898,7 @@
                 <a:ea typeface="Red Hat Mono" pitchFamily="34" charset="-122"/>
                 <a:cs typeface="Red Hat Mono" pitchFamily="34" charset="-120"/>
               </a:rPr>
-              <a:t>    origin { unLocode name }
+              <a:t>This division keeps the strengths of each paradigm where they belong. Writes go through the owning services with the validation, idempotency and transactional rules those services already enforce. Internal calls keep the speed and typing of gRPC. Clients get one place to ask questions, one schema to learn and one round trip per screen. The schema is the contract between the tracking view and every client, and it lives in the repository as SDL under `contracts/schema/`. Both implementation stacks in this book, Quarkus with SmallRye GraphQL and Python with Strawberry, are checked against that same schema, so the contract does not depend on a language.
 </a:t>
             </a:r>
             <a:pPr algn="l" indent="0" marL="0">
@@ -21827,7 +21916,7 @@
                 <a:ea typeface="Red Hat Mono" pitchFamily="34" charset="-122"/>
                 <a:cs typeface="Red Hat Mono" pitchFamily="34" charset="-120"/>
               </a:rPr>
-              <a:t>    destination { unLocode name }
+              <a:t>
 </a:t>
             </a:r>
             <a:pPr algn="l" indent="0" marL="0">
@@ -21845,7 +21934,7 @@
                 <a:ea typeface="Red Hat Mono" pitchFamily="34" charset="-122"/>
                 <a:cs typeface="Red Hat Mono" pitchFamily="34" charset="-120"/>
               </a:rPr>
-              <a:t>    delivery {
+              <a:t>The read-oriented emphasis is a design choice. The schema does contain one mutation, `registerHandlingEvent`, because recording a handling event is the one write a tracking client legitimately initiates, and Chapter 8 treats mutations in detail. Booking a cargo and assigning its route remain REST and gRPC operations in the owning services. Chapter 2 gives the criteria that put each interaction on its side of that line.
 </a:t>
             </a:r>
             <a:pPr algn="l" indent="0" marL="0">
@@ -21863,7 +21952,7 @@
                 <a:ea typeface="Red Hat Mono" pitchFamily="34" charset="-122"/>
                 <a:cs typeface="Red Hat Mono" pitchFamily="34" charset="-120"/>
               </a:rPr>
-              <a:t>      transportStatus
+              <a:t>
 </a:t>
             </a:r>
             <a:pPr algn="l" indent="0" marL="0">
@@ -21875,13 +21964,13 @@
             <a:r>
               <a:rPr lang="en-US" sz="1000" dirty="0">
                 <a:solidFill>
-                  <a:srgbClr val="E6E6E6"/>
+                  <a:srgbClr val="8FB98F"/>
                 </a:solidFill>
                 <a:latin typeface="Red Hat Mono" pitchFamily="34" charset="0"/>
                 <a:ea typeface="Red Hat Mono" pitchFamily="34" charset="-122"/>
                 <a:cs typeface="Red Hat Mono" pitchFamily="34" charset="-120"/>
               </a:rPr>
-              <a:t>      lastKnownLocation { name }
+              <a:t>## What a query looks like
 </a:t>
             </a:r>
             <a:pPr algn="l" indent="0" marL="0">
@@ -21899,7 +21988,7 @@
                 <a:ea typeface="Red Hat Mono" pitchFamily="34" charset="-122"/>
                 <a:cs typeface="Red Hat Mono" pitchFamily="34" charset="-120"/>
               </a:rPr>
-              <a:t>      estimatedTimeOfArrival
+              <a:t>
 </a:t>
             </a:r>
             <a:pPr algn="l" indent="0" marL="0">
@@ -21917,7 +22006,7 @@
                 <a:ea typeface="Red Hat Mono" pitchFamily="34" charset="-122"/>
                 <a:cs typeface="Red Hat Mono" pitchFamily="34" charset="-120"/>
               </a:rPr>
-              <a:t>  ...
+              <a:t>      ...
 </a:t>
             </a:r>
             <a:pPr algn="l" indent="0" marL="0">
@@ -21935,7 +22024,7 @@
                 <a:ea typeface="Red Hat Mono" pitchFamily="34" charset="-122"/>
                 <a:cs typeface="Red Hat Mono" pitchFamily="34" charset="-120"/>
               </a:rPr>
-              <a:t>  }
+              <a:t>      legs {
 </a:t>
             </a:r>
             <a:pPr algn="l" indent="0" marL="0">
@@ -21953,7 +22042,7 @@
                 <a:ea typeface="Red Hat Mono" pitchFamily="34" charset="-122"/>
                 <a:cs typeface="Red Hat Mono" pitchFamily="34" charset="-120"/>
               </a:rPr>
-              <a:t>}
+              <a:t>        voyage { number }
 </a:t>
             </a:r>
             <a:pPr algn="l" indent="0" marL="0">
@@ -21971,7 +22060,7 @@
                 <a:ea typeface="Red Hat Mono" pitchFamily="34" charset="-122"/>
                 <a:cs typeface="Red Hat Mono" pitchFamily="34" charset="-120"/>
               </a:rPr>
-              <a:t>...
+              <a:t>        ...
 </a:t>
             </a:r>
             <a:pPr algn="l" indent="0" marL="0">
@@ -21989,7 +22078,7 @@
                 <a:ea typeface="Red Hat Mono" pitchFamily="34" charset="-122"/>
                 <a:cs typeface="Red Hat Mono" pitchFamily="34" charset="-120"/>
               </a:rPr>
-              <a:t>{
+              <a:t>        node { type location { unLocode } completionTime }
 </a:t>
             </a:r>
             <a:pPr algn="l" indent="0" marL="0">
@@ -22007,7 +22096,7 @@
                 <a:ea typeface="Red Hat Mono" pitchFamily="34" charset="-122"/>
                 <a:cs typeface="Red Hat Mono" pitchFamily="34" charset="-120"/>
               </a:rPr>
-              <a:t>  "data": {
+              <a:t>      }
 </a:t>
             </a:r>
             <a:pPr algn="l" indent="0" marL="0">
@@ -22025,7 +22114,7 @@
                 <a:ea typeface="Red Hat Mono" pitchFamily="34" charset="-122"/>
                 <a:cs typeface="Red Hat Mono" pitchFamily="34" charset="-120"/>
               </a:rPr>
-              <a:t>    "cargo": {
+              <a:t>    }
 </a:t>
             </a:r>
             <a:pPr algn="l" indent="0" marL="0">
@@ -22043,7 +22132,7 @@
                 <a:ea typeface="Red Hat Mono" pitchFamily="34" charset="-122"/>
                 <a:cs typeface="Red Hat Mono" pitchFamily="34" charset="-120"/>
               </a:rPr>
-              <a:t>      "trackingId": "ABC123",
+              <a:t>  }
 </a:t>
             </a:r>
             <a:pPr algn="l" indent="0" marL="0">
@@ -22061,7 +22150,7 @@
                 <a:ea typeface="Red Hat Mono" pitchFamily="34" charset="-122"/>
                 <a:cs typeface="Red Hat Mono" pitchFamily="34" charset="-120"/>
               </a:rPr>
-              <a:t>      "origin": { "unLocode": "USNYC", "name": "New York" },
+              <a:t>}
 </a:t>
             </a:r>
             <a:pPr algn="l" indent="0" marL="0">
@@ -22079,7 +22168,7 @@
                 <a:ea typeface="Red Hat Mono" pitchFamily="34" charset="-122"/>
                 <a:cs typeface="Red Hat Mono" pitchFamily="34" charset="-120"/>
               </a:rPr>
-              <a:t>      "destination": { "unLocode": "NLRTM", "name": "Rotterdam" },
+              <a:t>```
 </a:t>
             </a:r>
             <a:pPr algn="l" indent="0" marL="0">
@@ -22097,7 +22186,7 @@
                 <a:ea typeface="Red Hat Mono" pitchFamily="34" charset="-122"/>
                 <a:cs typeface="Red Hat Mono" pitchFamily="34" charset="-120"/>
               </a:rPr>
-              <a:t>      "delivery": {
+              <a:t>
 </a:t>
             </a:r>
             <a:pPr algn="l" indent="0" marL="0">
@@ -22115,7 +22204,7 @@
                 <a:ea typeface="Red Hat Mono" pitchFamily="34" charset="-122"/>
                 <a:cs typeface="Red Hat Mono" pitchFamily="34" charset="-120"/>
               </a:rPr>
-              <a:t>        "transportStatus": "ONBOARD_CARRIER",
+              <a:t>The operation takes one variable, `$id`, typed with the schema's `TrackingId` scalar and marked non-null with `!`. The root field `cargo` resolves one `Cargo` by tracking id. Inside it, `origin`, `destination` and `lastKnownLocation` are `Location` objects of which the client asks only for the UN/LOCODE and the name. `itinerary` is nullable in the schema because a cargo that has not been routed has none, and `handlingHistory(first: 2)` uses the Relay connection pattern that Chapter 12 covers: edges that wrap nodes, so the client can page through events newest first.
 </a:t>
             </a:r>
             <a:pPr algn="l" indent="0" marL="0">
@@ -22133,7 +22222,7 @@
                 <a:ea typeface="Red Hat Mono" pitchFamily="34" charset="-122"/>
                 <a:cs typeface="Red Hat Mono" pitchFamily="34" charset="-120"/>
               </a:rPr>
-              <a:t>        "lastKnownLocation": { "name": "New York" },
+              <a:t>
 </a:t>
             </a:r>
             <a:pPr algn="l" indent="0" marL="0">
@@ -22151,7 +22240,7 @@
                 <a:ea typeface="Red Hat Mono" pitchFamily="34" charset="-122"/>
                 <a:cs typeface="Red Hat Mono" pitchFamily="34" charset="-120"/>
               </a:rPr>
-              <a:t>        "estimatedTimeOfArrival": "2026-10-11T18:00:00Z",
+              <a:t>The response mirrors the selection field for field:
 </a:t>
             </a:r>
             <a:pPr algn="l" indent="0" marL="0">
@@ -22281,7 +22370,7 @@
       </p:sp>
       <p:pic>
         <p:nvPicPr>
-          <p:cNvPr id="3" name="Image 0" descr="/work/_shared/assets/logo-candidate-2.png">    </p:cNvPr>
+          <p:cNvPr id="3" name="Image 0" descr="/tmp/pcwork/api-patterns-and-practices-graphql/presentation/_shared/assets/logo-candidate-2.png">    </p:cNvPr>
           <p:cNvPicPr>
             <a:picLocks noChangeAspect="1"/>
           </p:cNvPicPr>
@@ -23305,7 +23394,7 @@
       </p:sp>
       <p:pic>
         <p:nvPicPr>
-          <p:cNvPr id="3" name="Image 0" descr="/work/_shared/assets/logo-candidate-2.png">    </p:cNvPr>
+          <p:cNvPr id="3" name="Image 0" descr="/tmp/pcwork/api-patterns-and-practices-graphql/presentation/_shared/assets/logo-candidate-2.png">    </p:cNvPr>
           <p:cNvPicPr>
             <a:picLocks noChangeAspect="1"/>
           </p:cNvPicPr>
@@ -23407,7 +23496,7 @@
       </p:sp>
       <p:pic>
         <p:nvPicPr>
-          <p:cNvPr id="6" name="Image 1" descr="/work/_shared/png/22-normalized-cache-update.png">    </p:cNvPr>
+          <p:cNvPr id="6" name="Image 1" descr="/tmp/pcwork/api-patterns-and-practices-graphql/presentation/_shared/png/22-normalized-cache-update.png">    </p:cNvPr>
           <p:cNvPicPr>
             <a:picLocks noChangeAspect="1"/>
           </p:cNvPicPr>
@@ -23611,7 +23700,7 @@
       </p:sp>
       <p:pic>
         <p:nvPicPr>
-          <p:cNvPr id="5" name="Image 0" descr="/work/_shared/assets/redhat-logo-white.png">    </p:cNvPr>
+          <p:cNvPr id="5" name="Image 0" descr="/tmp/pcwork/api-patterns-and-practices-graphql/presentation/_shared/assets/redhat-logo-white.png">    </p:cNvPr>
           <p:cNvPicPr>
             <a:picLocks noChangeAspect="1"/>
           </p:cNvPicPr>
@@ -23699,7 +23788,7 @@
       </p:sp>
       <p:pic>
         <p:nvPicPr>
-          <p:cNvPr id="3" name="Image 0" descr="/work/_shared/assets/logo-candidate-2.png">    </p:cNvPr>
+          <p:cNvPr id="3" name="Image 0" descr="/tmp/pcwork/api-patterns-and-practices-graphql/presentation/_shared/assets/logo-candidate-2.png">    </p:cNvPr>
           <p:cNvPicPr>
             <a:picLocks noChangeAspect="1"/>
           </p:cNvPicPr>
@@ -23801,7 +23890,7 @@
       </p:sp>
       <p:pic>
         <p:nvPicPr>
-          <p:cNvPr id="6" name="Image 1" descr="/work/_shared/png/23-test-layers.png">    </p:cNvPr>
+          <p:cNvPr id="6" name="Image 1" descr="/tmp/pcwork/api-patterns-and-practices-graphql/presentation/_shared/png/23-test-layers.png">    </p:cNvPr>
           <p:cNvPicPr>
             <a:picLocks noChangeAspect="1"/>
           </p:cNvPicPr>
@@ -23927,7 +24016,7 @@
       </p:sp>
       <p:pic>
         <p:nvPicPr>
-          <p:cNvPr id="3" name="Image 0" descr="/work/_shared/assets/logo-candidate-2.png">    </p:cNvPr>
+          <p:cNvPr id="3" name="Image 0" descr="/tmp/pcwork/api-patterns-and-practices-graphql/presentation/_shared/assets/logo-candidate-2.png">    </p:cNvPr>
           <p:cNvPicPr>
             <a:picLocks noChangeAspect="1"/>
           </p:cNvPicPr>
@@ -24029,7 +24118,7 @@
       </p:sp>
       <p:pic>
         <p:nvPicPr>
-          <p:cNvPr id="6" name="Image 1" descr="/work/_shared/png/24-diagnosis-path.png">    </p:cNvPr>
+          <p:cNvPr id="6" name="Image 1" descr="/tmp/pcwork/api-patterns-and-practices-graphql/presentation/_shared/png/24-diagnosis-path.png">    </p:cNvPr>
           <p:cNvPicPr>
             <a:picLocks noChangeAspect="1"/>
           </p:cNvPicPr>
@@ -24233,7 +24322,7 @@
       </p:sp>
       <p:pic>
         <p:nvPicPr>
-          <p:cNvPr id="5" name="Image 0" descr="/work/_shared/assets/redhat-logo-white.png">    </p:cNvPr>
+          <p:cNvPr id="5" name="Image 0" descr="/tmp/pcwork/api-patterns-and-practices-graphql/presentation/_shared/assets/redhat-logo-white.png">    </p:cNvPr>
           <p:cNvPicPr>
             <a:picLocks noChangeAspect="1"/>
           </p:cNvPicPr>
@@ -24321,7 +24410,7 @@
       </p:sp>
       <p:pic>
         <p:nvPicPr>
-          <p:cNvPr id="3" name="Image 0" descr="/work/_shared/assets/logo-candidate-2.png">    </p:cNvPr>
+          <p:cNvPr id="3" name="Image 0" descr="/tmp/pcwork/api-patterns-and-practices-graphql/presentation/_shared/assets/logo-candidate-2.png">    </p:cNvPr>
           <p:cNvPicPr>
             <a:picLocks noChangeAspect="1"/>
           </p:cNvPicPr>
@@ -24423,7 +24512,7 @@
       </p:sp>
       <p:pic>
         <p:nvPicPr>
-          <p:cNvPr id="6" name="Image 1" descr="/work/_shared/png/26-compose-to-kubernetes.png">    </p:cNvPr>
+          <p:cNvPr id="6" name="Image 1" descr="/tmp/pcwork/api-patterns-and-practices-graphql/presentation/_shared/png/26-compose-to-kubernetes.png">    </p:cNvPr>
           <p:cNvPicPr>
             <a:picLocks noChangeAspect="1"/>
           </p:cNvPicPr>
@@ -24549,7 +24638,7 @@
       </p:sp>
       <p:pic>
         <p:nvPicPr>
-          <p:cNvPr id="3" name="Image 0" descr="/work/_shared/assets/logo-candidate-2.png">    </p:cNvPr>
+          <p:cNvPr id="3" name="Image 0" descr="/tmp/pcwork/api-patterns-and-practices-graphql/presentation/_shared/assets/logo-candidate-2.png">    </p:cNvPr>
           <p:cNvPicPr>
             <a:picLocks noChangeAspect="1"/>
           </p:cNvPicPr>
@@ -24651,7 +24740,7 @@
       </p:sp>
       <p:pic>
         <p:nvPicPr>
-          <p:cNvPr id="6" name="Image 1" descr="/work/_shared/png/27-final-architecture.png">    </p:cNvPr>
+          <p:cNvPr id="6" name="Image 1" descr="/tmp/pcwork/api-patterns-and-practices-graphql/presentation/_shared/png/27-final-architecture.png">    </p:cNvPr>
           <p:cNvPicPr>
             <a:picLocks noChangeAspect="1"/>
           </p:cNvPicPr>
@@ -24777,7 +24866,7 @@
       </p:sp>
       <p:pic>
         <p:nvPicPr>
-          <p:cNvPr id="3" name="Image 0" descr="/work/_shared/assets/logo-candidate-2.png">    </p:cNvPr>
+          <p:cNvPr id="3" name="Image 0" descr="/tmp/pcwork/api-patterns-and-practices-graphql/presentation/_shared/assets/logo-candidate-2.png">    </p:cNvPr>
           <p:cNvPicPr>
             <a:picLocks noChangeAspect="1"/>
           </p:cNvPicPr>
@@ -24879,7 +24968,7 @@
       </p:sp>
       <p:pic>
         <p:nvPicPr>
-          <p:cNvPr id="6" name="Image 1" descr="/work/_shared/png/27-request-defences.png">    </p:cNvPr>
+          <p:cNvPr id="6" name="Image 1" descr="/tmp/pcwork/api-patterns-and-practices-graphql/presentation/_shared/png/27-request-defences.png">    </p:cNvPr>
           <p:cNvPicPr>
             <a:picLocks noChangeAspect="1"/>
           </p:cNvPicPr>
@@ -25005,7 +25094,7 @@
       </p:sp>
       <p:pic>
         <p:nvPicPr>
-          <p:cNvPr id="3" name="Image 0" descr="/work/_shared/assets/logo-candidate-2.png">    </p:cNvPr>
+          <p:cNvPr id="3" name="Image 0" descr="/tmp/pcwork/api-patterns-and-practices-graphql/presentation/_shared/assets/logo-candidate-2.png">    </p:cNvPr>
           <p:cNvPicPr>
             <a:picLocks noChangeAspect="1"/>
           </p:cNvPicPr>
@@ -26620,7 +26709,7 @@
       </p:sp>
       <p:pic>
         <p:nvPicPr>
-          <p:cNvPr id="3" name="Image 0" descr="/work/_shared/assets/logo-candidate-2.png">    </p:cNvPr>
+          <p:cNvPr id="3" name="Image 0" descr="/tmp/pcwork/api-patterns-and-practices-graphql/presentation/_shared/assets/logo-candidate-2.png">    </p:cNvPr>
           <p:cNvPicPr>
             <a:picLocks noChangeAspect="1"/>
           </p:cNvPicPr>
@@ -28510,7 +28599,7 @@
       </p:sp>
       <p:pic>
         <p:nvPicPr>
-          <p:cNvPr id="5" name="Image 0" descr="/work/_shared/assets/redhat-logo-white.png">    </p:cNvPr>
+          <p:cNvPr id="5" name="Image 0" descr="/tmp/pcwork/api-patterns-and-practices-graphql/presentation/_shared/assets/redhat-logo-white.png">    </p:cNvPr>
           <p:cNvPicPr>
             <a:picLocks noChangeAspect="1"/>
           </p:cNvPicPr>
@@ -28598,7 +28687,7 @@
       </p:sp>
       <p:pic>
         <p:nvPicPr>
-          <p:cNvPr id="3" name="Image 0" descr="/work/_shared/assets/logo-candidate-2.png">    </p:cNvPr>
+          <p:cNvPr id="3" name="Image 0" descr="/tmp/pcwork/api-patterns-and-practices-graphql/presentation/_shared/assets/logo-candidate-2.png">    </p:cNvPr>
           <p:cNvPicPr>
             <a:picLocks noChangeAspect="1"/>
           </p:cNvPicPr>
@@ -29288,7 +29377,7 @@
       </p:sp>
       <p:pic>
         <p:nvPicPr>
-          <p:cNvPr id="3" name="Image 0" descr="/work/_shared/assets/logo-candidate-2.png">    </p:cNvPr>
+          <p:cNvPr id="3" name="Image 0" descr="/tmp/pcwork/api-patterns-and-practices-graphql/presentation/_shared/assets/logo-candidate-2.png">    </p:cNvPr>
           <p:cNvPicPr>
             <a:picLocks noChangeAspect="1"/>
           </p:cNvPicPr>
@@ -29978,7 +30067,7 @@
       </p:sp>
       <p:pic>
         <p:nvPicPr>
-          <p:cNvPr id="3" name="Image 0" descr="/work/_shared/assets/logo-candidate-2.png">    </p:cNvPr>
+          <p:cNvPr id="3" name="Image 0" descr="/tmp/pcwork/api-patterns-and-practices-graphql/presentation/_shared/assets/logo-candidate-2.png">    </p:cNvPr>
           <p:cNvPicPr>
             <a:picLocks noChangeAspect="1"/>
           </p:cNvPicPr>
@@ -30704,7 +30793,7 @@
       </p:sp>
       <p:pic>
         <p:nvPicPr>
-          <p:cNvPr id="3" name="Image 0" descr="/work/_shared/assets/logo-candidate-2.png">    </p:cNvPr>
+          <p:cNvPr id="3" name="Image 0" descr="/tmp/pcwork/api-patterns-and-practices-graphql/presentation/_shared/assets/logo-candidate-2.png">    </p:cNvPr>
           <p:cNvPicPr>
             <a:picLocks noChangeAspect="1"/>
           </p:cNvPicPr>
@@ -31304,7 +31393,7 @@
       </p:sp>
       <p:pic>
         <p:nvPicPr>
-          <p:cNvPr id="3" name="Image 0" descr="/work/_shared/assets/logo-candidate-2.png">    </p:cNvPr>
+          <p:cNvPr id="3" name="Image 0" descr="/tmp/pcwork/api-patterns-and-practices-graphql/presentation/_shared/assets/logo-candidate-2.png">    </p:cNvPr>
           <p:cNvPicPr>
             <a:picLocks noChangeAspect="1"/>
           </p:cNvPicPr>
@@ -32919,7 +33008,7 @@
       </p:sp>
       <p:pic>
         <p:nvPicPr>
-          <p:cNvPr id="3" name="Image 0" descr="/work/_shared/assets/logo-candidate-2.png">    </p:cNvPr>
+          <p:cNvPr id="3" name="Image 0" descr="/tmp/pcwork/api-patterns-and-practices-graphql/presentation/_shared/assets/logo-candidate-2.png">    </p:cNvPr>
           <p:cNvPicPr>
             <a:picLocks noChangeAspect="1"/>
           </p:cNvPicPr>
@@ -33693,7 +33782,7 @@
       </p:sp>
       <p:pic>
         <p:nvPicPr>
-          <p:cNvPr id="3" name="Image 0" descr="/work/_shared/assets/logo-candidate-2.png">    </p:cNvPr>
+          <p:cNvPr id="3" name="Image 0" descr="/tmp/pcwork/api-patterns-and-practices-graphql/presentation/_shared/assets/logo-candidate-2.png">    </p:cNvPr>
           <p:cNvPicPr>
             <a:picLocks noChangeAspect="1"/>
           </p:cNvPicPr>
@@ -34064,7 +34153,7 @@
       </p:sp>
       <p:pic>
         <p:nvPicPr>
-          <p:cNvPr id="3" name="Image 0" descr="/work/_shared/assets/logo-candidate-2.png">    </p:cNvPr>
+          <p:cNvPr id="3" name="Image 0" descr="/tmp/pcwork/api-patterns-and-practices-graphql/presentation/_shared/assets/logo-candidate-2.png">    </p:cNvPr>
           <p:cNvPicPr>
             <a:picLocks noChangeAspect="1"/>
           </p:cNvPicPr>
@@ -34270,6 +34359,454 @@
               <a:t>Red Hat is the world's leading provider of enterprise open source software solutions.</a:t>
             </a:r>
             <a:endParaRPr lang="en-US" sz="1300" dirty="0"/>
+          </a:p>
+        </p:txBody>
+      </p:sp>
+    </p:spTree>
+  </p:cSld>
+  <p:clrMapOvr>
+    <a:masterClrMapping/>
+  </p:clrMapOvr>
+</p:sld>
+</file>
+
+<file path=ppt/slides/slide79.xml><?xml version="1.0" encoding="utf-8"?>
+<p:sld xmlns:a="http://schemas.openxmlformats.org/drawingml/2006/main" xmlns:r="http://schemas.openxmlformats.org/officeDocument/2006/relationships" xmlns:p="http://schemas.openxmlformats.org/presentationml/2006/main">
+  <p:cSld name="Slide 79">
+    <p:spTree>
+      <p:nvGrpSpPr>
+        <p:cNvPr id="1" name=""/>
+        <p:cNvGrpSpPr/>
+        <p:nvPr/>
+      </p:nvGrpSpPr>
+      <p:grpSpPr>
+        <a:xfrm>
+          <a:off x="0" y="0"/>
+          <a:ext cx="0" cy="0"/>
+          <a:chOff x="0" y="0"/>
+          <a:chExt cx="0" cy="0"/>
+        </a:xfrm>
+      </p:grpSpPr>
+      <p:sp>
+        <p:nvSpPr>
+          <p:cNvPr id="2" name="Text 0"/>
+          <p:cNvSpPr/>
+          <p:nvPr/>
+        </p:nvSpPr>
+        <p:spPr>
+          <a:xfrm>
+            <a:off x="566928" y="6364224"/>
+            <a:ext cx="914400" cy="274320"/>
+          </a:xfrm>
+          <a:prstGeom prst="rect">
+            <a:avLst/>
+          </a:prstGeom>
+          <a:noFill/>
+          <a:ln/>
+        </p:spPr>
+        <p:txBody>
+          <a:bodyPr wrap="square" rtlCol="0" anchor="ctr"/>
+          <a:lstStyle/>
+          <a:p>
+            <a:pPr algn="l" indent="0" marL="0">
+              <a:buNone/>
+            </a:pPr>
+            <a:r>
+              <a:rPr lang="en-US" sz="1000" dirty="0">
+                <a:solidFill>
+                  <a:srgbClr val="8A8A8A"/>
+                </a:solidFill>
+                <a:latin typeface="Red Hat Text" pitchFamily="34" charset="0"/>
+                <a:ea typeface="Red Hat Text" pitchFamily="34" charset="-122"/>
+                <a:cs typeface="Red Hat Text" pitchFamily="34" charset="-120"/>
+              </a:rPr>
+              <a:t>79</a:t>
+            </a:r>
+            <a:endParaRPr lang="en-US" sz="1000" dirty="0"/>
+          </a:p>
+        </p:txBody>
+      </p:sp>
+      <p:pic>
+        <p:nvPicPr>
+          <p:cNvPr id="3" name="Image 0" descr="/tmp/pcwork/api-patterns-and-practices-graphql/presentation/_shared/assets/logo-candidate-2.png">    </p:cNvPr>
+          <p:cNvPicPr>
+            <a:picLocks noChangeAspect="1"/>
+          </p:cNvPicPr>
+          <p:nvPr/>
+        </p:nvPicPr>
+        <p:blipFill>
+          <a:blip r:embed="rId1"/>
+          <a:stretch>
+            <a:fillRect/>
+          </a:stretch>
+        </p:blipFill>
+        <p:spPr>
+          <a:xfrm>
+            <a:off x="10561320" y="6355080"/>
+            <a:ext cx="1033272" cy="246888"/>
+          </a:xfrm>
+          <a:prstGeom prst="rect">
+            <a:avLst/>
+          </a:prstGeom>
+        </p:spPr>
+      </p:pic>
+      <p:sp>
+        <p:nvSpPr>
+          <p:cNvPr id="4" name="Text 1"/>
+          <p:cNvSpPr/>
+          <p:nvPr/>
+        </p:nvSpPr>
+        <p:spPr>
+          <a:xfrm>
+            <a:off x="566928" y="384048"/>
+            <a:ext cx="11055096" cy="292608"/>
+          </a:xfrm>
+          <a:prstGeom prst="rect">
+            <a:avLst/>
+          </a:prstGeom>
+          <a:noFill/>
+          <a:ln/>
+        </p:spPr>
+        <p:txBody>
+          <a:bodyPr wrap="square" rtlCol="0" anchor="ctr"/>
+          <a:lstStyle/>
+          <a:p>
+            <a:pPr algn="l" indent="0" marL="0">
+              <a:buNone/>
+            </a:pPr>
+            <a:r>
+              <a:rPr lang="en-US" sz="1200" b="1" spc="400" kern="0" dirty="0">
+                <a:solidFill>
+                  <a:srgbClr val="EE0000"/>
+                </a:solidFill>
+                <a:latin typeface="Red Hat Display" pitchFamily="34" charset="0"/>
+                <a:ea typeface="Red Hat Display" pitchFamily="34" charset="-122"/>
+                <a:cs typeface="Red Hat Display" pitchFamily="34" charset="-120"/>
+              </a:rPr>
+              <a:t>SCAN TO EXPLORE</a:t>
+            </a:r>
+            <a:endParaRPr lang="en-US" sz="1200" dirty="0"/>
+          </a:p>
+        </p:txBody>
+      </p:sp>
+      <p:sp>
+        <p:nvSpPr>
+          <p:cNvPr id="5" name="Text 2"/>
+          <p:cNvSpPr/>
+          <p:nvPr/>
+        </p:nvSpPr>
+        <p:spPr>
+          <a:xfrm>
+            <a:off x="566928" y="676656"/>
+            <a:ext cx="11055096" cy="1005840"/>
+          </a:xfrm>
+          <a:prstGeom prst="rect">
+            <a:avLst/>
+          </a:prstGeom>
+          <a:noFill/>
+          <a:ln/>
+        </p:spPr>
+        <p:txBody>
+          <a:bodyPr wrap="square" rtlCol="0" anchor="t"/>
+          <a:lstStyle/>
+          <a:p>
+            <a:pPr algn="l" indent="0" marL="0">
+              <a:buNone/>
+            </a:pPr>
+            <a:r>
+              <a:rPr lang="en-US" sz="3000" b="1" dirty="0">
+                <a:solidFill>
+                  <a:srgbClr val="151515"/>
+                </a:solidFill>
+                <a:latin typeface="Red Hat Display" pitchFamily="34" charset="0"/>
+                <a:ea typeface="Red Hat Display" pitchFamily="34" charset="-122"/>
+                <a:cs typeface="Red Hat Display" pitchFamily="34" charset="-120"/>
+              </a:rPr>
+              <a:t>Take it with you</a:t>
+            </a:r>
+            <a:endParaRPr lang="en-US" sz="3000" dirty="0"/>
+          </a:p>
+        </p:txBody>
+      </p:sp>
+      <p:pic>
+        <p:nvPicPr>
+          <p:cNvPr id="6" name="Image 1" descr="/tmp/pcwork/api-patterns-and-practices-graphql/presentation/_shared/assets/qr-graphql-site.png">    </p:cNvPr>
+          <p:cNvPicPr>
+            <a:picLocks noChangeAspect="1"/>
+          </p:cNvPicPr>
+          <p:nvPr/>
+        </p:nvPicPr>
+        <p:blipFill>
+          <a:blip r:embed="rId2"/>
+          <a:stretch>
+            <a:fillRect/>
+          </a:stretch>
+        </p:blipFill>
+        <p:spPr>
+          <a:xfrm>
+            <a:off x="2103120" y="1627632"/>
+            <a:ext cx="2834640" cy="2834640"/>
+          </a:xfrm>
+          <a:prstGeom prst="rect">
+            <a:avLst/>
+          </a:prstGeom>
+        </p:spPr>
+      </p:pic>
+      <p:sp>
+        <p:nvSpPr>
+          <p:cNvPr id="7" name="Text 3"/>
+          <p:cNvSpPr/>
+          <p:nvPr/>
+        </p:nvSpPr>
+        <p:spPr>
+          <a:xfrm>
+            <a:off x="1417320" y="4553712"/>
+            <a:ext cx="4206240" cy="365760"/>
+          </a:xfrm>
+          <a:prstGeom prst="rect">
+            <a:avLst/>
+          </a:prstGeom>
+          <a:noFill/>
+          <a:ln/>
+        </p:spPr>
+        <p:txBody>
+          <a:bodyPr wrap="square" rtlCol="0" anchor="ctr"/>
+          <a:lstStyle/>
+          <a:p>
+            <a:pPr algn="ctr" indent="0" marL="0">
+              <a:buNone/>
+            </a:pPr>
+            <a:r>
+              <a:rPr lang="en-US" sz="1800" b="1" dirty="0">
+                <a:solidFill>
+                  <a:srgbClr val="151515"/>
+                </a:solidFill>
+                <a:latin typeface="Red Hat Display" pitchFamily="34" charset="0"/>
+                <a:ea typeface="Red Hat Display" pitchFamily="34" charset="-122"/>
+                <a:cs typeface="Red Hat Display" pitchFamily="34" charset="-120"/>
+              </a:rPr>
+              <a:t>The site</a:t>
+            </a:r>
+            <a:endParaRPr lang="en-US" sz="1800" dirty="0"/>
+          </a:p>
+        </p:txBody>
+      </p:sp>
+      <p:sp>
+        <p:nvSpPr>
+          <p:cNvPr id="8" name="Text 4"/>
+          <p:cNvSpPr/>
+          <p:nvPr/>
+        </p:nvSpPr>
+        <p:spPr>
+          <a:xfrm>
+            <a:off x="1325880" y="4937760"/>
+            <a:ext cx="4389120" cy="658368"/>
+          </a:xfrm>
+          <a:prstGeom prst="rect">
+            <a:avLst/>
+          </a:prstGeom>
+          <a:noFill/>
+          <a:ln/>
+        </p:spPr>
+        <p:txBody>
+          <a:bodyPr wrap="square" rtlCol="0" anchor="t"/>
+          <a:lstStyle/>
+          <a:p>
+            <a:pPr algn="ctr" indent="0" marL="0">
+              <a:buNone/>
+            </a:pPr>
+            <a:r>
+              <a:rPr lang="en-US" sz="1300" i="1" dirty="0">
+                <a:solidFill>
+                  <a:srgbClr val="5A5A5A"/>
+                </a:solidFill>
+                <a:latin typeface="Red Hat Text" pitchFamily="34" charset="0"/>
+                <a:ea typeface="Red Hat Text" pitchFamily="34" charset="-122"/>
+                <a:cs typeface="Red Hat Text" pitchFamily="34" charset="-120"/>
+              </a:rPr>
+              <a:t>Chapters, the GraphQL schema and contracts, and both-stack runnable examples</a:t>
+            </a:r>
+            <a:endParaRPr lang="en-US" sz="1300" dirty="0"/>
+          </a:p>
+        </p:txBody>
+      </p:sp>
+      <p:sp>
+        <p:nvSpPr>
+          <p:cNvPr id="9" name="Text 5"/>
+          <p:cNvSpPr/>
+          <p:nvPr/>
+        </p:nvSpPr>
+        <p:spPr>
+          <a:xfrm>
+            <a:off x="1325880" y="5596128"/>
+            <a:ext cx="4389120" cy="292608"/>
+          </a:xfrm>
+          <a:prstGeom prst="rect">
+            <a:avLst/>
+          </a:prstGeom>
+          <a:noFill/>
+          <a:ln/>
+        </p:spPr>
+        <p:txBody>
+          <a:bodyPr wrap="square" rtlCol="0" anchor="ctr"/>
+          <a:lstStyle/>
+          <a:p>
+            <a:pPr algn="ctr" indent="0" marL="0">
+              <a:buNone/>
+            </a:pPr>
+            <a:r>
+              <a:rPr lang="en-US" sz="1000" dirty="0">
+                <a:solidFill>
+                  <a:srgbClr val="EE0000"/>
+                </a:solidFill>
+                <a:latin typeface="Red Hat Mono" pitchFamily="34" charset="0"/>
+                <a:ea typeface="Red Hat Mono" pitchFamily="34" charset="-122"/>
+                <a:cs typeface="Red Hat Mono" pitchFamily="34" charset="-120"/>
+              </a:rPr>
+              <a:t>patterncatalyst.github.io/api-patterns-and-practices-graphql</a:t>
+            </a:r>
+            <a:endParaRPr lang="en-US" sz="1000" dirty="0"/>
+          </a:p>
+        </p:txBody>
+      </p:sp>
+      <p:pic>
+        <p:nvPicPr>
+          <p:cNvPr id="10" name="Image 2" descr="/tmp/pcwork/api-patterns-and-practices-graphql/presentation/_shared/assets/qr-hub.png">    </p:cNvPr>
+          <p:cNvPicPr>
+            <a:picLocks noChangeAspect="1"/>
+          </p:cNvPicPr>
+          <p:nvPr/>
+        </p:nvPicPr>
+        <p:blipFill>
+          <a:blip r:embed="rId3"/>
+          <a:stretch>
+            <a:fillRect/>
+          </a:stretch>
+        </p:blipFill>
+        <p:spPr>
+          <a:xfrm>
+            <a:off x="7251192" y="1627632"/>
+            <a:ext cx="2834640" cy="2834640"/>
+          </a:xfrm>
+          <a:prstGeom prst="rect">
+            <a:avLst/>
+          </a:prstGeom>
+        </p:spPr>
+      </p:pic>
+      <p:sp>
+        <p:nvSpPr>
+          <p:cNvPr id="11" name="Text 6"/>
+          <p:cNvSpPr/>
+          <p:nvPr/>
+        </p:nvSpPr>
+        <p:spPr>
+          <a:xfrm>
+            <a:off x="6565392" y="4553712"/>
+            <a:ext cx="4206240" cy="365760"/>
+          </a:xfrm>
+          <a:prstGeom prst="rect">
+            <a:avLst/>
+          </a:prstGeom>
+          <a:noFill/>
+          <a:ln/>
+        </p:spPr>
+        <p:txBody>
+          <a:bodyPr wrap="square" rtlCol="0" anchor="ctr"/>
+          <a:lstStyle/>
+          <a:p>
+            <a:pPr algn="ctr" indent="0" marL="0">
+              <a:buNone/>
+            </a:pPr>
+            <a:r>
+              <a:rPr lang="en-US" sz="1800" b="1" dirty="0">
+                <a:solidFill>
+                  <a:srgbClr val="151515"/>
+                </a:solidFill>
+                <a:latin typeface="Red Hat Display" pitchFamily="34" charset="0"/>
+                <a:ea typeface="Red Hat Display" pitchFamily="34" charset="-122"/>
+                <a:cs typeface="Red Hat Display" pitchFamily="34" charset="-120"/>
+              </a:rPr>
+              <a:t>Workshops &amp; Tutorials</a:t>
+            </a:r>
+            <a:endParaRPr lang="en-US" sz="1800" dirty="0"/>
+          </a:p>
+        </p:txBody>
+      </p:sp>
+      <p:sp>
+        <p:nvSpPr>
+          <p:cNvPr id="12" name="Text 7"/>
+          <p:cNvSpPr/>
+          <p:nvPr/>
+        </p:nvSpPr>
+        <p:spPr>
+          <a:xfrm>
+            <a:off x="6473952" y="4937760"/>
+            <a:ext cx="4389120" cy="658368"/>
+          </a:xfrm>
+          <a:prstGeom prst="rect">
+            <a:avLst/>
+          </a:prstGeom>
+          <a:noFill/>
+          <a:ln/>
+        </p:spPr>
+        <p:txBody>
+          <a:bodyPr wrap="square" rtlCol="0" anchor="t"/>
+          <a:lstStyle/>
+          <a:p>
+            <a:pPr algn="ctr" indent="0" marL="0">
+              <a:buNone/>
+            </a:pPr>
+            <a:r>
+              <a:rPr lang="en-US" sz="1300" i="1" dirty="0">
+                <a:solidFill>
+                  <a:srgbClr val="5A5A5A"/>
+                </a:solidFill>
+                <a:latin typeface="Red Hat Text" pitchFamily="34" charset="0"/>
+                <a:ea typeface="Red Hat Text" pitchFamily="34" charset="-122"/>
+                <a:cs typeface="Red Hat Text" pitchFamily="34" charset="-120"/>
+              </a:rPr>
+              <a:t>The whole series: every workshop, tutorial, and deck in one place</a:t>
+            </a:r>
+            <a:endParaRPr lang="en-US" sz="1300" dirty="0"/>
+          </a:p>
+        </p:txBody>
+      </p:sp>
+      <p:sp>
+        <p:nvSpPr>
+          <p:cNvPr id="13" name="Text 8"/>
+          <p:cNvSpPr/>
+          <p:nvPr/>
+        </p:nvSpPr>
+        <p:spPr>
+          <a:xfrm>
+            <a:off x="6473952" y="5596128"/>
+            <a:ext cx="4389120" cy="292608"/>
+          </a:xfrm>
+          <a:prstGeom prst="rect">
+            <a:avLst/>
+          </a:prstGeom>
+          <a:noFill/>
+          <a:ln/>
+        </p:spPr>
+        <p:txBody>
+          <a:bodyPr wrap="square" rtlCol="0" anchor="ctr"/>
+          <a:lstStyle/>
+          <a:p>
+            <a:pPr algn="ctr" indent="0" marL="0">
+              <a:buNone/>
+            </a:pPr>
+            <a:r>
+              <a:rPr lang="en-US" sz="900" dirty="0">
+                <a:solidFill>
+                  <a:srgbClr val="EE0000"/>
+                </a:solidFill>
+                <a:latin typeface="Red Hat Mono" pitchFamily="34" charset="0"/>
+                <a:ea typeface="Red Hat Mono" pitchFamily="34" charset="-122"/>
+                <a:cs typeface="Red Hat Mono" pitchFamily="34" charset="-120"/>
+              </a:rPr>
+              <a:t>patterncatalyst.github.io/patterncatalyst-workshops-tutorials-list</a:t>
+            </a:r>
+            <a:endParaRPr lang="en-US" sz="900" dirty="0"/>
           </a:p>
         </p:txBody>
       </p:sp>
@@ -34339,7 +34876,7 @@
       </p:sp>
       <p:pic>
         <p:nvPicPr>
-          <p:cNvPr id="3" name="Image 0" descr="/work/_shared/assets/logo-candidate-2.png">    </p:cNvPr>
+          <p:cNvPr id="3" name="Image 0" descr="/tmp/pcwork/api-patterns-and-practices-graphql/presentation/_shared/assets/logo-candidate-2.png">    </p:cNvPr>
           <p:cNvPicPr>
             <a:picLocks noChangeAspect="1"/>
           </p:cNvPicPr>
@@ -34441,7 +34978,7 @@
       </p:sp>
       <p:pic>
         <p:nvPicPr>
-          <p:cNvPr id="6" name="Image 1" descr="/work/_shared/png/02-decision-framework.png">    </p:cNvPr>
+          <p:cNvPr id="6" name="Image 1" descr="/tmp/pcwork/api-patterns-and-practices-graphql/presentation/_shared/png/02-decision-framework.png">    </p:cNvPr>
           <p:cNvPicPr>
             <a:picLocks noChangeAspect="1"/>
           </p:cNvPicPr>
@@ -34567,7 +35104,7 @@
       </p:sp>
       <p:pic>
         <p:nvPicPr>
-          <p:cNvPr id="3" name="Image 0" descr="/work/_shared/assets/logo-candidate-2.png">    </p:cNvPr>
+          <p:cNvPr id="3" name="Image 0" descr="/tmp/pcwork/api-patterns-and-practices-graphql/presentation/_shared/assets/logo-candidate-2.png">    </p:cNvPr>
           <p:cNvPicPr>
             <a:picLocks noChangeAspect="1"/>
           </p:cNvPicPr>
@@ -34669,7 +35206,7 @@
       </p:sp>
       <p:pic>
         <p:nvPicPr>
-          <p:cNvPr id="6" name="Image 1" descr="/work/_shared/png/02-tracking-view-topology.png">    </p:cNvPr>
+          <p:cNvPr id="6" name="Image 1" descr="/tmp/pcwork/api-patterns-and-practices-graphql/presentation/_shared/png/02-tracking-view-topology.png">    </p:cNvPr>
           <p:cNvPicPr>
             <a:picLocks noChangeAspect="1"/>
           </p:cNvPicPr>

</xml_diff>

<commit_message>
docs(deck): professional-voice pass on the three GraphQL decks
Voice cleanup of the reader-facing deck text, with the pptx rebuilt from source:

- Recast every em dash in slide text to other punctuation: figure captions
  become `Figure N.x:`, and the deck title property drops the dash. Zero em
  dashes remain in the deck sources.
- Rewrite two speaker notes that opened with "This section covers ..." to lead
  with the content, and name the related concepts instead of chapter numbers.

Kept by design: the ALL-CAPS eyebrow kickers (a deck style element), the `!`
in GraphQL non-null notation like `Boolean!`, and "fails silently" as the
pagination term. The `_shared` build helpers and the figure PNG cache
(gitignored) are unchanged; only deck.js and the rebuilt pptx move.

Rebuilt all three decks in the pinned Node 24 image; QA passes (figure embeds
48/15/16, including the two QR codes, within cap; 0 warnings).
</commit_message>
<xml_diff>
--- a/presentation/api-patterns-graphql-100/api-patterns-graphql-100.pptx
+++ b/presentation/api-patterns-graphql-100/api-patterns-graphql-100.pptx
@@ -7859,7 +7859,7 @@
       </p:grpSpPr>
       <p:pic>
         <p:nvPicPr>
-          <p:cNvPr id="2" name="Image 0" descr="/tmp/pcwork/api-patterns-and-practices-graphql/presentation/_shared/assets/cover-panel.png">    </p:cNvPr>
+          <p:cNvPr id="2" name="Image 0" descr="/work/_shared/assets/cover-panel.png">    </p:cNvPr>
           <p:cNvPicPr>
             <a:picLocks noChangeAspect="1"/>
           </p:cNvPicPr>
@@ -8073,7 +8073,7 @@
       </p:sp>
       <p:pic>
         <p:nvPicPr>
-          <p:cNvPr id="7" name="Image 1" descr="/tmp/pcwork/api-patterns-and-practices-graphql/presentation/_shared/assets/logo-candidate-2.png">    </p:cNvPr>
+          <p:cNvPr id="7" name="Image 1" descr="/work/_shared/assets/logo-candidate-2.png">    </p:cNvPr>
           <p:cNvPicPr>
             <a:picLocks noChangeAspect="1"/>
           </p:cNvPicPr>
@@ -8239,7 +8239,7 @@
       </p:sp>
       <p:pic>
         <p:nvPicPr>
-          <p:cNvPr id="5" name="Image 0" descr="/tmp/pcwork/api-patterns-and-practices-graphql/presentation/_shared/assets/redhat-logo-white.png">    </p:cNvPr>
+          <p:cNvPr id="5" name="Image 0" descr="/work/_shared/assets/redhat-logo-white.png">    </p:cNvPr>
           <p:cNvPicPr>
             <a:picLocks noChangeAspect="1"/>
           </p:cNvPicPr>
@@ -8327,7 +8327,7 @@
       </p:sp>
       <p:pic>
         <p:nvPicPr>
-          <p:cNvPr id="3" name="Image 0" descr="/tmp/pcwork/api-patterns-and-practices-graphql/presentation/_shared/assets/logo-candidate-2.png">    </p:cNvPr>
+          <p:cNvPr id="3" name="Image 0" descr="/work/_shared/assets/logo-candidate-2.png">    </p:cNvPr>
           <p:cNvPicPr>
             <a:picLocks noChangeAspect="1"/>
           </p:cNvPicPr>
@@ -8429,7 +8429,7 @@
       </p:sp>
       <p:pic>
         <p:nvPicPr>
-          <p:cNvPr id="6" name="Image 1" descr="/tmp/pcwork/api-patterns-and-practices-graphql/presentation/_shared/png/03-type-system-map.png">    </p:cNvPr>
+          <p:cNvPr id="6" name="Image 1" descr="/work/_shared/png/03-type-system-map.png">    </p:cNvPr>
           <p:cNvPicPr>
             <a:picLocks noChangeAspect="1"/>
           </p:cNvPicPr>
@@ -8483,7 +8483,7 @@
                 <a:ea typeface="Red Hat Text" pitchFamily="34" charset="-122"/>
                 <a:cs typeface="Red Hat Text" pitchFamily="34" charset="-120"/>
               </a:rPr>
-              <a:t>Figure 3.1 — The tracking view's types by kind. Every leaf of a selection ends in a scalar or an enum.</a:t>
+              <a:t>Figure 3.1: The tracking view's types by kind. Every leaf of a selection ends in a scalar or an enum.</a:t>
             </a:r>
             <a:endParaRPr lang="en-US" sz="1300" dirty="0"/>
           </a:p>
@@ -8555,7 +8555,7 @@
       </p:sp>
       <p:pic>
         <p:nvPicPr>
-          <p:cNvPr id="3" name="Image 0" descr="/tmp/pcwork/api-patterns-and-practices-graphql/presentation/_shared/assets/logo-candidate-2.png">    </p:cNvPr>
+          <p:cNvPr id="3" name="Image 0" descr="/work/_shared/assets/logo-candidate-2.png">    </p:cNvPr>
           <p:cNvPicPr>
             <a:picLocks noChangeAspect="1"/>
           </p:cNvPicPr>
@@ -9263,7 +9263,7 @@
       </p:sp>
       <p:pic>
         <p:nvPicPr>
-          <p:cNvPr id="3" name="Image 0" descr="/tmp/pcwork/api-patterns-and-practices-graphql/presentation/_shared/assets/logo-candidate-2.png">    </p:cNvPr>
+          <p:cNvPr id="3" name="Image 0" descr="/work/_shared/assets/logo-candidate-2.png">    </p:cNvPr>
           <p:cNvPicPr>
             <a:picLocks noChangeAspect="1"/>
           </p:cNvPicPr>
@@ -9365,7 +9365,7 @@
       </p:sp>
       <p:pic>
         <p:nvPicPr>
-          <p:cNvPr id="6" name="Image 1" descr="/tmp/pcwork/api-patterns-and-practices-graphql/presentation/_shared/png/03-scalar-coercion.png">    </p:cNvPr>
+          <p:cNvPr id="6" name="Image 1" descr="/work/_shared/png/03-scalar-coercion.png">    </p:cNvPr>
           <p:cNvPicPr>
             <a:picLocks noChangeAspect="1"/>
           </p:cNvPicPr>
@@ -9419,7 +9419,7 @@
                 <a:ea typeface="Red Hat Text" pitchFamily="34" charset="-122"/>
                 <a:cs typeface="Red Hat Text" pitchFamily="34" charset="-120"/>
               </a:rPr>
-              <a:t>Figure 3.2 — Three coercions around one internal value. Whatever enters, the output is one canonical string.</a:t>
+              <a:t>Figure 3.2: Three coercions around one internal value. Whatever enters, the output is one canonical string.</a:t>
             </a:r>
             <a:endParaRPr lang="en-US" sz="1300" dirty="0"/>
           </a:p>
@@ -9491,7 +9491,7 @@
       </p:sp>
       <p:pic>
         <p:nvPicPr>
-          <p:cNvPr id="3" name="Image 0" descr="/tmp/pcwork/api-patterns-and-practices-graphql/presentation/_shared/assets/logo-candidate-2.png">    </p:cNvPr>
+          <p:cNvPr id="3" name="Image 0" descr="/work/_shared/assets/logo-candidate-2.png">    </p:cNvPr>
           <p:cNvPicPr>
             <a:picLocks noChangeAspect="1"/>
           </p:cNvPicPr>
@@ -9593,7 +9593,7 @@
       </p:sp>
       <p:pic>
         <p:nvPicPr>
-          <p:cNvPr id="6" name="Image 1" descr="/tmp/pcwork/api-patterns-and-practices-graphql/presentation/_shared/png/04-wrapper-matrix.png">    </p:cNvPr>
+          <p:cNvPr id="6" name="Image 1" descr="/work/_shared/png/04-wrapper-matrix.png">    </p:cNvPr>
           <p:cNvPicPr>
             <a:picLocks noChangeAspect="1"/>
           </p:cNvPicPr>
@@ -9647,7 +9647,7 @@
                 <a:ea typeface="Red Hat Text" pitchFamily="34" charset="-122"/>
                 <a:cs typeface="Red Hat Text" pitchFamily="34" charset="-120"/>
               </a:rPr>
-              <a:t>Figure 4.1 — The six wrapper combinations and what each allows in a response.</a:t>
+              <a:t>Figure 4.1: The six wrapper combinations and what each allows in a response.</a:t>
             </a:r>
             <a:endParaRPr lang="en-US" sz="1300" dirty="0"/>
           </a:p>
@@ -9719,7 +9719,7 @@
       </p:sp>
       <p:pic>
         <p:nvPicPr>
-          <p:cNvPr id="3" name="Image 0" descr="/tmp/pcwork/api-patterns-and-practices-graphql/presentation/_shared/assets/logo-candidate-2.png">    </p:cNvPr>
+          <p:cNvPr id="3" name="Image 0" descr="/work/_shared/assets/logo-candidate-2.png">    </p:cNvPr>
           <p:cNvPicPr>
             <a:picLocks noChangeAspect="1"/>
           </p:cNvPicPr>
@@ -9821,7 +9821,7 @@
       </p:sp>
       <p:pic>
         <p:nvPicPr>
-          <p:cNvPr id="6" name="Image 1" descr="/tmp/pcwork/api-patterns-and-practices-graphql/presentation/_shared/png/04-null-bubbling-walk.png">    </p:cNvPr>
+          <p:cNvPr id="6" name="Image 1" descr="/work/_shared/png/04-null-bubbling-walk.png">    </p:cNvPr>
           <p:cNvPicPr>
             <a:picLocks noChangeAspect="1"/>
           </p:cNvPicPr>
@@ -9875,7 +9875,7 @@
                 <a:ea typeface="Red Hat Text" pitchFamily="34" charset="-122"/>
                 <a:cs typeface="Red Hat Text" pitchFamily="34" charset="-120"/>
               </a:rPr>
-              <a:t>Figure 4.2 — One null climbing from Leg.loadLocation to Cargo.itinerary, the first nullable position.</a:t>
+              <a:t>Figure 4.2: One null climbing from Leg.loadLocation to Cargo.itinerary, the first nullable position.</a:t>
             </a:r>
             <a:endParaRPr lang="en-US" sz="1300" dirty="0"/>
           </a:p>
@@ -9947,7 +9947,7 @@
       </p:sp>
       <p:pic>
         <p:nvPicPr>
-          <p:cNvPr id="3" name="Image 0" descr="/tmp/pcwork/api-patterns-and-practices-graphql/presentation/_shared/assets/logo-candidate-2.png">    </p:cNvPr>
+          <p:cNvPr id="3" name="Image 0" descr="/work/_shared/assets/logo-candidate-2.png">    </p:cNvPr>
           <p:cNvPicPr>
             <a:picLocks noChangeAspect="1"/>
           </p:cNvPicPr>
@@ -10049,7 +10049,7 @@
       </p:sp>
       <p:pic>
         <p:nvPicPr>
-          <p:cNvPr id="6" name="Image 1" descr="/tmp/pcwork/api-patterns-and-practices-graphql/presentation/_shared/png/05-contract-loop.png">    </p:cNvPr>
+          <p:cNvPr id="6" name="Image 1" descr="/work/_shared/png/05-contract-loop.png">    </p:cNvPr>
           <p:cNvPicPr>
             <a:picLocks noChangeAspect="1"/>
           </p:cNvPicPr>
@@ -10103,7 +10103,7 @@
                 <a:ea typeface="Red Hat Text" pitchFamily="34" charset="-122"/>
                 <a:cs typeface="Red Hat Text" pitchFamily="34" charset="-120"/>
               </a:rPr>
-              <a:t>Figure 5.1 — Code builds the schema, the export makes it a file, and the diff compares it both ways.</a:t>
+              <a:t>Figure 5.1: Code builds the schema, the export makes it a file, and the diff compares it both ways.</a:t>
             </a:r>
             <a:endParaRPr lang="en-US" sz="1300" dirty="0"/>
           </a:p>
@@ -10253,7 +10253,7 @@
       </p:sp>
       <p:pic>
         <p:nvPicPr>
-          <p:cNvPr id="5" name="Image 0" descr="/tmp/pcwork/api-patterns-and-practices-graphql/presentation/_shared/assets/redhat-logo-white.png">    </p:cNvPr>
+          <p:cNvPr id="5" name="Image 0" descr="/work/_shared/assets/redhat-logo-white.png">    </p:cNvPr>
           <p:cNvPicPr>
             <a:picLocks noChangeAspect="1"/>
           </p:cNvPicPr>
@@ -10341,7 +10341,7 @@
       </p:sp>
       <p:pic>
         <p:nvPicPr>
-          <p:cNvPr id="3" name="Image 0" descr="/tmp/pcwork/api-patterns-and-practices-graphql/presentation/_shared/assets/logo-candidate-2.png">    </p:cNvPr>
+          <p:cNvPr id="3" name="Image 0" descr="/work/_shared/assets/logo-candidate-2.png">    </p:cNvPr>
           <p:cNvPicPr>
             <a:picLocks noChangeAspect="1"/>
           </p:cNvPicPr>
@@ -10443,7 +10443,7 @@
       </p:sp>
       <p:pic>
         <p:nvPicPr>
-          <p:cNvPr id="6" name="Image 1" descr="/tmp/pcwork/api-patterns-and-practices-graphql/presentation/_shared/png/06-request-phases.png">    </p:cNvPr>
+          <p:cNvPr id="6" name="Image 1" descr="/work/_shared/png/06-request-phases.png">    </p:cNvPr>
           <p:cNvPicPr>
             <a:picLocks noChangeAspect="1"/>
           </p:cNvPicPr>
@@ -10497,7 +10497,7 @@
                 <a:ea typeface="Red Hat Text" pitchFamily="34" charset="-122"/>
                 <a:cs typeface="Red Hat Text" pitchFamily="34" charset="-120"/>
               </a:rPr>
-              <a:t>Figure 6.1 — Parse, validate and coerce run before any resolver. A failure ends the request with no data.</a:t>
+              <a:t>Figure 6.1: Parse, validate and coerce run before any resolver. A failure ends the request with no data.</a:t>
             </a:r>
             <a:endParaRPr lang="en-US" sz="1300" dirty="0"/>
           </a:p>
@@ -10569,7 +10569,7 @@
       </p:sp>
       <p:pic>
         <p:nvPicPr>
-          <p:cNvPr id="3" name="Image 0" descr="/tmp/pcwork/api-patterns-and-practices-graphql/presentation/_shared/assets/logo-candidate-2.png">    </p:cNvPr>
+          <p:cNvPr id="3" name="Image 0" descr="/work/_shared/assets/logo-candidate-2.png">    </p:cNvPr>
           <p:cNvPicPr>
             <a:picLocks noChangeAspect="1"/>
           </p:cNvPicPr>
@@ -10671,7 +10671,7 @@
       </p:sp>
       <p:pic>
         <p:nvPicPr>
-          <p:cNvPr id="6" name="Image 1" descr="/tmp/pcwork/api-patterns-and-practices-graphql/presentation/_shared/png/07-resolver-chain.png">    </p:cNvPr>
+          <p:cNvPr id="6" name="Image 1" descr="/work/_shared/png/07-resolver-chain.png">    </p:cNvPr>
           <p:cNvPicPr>
             <a:picLocks noChangeAspect="1"/>
           </p:cNvPicPr>
@@ -10725,7 +10725,7 @@
                 <a:ea typeface="Red Hat Text" pitchFamily="34" charset="-122"/>
                 <a:cs typeface="Red Hat Text" pitchFamily="34" charset="-120"/>
               </a:rPr>
-              <a:t>Figure 7.2 — The parent value feeds the child resolver, the child derives a key, and the key goes to a source.</a:t>
+              <a:t>Figure 7.2: The parent value feeds the child resolver, the child derives a key, and the key goes to a source.</a:t>
             </a:r>
             <a:endParaRPr lang="en-US" sz="1300" dirty="0"/>
           </a:p>
@@ -10797,7 +10797,7 @@
       </p:sp>
       <p:pic>
         <p:nvPicPr>
-          <p:cNvPr id="3" name="Image 0" descr="/tmp/pcwork/api-patterns-and-practices-graphql/presentation/_shared/assets/logo-candidate-2.png">    </p:cNvPr>
+          <p:cNvPr id="3" name="Image 0" descr="/work/_shared/assets/logo-candidate-2.png">    </p:cNvPr>
           <p:cNvPicPr>
             <a:picLocks noChangeAspect="1"/>
           </p:cNvPicPr>
@@ -11334,7 +11334,7 @@
       </p:sp>
       <p:pic>
         <p:nvPicPr>
-          <p:cNvPr id="3" name="Image 0" descr="/tmp/pcwork/api-patterns-and-practices-graphql/presentation/_shared/assets/logo-candidate-2.png">    </p:cNvPr>
+          <p:cNvPr id="3" name="Image 0" descr="/work/_shared/assets/logo-candidate-2.png">    </p:cNvPr>
           <p:cNvPicPr>
             <a:picLocks noChangeAspect="1"/>
           </p:cNvPicPr>
@@ -11768,7 +11768,7 @@
                 <a:ea typeface="Red Hat Mono" pitchFamily="34" charset="-122"/>
                 <a:cs typeface="Red Hat Mono" pitchFamily="34" charset="-120"/>
               </a:rPr>
-              <a:t>returns `{"__typename":"Location","name":"Rotterdam"}`, and a `... on Cargo` fragment in the same selection would contribute nothing, as Chapter 3 showed. The spec covers both in "Fragments" and "Inline Fragments".
+              <a:t>returns `{"__typename":"Location","name":"Rotterdam"}`, and a `... on Cargo` fragment in the same selection would contribute nothing, as the type system already showed. The spec covers both in "Fragments" and "Inline Fragments".
 </a:t>
             </a:r>
             <a:pPr algn="l" indent="0" marL="0">
@@ -11898,7 +11898,7 @@
       </p:sp>
       <p:pic>
         <p:nvPicPr>
-          <p:cNvPr id="3" name="Image 0" descr="/tmp/pcwork/api-patterns-and-practices-graphql/presentation/_shared/assets/logo-candidate-2.png">    </p:cNvPr>
+          <p:cNvPr id="3" name="Image 0" descr="/work/_shared/assets/logo-candidate-2.png">    </p:cNvPr>
           <p:cNvPicPr>
             <a:picLocks noChangeAspect="1"/>
           </p:cNvPicPr>
@@ -12000,7 +12000,7 @@
       </p:sp>
       <p:pic>
         <p:nvPicPr>
-          <p:cNvPr id="6" name="Image 1" descr="/tmp/pcwork/api-patterns-and-practices-graphql/presentation/_shared/png/08-mutation-flow.png">    </p:cNvPr>
+          <p:cNvPr id="6" name="Image 1" descr="/work/_shared/png/08-mutation-flow.png">    </p:cNvPr>
           <p:cNvPicPr>
             <a:picLocks noChangeAspect="1"/>
           </p:cNvPicPr>
@@ -12054,7 +12054,7 @@
                 <a:ea typeface="Red Hat Text" pitchFamily="34" charset="-122"/>
                 <a:cs typeface="Red Hat Text" pitchFamily="34" charset="-120"/>
               </a:rPr>
-              <a:t>Figure 8.2 — Coercion belongs to the engine; validation, lookup, append and re-read run in the resolver.</a:t>
+              <a:t>Figure 8.2: Coercion belongs to the engine; validation, lookup, append and re-read run in the resolver.</a:t>
             </a:r>
             <a:endParaRPr lang="en-US" sz="1300" dirty="0"/>
           </a:p>
@@ -12126,7 +12126,7 @@
       </p:sp>
       <p:pic>
         <p:nvPicPr>
-          <p:cNvPr id="3" name="Image 0" descr="/tmp/pcwork/api-patterns-and-practices-graphql/presentation/_shared/assets/logo-candidate-2.png">    </p:cNvPr>
+          <p:cNvPr id="3" name="Image 0" descr="/work/_shared/assets/logo-candidate-2.png">    </p:cNvPr>
           <p:cNvPicPr>
             <a:picLocks noChangeAspect="1"/>
           </p:cNvPicPr>
@@ -12228,7 +12228,7 @@
       </p:sp>
       <p:pic>
         <p:nvPicPr>
-          <p:cNvPr id="6" name="Image 1" descr="/tmp/pcwork/api-patterns-and-practices-graphql/presentation/_shared/png/08-idempotent-replay.png">    </p:cNvPr>
+          <p:cNvPr id="6" name="Image 1" descr="/work/_shared/png/08-idempotent-replay.png">    </p:cNvPr>
           <p:cNvPicPr>
             <a:picLocks noChangeAspect="1"/>
           </p:cNvPicPr>
@@ -12282,7 +12282,7 @@
                 <a:ea typeface="Red Hat Text" pitchFamily="34" charset="-122"/>
                 <a:cs typeface="Red Hat Text" pitchFamily="34" charset="-120"/>
               </a:rPr>
-              <a:t>Figure 8.3 — The same retry with and without a key. With one, the second request becomes a read.</a:t>
+              <a:t>Figure 8.3: The same retry with and without a key. With one, the second request becomes a read.</a:t>
             </a:r>
             <a:endParaRPr lang="en-US" sz="1300" dirty="0"/>
           </a:p>
@@ -12432,7 +12432,7 @@
       </p:sp>
       <p:pic>
         <p:nvPicPr>
-          <p:cNvPr id="5" name="Image 0" descr="/tmp/pcwork/api-patterns-and-practices-graphql/presentation/_shared/assets/redhat-logo-white.png">    </p:cNvPr>
+          <p:cNvPr id="5" name="Image 0" descr="/work/_shared/assets/redhat-logo-white.png">    </p:cNvPr>
           <p:cNvPicPr>
             <a:picLocks noChangeAspect="1"/>
           </p:cNvPicPr>
@@ -12520,7 +12520,7 @@
       </p:sp>
       <p:pic>
         <p:nvPicPr>
-          <p:cNvPr id="3" name="Image 0" descr="/tmp/pcwork/api-patterns-and-practices-graphql/presentation/_shared/assets/logo-candidate-2.png">    </p:cNvPr>
+          <p:cNvPr id="3" name="Image 0" descr="/work/_shared/assets/logo-candidate-2.png">    </p:cNvPr>
           <p:cNvPicPr>
             <a:picLocks noChangeAspect="1"/>
           </p:cNvPicPr>
@@ -12622,7 +12622,7 @@
       </p:sp>
       <p:pic>
         <p:nvPicPr>
-          <p:cNvPr id="6" name="Image 1" descr="/tmp/pcwork/api-patterns-and-practices-graphql/presentation/_shared/png/09-error-taxonomy.png">    </p:cNvPr>
+          <p:cNvPr id="6" name="Image 1" descr="/work/_shared/png/09-error-taxonomy.png">    </p:cNvPr>
           <p:cNvPicPr>
             <a:picLocks noChangeAspect="1"/>
           </p:cNvPicPr>
@@ -12676,7 +12676,7 @@
                 <a:ea typeface="Red Hat Text" pitchFamily="34" charset="-122"/>
                 <a:cs typeface="Red Hat Text" pitchFamily="34" charset="-120"/>
               </a:rPr>
-              <a:t>Figure 9.1 — Three kinds of failure and the response each produces; only the first precedes a resolver.</a:t>
+              <a:t>Figure 9.1: Three kinds of failure and the response each produces; only the first precedes a resolver.</a:t>
             </a:r>
             <a:endParaRPr lang="en-US" sz="1300" dirty="0"/>
           </a:p>
@@ -12748,7 +12748,7 @@
       </p:sp>
       <p:pic>
         <p:nvPicPr>
-          <p:cNvPr id="3" name="Image 0" descr="/tmp/pcwork/api-patterns-and-practices-graphql/presentation/_shared/assets/logo-candidate-2.png">    </p:cNvPr>
+          <p:cNvPr id="3" name="Image 0" descr="/work/_shared/assets/logo-candidate-2.png">    </p:cNvPr>
           <p:cNvPicPr>
             <a:picLocks noChangeAspect="1"/>
           </p:cNvPicPr>
@@ -12850,7 +12850,7 @@
       </p:sp>
       <p:pic>
         <p:nvPicPr>
-          <p:cNvPr id="6" name="Image 1" descr="/tmp/pcwork/api-patterns-and-practices-graphql/presentation/_shared/png/09-partial-data-errors.png">    </p:cNvPr>
+          <p:cNvPr id="6" name="Image 1" descr="/work/_shared/png/09-partial-data-errors.png">    </p:cNvPr>
           <p:cNvPicPr>
             <a:picLocks noChangeAspect="1"/>
           </p:cNvPicPr>
@@ -12904,7 +12904,7 @@
                 <a:ea typeface="Red Hat Text" pitchFamily="34" charset="-122"/>
                 <a:cs typeface="Red Hat Text" pitchFamily="34" charset="-120"/>
               </a:rPr>
-              <a:t>Figure 9.2 — A path names where it broke, and the null lands at the nearest nullable ancestor.</a:t>
+              <a:t>Figure 9.2: A path names where it broke, and the null lands at the nearest nullable ancestor.</a:t>
             </a:r>
             <a:endParaRPr lang="en-US" sz="1300" dirty="0"/>
           </a:p>
@@ -12976,7 +12976,7 @@
       </p:sp>
       <p:pic>
         <p:nvPicPr>
-          <p:cNvPr id="3" name="Image 0" descr="/tmp/pcwork/api-patterns-and-practices-graphql/presentation/_shared/assets/logo-candidate-2.png">    </p:cNvPr>
+          <p:cNvPr id="3" name="Image 0" descr="/work/_shared/assets/logo-candidate-2.png">    </p:cNvPr>
           <p:cNvPicPr>
             <a:picLocks noChangeAspect="1"/>
           </p:cNvPicPr>
@@ -13414,7 +13414,7 @@
       </p:sp>
       <p:pic>
         <p:nvPicPr>
-          <p:cNvPr id="3" name="Image 0" descr="/tmp/pcwork/api-patterns-and-practices-graphql/presentation/_shared/assets/logo-candidate-2.png">    </p:cNvPr>
+          <p:cNvPr id="3" name="Image 0" descr="/work/_shared/assets/logo-candidate-2.png">    </p:cNvPr>
           <p:cNvPicPr>
             <a:picLocks noChangeAspect="1"/>
           </p:cNvPicPr>
@@ -13516,7 +13516,7 @@
       </p:sp>
       <p:pic>
         <p:nvPicPr>
-          <p:cNvPr id="6" name="Image 1" descr="/tmp/pcwork/api-patterns-and-practices-graphql/presentation/_shared/png/09-error-masking.png">    </p:cNvPr>
+          <p:cNvPr id="6" name="Image 1" descr="/work/_shared/png/09-error-masking.png">    </p:cNvPr>
           <p:cNvPicPr>
             <a:picLocks noChangeAspect="1"/>
           </p:cNvPicPr>
@@ -13570,7 +13570,7 @@
                 <a:ea typeface="Red Hat Text" pitchFamily="34" charset="-122"/>
                 <a:cs typeface="Red Hat Text" pitchFamily="34" charset="-120"/>
               </a:rPr>
-              <a:t>Figure 9.3 — Masking is an allowlist. The client sees only what the service listed; the log sees everything.</a:t>
+              <a:t>Figure 9.3: Masking is an allowlist. The client sees only what the service listed; the log sees everything.</a:t>
             </a:r>
             <a:endParaRPr lang="en-US" sz="1300" dirty="0"/>
           </a:p>
@@ -13720,7 +13720,7 @@
       </p:sp>
       <p:pic>
         <p:nvPicPr>
-          <p:cNvPr id="5" name="Image 0" descr="/tmp/pcwork/api-patterns-and-practices-graphql/presentation/_shared/assets/redhat-logo-white.png">    </p:cNvPr>
+          <p:cNvPr id="5" name="Image 0" descr="/work/_shared/assets/redhat-logo-white.png">    </p:cNvPr>
           <p:cNvPicPr>
             <a:picLocks noChangeAspect="1"/>
           </p:cNvPicPr>
@@ -13808,7 +13808,7 @@
       </p:sp>
       <p:pic>
         <p:nvPicPr>
-          <p:cNvPr id="3" name="Image 0" descr="/tmp/pcwork/api-patterns-and-practices-graphql/presentation/_shared/assets/logo-candidate-2.png">    </p:cNvPr>
+          <p:cNvPr id="3" name="Image 0" descr="/work/_shared/assets/logo-candidate-2.png">    </p:cNvPr>
           <p:cNvPicPr>
             <a:picLocks noChangeAspect="1"/>
           </p:cNvPicPr>
@@ -13910,7 +13910,7 @@
       </p:sp>
       <p:pic>
         <p:nvPicPr>
-          <p:cNvPr id="6" name="Image 1" descr="/tmp/pcwork/api-patterns-and-practices-graphql/presentation/_shared/png/10-demand-oriented-schema.png">    </p:cNvPr>
+          <p:cNvPr id="6" name="Image 1" descr="/work/_shared/png/10-demand-oriented-schema.png">    </p:cNvPr>
           <p:cNvPicPr>
             <a:picLocks noChangeAspect="1"/>
           </p:cNvPicPr>
@@ -13964,7 +13964,7 @@
                 <a:ea typeface="Red Hat Text" pitchFamily="34" charset="-122"/>
                 <a:cs typeface="Red Hat Text" pitchFamily="34" charset="-120"/>
               </a:rPr>
-              <a:t>Figure 10.1 — One screen, one query, five owners. The panels choose fields; sources answer them.</a:t>
+              <a:t>Figure 10.1: One screen, one query, five owners. The panels choose fields; sources answer them.</a:t>
             </a:r>
             <a:endParaRPr lang="en-US" sz="1300" dirty="0"/>
           </a:p>
@@ -14114,7 +14114,7 @@
       </p:sp>
       <p:pic>
         <p:nvPicPr>
-          <p:cNvPr id="5" name="Image 0" descr="/tmp/pcwork/api-patterns-and-practices-graphql/presentation/_shared/assets/redhat-logo-white.png">    </p:cNvPr>
+          <p:cNvPr id="5" name="Image 0" descr="/work/_shared/assets/redhat-logo-white.png">    </p:cNvPr>
           <p:cNvPicPr>
             <a:picLocks noChangeAspect="1"/>
           </p:cNvPicPr>
@@ -14202,7 +14202,7 @@
       </p:sp>
       <p:pic>
         <p:nvPicPr>
-          <p:cNvPr id="3" name="Image 0" descr="/tmp/pcwork/api-patterns-and-practices-graphql/presentation/_shared/assets/logo-candidate-2.png">    </p:cNvPr>
+          <p:cNvPr id="3" name="Image 0" descr="/work/_shared/assets/logo-candidate-2.png">    </p:cNvPr>
           <p:cNvPicPr>
             <a:picLocks noChangeAspect="1"/>
           </p:cNvPicPr>
@@ -14304,7 +14304,7 @@
       </p:sp>
       <p:pic>
         <p:nvPicPr>
-          <p:cNvPr id="6" name="Image 1" descr="/tmp/pcwork/api-patterns-and-practices-graphql/presentation/_shared/png/10-node-identity.png">    </p:cNvPr>
+          <p:cNvPr id="6" name="Image 1" descr="/work/_shared/png/10-node-identity.png">    </p:cNvPr>
           <p:cNvPicPr>
             <a:picLocks noChangeAspect="1"/>
           </p:cNvPicPr>
@@ -14358,7 +14358,7 @@
                 <a:ea typeface="Red Hat Text" pitchFamily="34" charset="-122"/>
                 <a:cs typeface="Red Hat Text" pitchFamily="34" charset="-120"/>
               </a:rPr>
-              <a:t>Figure 10.2 — Ids reach a client cache along any path. node and nodes turn any of them back into one object.</a:t>
+              <a:t>Figure 10.2: Ids reach a client cache along any path. node and nodes turn any of them back into one object.</a:t>
             </a:r>
             <a:endParaRPr lang="en-US" sz="1300" dirty="0"/>
           </a:p>
@@ -14430,7 +14430,7 @@
       </p:sp>
       <p:pic>
         <p:nvPicPr>
-          <p:cNvPr id="3" name="Image 0" descr="/tmp/pcwork/api-patterns-and-practices-graphql/presentation/_shared/assets/logo-candidate-2.png">    </p:cNvPr>
+          <p:cNvPr id="3" name="Image 0" descr="/work/_shared/assets/logo-candidate-2.png">    </p:cNvPr>
           <p:cNvPicPr>
             <a:picLocks noChangeAspect="1"/>
           </p:cNvPicPr>
@@ -14532,7 +14532,7 @@
       </p:sp>
       <p:pic>
         <p:nvPicPr>
-          <p:cNvPr id="6" name="Image 1" descr="/tmp/pcwork/api-patterns-and-practices-graphql/presentation/_shared/png/11-change-classes.png">    </p:cNvPr>
+          <p:cNvPr id="6" name="Image 1" descr="/work/_shared/png/11-change-classes.png">    </p:cNvPr>
           <p:cNvPicPr>
             <a:picLocks noChangeAspect="1"/>
           </p:cNvPicPr>
@@ -14586,7 +14586,7 @@
                 <a:ea typeface="Red Hat Text" pitchFamily="34" charset="-122"/>
                 <a:cs typeface="Red Hat Text" pitchFamily="34" charset="-120"/>
               </a:rPr>
-              <a:t>Figure 11.1 — Safe, dangerous and breaking changes, each with a fixture and the gate's verdict.</a:t>
+              <a:t>Figure 11.1: Safe, dangerous and breaking changes, each with a fixture and the gate's verdict.</a:t>
             </a:r>
             <a:endParaRPr lang="en-US" sz="1300" dirty="0"/>
           </a:p>
@@ -14658,7 +14658,7 @@
       </p:sp>
       <p:pic>
         <p:nvPicPr>
-          <p:cNvPr id="3" name="Image 0" descr="/tmp/pcwork/api-patterns-and-practices-graphql/presentation/_shared/assets/logo-candidate-2.png">    </p:cNvPr>
+          <p:cNvPr id="3" name="Image 0" descr="/work/_shared/assets/logo-candidate-2.png">    </p:cNvPr>
           <p:cNvPicPr>
             <a:picLocks noChangeAspect="1"/>
           </p:cNvPicPr>
@@ -15114,7 +15114,7 @@
       </p:sp>
       <p:pic>
         <p:nvPicPr>
-          <p:cNvPr id="3" name="Image 0" descr="/tmp/pcwork/api-patterns-and-practices-graphql/presentation/_shared/assets/logo-candidate-2.png">    </p:cNvPr>
+          <p:cNvPr id="3" name="Image 0" descr="/work/_shared/assets/logo-candidate-2.png">    </p:cNvPr>
           <p:cNvPicPr>
             <a:picLocks noChangeAspect="1"/>
           </p:cNvPicPr>
@@ -15216,7 +15216,7 @@
       </p:sp>
       <p:pic>
         <p:nvPicPr>
-          <p:cNvPr id="6" name="Image 1" descr="/tmp/pcwork/api-patterns-and-practices-graphql/presentation/_shared/png/11-deprecation-lifecycle.png">    </p:cNvPr>
+          <p:cNvPr id="6" name="Image 1" descr="/work/_shared/png/11-deprecation-lifecycle.png">    </p:cNvPr>
           <p:cNvPicPr>
             <a:picLocks noChangeAspect="1"/>
           </p:cNvPicPr>
@@ -15270,7 +15270,7 @@
                 <a:ea typeface="Red Hat Text" pitchFamily="34" charset="-122"/>
                 <a:cs typeface="Red Hat Text" pitchFamily="34" charset="-120"/>
               </a:rPr>
-              <a:t>Figure 11.2 — Add, deprecate, observe, then remove with a recorded sign-off.</a:t>
+              <a:t>Figure 11.2: Add, deprecate, observe, then remove with a recorded sign-off.</a:t>
             </a:r>
             <a:endParaRPr lang="en-US" sz="1300" dirty="0"/>
           </a:p>
@@ -15420,7 +15420,7 @@
       </p:sp>
       <p:pic>
         <p:nvPicPr>
-          <p:cNvPr id="5" name="Image 0" descr="/tmp/pcwork/api-patterns-and-practices-graphql/presentation/_shared/assets/redhat-logo-white.png">    </p:cNvPr>
+          <p:cNvPr id="5" name="Image 0" descr="/work/_shared/assets/redhat-logo-white.png">    </p:cNvPr>
           <p:cNvPicPr>
             <a:picLocks noChangeAspect="1"/>
           </p:cNvPicPr>
@@ -15508,7 +15508,7 @@
       </p:sp>
       <p:pic>
         <p:nvPicPr>
-          <p:cNvPr id="3" name="Image 0" descr="/tmp/pcwork/api-patterns-and-practices-graphql/presentation/_shared/assets/logo-candidate-2.png">    </p:cNvPr>
+          <p:cNvPr id="3" name="Image 0" descr="/work/_shared/assets/logo-candidate-2.png">    </p:cNvPr>
           <p:cNvPicPr>
             <a:picLocks noChangeAspect="1"/>
           </p:cNvPicPr>
@@ -15610,7 +15610,7 @@
       </p:sp>
       <p:pic>
         <p:nvPicPr>
-          <p:cNvPr id="6" name="Image 1" descr="/tmp/pcwork/api-patterns-and-practices-graphql/presentation/_shared/png/12-connection-anatomy.png">    </p:cNvPr>
+          <p:cNvPr id="6" name="Image 1" descr="/work/_shared/png/12-connection-anatomy.png">    </p:cNvPr>
           <p:cNvPicPr>
             <a:picLocks noChangeAspect="1"/>
           </p:cNvPicPr>
@@ -15664,7 +15664,7 @@
                 <a:ea typeface="Red Hat Text" pitchFamily="34" charset="-122"/>
                 <a:cs typeface="Red Hat Text" pitchFamily="34" charset="-120"/>
               </a:rPr>
-              <a:t>Figure 12.2 — A connection has edges and pageInfo. The edge's node is the one nullable link in the chain.</a:t>
+              <a:t>Figure 12.2: A connection has edges and pageInfo. The edge's node is the one nullable link in the chain.</a:t>
             </a:r>
             <a:endParaRPr lang="en-US" sz="1300" dirty="0"/>
           </a:p>
@@ -15736,7 +15736,7 @@
       </p:sp>
       <p:pic>
         <p:nvPicPr>
-          <p:cNvPr id="3" name="Image 0" descr="/tmp/pcwork/api-patterns-and-practices-graphql/presentation/_shared/assets/logo-candidate-2.png">    </p:cNvPr>
+          <p:cNvPr id="3" name="Image 0" descr="/work/_shared/assets/logo-candidate-2.png">    </p:cNvPr>
           <p:cNvPicPr>
             <a:picLocks noChangeAspect="1"/>
           </p:cNvPicPr>
@@ -15838,7 +15838,7 @@
       </p:sp>
       <p:pic>
         <p:nvPicPr>
-          <p:cNvPr id="6" name="Image 1" descr="/tmp/pcwork/api-patterns-and-practices-graphql/presentation/_shared/png/12-offset-vs-keyset.png">    </p:cNvPr>
+          <p:cNvPr id="6" name="Image 1" descr="/work/_shared/png/12-offset-vs-keyset.png">    </p:cNvPr>
           <p:cNvPicPr>
             <a:picLocks noChangeAspect="1"/>
           </p:cNvPicPr>
@@ -15892,7 +15892,7 @@
                 <a:ea typeface="Red Hat Text" pitchFamily="34" charset="-122"/>
                 <a:cs typeface="Red Hat Text" pitchFamily="34" charset="-120"/>
               </a:rPr>
-              <a:t>Figure 12.1 — One insert, two designs. Offset repeats an item; the keyset cursor seeks past it.</a:t>
+              <a:t>Figure 12.1: One insert, two designs. Offset repeats an item; the keyset cursor seeks past it.</a:t>
             </a:r>
             <a:endParaRPr lang="en-US" sz="1300" dirty="0"/>
           </a:p>
@@ -15964,7 +15964,7 @@
       </p:sp>
       <p:pic>
         <p:nvPicPr>
-          <p:cNvPr id="3" name="Image 0" descr="/tmp/pcwork/api-patterns-and-practices-graphql/presentation/_shared/assets/logo-candidate-2.png">    </p:cNvPr>
+          <p:cNvPr id="3" name="Image 0" descr="/work/_shared/assets/logo-candidate-2.png">    </p:cNvPr>
           <p:cNvPicPr>
             <a:picLocks noChangeAspect="1"/>
           </p:cNvPicPr>
@@ -16402,7 +16402,7 @@
       </p:sp>
       <p:pic>
         <p:nvPicPr>
-          <p:cNvPr id="3" name="Image 0" descr="/tmp/pcwork/api-patterns-and-practices-graphql/presentation/_shared/assets/logo-candidate-2.png">    </p:cNvPr>
+          <p:cNvPr id="3" name="Image 0" descr="/work/_shared/assets/logo-candidate-2.png">    </p:cNvPr>
           <p:cNvPicPr>
             <a:picLocks noChangeAspect="1"/>
           </p:cNvPicPr>
@@ -16504,7 +16504,7 @@
       </p:sp>
       <p:pic>
         <p:nvPicPr>
-          <p:cNvPr id="6" name="Image 1" descr="/tmp/pcwork/api-patterns-and-practices-graphql/presentation/_shared/png/13-n-plus-one-fanout.png">    </p:cNvPr>
+          <p:cNvPr id="6" name="Image 1" descr="/work/_shared/png/13-n-plus-one-fanout.png">    </p:cNvPr>
           <p:cNvPicPr>
             <a:picLocks noChangeAspect="1"/>
           </p:cNvPicPr>
@@ -16558,7 +16558,7 @@
                 <a:ea typeface="Red Hat Text" pitchFamily="34" charset="-122"/>
                 <a:cs typeface="Red Hat Text" pitchFamily="34" charset="-120"/>
               </a:rPr>
-              <a:t>Figure 13.1 — Before batching: one call per field occurrence, 29 in all. Highlighted keys are fetched twice.</a:t>
+              <a:t>Figure 13.1: Before batching: one call per field occurrence, 29 in all. Highlighted keys are fetched twice.</a:t>
             </a:r>
             <a:endParaRPr lang="en-US" sz="1300" dirty="0"/>
           </a:p>
@@ -16630,7 +16630,7 @@
       </p:sp>
       <p:pic>
         <p:nvPicPr>
-          <p:cNvPr id="3" name="Image 0" descr="/tmp/pcwork/api-patterns-and-practices-graphql/presentation/_shared/assets/logo-candidate-2.png">    </p:cNvPr>
+          <p:cNvPr id="3" name="Image 0" descr="/work/_shared/assets/logo-candidate-2.png">    </p:cNvPr>
           <p:cNvPicPr>
             <a:picLocks noChangeAspect="1"/>
           </p:cNvPicPr>
@@ -16732,7 +16732,7 @@
       </p:sp>
       <p:pic>
         <p:nvPicPr>
-          <p:cNvPr id="6" name="Image 1" descr="/tmp/pcwork/api-patterns-and-practices-graphql/presentation/_shared/png/13-batched-load.png">    </p:cNvPr>
+          <p:cNvPr id="6" name="Image 1" descr="/work/_shared/png/13-batched-load.png">    </p:cNvPr>
           <p:cNvPicPr>
             <a:picLocks noChangeAspect="1"/>
           </p:cNvPicPr>
@@ -16786,7 +16786,7 @@
                 <a:ea typeface="Red Hat Text" pitchFamily="34" charset="-122"/>
                 <a:cs typeface="Red Hat Text" pitchFamily="34" charset="-120"/>
               </a:rPr>
-              <a:t>Figure 13.2 — The same query with one bulk call per level, without changing a field of the schema.</a:t>
+              <a:t>Figure 13.2: The same query with one bulk call per level, without changing a field of the schema.</a:t>
             </a:r>
             <a:endParaRPr lang="en-US" sz="1300" dirty="0"/>
           </a:p>
@@ -16858,7 +16858,7 @@
       </p:sp>
       <p:pic>
         <p:nvPicPr>
-          <p:cNvPr id="3" name="Image 0" descr="/tmp/pcwork/api-patterns-and-practices-graphql/presentation/_shared/assets/logo-candidate-2.png">    </p:cNvPr>
+          <p:cNvPr id="3" name="Image 0" descr="/work/_shared/assets/logo-candidate-2.png">    </p:cNvPr>
           <p:cNvPicPr>
             <a:picLocks noChangeAspect="1"/>
           </p:cNvPicPr>
@@ -16960,7 +16960,7 @@
       </p:sp>
       <p:pic>
         <p:nvPicPr>
-          <p:cNvPr id="6" name="Image 1" descr="/tmp/pcwork/api-patterns-and-practices-graphql/presentation/_shared/png/01-three-paradigms.png">    </p:cNvPr>
+          <p:cNvPr id="6" name="Image 1" descr="/work/_shared/png/01-three-paradigms.png">    </p:cNvPr>
           <p:cNvPicPr>
             <a:picLocks noChangeAspect="1"/>
           </p:cNvPicPr>
@@ -17014,7 +17014,7 @@
                 <a:ea typeface="Red Hat Text" pitchFamily="34" charset="-122"/>
                 <a:cs typeface="Red Hat Text" pitchFamily="34" charset="-120"/>
               </a:rPr>
-              <a:t>Figure 1.1 — Three paradigms, one intent: REST, gRPC and GraphQL answering one tracking question.</a:t>
+              <a:t>Figure 1.1: Three paradigms, one intent: REST, gRPC and GraphQL answering one tracking question.</a:t>
             </a:r>
             <a:endParaRPr lang="en-US" sz="1300" dirty="0"/>
           </a:p>
@@ -17086,7 +17086,7 @@
       </p:sp>
       <p:pic>
         <p:nvPicPr>
-          <p:cNvPr id="3" name="Image 0" descr="/tmp/pcwork/api-patterns-and-practices-graphql/presentation/_shared/assets/logo-candidate-2.png">    </p:cNvPr>
+          <p:cNvPr id="3" name="Image 0" descr="/work/_shared/assets/logo-candidate-2.png">    </p:cNvPr>
           <p:cNvPicPr>
             <a:picLocks noChangeAspect="1"/>
           </p:cNvPicPr>
@@ -17188,7 +17188,7 @@
       </p:sp>
       <p:pic>
         <p:nvPicPr>
-          <p:cNvPr id="6" name="Image 1" descr="/tmp/pcwork/api-patterns-and-practices-graphql/presentation/_shared/png/13-dataloader-tick.png">    </p:cNvPr>
+          <p:cNvPr id="6" name="Image 1" descr="/work/_shared/png/13-dataloader-tick.png">    </p:cNvPr>
           <p:cNvPicPr>
             <a:picLocks noChangeAspect="1"/>
           </p:cNvPicPr>
@@ -17242,7 +17242,7 @@
                 <a:ea typeface="Red Hat Text" pitchFamily="34" charset="-122"/>
                 <a:cs typeface="Red Hat Text" pitchFamily="34" charset="-120"/>
               </a:rPr>
-              <a:t>Figure 13.3 — Loads queue during a tick, one bulk call follows, and the next level starts when it returns.</a:t>
+              <a:t>Figure 13.3: Loads queue during a tick, one bulk call follows, and the next level starts when it returns.</a:t>
             </a:r>
             <a:endParaRPr lang="en-US" sz="1300" dirty="0"/>
           </a:p>
@@ -17392,7 +17392,7 @@
       </p:sp>
       <p:pic>
         <p:nvPicPr>
-          <p:cNvPr id="5" name="Image 0" descr="/tmp/pcwork/api-patterns-and-practices-graphql/presentation/_shared/assets/redhat-logo-white.png">    </p:cNvPr>
+          <p:cNvPr id="5" name="Image 0" descr="/work/_shared/assets/redhat-logo-white.png">    </p:cNvPr>
           <p:cNvPicPr>
             <a:picLocks noChangeAspect="1"/>
           </p:cNvPicPr>
@@ -17480,7 +17480,7 @@
       </p:sp>
       <p:pic>
         <p:nvPicPr>
-          <p:cNvPr id="3" name="Image 0" descr="/tmp/pcwork/api-patterns-and-practices-graphql/presentation/_shared/assets/logo-candidate-2.png">    </p:cNvPr>
+          <p:cNvPr id="3" name="Image 0" descr="/work/_shared/assets/logo-candidate-2.png">    </p:cNvPr>
           <p:cNvPicPr>
             <a:picLocks noChangeAspect="1"/>
           </p:cNvPicPr>
@@ -17582,7 +17582,7 @@
       </p:sp>
       <p:pic>
         <p:nvPicPr>
-          <p:cNvPr id="6" name="Image 1" descr="/tmp/pcwork/api-patterns-and-practices-graphql/presentation/_shared/png/14-limit-pipeline.png">    </p:cNvPr>
+          <p:cNvPr id="6" name="Image 1" descr="/work/_shared/png/14-limit-pipeline.png">    </p:cNvPr>
           <p:cNvPicPr>
             <a:picLocks noChangeAspect="1"/>
           </p:cNvPicPr>
@@ -17636,7 +17636,7 @@
                 <a:ea typeface="Red Hat Text" pitchFamily="34" charset="-122"/>
                 <a:cs typeface="Red Hat Text" pitchFamily="34" charset="-120"/>
               </a:rPr>
-              <a:t>Figure 14.2 — Where each limit fires. Every refusal ends before the sources are reached.</a:t>
+              <a:t>Figure 14.2: Where each limit fires. Every refusal ends before the sources are reached.</a:t>
             </a:r>
             <a:endParaRPr lang="en-US" sz="1300" dirty="0"/>
           </a:p>
@@ -17708,7 +17708,7 @@
       </p:sp>
       <p:pic>
         <p:nvPicPr>
-          <p:cNvPr id="3" name="Image 0" descr="/tmp/pcwork/api-patterns-and-practices-graphql/presentation/_shared/assets/logo-candidate-2.png">    </p:cNvPr>
+          <p:cNvPr id="3" name="Image 0" descr="/work/_shared/assets/logo-candidate-2.png">    </p:cNvPr>
           <p:cNvPicPr>
             <a:picLocks noChangeAspect="1"/>
           </p:cNvPicPr>
@@ -17810,7 +17810,7 @@
       </p:sp>
       <p:pic>
         <p:nvPicPr>
-          <p:cNvPr id="6" name="Image 1" descr="/tmp/pcwork/api-patterns-and-practices-graphql/presentation/_shared/png/14-cost-accumulation.png">    </p:cNvPr>
+          <p:cNvPr id="6" name="Image 1" descr="/work/_shared/png/14-cost-accumulation.png">    </p:cNvPr>
           <p:cNvPicPr>
             <a:picLocks noChangeAspect="1"/>
           </p:cNvPicPr>
@@ -17864,7 +17864,7 @@
                 <a:ea typeface="Red Hat Text" pitchFamily="34" charset="-122"/>
                 <a:cs typeface="Red Hat Text" pitchFamily="34" charset="-120"/>
               </a:rPr>
-              <a:t>Figure 14.3 — The nested query priced bottom-up: 385,151 units. The four-cargo query of Chapter 13 is 53.</a:t>
+              <a:t>Figure 14.3: The nested query priced bottom-up: 385,151 units. The four-cargo query of Chapter 13 is 53.</a:t>
             </a:r>
             <a:endParaRPr lang="en-US" sz="1300" dirty="0"/>
           </a:p>
@@ -17936,7 +17936,7 @@
       </p:sp>
       <p:pic>
         <p:nvPicPr>
-          <p:cNvPr id="3" name="Image 0" descr="/tmp/pcwork/api-patterns-and-practices-graphql/presentation/_shared/assets/logo-candidate-2.png">    </p:cNvPr>
+          <p:cNvPr id="3" name="Image 0" descr="/work/_shared/assets/logo-candidate-2.png">    </p:cNvPr>
           <p:cNvPicPr>
             <a:picLocks noChangeAspect="1"/>
           </p:cNvPicPr>
@@ -18038,7 +18038,7 @@
       </p:sp>
       <p:pic>
         <p:nvPicPr>
-          <p:cNvPr id="6" name="Image 1" descr="/tmp/pcwork/api-patterns-and-practices-graphql/presentation/_shared/png/15-apq-handshake.png">    </p:cNvPr>
+          <p:cNvPr id="6" name="Image 1" descr="/work/_shared/png/15-apq-handshake.png">    </p:cNvPr>
           <p:cNvPicPr>
             <a:picLocks noChangeAspect="1"/>
           </p:cNvPicPr>
@@ -18092,7 +18092,7 @@
                 <a:ea typeface="Red Hat Text" pitchFamily="34" charset="-122"/>
                 <a:cs typeface="Red Hat Text" pitchFamily="34" charset="-120"/>
               </a:rPr>
-              <a:t>Figure 15.1 — A miss, a registration, and a hit by GET, with request and response sizes in bytes.</a:t>
+              <a:t>Figure 15.1: A miss, a registration, and a hit by GET, with request and response sizes in bytes.</a:t>
             </a:r>
             <a:endParaRPr lang="en-US" sz="1300" dirty="0"/>
           </a:p>
@@ -18164,7 +18164,7 @@
       </p:sp>
       <p:pic>
         <p:nvPicPr>
-          <p:cNvPr id="3" name="Image 0" descr="/tmp/pcwork/api-patterns-and-practices-graphql/presentation/_shared/assets/logo-candidate-2.png">    </p:cNvPr>
+          <p:cNvPr id="3" name="Image 0" descr="/work/_shared/assets/logo-candidate-2.png">    </p:cNvPr>
           <p:cNvPicPr>
             <a:picLocks noChangeAspect="1"/>
           </p:cNvPicPr>
@@ -18266,7 +18266,7 @@
       </p:sp>
       <p:pic>
         <p:nvPicPr>
-          <p:cNvPr id="6" name="Image 1" descr="/tmp/pcwork/api-patterns-and-practices-graphql/presentation/_shared/png/15-apq-vs-trusted.png">    </p:cNvPr>
+          <p:cNvPr id="6" name="Image 1" descr="/work/_shared/png/15-apq-vs-trusted.png">    </p:cNvPr>
           <p:cNvPicPr>
             <a:picLocks noChangeAspect="1"/>
           </p:cNvPicPr>
@@ -18320,7 +18320,7 @@
                 <a:ea typeface="Red Hat Text" pitchFamily="34" charset="-122"/>
                 <a:cs typeface="Red Hat Text" pitchFamily="34" charset="-120"/>
               </a:rPr>
-              <a:t>Figure 15.2 — APQ and trusted documents compare on who registers and what the server accepts.</a:t>
+              <a:t>Figure 15.2: APQ and trusted documents compare on who registers and what the server accepts.</a:t>
             </a:r>
             <a:endParaRPr lang="en-US" sz="1300" dirty="0"/>
           </a:p>
@@ -18392,7 +18392,7 @@
       </p:sp>
       <p:pic>
         <p:nvPicPr>
-          <p:cNvPr id="3" name="Image 0" descr="/tmp/pcwork/api-patterns-and-practices-graphql/presentation/_shared/assets/logo-candidate-2.png">    </p:cNvPr>
+          <p:cNvPr id="3" name="Image 0" descr="/work/_shared/assets/logo-candidate-2.png">    </p:cNvPr>
           <p:cNvPicPr>
             <a:picLocks noChangeAspect="1"/>
           </p:cNvPicPr>
@@ -18494,7 +18494,7 @@
       </p:sp>
       <p:pic>
         <p:nvPicPr>
-          <p:cNvPr id="6" name="Image 1" descr="/tmp/pcwork/api-patterns-and-practices-graphql/presentation/_shared/png/16-cache-layers.png">    </p:cNvPr>
+          <p:cNvPr id="6" name="Image 1" descr="/work/_shared/png/16-cache-layers.png">    </p:cNvPr>
           <p:cNvPicPr>
             <a:picLocks noChangeAspect="1"/>
           </p:cNvPicPr>
@@ -18548,7 +18548,7 @@
                 <a:ea typeface="Red Hat Text" pitchFamily="34" charset="-122"/>
                 <a:cs typeface="Red Hat Text" pitchFamily="34" charset="-120"/>
               </a:rPr>
-              <a:t>Figure 16.1 — Four places to keep an answer, nearest the caller first, with the key and the eviction of each.</a:t>
+              <a:t>Figure 16.1: Four places to keep an answer, nearest the caller first, with the key and the eviction of each.</a:t>
             </a:r>
             <a:endParaRPr lang="en-US" sz="1300" dirty="0"/>
           </a:p>
@@ -18620,7 +18620,7 @@
       </p:sp>
       <p:pic>
         <p:nvPicPr>
-          <p:cNvPr id="3" name="Image 0" descr="/tmp/pcwork/api-patterns-and-practices-graphql/presentation/_shared/assets/logo-candidate-2.png">    </p:cNvPr>
+          <p:cNvPr id="3" name="Image 0" descr="/work/_shared/assets/logo-candidate-2.png">    </p:cNvPr>
           <p:cNvPicPr>
             <a:picLocks noChangeAspect="1"/>
           </p:cNvPicPr>
@@ -18722,7 +18722,7 @@
       </p:sp>
       <p:pic>
         <p:nvPicPr>
-          <p:cNvPr id="6" name="Image 1" descr="/tmp/pcwork/api-patterns-and-practices-graphql/presentation/_shared/png/16-cache-policy-decision.png">    </p:cNvPr>
+          <p:cNvPr id="6" name="Image 1" descr="/work/_shared/png/16-cache-policy-decision.png">    </p:cNvPr>
           <p:cNvPicPr>
             <a:picLocks noChangeAspect="1"/>
           </p:cNvPicPr>
@@ -18776,7 +18776,7 @@
                 <a:ea typeface="Red Hat Text" pitchFamily="34" charset="-122"/>
                 <a:cs typeface="Red Hat Text" pitchFamily="34" charset="-120"/>
               </a:rPr>
-              <a:t>Figure 16.3 — Four tests, and any no ends in no-store.</a:t>
+              <a:t>Figure 16.3: Four tests, and any no ends in no-store.</a:t>
             </a:r>
             <a:endParaRPr lang="en-US" sz="1300" dirty="0"/>
           </a:p>
@@ -18926,7 +18926,7 @@
       </p:sp>
       <p:pic>
         <p:nvPicPr>
-          <p:cNvPr id="5" name="Image 0" descr="/tmp/pcwork/api-patterns-and-practices-graphql/presentation/_shared/assets/redhat-logo-white.png">    </p:cNvPr>
+          <p:cNvPr id="5" name="Image 0" descr="/work/_shared/assets/redhat-logo-white.png">    </p:cNvPr>
           <p:cNvPicPr>
             <a:picLocks noChangeAspect="1"/>
           </p:cNvPicPr>
@@ -19014,7 +19014,7 @@
       </p:sp>
       <p:pic>
         <p:nvPicPr>
-          <p:cNvPr id="3" name="Image 0" descr="/tmp/pcwork/api-patterns-and-practices-graphql/presentation/_shared/assets/logo-candidate-2.png">    </p:cNvPr>
+          <p:cNvPr id="3" name="Image 0" descr="/work/_shared/assets/logo-candidate-2.png">    </p:cNvPr>
           <p:cNvPicPr>
             <a:picLocks noChangeAspect="1"/>
           </p:cNvPicPr>
@@ -19116,7 +19116,7 @@
       </p:sp>
       <p:pic>
         <p:nvPicPr>
-          <p:cNvPr id="6" name="Image 1" descr="/tmp/pcwork/api-patterns-and-practices-graphql/presentation/_shared/png/17-hardened-request-path.png">    </p:cNvPr>
+          <p:cNvPr id="6" name="Image 1" descr="/work/_shared/png/17-hardened-request-path.png">    </p:cNvPr>
           <p:cNvPicPr>
             <a:picLocks noChangeAspect="1"/>
           </p:cNvPicPr>
@@ -19170,7 +19170,7 @@
                 <a:ea typeface="Red Hat Text" pitchFamily="34" charset="-122"/>
                 <a:cs typeface="Red Hat Text" pitchFamily="34" charset="-120"/>
               </a:rPr>
-              <a:t>Figure 17.1 — The gates in front of a public instance. A refused request makes no source call.</a:t>
+              <a:t>Figure 17.1: The gates in front of a public instance. A refused request makes no source call.</a:t>
             </a:r>
             <a:endParaRPr lang="en-US" sz="1300" dirty="0"/>
           </a:p>
@@ -19242,7 +19242,7 @@
       </p:sp>
       <p:pic>
         <p:nvPicPr>
-          <p:cNvPr id="3" name="Image 0" descr="/tmp/pcwork/api-patterns-and-practices-graphql/presentation/_shared/assets/logo-candidate-2.png">    </p:cNvPr>
+          <p:cNvPr id="3" name="Image 0" descr="/work/_shared/assets/logo-candidate-2.png">    </p:cNvPr>
           <p:cNvPicPr>
             <a:picLocks noChangeAspect="1"/>
           </p:cNvPicPr>
@@ -19344,7 +19344,7 @@
       </p:sp>
       <p:pic>
         <p:nvPicPr>
-          <p:cNvPr id="6" name="Image 1" descr="/tmp/pcwork/api-patterns-and-practices-graphql/presentation/_shared/png/01-request-path.png">    </p:cNvPr>
+          <p:cNvPr id="6" name="Image 1" descr="/work/_shared/png/01-request-path.png">    </p:cNvPr>
           <p:cNvPicPr>
             <a:picLocks noChangeAspect="1"/>
           </p:cNvPicPr>
@@ -19398,7 +19398,7 @@
                 <a:ea typeface="Red Hat Text" pitchFamily="34" charset="-122"/>
                 <a:cs typeface="Red Hat Text" pitchFamily="34" charset="-120"/>
               </a:rPr>
-              <a:t>Figure 1.2 — One endpoint, one POST, four server stages and a fan-out to the services that own the data.</a:t>
+              <a:t>Figure 1.2: One endpoint, one POST, four server stages and a fan-out to the services that own the data.</a:t>
             </a:r>
             <a:endParaRPr lang="en-US" sz="1300" dirty="0"/>
           </a:p>
@@ -19470,7 +19470,7 @@
       </p:sp>
       <p:pic>
         <p:nvPicPr>
-          <p:cNvPr id="3" name="Image 0" descr="/tmp/pcwork/api-patterns-and-practices-graphql/presentation/_shared/assets/logo-candidate-2.png">    </p:cNvPr>
+          <p:cNvPr id="3" name="Image 0" descr="/work/_shared/assets/logo-candidate-2.png">    </p:cNvPr>
           <p:cNvPicPr>
             <a:picLocks noChangeAspect="1"/>
           </p:cNvPicPr>
@@ -19572,7 +19572,7 @@
       </p:sp>
       <p:pic>
         <p:nvPicPr>
-          <p:cNvPr id="6" name="Image 1" descr="/tmp/pcwork/api-patterns-and-practices-graphql/presentation/_shared/png/17-public-vs-internal-endpoints.png">    </p:cNvPr>
+          <p:cNvPr id="6" name="Image 1" descr="/work/_shared/png/17-public-vs-internal-endpoints.png">    </p:cNvPr>
           <p:cNvPicPr>
             <a:picLocks noChangeAspect="1"/>
           </p:cNvPicPr>
@@ -19626,7 +19626,7 @@
                 <a:ea typeface="Red Hat Text" pitchFamily="34" charset="-122"/>
                 <a:cs typeface="Red Hat Text" pitchFamily="34" charset="-120"/>
               </a:rPr>
-              <a:t>Figure 17.2 — One image, deployed twice. Only the internal instance answers a schema query.</a:t>
+              <a:t>Figure 17.2: One image, deployed twice. Only the internal instance answers a schema query.</a:t>
             </a:r>
             <a:endParaRPr lang="en-US" sz="1300" dirty="0"/>
           </a:p>
@@ -19698,7 +19698,7 @@
       </p:sp>
       <p:pic>
         <p:nvPicPr>
-          <p:cNvPr id="3" name="Image 0" descr="/tmp/pcwork/api-patterns-and-practices-graphql/presentation/_shared/assets/logo-candidate-2.png">    </p:cNvPr>
+          <p:cNvPr id="3" name="Image 0" descr="/work/_shared/assets/logo-candidate-2.png">    </p:cNvPr>
           <p:cNvPicPr>
             <a:picLocks noChangeAspect="1"/>
           </p:cNvPicPr>
@@ -19800,7 +19800,7 @@
       </p:sp>
       <p:pic>
         <p:nvPicPr>
-          <p:cNvPr id="6" name="Image 1" descr="/tmp/pcwork/api-patterns-and-practices-graphql/presentation/_shared/png/18-authorization-layers.png">    </p:cNvPr>
+          <p:cNvPr id="6" name="Image 1" descr="/work/_shared/png/18-authorization-layers.png">    </p:cNvPr>
           <p:cNvPicPr>
             <a:picLocks noChangeAspect="1"/>
           </p:cNvPicPr>
@@ -19854,7 +19854,7 @@
                 <a:ea typeface="Red Hat Text" pitchFamily="34" charset="-122"/>
                 <a:cs typeface="Red Hat Text" pitchFamily="34" charset="-120"/>
               </a:rPr>
-              <a:t>Figure 18.2 — Three layers. An operation or a field refuses with a coded error; an object refuses with a null.</a:t>
+              <a:t>Figure 18.2: Three layers. An operation or a field refuses with a coded error; an object refuses with a null.</a:t>
             </a:r>
             <a:endParaRPr lang="en-US" sz="1300" dirty="0"/>
           </a:p>
@@ -19926,7 +19926,7 @@
       </p:sp>
       <p:pic>
         <p:nvPicPr>
-          <p:cNvPr id="3" name="Image 0" descr="/tmp/pcwork/api-patterns-and-practices-graphql/presentation/_shared/assets/logo-candidate-2.png">    </p:cNvPr>
+          <p:cNvPr id="3" name="Image 0" descr="/work/_shared/assets/logo-candidate-2.png">    </p:cNvPr>
           <p:cNvPicPr>
             <a:picLocks noChangeAspect="1"/>
           </p:cNvPicPr>
@@ -20028,7 +20028,7 @@
       </p:sp>
       <p:pic>
         <p:nvPicPr>
-          <p:cNvPr id="6" name="Image 1" descr="/tmp/pcwork/api-patterns-and-practices-graphql/presentation/_shared/png/18-errors-vs-nulls.png">    </p:cNvPr>
+          <p:cNvPr id="6" name="Image 1" descr="/work/_shared/png/18-errors-vs-nulls.png">    </p:cNvPr>
           <p:cNvPicPr>
             <a:picLocks noChangeAspect="1"/>
           </p:cNvPicPr>
@@ -20082,7 +20082,7 @@
                 <a:ea typeface="Red Hat Text" pitchFamily="34" charset="-122"/>
                 <a:cs typeface="Red Hat Text" pitchFamily="34" charset="-120"/>
               </a:rPr>
-              <a:t>Figure 18.3 — Fields: error. Objects: null. A refused object looks like one that does not exist.</a:t>
+              <a:t>Figure 18.3: Fields: error. Objects: null. A refused object looks like one that does not exist.</a:t>
             </a:r>
             <a:endParaRPr lang="en-US" sz="1300" dirty="0"/>
           </a:p>
@@ -20232,7 +20232,7 @@
       </p:sp>
       <p:pic>
         <p:nvPicPr>
-          <p:cNvPr id="5" name="Image 0" descr="/tmp/pcwork/api-patterns-and-practices-graphql/presentation/_shared/assets/redhat-logo-white.png">    </p:cNvPr>
+          <p:cNvPr id="5" name="Image 0" descr="/work/_shared/assets/redhat-logo-white.png">    </p:cNvPr>
           <p:cNvPicPr>
             <a:picLocks noChangeAspect="1"/>
           </p:cNvPicPr>
@@ -20320,7 +20320,7 @@
       </p:sp>
       <p:pic>
         <p:nvPicPr>
-          <p:cNvPr id="3" name="Image 0" descr="/tmp/pcwork/api-patterns-and-practices-graphql/presentation/_shared/assets/logo-candidate-2.png">    </p:cNvPr>
+          <p:cNvPr id="3" name="Image 0" descr="/work/_shared/assets/logo-candidate-2.png">    </p:cNvPr>
           <p:cNvPicPr>
             <a:picLocks noChangeAspect="1"/>
           </p:cNvPicPr>
@@ -20422,7 +20422,7 @@
       </p:sp>
       <p:pic>
         <p:nvPicPr>
-          <p:cNvPr id="6" name="Image 1" descr="/tmp/pcwork/api-patterns-and-practices-graphql/presentation/_shared/png/19-one-endpoint-blind-spot.png">    </p:cNvPr>
+          <p:cNvPr id="6" name="Image 1" descr="/work/_shared/png/19-one-endpoint-blind-spot.png">    </p:cNvPr>
           <p:cNvPicPr>
             <a:picLocks noChangeAspect="1"/>
           </p:cNvPicPr>
@@ -20476,7 +20476,7 @@
                 <a:ea typeface="Red Hat Text" pitchFamily="34" charset="-122"/>
                 <a:cs typeface="Red Hat Text" pitchFamily="34" charset="-120"/>
               </a:rPr>
-              <a:t>Figure 19.1 — The same nine requests, keyed two ways. The operation name and error code separate them.</a:t>
+              <a:t>Figure 19.1: The same nine requests, keyed two ways. The operation name and error code separate them.</a:t>
             </a:r>
             <a:endParaRPr lang="en-US" sz="1300" dirty="0"/>
           </a:p>
@@ -20548,7 +20548,7 @@
       </p:sp>
       <p:pic>
         <p:nvPicPr>
-          <p:cNvPr id="3" name="Image 0" descr="/tmp/pcwork/api-patterns-and-practices-graphql/presentation/_shared/assets/logo-candidate-2.png">    </p:cNvPr>
+          <p:cNvPr id="3" name="Image 0" descr="/work/_shared/assets/logo-candidate-2.png">    </p:cNvPr>
           <p:cNvPicPr>
             <a:picLocks noChangeAspect="1"/>
           </p:cNvPicPr>
@@ -20650,7 +20650,7 @@
       </p:sp>
       <p:pic>
         <p:nvPicPr>
-          <p:cNvPr id="6" name="Image 1" descr="/tmp/pcwork/api-patterns-and-practices-graphql/presentation/_shared/png/19-span-per-resolver.png">    </p:cNvPr>
+          <p:cNvPr id="6" name="Image 1" descr="/work/_shared/png/19-span-per-resolver.png">    </p:cNvPr>
           <p:cNvPicPr>
             <a:picLocks noChangeAspect="1"/>
           </p:cNvPicPr>
@@ -20704,7 +20704,7 @@
                 <a:ea typeface="Red Hat Text" pitchFamily="34" charset="-122"/>
                 <a:cs typeface="Red Hat Text" pitchFamily="34" charset="-120"/>
               </a:rPr>
-              <a:t>Figure 19.3 — Twenty-five resolver spans in four levels, and one source call per batch.</a:t>
+              <a:t>Figure 19.3: Twenty-five resolver spans in four levels, and one source call per batch.</a:t>
             </a:r>
             <a:endParaRPr lang="en-US" sz="1300" dirty="0"/>
           </a:p>
@@ -20776,7 +20776,7 @@
       </p:sp>
       <p:pic>
         <p:nvPicPr>
-          <p:cNvPr id="3" name="Image 0" descr="/tmp/pcwork/api-patterns-and-practices-graphql/presentation/_shared/assets/logo-candidate-2.png">    </p:cNvPr>
+          <p:cNvPr id="3" name="Image 0" descr="/work/_shared/assets/logo-candidate-2.png">    </p:cNvPr>
           <p:cNvPicPr>
             <a:picLocks noChangeAspect="1"/>
           </p:cNvPicPr>
@@ -20878,7 +20878,7 @@
       </p:sp>
       <p:pic>
         <p:nvPicPr>
-          <p:cNvPr id="6" name="Image 1" descr="/tmp/pcwork/api-patterns-and-practices-graphql/presentation/_shared/png/20-subgraph-ownership.png">    </p:cNvPr>
+          <p:cNvPr id="6" name="Image 1" descr="/work/_shared/png/20-subgraph-ownership.png">    </p:cNvPr>
           <p:cNvPicPr>
             <a:picLocks noChangeAspect="1"/>
           </p:cNvPicPr>
@@ -20932,7 +20932,7 @@
                 <a:ea typeface="Red Hat Text" pitchFamily="34" charset="-122"/>
                 <a:cs typeface="Red Hat Text" pitchFamily="34" charset="-120"/>
               </a:rPr>
-              <a:t>Figure 20.1 — Each field has one owner. An entity is shared by its key; a reference names a place only.</a:t>
+              <a:t>Figure 20.1: Each field has one owner. An entity is shared by its key; a reference names a place only.</a:t>
             </a:r>
             <a:endParaRPr lang="en-US" sz="1300" dirty="0"/>
           </a:p>
@@ -21004,7 +21004,7 @@
       </p:sp>
       <p:pic>
         <p:nvPicPr>
-          <p:cNvPr id="3" name="Image 0" descr="/tmp/pcwork/api-patterns-and-practices-graphql/presentation/_shared/assets/logo-candidate-2.png">    </p:cNvPr>
+          <p:cNvPr id="3" name="Image 0" descr="/work/_shared/assets/logo-candidate-2.png">    </p:cNvPr>
           <p:cNvPicPr>
             <a:picLocks noChangeAspect="1"/>
           </p:cNvPicPr>
@@ -21106,7 +21106,7 @@
       </p:sp>
       <p:pic>
         <p:nvPicPr>
-          <p:cNvPr id="6" name="Image 1" descr="/tmp/pcwork/api-patterns-and-practices-graphql/presentation/_shared/png/20-query-plan.png">    </p:cNvPr>
+          <p:cNvPr id="6" name="Image 1" descr="/work/_shared/png/20-query-plan.png">    </p:cNvPr>
           <p:cNvPicPr>
             <a:picLocks noChangeAspect="1"/>
           </p:cNvPicPr>
@@ -21160,7 +21160,7 @@
                 <a:ea typeface="Red Hat Text" pitchFamily="34" charset="-122"/>
                 <a:cs typeface="Red Hat Text" pitchFamily="34" charset="-120"/>
               </a:rPr>
-              <a:t>Figure 20.3 — One client request, three subgraph fetches. The cargo subgraph is asked twice.</a:t>
+              <a:t>Figure 20.3: One client request, three subgraph fetches. The cargo subgraph is asked twice.</a:t>
             </a:r>
             <a:endParaRPr lang="en-US" sz="1300" dirty="0"/>
           </a:p>
@@ -21310,7 +21310,7 @@
       </p:sp>
       <p:pic>
         <p:nvPicPr>
-          <p:cNvPr id="5" name="Image 0" descr="/tmp/pcwork/api-patterns-and-practices-graphql/presentation/_shared/assets/redhat-logo-white.png">    </p:cNvPr>
+          <p:cNvPr id="5" name="Image 0" descr="/work/_shared/assets/redhat-logo-white.png">    </p:cNvPr>
           <p:cNvPicPr>
             <a:picLocks noChangeAspect="1"/>
           </p:cNvPicPr>
@@ -21398,7 +21398,7 @@
       </p:sp>
       <p:pic>
         <p:nvPicPr>
-          <p:cNvPr id="3" name="Image 0" descr="/tmp/pcwork/api-patterns-and-practices-graphql/presentation/_shared/assets/logo-candidate-2.png">    </p:cNvPr>
+          <p:cNvPr id="3" name="Image 0" descr="/work/_shared/assets/logo-candidate-2.png">    </p:cNvPr>
           <p:cNvPicPr>
             <a:picLocks noChangeAspect="1"/>
           </p:cNvPicPr>
@@ -21500,7 +21500,7 @@
       </p:sp>
       <p:pic>
         <p:nvPicPr>
-          <p:cNvPr id="6" name="Image 1" descr="/tmp/pcwork/api-patterns-and-practices-graphql/presentation/_shared/png/21-three-ways-to-push.png">    </p:cNvPr>
+          <p:cNvPr id="6" name="Image 1" descr="/work/_shared/png/21-three-ways-to-push.png">    </p:cNvPr>
           <p:cNvPicPr>
             <a:picLocks noChangeAspect="1"/>
           </p:cNvPicPr>
@@ -21554,7 +21554,7 @@
                 <a:ea typeface="Red Hat Text" pitchFamily="34" charset="-122"/>
                 <a:cs typeface="Red Hat Text" pitchFamily="34" charset="-120"/>
               </a:rPr>
-              <a:t>Figure 21.1 — GraphQL columns keep the selection set and schema; the plain feed trades them for resume.</a:t>
+              <a:t>Figure 21.1: GraphQL columns keep the selection set and schema; the plain feed trades them for resume.</a:t>
             </a:r>
             <a:endParaRPr lang="en-US" sz="1300" dirty="0"/>
           </a:p>
@@ -21626,7 +21626,7 @@
       </p:sp>
       <p:pic>
         <p:nvPicPr>
-          <p:cNvPr id="3" name="Image 0" descr="/tmp/pcwork/api-patterns-and-practices-graphql/presentation/_shared/assets/logo-candidate-2.png">    </p:cNvPr>
+          <p:cNvPr id="3" name="Image 0" descr="/work/_shared/assets/logo-candidate-2.png">    </p:cNvPr>
           <p:cNvPicPr>
             <a:picLocks noChangeAspect="1"/>
           </p:cNvPicPr>
@@ -21862,7 +21862,7 @@
                 <a:ea typeface="Red Hat Mono" pitchFamily="34" charset="-122"/>
                 <a:cs typeface="Red Hat Mono" pitchFamily="34" charset="-120"/>
               </a:rPr>
-              <a:t>The services behind the tracking view own the data and the rules. The cargo service decides what a booking is. The routing service decides which itinerary satisfies a route specification. The handling service records what physically happened. The delivery state is derived from those events and the itinerary, and Chapter 7 puts that derivation in the tracking view. Each of them may speak REST or gRPC, exactly as the sibling books describe, and none of them needs to know GraphQL exists. The tracking view owns no business data. It owns a schema, a set of resolvers that know which service to ask for which field, and the logic that stitches the answers into a graph and derives the delivery state.
+              <a:t>The services behind the tracking view own the data and the rules. The cargo service decides what a booking is. The routing service decides which itinerary satisfies a route specification. The handling service records what physically happened. The delivery state is derived from those events and the itinerary, and that derivation lives inside the tracking view itself. Each of them may speak REST or gRPC, exactly as the sibling books describe, and none of them needs to know GraphQL exists. The tracking view owns no business data. It owns a schema, a set of resolvers that know which service to ask for which field, and the logic that stitches the answers into a graph and derives the delivery state.
 </a:t>
             </a:r>
             <a:pPr algn="l" indent="0" marL="0">
@@ -21934,7 +21934,7 @@
                 <a:ea typeface="Red Hat Mono" pitchFamily="34" charset="-122"/>
                 <a:cs typeface="Red Hat Mono" pitchFamily="34" charset="-120"/>
               </a:rPr>
-              <a:t>The read-oriented emphasis is a design choice. The schema does contain one mutation, `registerHandlingEvent`, because recording a handling event is the one write a tracking client legitimately initiates, and Chapter 8 treats mutations in detail. Booking a cargo and assigning its route remain REST and gRPC operations in the owning services. Chapter 2 gives the criteria that put each interaction on its side of that line.
+              <a:t>The read-oriented emphasis is a design choice. The schema does contain one mutation, `registerHandlingEvent`, because recording a handling event is the one write a tracking client legitimately initiates, and mutation design gets full treatment later in the book. Booking a cargo and assigning its route remain REST and gRPC operations in the owning services. A decision framework gives the criteria that put each interaction on its side of that line.
 </a:t>
             </a:r>
             <a:pPr algn="l" indent="0" marL="0">
@@ -22204,7 +22204,7 @@
                 <a:ea typeface="Red Hat Mono" pitchFamily="34" charset="-122"/>
                 <a:cs typeface="Red Hat Mono" pitchFamily="34" charset="-120"/>
               </a:rPr>
-              <a:t>The operation takes one variable, `$id`, typed with the schema's `TrackingId` scalar and marked non-null with `!`. The root field `cargo` resolves one `Cargo` by tracking id. Inside it, `origin`, `destination` and `lastKnownLocation` are `Location` objects of which the client asks only for the UN/LOCODE and the name. `itinerary` is nullable in the schema because a cargo that has not been routed has none, and `handlingHistory(first: 2)` uses the Relay connection pattern that Chapter 12 covers: edges that wrap nodes, so the client can page through events newest first.
+              <a:t>The operation takes one variable, `$id`, typed with the schema's `TrackingId` scalar and marked non-null with `!`. The root field `cargo` resolves one `Cargo` by tracking id. Inside it, `origin`, `destination` and `lastKnownLocation` are `Location` objects of which the client asks only for the UN/LOCODE and the name. `itinerary` is nullable in the schema because a cargo that has not been routed has none, and `handlingHistory(first: 2)` uses the Relay connection pattern: edges that wrap nodes, so the client can page through events newest first.
 </a:t>
             </a:r>
             <a:pPr algn="l" indent="0" marL="0">
@@ -22370,7 +22370,7 @@
       </p:sp>
       <p:pic>
         <p:nvPicPr>
-          <p:cNvPr id="3" name="Image 0" descr="/tmp/pcwork/api-patterns-and-practices-graphql/presentation/_shared/assets/logo-candidate-2.png">    </p:cNvPr>
+          <p:cNvPr id="3" name="Image 0" descr="/work/_shared/assets/logo-candidate-2.png">    </p:cNvPr>
           <p:cNvPicPr>
             <a:picLocks noChangeAspect="1"/>
           </p:cNvPicPr>
@@ -23394,7 +23394,7 @@
       </p:sp>
       <p:pic>
         <p:nvPicPr>
-          <p:cNvPr id="3" name="Image 0" descr="/tmp/pcwork/api-patterns-and-practices-graphql/presentation/_shared/assets/logo-candidate-2.png">    </p:cNvPr>
+          <p:cNvPr id="3" name="Image 0" descr="/work/_shared/assets/logo-candidate-2.png">    </p:cNvPr>
           <p:cNvPicPr>
             <a:picLocks noChangeAspect="1"/>
           </p:cNvPicPr>
@@ -23496,7 +23496,7 @@
       </p:sp>
       <p:pic>
         <p:nvPicPr>
-          <p:cNvPr id="6" name="Image 1" descr="/tmp/pcwork/api-patterns-and-practices-graphql/presentation/_shared/png/22-normalized-cache-update.png">    </p:cNvPr>
+          <p:cNvPr id="6" name="Image 1" descr="/work/_shared/png/22-normalized-cache-update.png">    </p:cNvPr>
           <p:cNvPicPr>
             <a:picLocks noChangeAspect="1"/>
           </p:cNvPicPr>
@@ -23550,7 +23550,7 @@
                 <a:ea typeface="Red Hat Text" pitchFamily="34" charset="-122"/>
                 <a:cs typeface="Red Hat Text" pitchFamily="34" charset="-120"/>
               </a:rPr>
-              <a:t>Figure 22.2 — Two requests leave the client; the second query is answered from the first one's entry.</a:t>
+              <a:t>Figure 22.2: Two requests leave the client; the second query is answered from the first one's entry.</a:t>
             </a:r>
             <a:endParaRPr lang="en-US" sz="1300" dirty="0"/>
           </a:p>
@@ -23700,7 +23700,7 @@
       </p:sp>
       <p:pic>
         <p:nvPicPr>
-          <p:cNvPr id="5" name="Image 0" descr="/tmp/pcwork/api-patterns-and-practices-graphql/presentation/_shared/assets/redhat-logo-white.png">    </p:cNvPr>
+          <p:cNvPr id="5" name="Image 0" descr="/work/_shared/assets/redhat-logo-white.png">    </p:cNvPr>
           <p:cNvPicPr>
             <a:picLocks noChangeAspect="1"/>
           </p:cNvPicPr>
@@ -23788,7 +23788,7 @@
       </p:sp>
       <p:pic>
         <p:nvPicPr>
-          <p:cNvPr id="3" name="Image 0" descr="/tmp/pcwork/api-patterns-and-practices-graphql/presentation/_shared/assets/logo-candidate-2.png">    </p:cNvPr>
+          <p:cNvPr id="3" name="Image 0" descr="/work/_shared/assets/logo-candidate-2.png">    </p:cNvPr>
           <p:cNvPicPr>
             <a:picLocks noChangeAspect="1"/>
           </p:cNvPicPr>
@@ -23890,7 +23890,7 @@
       </p:sp>
       <p:pic>
         <p:nvPicPr>
-          <p:cNvPr id="6" name="Image 1" descr="/tmp/pcwork/api-patterns-and-practices-graphql/presentation/_shared/png/23-test-layers.png">    </p:cNvPr>
+          <p:cNvPr id="6" name="Image 1" descr="/work/_shared/png/23-test-layers.png">    </p:cNvPr>
           <p:cNvPicPr>
             <a:picLocks noChangeAspect="1"/>
           </p:cNvPicPr>
@@ -23944,7 +23944,7 @@
                 <a:ea typeface="Red Hat Text" pitchFamily="34" charset="-122"/>
                 <a:cs typeface="Red Hat Text" pitchFamily="34" charset="-120"/>
               </a:rPr>
-              <a:t>Figure 23.1 — Six layers: three run in each stack's test image, three against the live stacks.</a:t>
+              <a:t>Figure 23.1: Six layers: three run in each stack's test image, three against the live stacks.</a:t>
             </a:r>
             <a:endParaRPr lang="en-US" sz="1300" dirty="0"/>
           </a:p>
@@ -24016,7 +24016,7 @@
       </p:sp>
       <p:pic>
         <p:nvPicPr>
-          <p:cNvPr id="3" name="Image 0" descr="/tmp/pcwork/api-patterns-and-practices-graphql/presentation/_shared/assets/logo-candidate-2.png">    </p:cNvPr>
+          <p:cNvPr id="3" name="Image 0" descr="/work/_shared/assets/logo-candidate-2.png">    </p:cNvPr>
           <p:cNvPicPr>
             <a:picLocks noChangeAspect="1"/>
           </p:cNvPicPr>
@@ -24118,7 +24118,7 @@
       </p:sp>
       <p:pic>
         <p:nvPicPr>
-          <p:cNvPr id="6" name="Image 1" descr="/tmp/pcwork/api-patterns-and-practices-graphql/presentation/_shared/png/24-diagnosis-path.png">    </p:cNvPr>
+          <p:cNvPr id="6" name="Image 1" descr="/work/_shared/png/24-diagnosis-path.png">    </p:cNvPr>
           <p:cNvPicPr>
             <a:picLocks noChangeAspect="1"/>
           </p:cNvPicPr>
@@ -24172,7 +24172,7 @@
                 <a:ea typeface="Red Hat Text" pitchFamily="34" charset="-122"/>
                 <a:cs typeface="Red Hat Text" pitchFamily="34" charset="-120"/>
               </a:rPr>
-              <a:t>Figure 24.1 — One masked error followed to the data, through the trace id, the trace and the log.</a:t>
+              <a:t>Figure 24.1: One masked error followed to the data, through the trace id, the trace and the log.</a:t>
             </a:r>
             <a:endParaRPr lang="en-US" sz="1300" dirty="0"/>
           </a:p>
@@ -24322,7 +24322,7 @@
       </p:sp>
       <p:pic>
         <p:nvPicPr>
-          <p:cNvPr id="5" name="Image 0" descr="/tmp/pcwork/api-patterns-and-practices-graphql/presentation/_shared/assets/redhat-logo-white.png">    </p:cNvPr>
+          <p:cNvPr id="5" name="Image 0" descr="/work/_shared/assets/redhat-logo-white.png">    </p:cNvPr>
           <p:cNvPicPr>
             <a:picLocks noChangeAspect="1"/>
           </p:cNvPicPr>
@@ -24410,7 +24410,7 @@
       </p:sp>
       <p:pic>
         <p:nvPicPr>
-          <p:cNvPr id="3" name="Image 0" descr="/tmp/pcwork/api-patterns-and-practices-graphql/presentation/_shared/assets/logo-candidate-2.png">    </p:cNvPr>
+          <p:cNvPr id="3" name="Image 0" descr="/work/_shared/assets/logo-candidate-2.png">    </p:cNvPr>
           <p:cNvPicPr>
             <a:picLocks noChangeAspect="1"/>
           </p:cNvPicPr>
@@ -24512,7 +24512,7 @@
       </p:sp>
       <p:pic>
         <p:nvPicPr>
-          <p:cNvPr id="6" name="Image 1" descr="/tmp/pcwork/api-patterns-and-practices-graphql/presentation/_shared/png/26-compose-to-kubernetes.png">    </p:cNvPr>
+          <p:cNvPr id="6" name="Image 1" descr="/work/_shared/png/26-compose-to-kubernetes.png">    </p:cNvPr>
           <p:cNvPicPr>
             <a:picLocks noChangeAspect="1"/>
           </p:cNvPicPr>
@@ -24566,7 +24566,7 @@
                 <a:ea typeface="Red Hat Text" pitchFamily="34" charset="-122"/>
                 <a:cs typeface="Red Hat Text" pitchFamily="34" charset="-120"/>
               </a:rPr>
-              <a:t>Figure 26.1 — Compose concepts and the chart templates that carry them; images and environment match.</a:t>
+              <a:t>Figure 26.1: Compose concepts and the chart templates that carry them; images and environment match.</a:t>
             </a:r>
             <a:endParaRPr lang="en-US" sz="1300" dirty="0"/>
           </a:p>
@@ -24638,7 +24638,7 @@
       </p:sp>
       <p:pic>
         <p:nvPicPr>
-          <p:cNvPr id="3" name="Image 0" descr="/tmp/pcwork/api-patterns-and-practices-graphql/presentation/_shared/assets/logo-candidate-2.png">    </p:cNvPr>
+          <p:cNvPr id="3" name="Image 0" descr="/work/_shared/assets/logo-candidate-2.png">    </p:cNvPr>
           <p:cNvPicPr>
             <a:picLocks noChangeAspect="1"/>
           </p:cNvPicPr>
@@ -24740,7 +24740,7 @@
       </p:sp>
       <p:pic>
         <p:nvPicPr>
-          <p:cNvPr id="6" name="Image 1" descr="/tmp/pcwork/api-patterns-and-practices-graphql/presentation/_shared/png/27-final-architecture.png">    </p:cNvPr>
+          <p:cNvPr id="6" name="Image 1" descr="/work/_shared/png/27-final-architecture.png">    </p:cNvPr>
           <p:cNvPicPr>
             <a:picLocks noChangeAspect="1"/>
           </p:cNvPicPr>
@@ -24794,7 +24794,7 @@
                 <a:ea typeface="Red Hat Text" pitchFamily="34" charset="-122"/>
                 <a:cs typeface="Red Hat Text" pitchFamily="34" charset="-120"/>
               </a:rPr>
-              <a:t>Figure 27.1 — The final project's compose tier. Each component implements one pattern from the deck.</a:t>
+              <a:t>Figure 27.1: The final project's compose tier. Each component implements one pattern from the deck.</a:t>
             </a:r>
             <a:endParaRPr lang="en-US" sz="1300" dirty="0"/>
           </a:p>
@@ -24866,7 +24866,7 @@
       </p:sp>
       <p:pic>
         <p:nvPicPr>
-          <p:cNvPr id="3" name="Image 0" descr="/tmp/pcwork/api-patterns-and-practices-graphql/presentation/_shared/assets/logo-candidate-2.png">    </p:cNvPr>
+          <p:cNvPr id="3" name="Image 0" descr="/work/_shared/assets/logo-candidate-2.png">    </p:cNvPr>
           <p:cNvPicPr>
             <a:picLocks noChangeAspect="1"/>
           </p:cNvPicPr>
@@ -24968,7 +24968,7 @@
       </p:sp>
       <p:pic>
         <p:nvPicPr>
-          <p:cNvPr id="6" name="Image 1" descr="/tmp/pcwork/api-patterns-and-practices-graphql/presentation/_shared/png/27-request-defences.png">    </p:cNvPr>
+          <p:cNvPr id="6" name="Image 1" descr="/work/_shared/png/27-request-defences.png">    </p:cNvPr>
           <p:cNvPicPr>
             <a:picLocks noChangeAspect="1"/>
           </p:cNvPicPr>
@@ -25022,7 +25022,7 @@
                 <a:ea typeface="Red Hat Text" pitchFamily="34" charset="-122"/>
                 <a:cs typeface="Red Hat Text" pitchFamily="34" charset="-120"/>
               </a:rPr>
-              <a:t>Figure 27.2 — The defences in the order a request meets them, and the answer each gives.</a:t>
+              <a:t>Figure 27.2: The defences in the order a request meets them, and the answer each gives.</a:t>
             </a:r>
             <a:endParaRPr lang="en-US" sz="1300" dirty="0"/>
           </a:p>
@@ -25094,7 +25094,7 @@
       </p:sp>
       <p:pic>
         <p:nvPicPr>
-          <p:cNvPr id="3" name="Image 0" descr="/tmp/pcwork/api-patterns-and-practices-graphql/presentation/_shared/assets/logo-candidate-2.png">    </p:cNvPr>
+          <p:cNvPr id="3" name="Image 0" descr="/work/_shared/assets/logo-candidate-2.png">    </p:cNvPr>
           <p:cNvPicPr>
             <a:picLocks noChangeAspect="1"/>
           </p:cNvPicPr>
@@ -26709,7 +26709,7 @@
       </p:sp>
       <p:pic>
         <p:nvPicPr>
-          <p:cNvPr id="3" name="Image 0" descr="/tmp/pcwork/api-patterns-and-practices-graphql/presentation/_shared/assets/logo-candidate-2.png">    </p:cNvPr>
+          <p:cNvPr id="3" name="Image 0" descr="/work/_shared/assets/logo-candidate-2.png">    </p:cNvPr>
           <p:cNvPicPr>
             <a:picLocks noChangeAspect="1"/>
           </p:cNvPicPr>
@@ -28599,7 +28599,7 @@
       </p:sp>
       <p:pic>
         <p:nvPicPr>
-          <p:cNvPr id="5" name="Image 0" descr="/tmp/pcwork/api-patterns-and-practices-graphql/presentation/_shared/assets/redhat-logo-white.png">    </p:cNvPr>
+          <p:cNvPr id="5" name="Image 0" descr="/work/_shared/assets/redhat-logo-white.png">    </p:cNvPr>
           <p:cNvPicPr>
             <a:picLocks noChangeAspect="1"/>
           </p:cNvPicPr>
@@ -28687,7 +28687,7 @@
       </p:sp>
       <p:pic>
         <p:nvPicPr>
-          <p:cNvPr id="3" name="Image 0" descr="/tmp/pcwork/api-patterns-and-practices-graphql/presentation/_shared/assets/logo-candidate-2.png">    </p:cNvPr>
+          <p:cNvPr id="3" name="Image 0" descr="/work/_shared/assets/logo-candidate-2.png">    </p:cNvPr>
           <p:cNvPicPr>
             <a:picLocks noChangeAspect="1"/>
           </p:cNvPicPr>
@@ -29377,7 +29377,7 @@
       </p:sp>
       <p:pic>
         <p:nvPicPr>
-          <p:cNvPr id="3" name="Image 0" descr="/tmp/pcwork/api-patterns-and-practices-graphql/presentation/_shared/assets/logo-candidate-2.png">    </p:cNvPr>
+          <p:cNvPr id="3" name="Image 0" descr="/work/_shared/assets/logo-candidate-2.png">    </p:cNvPr>
           <p:cNvPicPr>
             <a:picLocks noChangeAspect="1"/>
           </p:cNvPicPr>
@@ -30067,7 +30067,7 @@
       </p:sp>
       <p:pic>
         <p:nvPicPr>
-          <p:cNvPr id="3" name="Image 0" descr="/tmp/pcwork/api-patterns-and-practices-graphql/presentation/_shared/assets/logo-candidate-2.png">    </p:cNvPr>
+          <p:cNvPr id="3" name="Image 0" descr="/work/_shared/assets/logo-candidate-2.png">    </p:cNvPr>
           <p:cNvPicPr>
             <a:picLocks noChangeAspect="1"/>
           </p:cNvPicPr>
@@ -30793,7 +30793,7 @@
       </p:sp>
       <p:pic>
         <p:nvPicPr>
-          <p:cNvPr id="3" name="Image 0" descr="/tmp/pcwork/api-patterns-and-practices-graphql/presentation/_shared/assets/logo-candidate-2.png">    </p:cNvPr>
+          <p:cNvPr id="3" name="Image 0" descr="/work/_shared/assets/logo-candidate-2.png">    </p:cNvPr>
           <p:cNvPicPr>
             <a:picLocks noChangeAspect="1"/>
           </p:cNvPicPr>
@@ -31393,7 +31393,7 @@
       </p:sp>
       <p:pic>
         <p:nvPicPr>
-          <p:cNvPr id="3" name="Image 0" descr="/tmp/pcwork/api-patterns-and-practices-graphql/presentation/_shared/assets/logo-candidate-2.png">    </p:cNvPr>
+          <p:cNvPr id="3" name="Image 0" descr="/work/_shared/assets/logo-candidate-2.png">    </p:cNvPr>
           <p:cNvPicPr>
             <a:picLocks noChangeAspect="1"/>
           </p:cNvPicPr>
@@ -33008,7 +33008,7 @@
       </p:sp>
       <p:pic>
         <p:nvPicPr>
-          <p:cNvPr id="3" name="Image 0" descr="/tmp/pcwork/api-patterns-and-practices-graphql/presentation/_shared/assets/logo-candidate-2.png">    </p:cNvPr>
+          <p:cNvPr id="3" name="Image 0" descr="/work/_shared/assets/logo-candidate-2.png">    </p:cNvPr>
           <p:cNvPicPr>
             <a:picLocks noChangeAspect="1"/>
           </p:cNvPicPr>
@@ -33782,7 +33782,7 @@
       </p:sp>
       <p:pic>
         <p:nvPicPr>
-          <p:cNvPr id="3" name="Image 0" descr="/tmp/pcwork/api-patterns-and-practices-graphql/presentation/_shared/assets/logo-candidate-2.png">    </p:cNvPr>
+          <p:cNvPr id="3" name="Image 0" descr="/work/_shared/assets/logo-candidate-2.png">    </p:cNvPr>
           <p:cNvPicPr>
             <a:picLocks noChangeAspect="1"/>
           </p:cNvPicPr>
@@ -34153,7 +34153,7 @@
       </p:sp>
       <p:pic>
         <p:nvPicPr>
-          <p:cNvPr id="3" name="Image 0" descr="/tmp/pcwork/api-patterns-and-practices-graphql/presentation/_shared/assets/logo-candidate-2.png">    </p:cNvPr>
+          <p:cNvPr id="3" name="Image 0" descr="/work/_shared/assets/logo-candidate-2.png">    </p:cNvPr>
           <p:cNvPicPr>
             <a:picLocks noChangeAspect="1"/>
           </p:cNvPicPr>
@@ -34428,7 +34428,7 @@
       </p:sp>
       <p:pic>
         <p:nvPicPr>
-          <p:cNvPr id="3" name="Image 0" descr="/tmp/pcwork/api-patterns-and-practices-graphql/presentation/_shared/assets/logo-candidate-2.png">    </p:cNvPr>
+          <p:cNvPr id="3" name="Image 0" descr="/work/_shared/assets/logo-candidate-2.png">    </p:cNvPr>
           <p:cNvPicPr>
             <a:picLocks noChangeAspect="1"/>
           </p:cNvPicPr>
@@ -34530,7 +34530,7 @@
       </p:sp>
       <p:pic>
         <p:nvPicPr>
-          <p:cNvPr id="6" name="Image 1" descr="/tmp/pcwork/api-patterns-and-practices-graphql/presentation/_shared/assets/qr-graphql-site.png">    </p:cNvPr>
+          <p:cNvPr id="6" name="Image 1" descr="/work/_shared/assets/qr-graphql-site.png">    </p:cNvPr>
           <p:cNvPicPr>
             <a:picLocks noChangeAspect="1"/>
           </p:cNvPicPr>
@@ -34671,7 +34671,7 @@
       </p:sp>
       <p:pic>
         <p:nvPicPr>
-          <p:cNvPr id="10" name="Image 2" descr="/tmp/pcwork/api-patterns-and-practices-graphql/presentation/_shared/assets/qr-hub.png">    </p:cNvPr>
+          <p:cNvPr id="10" name="Image 2" descr="/work/_shared/assets/qr-hub.png">    </p:cNvPr>
           <p:cNvPicPr>
             <a:picLocks noChangeAspect="1"/>
           </p:cNvPicPr>
@@ -34876,7 +34876,7 @@
       </p:sp>
       <p:pic>
         <p:nvPicPr>
-          <p:cNvPr id="3" name="Image 0" descr="/tmp/pcwork/api-patterns-and-practices-graphql/presentation/_shared/assets/logo-candidate-2.png">    </p:cNvPr>
+          <p:cNvPr id="3" name="Image 0" descr="/work/_shared/assets/logo-candidate-2.png">    </p:cNvPr>
           <p:cNvPicPr>
             <a:picLocks noChangeAspect="1"/>
           </p:cNvPicPr>
@@ -34978,7 +34978,7 @@
       </p:sp>
       <p:pic>
         <p:nvPicPr>
-          <p:cNvPr id="6" name="Image 1" descr="/tmp/pcwork/api-patterns-and-practices-graphql/presentation/_shared/png/02-decision-framework.png">    </p:cNvPr>
+          <p:cNvPr id="6" name="Image 1" descr="/work/_shared/png/02-decision-framework.png">    </p:cNvPr>
           <p:cNvPicPr>
             <a:picLocks noChangeAspect="1"/>
           </p:cNvPicPr>
@@ -35032,7 +35032,7 @@
                 <a:ea typeface="Red Hat Text" pitchFamily="34" charset="-122"/>
                 <a:cs typeface="Red Hat Text" pitchFamily="34" charset="-120"/>
               </a:rPr>
-              <a:t>Figure 2.1 — Seven axes feed one decision per interaction; the shipping domain lands on four answers.</a:t>
+              <a:t>Figure 2.1: Seven axes feed one decision per interaction; the shipping domain lands on four answers.</a:t>
             </a:r>
             <a:endParaRPr lang="en-US" sz="1300" dirty="0"/>
           </a:p>
@@ -35104,7 +35104,7 @@
       </p:sp>
       <p:pic>
         <p:nvPicPr>
-          <p:cNvPr id="3" name="Image 0" descr="/tmp/pcwork/api-patterns-and-practices-graphql/presentation/_shared/assets/logo-candidate-2.png">    </p:cNvPr>
+          <p:cNvPr id="3" name="Image 0" descr="/work/_shared/assets/logo-candidate-2.png">    </p:cNvPr>
           <p:cNvPicPr>
             <a:picLocks noChangeAspect="1"/>
           </p:cNvPicPr>
@@ -35206,7 +35206,7 @@
       </p:sp>
       <p:pic>
         <p:nvPicPr>
-          <p:cNvPr id="6" name="Image 1" descr="/tmp/pcwork/api-patterns-and-practices-graphql/presentation/_shared/png/02-tracking-view-topology.png">    </p:cNvPr>
+          <p:cNvPr id="6" name="Image 1" descr="/work/_shared/png/02-tracking-view-topology.png">    </p:cNvPr>
           <p:cNvPicPr>
             <a:picLocks noChangeAspect="1"/>
           </p:cNvPicPr>
@@ -35260,7 +35260,7 @@
                 <a:ea typeface="Red Hat Text" pitchFamily="34" charset="-122"/>
                 <a:cs typeface="Red Hat Text" pitchFamily="34" charset="-120"/>
               </a:rPr>
-              <a:t>Figure 2.2 — The tracking view fronts three sources for reads; writes and bulk feeds take their own paths.</a:t>
+              <a:t>Figure 2.2: The tracking view fronts three sources for reads; writes and bulk feeds take their own paths.</a:t>
             </a:r>
             <a:endParaRPr lang="en-US" sz="1300" dirty="0"/>
           </a:p>

</xml_diff>

<commit_message>
docs(deck): professional-voice pass on the three GraphQL decks (#10)
Voice cleanup of the reader-facing deck text, with the pptx rebuilt from source:

- Recast every em dash in slide text to other punctuation: figure captions
  become `Figure N.x:`, and the deck title property drops the dash. Zero em
  dashes remain in the deck sources.
- Rewrite two speaker notes that opened with "This section covers ..." to lead
  with the content, and name the related concepts instead of chapter numbers.

Kept by design: the ALL-CAPS eyebrow kickers (a deck style element), the `!`
in GraphQL non-null notation like `Boolean!`, and "fails silently" as the
pagination term. The `_shared` build helpers and the figure PNG cache
(gitignored) are unchanged; only deck.js and the rebuilt pptx move.

Rebuilt all three decks in the pinned Node 24 image; QA passes (figure embeds
48/15/16, including the two QR codes, within cap; 0 warnings).
</commit_message>
<xml_diff>
--- a/presentation/api-patterns-graphql-100/api-patterns-graphql-100.pptx
+++ b/presentation/api-patterns-graphql-100/api-patterns-graphql-100.pptx
@@ -7859,7 +7859,7 @@
       </p:grpSpPr>
       <p:pic>
         <p:nvPicPr>
-          <p:cNvPr id="2" name="Image 0" descr="/tmp/pcwork/api-patterns-and-practices-graphql/presentation/_shared/assets/cover-panel.png">    </p:cNvPr>
+          <p:cNvPr id="2" name="Image 0" descr="/work/_shared/assets/cover-panel.png">    </p:cNvPr>
           <p:cNvPicPr>
             <a:picLocks noChangeAspect="1"/>
           </p:cNvPicPr>
@@ -8073,7 +8073,7 @@
       </p:sp>
       <p:pic>
         <p:nvPicPr>
-          <p:cNvPr id="7" name="Image 1" descr="/tmp/pcwork/api-patterns-and-practices-graphql/presentation/_shared/assets/logo-candidate-2.png">    </p:cNvPr>
+          <p:cNvPr id="7" name="Image 1" descr="/work/_shared/assets/logo-candidate-2.png">    </p:cNvPr>
           <p:cNvPicPr>
             <a:picLocks noChangeAspect="1"/>
           </p:cNvPicPr>
@@ -8239,7 +8239,7 @@
       </p:sp>
       <p:pic>
         <p:nvPicPr>
-          <p:cNvPr id="5" name="Image 0" descr="/tmp/pcwork/api-patterns-and-practices-graphql/presentation/_shared/assets/redhat-logo-white.png">    </p:cNvPr>
+          <p:cNvPr id="5" name="Image 0" descr="/work/_shared/assets/redhat-logo-white.png">    </p:cNvPr>
           <p:cNvPicPr>
             <a:picLocks noChangeAspect="1"/>
           </p:cNvPicPr>
@@ -8327,7 +8327,7 @@
       </p:sp>
       <p:pic>
         <p:nvPicPr>
-          <p:cNvPr id="3" name="Image 0" descr="/tmp/pcwork/api-patterns-and-practices-graphql/presentation/_shared/assets/logo-candidate-2.png">    </p:cNvPr>
+          <p:cNvPr id="3" name="Image 0" descr="/work/_shared/assets/logo-candidate-2.png">    </p:cNvPr>
           <p:cNvPicPr>
             <a:picLocks noChangeAspect="1"/>
           </p:cNvPicPr>
@@ -8429,7 +8429,7 @@
       </p:sp>
       <p:pic>
         <p:nvPicPr>
-          <p:cNvPr id="6" name="Image 1" descr="/tmp/pcwork/api-patterns-and-practices-graphql/presentation/_shared/png/03-type-system-map.png">    </p:cNvPr>
+          <p:cNvPr id="6" name="Image 1" descr="/work/_shared/png/03-type-system-map.png">    </p:cNvPr>
           <p:cNvPicPr>
             <a:picLocks noChangeAspect="1"/>
           </p:cNvPicPr>
@@ -8483,7 +8483,7 @@
                 <a:ea typeface="Red Hat Text" pitchFamily="34" charset="-122"/>
                 <a:cs typeface="Red Hat Text" pitchFamily="34" charset="-120"/>
               </a:rPr>
-              <a:t>Figure 3.1 — The tracking view's types by kind. Every leaf of a selection ends in a scalar or an enum.</a:t>
+              <a:t>Figure 3.1: The tracking view's types by kind. Every leaf of a selection ends in a scalar or an enum.</a:t>
             </a:r>
             <a:endParaRPr lang="en-US" sz="1300" dirty="0"/>
           </a:p>
@@ -8555,7 +8555,7 @@
       </p:sp>
       <p:pic>
         <p:nvPicPr>
-          <p:cNvPr id="3" name="Image 0" descr="/tmp/pcwork/api-patterns-and-practices-graphql/presentation/_shared/assets/logo-candidate-2.png">    </p:cNvPr>
+          <p:cNvPr id="3" name="Image 0" descr="/work/_shared/assets/logo-candidate-2.png">    </p:cNvPr>
           <p:cNvPicPr>
             <a:picLocks noChangeAspect="1"/>
           </p:cNvPicPr>
@@ -9263,7 +9263,7 @@
       </p:sp>
       <p:pic>
         <p:nvPicPr>
-          <p:cNvPr id="3" name="Image 0" descr="/tmp/pcwork/api-patterns-and-practices-graphql/presentation/_shared/assets/logo-candidate-2.png">    </p:cNvPr>
+          <p:cNvPr id="3" name="Image 0" descr="/work/_shared/assets/logo-candidate-2.png">    </p:cNvPr>
           <p:cNvPicPr>
             <a:picLocks noChangeAspect="1"/>
           </p:cNvPicPr>
@@ -9365,7 +9365,7 @@
       </p:sp>
       <p:pic>
         <p:nvPicPr>
-          <p:cNvPr id="6" name="Image 1" descr="/tmp/pcwork/api-patterns-and-practices-graphql/presentation/_shared/png/03-scalar-coercion.png">    </p:cNvPr>
+          <p:cNvPr id="6" name="Image 1" descr="/work/_shared/png/03-scalar-coercion.png">    </p:cNvPr>
           <p:cNvPicPr>
             <a:picLocks noChangeAspect="1"/>
           </p:cNvPicPr>
@@ -9419,7 +9419,7 @@
                 <a:ea typeface="Red Hat Text" pitchFamily="34" charset="-122"/>
                 <a:cs typeface="Red Hat Text" pitchFamily="34" charset="-120"/>
               </a:rPr>
-              <a:t>Figure 3.2 — Three coercions around one internal value. Whatever enters, the output is one canonical string.</a:t>
+              <a:t>Figure 3.2: Three coercions around one internal value. Whatever enters, the output is one canonical string.</a:t>
             </a:r>
             <a:endParaRPr lang="en-US" sz="1300" dirty="0"/>
           </a:p>
@@ -9491,7 +9491,7 @@
       </p:sp>
       <p:pic>
         <p:nvPicPr>
-          <p:cNvPr id="3" name="Image 0" descr="/tmp/pcwork/api-patterns-and-practices-graphql/presentation/_shared/assets/logo-candidate-2.png">    </p:cNvPr>
+          <p:cNvPr id="3" name="Image 0" descr="/work/_shared/assets/logo-candidate-2.png">    </p:cNvPr>
           <p:cNvPicPr>
             <a:picLocks noChangeAspect="1"/>
           </p:cNvPicPr>
@@ -9593,7 +9593,7 @@
       </p:sp>
       <p:pic>
         <p:nvPicPr>
-          <p:cNvPr id="6" name="Image 1" descr="/tmp/pcwork/api-patterns-and-practices-graphql/presentation/_shared/png/04-wrapper-matrix.png">    </p:cNvPr>
+          <p:cNvPr id="6" name="Image 1" descr="/work/_shared/png/04-wrapper-matrix.png">    </p:cNvPr>
           <p:cNvPicPr>
             <a:picLocks noChangeAspect="1"/>
           </p:cNvPicPr>
@@ -9647,7 +9647,7 @@
                 <a:ea typeface="Red Hat Text" pitchFamily="34" charset="-122"/>
                 <a:cs typeface="Red Hat Text" pitchFamily="34" charset="-120"/>
               </a:rPr>
-              <a:t>Figure 4.1 — The six wrapper combinations and what each allows in a response.</a:t>
+              <a:t>Figure 4.1: The six wrapper combinations and what each allows in a response.</a:t>
             </a:r>
             <a:endParaRPr lang="en-US" sz="1300" dirty="0"/>
           </a:p>
@@ -9719,7 +9719,7 @@
       </p:sp>
       <p:pic>
         <p:nvPicPr>
-          <p:cNvPr id="3" name="Image 0" descr="/tmp/pcwork/api-patterns-and-practices-graphql/presentation/_shared/assets/logo-candidate-2.png">    </p:cNvPr>
+          <p:cNvPr id="3" name="Image 0" descr="/work/_shared/assets/logo-candidate-2.png">    </p:cNvPr>
           <p:cNvPicPr>
             <a:picLocks noChangeAspect="1"/>
           </p:cNvPicPr>
@@ -9821,7 +9821,7 @@
       </p:sp>
       <p:pic>
         <p:nvPicPr>
-          <p:cNvPr id="6" name="Image 1" descr="/tmp/pcwork/api-patterns-and-practices-graphql/presentation/_shared/png/04-null-bubbling-walk.png">    </p:cNvPr>
+          <p:cNvPr id="6" name="Image 1" descr="/work/_shared/png/04-null-bubbling-walk.png">    </p:cNvPr>
           <p:cNvPicPr>
             <a:picLocks noChangeAspect="1"/>
           </p:cNvPicPr>
@@ -9875,7 +9875,7 @@
                 <a:ea typeface="Red Hat Text" pitchFamily="34" charset="-122"/>
                 <a:cs typeface="Red Hat Text" pitchFamily="34" charset="-120"/>
               </a:rPr>
-              <a:t>Figure 4.2 — One null climbing from Leg.loadLocation to Cargo.itinerary, the first nullable position.</a:t>
+              <a:t>Figure 4.2: One null climbing from Leg.loadLocation to Cargo.itinerary, the first nullable position.</a:t>
             </a:r>
             <a:endParaRPr lang="en-US" sz="1300" dirty="0"/>
           </a:p>
@@ -9947,7 +9947,7 @@
       </p:sp>
       <p:pic>
         <p:nvPicPr>
-          <p:cNvPr id="3" name="Image 0" descr="/tmp/pcwork/api-patterns-and-practices-graphql/presentation/_shared/assets/logo-candidate-2.png">    </p:cNvPr>
+          <p:cNvPr id="3" name="Image 0" descr="/work/_shared/assets/logo-candidate-2.png">    </p:cNvPr>
           <p:cNvPicPr>
             <a:picLocks noChangeAspect="1"/>
           </p:cNvPicPr>
@@ -10049,7 +10049,7 @@
       </p:sp>
       <p:pic>
         <p:nvPicPr>
-          <p:cNvPr id="6" name="Image 1" descr="/tmp/pcwork/api-patterns-and-practices-graphql/presentation/_shared/png/05-contract-loop.png">    </p:cNvPr>
+          <p:cNvPr id="6" name="Image 1" descr="/work/_shared/png/05-contract-loop.png">    </p:cNvPr>
           <p:cNvPicPr>
             <a:picLocks noChangeAspect="1"/>
           </p:cNvPicPr>
@@ -10103,7 +10103,7 @@
                 <a:ea typeface="Red Hat Text" pitchFamily="34" charset="-122"/>
                 <a:cs typeface="Red Hat Text" pitchFamily="34" charset="-120"/>
               </a:rPr>
-              <a:t>Figure 5.1 — Code builds the schema, the export makes it a file, and the diff compares it both ways.</a:t>
+              <a:t>Figure 5.1: Code builds the schema, the export makes it a file, and the diff compares it both ways.</a:t>
             </a:r>
             <a:endParaRPr lang="en-US" sz="1300" dirty="0"/>
           </a:p>
@@ -10253,7 +10253,7 @@
       </p:sp>
       <p:pic>
         <p:nvPicPr>
-          <p:cNvPr id="5" name="Image 0" descr="/tmp/pcwork/api-patterns-and-practices-graphql/presentation/_shared/assets/redhat-logo-white.png">    </p:cNvPr>
+          <p:cNvPr id="5" name="Image 0" descr="/work/_shared/assets/redhat-logo-white.png">    </p:cNvPr>
           <p:cNvPicPr>
             <a:picLocks noChangeAspect="1"/>
           </p:cNvPicPr>
@@ -10341,7 +10341,7 @@
       </p:sp>
       <p:pic>
         <p:nvPicPr>
-          <p:cNvPr id="3" name="Image 0" descr="/tmp/pcwork/api-patterns-and-practices-graphql/presentation/_shared/assets/logo-candidate-2.png">    </p:cNvPr>
+          <p:cNvPr id="3" name="Image 0" descr="/work/_shared/assets/logo-candidate-2.png">    </p:cNvPr>
           <p:cNvPicPr>
             <a:picLocks noChangeAspect="1"/>
           </p:cNvPicPr>
@@ -10443,7 +10443,7 @@
       </p:sp>
       <p:pic>
         <p:nvPicPr>
-          <p:cNvPr id="6" name="Image 1" descr="/tmp/pcwork/api-patterns-and-practices-graphql/presentation/_shared/png/06-request-phases.png">    </p:cNvPr>
+          <p:cNvPr id="6" name="Image 1" descr="/work/_shared/png/06-request-phases.png">    </p:cNvPr>
           <p:cNvPicPr>
             <a:picLocks noChangeAspect="1"/>
           </p:cNvPicPr>
@@ -10497,7 +10497,7 @@
                 <a:ea typeface="Red Hat Text" pitchFamily="34" charset="-122"/>
                 <a:cs typeface="Red Hat Text" pitchFamily="34" charset="-120"/>
               </a:rPr>
-              <a:t>Figure 6.1 — Parse, validate and coerce run before any resolver. A failure ends the request with no data.</a:t>
+              <a:t>Figure 6.1: Parse, validate and coerce run before any resolver. A failure ends the request with no data.</a:t>
             </a:r>
             <a:endParaRPr lang="en-US" sz="1300" dirty="0"/>
           </a:p>
@@ -10569,7 +10569,7 @@
       </p:sp>
       <p:pic>
         <p:nvPicPr>
-          <p:cNvPr id="3" name="Image 0" descr="/tmp/pcwork/api-patterns-and-practices-graphql/presentation/_shared/assets/logo-candidate-2.png">    </p:cNvPr>
+          <p:cNvPr id="3" name="Image 0" descr="/work/_shared/assets/logo-candidate-2.png">    </p:cNvPr>
           <p:cNvPicPr>
             <a:picLocks noChangeAspect="1"/>
           </p:cNvPicPr>
@@ -10671,7 +10671,7 @@
       </p:sp>
       <p:pic>
         <p:nvPicPr>
-          <p:cNvPr id="6" name="Image 1" descr="/tmp/pcwork/api-patterns-and-practices-graphql/presentation/_shared/png/07-resolver-chain.png">    </p:cNvPr>
+          <p:cNvPr id="6" name="Image 1" descr="/work/_shared/png/07-resolver-chain.png">    </p:cNvPr>
           <p:cNvPicPr>
             <a:picLocks noChangeAspect="1"/>
           </p:cNvPicPr>
@@ -10725,7 +10725,7 @@
                 <a:ea typeface="Red Hat Text" pitchFamily="34" charset="-122"/>
                 <a:cs typeface="Red Hat Text" pitchFamily="34" charset="-120"/>
               </a:rPr>
-              <a:t>Figure 7.2 — The parent value feeds the child resolver, the child derives a key, and the key goes to a source.</a:t>
+              <a:t>Figure 7.2: The parent value feeds the child resolver, the child derives a key, and the key goes to a source.</a:t>
             </a:r>
             <a:endParaRPr lang="en-US" sz="1300" dirty="0"/>
           </a:p>
@@ -10797,7 +10797,7 @@
       </p:sp>
       <p:pic>
         <p:nvPicPr>
-          <p:cNvPr id="3" name="Image 0" descr="/tmp/pcwork/api-patterns-and-practices-graphql/presentation/_shared/assets/logo-candidate-2.png">    </p:cNvPr>
+          <p:cNvPr id="3" name="Image 0" descr="/work/_shared/assets/logo-candidate-2.png">    </p:cNvPr>
           <p:cNvPicPr>
             <a:picLocks noChangeAspect="1"/>
           </p:cNvPicPr>
@@ -11334,7 +11334,7 @@
       </p:sp>
       <p:pic>
         <p:nvPicPr>
-          <p:cNvPr id="3" name="Image 0" descr="/tmp/pcwork/api-patterns-and-practices-graphql/presentation/_shared/assets/logo-candidate-2.png">    </p:cNvPr>
+          <p:cNvPr id="3" name="Image 0" descr="/work/_shared/assets/logo-candidate-2.png">    </p:cNvPr>
           <p:cNvPicPr>
             <a:picLocks noChangeAspect="1"/>
           </p:cNvPicPr>
@@ -11768,7 +11768,7 @@
                 <a:ea typeface="Red Hat Mono" pitchFamily="34" charset="-122"/>
                 <a:cs typeface="Red Hat Mono" pitchFamily="34" charset="-120"/>
               </a:rPr>
-              <a:t>returns `{"__typename":"Location","name":"Rotterdam"}`, and a `... on Cargo` fragment in the same selection would contribute nothing, as Chapter 3 showed. The spec covers both in "Fragments" and "Inline Fragments".
+              <a:t>returns `{"__typename":"Location","name":"Rotterdam"}`, and a `... on Cargo` fragment in the same selection would contribute nothing, as the type system already showed. The spec covers both in "Fragments" and "Inline Fragments".
 </a:t>
             </a:r>
             <a:pPr algn="l" indent="0" marL="0">
@@ -11898,7 +11898,7 @@
       </p:sp>
       <p:pic>
         <p:nvPicPr>
-          <p:cNvPr id="3" name="Image 0" descr="/tmp/pcwork/api-patterns-and-practices-graphql/presentation/_shared/assets/logo-candidate-2.png">    </p:cNvPr>
+          <p:cNvPr id="3" name="Image 0" descr="/work/_shared/assets/logo-candidate-2.png">    </p:cNvPr>
           <p:cNvPicPr>
             <a:picLocks noChangeAspect="1"/>
           </p:cNvPicPr>
@@ -12000,7 +12000,7 @@
       </p:sp>
       <p:pic>
         <p:nvPicPr>
-          <p:cNvPr id="6" name="Image 1" descr="/tmp/pcwork/api-patterns-and-practices-graphql/presentation/_shared/png/08-mutation-flow.png">    </p:cNvPr>
+          <p:cNvPr id="6" name="Image 1" descr="/work/_shared/png/08-mutation-flow.png">    </p:cNvPr>
           <p:cNvPicPr>
             <a:picLocks noChangeAspect="1"/>
           </p:cNvPicPr>
@@ -12054,7 +12054,7 @@
                 <a:ea typeface="Red Hat Text" pitchFamily="34" charset="-122"/>
                 <a:cs typeface="Red Hat Text" pitchFamily="34" charset="-120"/>
               </a:rPr>
-              <a:t>Figure 8.2 — Coercion belongs to the engine; validation, lookup, append and re-read run in the resolver.</a:t>
+              <a:t>Figure 8.2: Coercion belongs to the engine; validation, lookup, append and re-read run in the resolver.</a:t>
             </a:r>
             <a:endParaRPr lang="en-US" sz="1300" dirty="0"/>
           </a:p>
@@ -12126,7 +12126,7 @@
       </p:sp>
       <p:pic>
         <p:nvPicPr>
-          <p:cNvPr id="3" name="Image 0" descr="/tmp/pcwork/api-patterns-and-practices-graphql/presentation/_shared/assets/logo-candidate-2.png">    </p:cNvPr>
+          <p:cNvPr id="3" name="Image 0" descr="/work/_shared/assets/logo-candidate-2.png">    </p:cNvPr>
           <p:cNvPicPr>
             <a:picLocks noChangeAspect="1"/>
           </p:cNvPicPr>
@@ -12228,7 +12228,7 @@
       </p:sp>
       <p:pic>
         <p:nvPicPr>
-          <p:cNvPr id="6" name="Image 1" descr="/tmp/pcwork/api-patterns-and-practices-graphql/presentation/_shared/png/08-idempotent-replay.png">    </p:cNvPr>
+          <p:cNvPr id="6" name="Image 1" descr="/work/_shared/png/08-idempotent-replay.png">    </p:cNvPr>
           <p:cNvPicPr>
             <a:picLocks noChangeAspect="1"/>
           </p:cNvPicPr>
@@ -12282,7 +12282,7 @@
                 <a:ea typeface="Red Hat Text" pitchFamily="34" charset="-122"/>
                 <a:cs typeface="Red Hat Text" pitchFamily="34" charset="-120"/>
               </a:rPr>
-              <a:t>Figure 8.3 — The same retry with and without a key. With one, the second request becomes a read.</a:t>
+              <a:t>Figure 8.3: The same retry with and without a key. With one, the second request becomes a read.</a:t>
             </a:r>
             <a:endParaRPr lang="en-US" sz="1300" dirty="0"/>
           </a:p>
@@ -12432,7 +12432,7 @@
       </p:sp>
       <p:pic>
         <p:nvPicPr>
-          <p:cNvPr id="5" name="Image 0" descr="/tmp/pcwork/api-patterns-and-practices-graphql/presentation/_shared/assets/redhat-logo-white.png">    </p:cNvPr>
+          <p:cNvPr id="5" name="Image 0" descr="/work/_shared/assets/redhat-logo-white.png">    </p:cNvPr>
           <p:cNvPicPr>
             <a:picLocks noChangeAspect="1"/>
           </p:cNvPicPr>
@@ -12520,7 +12520,7 @@
       </p:sp>
       <p:pic>
         <p:nvPicPr>
-          <p:cNvPr id="3" name="Image 0" descr="/tmp/pcwork/api-patterns-and-practices-graphql/presentation/_shared/assets/logo-candidate-2.png">    </p:cNvPr>
+          <p:cNvPr id="3" name="Image 0" descr="/work/_shared/assets/logo-candidate-2.png">    </p:cNvPr>
           <p:cNvPicPr>
             <a:picLocks noChangeAspect="1"/>
           </p:cNvPicPr>
@@ -12622,7 +12622,7 @@
       </p:sp>
       <p:pic>
         <p:nvPicPr>
-          <p:cNvPr id="6" name="Image 1" descr="/tmp/pcwork/api-patterns-and-practices-graphql/presentation/_shared/png/09-error-taxonomy.png">    </p:cNvPr>
+          <p:cNvPr id="6" name="Image 1" descr="/work/_shared/png/09-error-taxonomy.png">    </p:cNvPr>
           <p:cNvPicPr>
             <a:picLocks noChangeAspect="1"/>
           </p:cNvPicPr>
@@ -12676,7 +12676,7 @@
                 <a:ea typeface="Red Hat Text" pitchFamily="34" charset="-122"/>
                 <a:cs typeface="Red Hat Text" pitchFamily="34" charset="-120"/>
               </a:rPr>
-              <a:t>Figure 9.1 — Three kinds of failure and the response each produces; only the first precedes a resolver.</a:t>
+              <a:t>Figure 9.1: Three kinds of failure and the response each produces; only the first precedes a resolver.</a:t>
             </a:r>
             <a:endParaRPr lang="en-US" sz="1300" dirty="0"/>
           </a:p>
@@ -12748,7 +12748,7 @@
       </p:sp>
       <p:pic>
         <p:nvPicPr>
-          <p:cNvPr id="3" name="Image 0" descr="/tmp/pcwork/api-patterns-and-practices-graphql/presentation/_shared/assets/logo-candidate-2.png">    </p:cNvPr>
+          <p:cNvPr id="3" name="Image 0" descr="/work/_shared/assets/logo-candidate-2.png">    </p:cNvPr>
           <p:cNvPicPr>
             <a:picLocks noChangeAspect="1"/>
           </p:cNvPicPr>
@@ -12850,7 +12850,7 @@
       </p:sp>
       <p:pic>
         <p:nvPicPr>
-          <p:cNvPr id="6" name="Image 1" descr="/tmp/pcwork/api-patterns-and-practices-graphql/presentation/_shared/png/09-partial-data-errors.png">    </p:cNvPr>
+          <p:cNvPr id="6" name="Image 1" descr="/work/_shared/png/09-partial-data-errors.png">    </p:cNvPr>
           <p:cNvPicPr>
             <a:picLocks noChangeAspect="1"/>
           </p:cNvPicPr>
@@ -12904,7 +12904,7 @@
                 <a:ea typeface="Red Hat Text" pitchFamily="34" charset="-122"/>
                 <a:cs typeface="Red Hat Text" pitchFamily="34" charset="-120"/>
               </a:rPr>
-              <a:t>Figure 9.2 — A path names where it broke, and the null lands at the nearest nullable ancestor.</a:t>
+              <a:t>Figure 9.2: A path names where it broke, and the null lands at the nearest nullable ancestor.</a:t>
             </a:r>
             <a:endParaRPr lang="en-US" sz="1300" dirty="0"/>
           </a:p>
@@ -12976,7 +12976,7 @@
       </p:sp>
       <p:pic>
         <p:nvPicPr>
-          <p:cNvPr id="3" name="Image 0" descr="/tmp/pcwork/api-patterns-and-practices-graphql/presentation/_shared/assets/logo-candidate-2.png">    </p:cNvPr>
+          <p:cNvPr id="3" name="Image 0" descr="/work/_shared/assets/logo-candidate-2.png">    </p:cNvPr>
           <p:cNvPicPr>
             <a:picLocks noChangeAspect="1"/>
           </p:cNvPicPr>
@@ -13414,7 +13414,7 @@
       </p:sp>
       <p:pic>
         <p:nvPicPr>
-          <p:cNvPr id="3" name="Image 0" descr="/tmp/pcwork/api-patterns-and-practices-graphql/presentation/_shared/assets/logo-candidate-2.png">    </p:cNvPr>
+          <p:cNvPr id="3" name="Image 0" descr="/work/_shared/assets/logo-candidate-2.png">    </p:cNvPr>
           <p:cNvPicPr>
             <a:picLocks noChangeAspect="1"/>
           </p:cNvPicPr>
@@ -13516,7 +13516,7 @@
       </p:sp>
       <p:pic>
         <p:nvPicPr>
-          <p:cNvPr id="6" name="Image 1" descr="/tmp/pcwork/api-patterns-and-practices-graphql/presentation/_shared/png/09-error-masking.png">    </p:cNvPr>
+          <p:cNvPr id="6" name="Image 1" descr="/work/_shared/png/09-error-masking.png">    </p:cNvPr>
           <p:cNvPicPr>
             <a:picLocks noChangeAspect="1"/>
           </p:cNvPicPr>
@@ -13570,7 +13570,7 @@
                 <a:ea typeface="Red Hat Text" pitchFamily="34" charset="-122"/>
                 <a:cs typeface="Red Hat Text" pitchFamily="34" charset="-120"/>
               </a:rPr>
-              <a:t>Figure 9.3 — Masking is an allowlist. The client sees only what the service listed; the log sees everything.</a:t>
+              <a:t>Figure 9.3: Masking is an allowlist. The client sees only what the service listed; the log sees everything.</a:t>
             </a:r>
             <a:endParaRPr lang="en-US" sz="1300" dirty="0"/>
           </a:p>
@@ -13720,7 +13720,7 @@
       </p:sp>
       <p:pic>
         <p:nvPicPr>
-          <p:cNvPr id="5" name="Image 0" descr="/tmp/pcwork/api-patterns-and-practices-graphql/presentation/_shared/assets/redhat-logo-white.png">    </p:cNvPr>
+          <p:cNvPr id="5" name="Image 0" descr="/work/_shared/assets/redhat-logo-white.png">    </p:cNvPr>
           <p:cNvPicPr>
             <a:picLocks noChangeAspect="1"/>
           </p:cNvPicPr>
@@ -13808,7 +13808,7 @@
       </p:sp>
       <p:pic>
         <p:nvPicPr>
-          <p:cNvPr id="3" name="Image 0" descr="/tmp/pcwork/api-patterns-and-practices-graphql/presentation/_shared/assets/logo-candidate-2.png">    </p:cNvPr>
+          <p:cNvPr id="3" name="Image 0" descr="/work/_shared/assets/logo-candidate-2.png">    </p:cNvPr>
           <p:cNvPicPr>
             <a:picLocks noChangeAspect="1"/>
           </p:cNvPicPr>
@@ -13910,7 +13910,7 @@
       </p:sp>
       <p:pic>
         <p:nvPicPr>
-          <p:cNvPr id="6" name="Image 1" descr="/tmp/pcwork/api-patterns-and-practices-graphql/presentation/_shared/png/10-demand-oriented-schema.png">    </p:cNvPr>
+          <p:cNvPr id="6" name="Image 1" descr="/work/_shared/png/10-demand-oriented-schema.png">    </p:cNvPr>
           <p:cNvPicPr>
             <a:picLocks noChangeAspect="1"/>
           </p:cNvPicPr>
@@ -13964,7 +13964,7 @@
                 <a:ea typeface="Red Hat Text" pitchFamily="34" charset="-122"/>
                 <a:cs typeface="Red Hat Text" pitchFamily="34" charset="-120"/>
               </a:rPr>
-              <a:t>Figure 10.1 — One screen, one query, five owners. The panels choose fields; sources answer them.</a:t>
+              <a:t>Figure 10.1: One screen, one query, five owners. The panels choose fields; sources answer them.</a:t>
             </a:r>
             <a:endParaRPr lang="en-US" sz="1300" dirty="0"/>
           </a:p>
@@ -14114,7 +14114,7 @@
       </p:sp>
       <p:pic>
         <p:nvPicPr>
-          <p:cNvPr id="5" name="Image 0" descr="/tmp/pcwork/api-patterns-and-practices-graphql/presentation/_shared/assets/redhat-logo-white.png">    </p:cNvPr>
+          <p:cNvPr id="5" name="Image 0" descr="/work/_shared/assets/redhat-logo-white.png">    </p:cNvPr>
           <p:cNvPicPr>
             <a:picLocks noChangeAspect="1"/>
           </p:cNvPicPr>
@@ -14202,7 +14202,7 @@
       </p:sp>
       <p:pic>
         <p:nvPicPr>
-          <p:cNvPr id="3" name="Image 0" descr="/tmp/pcwork/api-patterns-and-practices-graphql/presentation/_shared/assets/logo-candidate-2.png">    </p:cNvPr>
+          <p:cNvPr id="3" name="Image 0" descr="/work/_shared/assets/logo-candidate-2.png">    </p:cNvPr>
           <p:cNvPicPr>
             <a:picLocks noChangeAspect="1"/>
           </p:cNvPicPr>
@@ -14304,7 +14304,7 @@
       </p:sp>
       <p:pic>
         <p:nvPicPr>
-          <p:cNvPr id="6" name="Image 1" descr="/tmp/pcwork/api-patterns-and-practices-graphql/presentation/_shared/png/10-node-identity.png">    </p:cNvPr>
+          <p:cNvPr id="6" name="Image 1" descr="/work/_shared/png/10-node-identity.png">    </p:cNvPr>
           <p:cNvPicPr>
             <a:picLocks noChangeAspect="1"/>
           </p:cNvPicPr>
@@ -14358,7 +14358,7 @@
                 <a:ea typeface="Red Hat Text" pitchFamily="34" charset="-122"/>
                 <a:cs typeface="Red Hat Text" pitchFamily="34" charset="-120"/>
               </a:rPr>
-              <a:t>Figure 10.2 — Ids reach a client cache along any path. node and nodes turn any of them back into one object.</a:t>
+              <a:t>Figure 10.2: Ids reach a client cache along any path. node and nodes turn any of them back into one object.</a:t>
             </a:r>
             <a:endParaRPr lang="en-US" sz="1300" dirty="0"/>
           </a:p>
@@ -14430,7 +14430,7 @@
       </p:sp>
       <p:pic>
         <p:nvPicPr>
-          <p:cNvPr id="3" name="Image 0" descr="/tmp/pcwork/api-patterns-and-practices-graphql/presentation/_shared/assets/logo-candidate-2.png">    </p:cNvPr>
+          <p:cNvPr id="3" name="Image 0" descr="/work/_shared/assets/logo-candidate-2.png">    </p:cNvPr>
           <p:cNvPicPr>
             <a:picLocks noChangeAspect="1"/>
           </p:cNvPicPr>
@@ -14532,7 +14532,7 @@
       </p:sp>
       <p:pic>
         <p:nvPicPr>
-          <p:cNvPr id="6" name="Image 1" descr="/tmp/pcwork/api-patterns-and-practices-graphql/presentation/_shared/png/11-change-classes.png">    </p:cNvPr>
+          <p:cNvPr id="6" name="Image 1" descr="/work/_shared/png/11-change-classes.png">    </p:cNvPr>
           <p:cNvPicPr>
             <a:picLocks noChangeAspect="1"/>
           </p:cNvPicPr>
@@ -14586,7 +14586,7 @@
                 <a:ea typeface="Red Hat Text" pitchFamily="34" charset="-122"/>
                 <a:cs typeface="Red Hat Text" pitchFamily="34" charset="-120"/>
               </a:rPr>
-              <a:t>Figure 11.1 — Safe, dangerous and breaking changes, each with a fixture and the gate's verdict.</a:t>
+              <a:t>Figure 11.1: Safe, dangerous and breaking changes, each with a fixture and the gate's verdict.</a:t>
             </a:r>
             <a:endParaRPr lang="en-US" sz="1300" dirty="0"/>
           </a:p>
@@ -14658,7 +14658,7 @@
       </p:sp>
       <p:pic>
         <p:nvPicPr>
-          <p:cNvPr id="3" name="Image 0" descr="/tmp/pcwork/api-patterns-and-practices-graphql/presentation/_shared/assets/logo-candidate-2.png">    </p:cNvPr>
+          <p:cNvPr id="3" name="Image 0" descr="/work/_shared/assets/logo-candidate-2.png">    </p:cNvPr>
           <p:cNvPicPr>
             <a:picLocks noChangeAspect="1"/>
           </p:cNvPicPr>
@@ -15114,7 +15114,7 @@
       </p:sp>
       <p:pic>
         <p:nvPicPr>
-          <p:cNvPr id="3" name="Image 0" descr="/tmp/pcwork/api-patterns-and-practices-graphql/presentation/_shared/assets/logo-candidate-2.png">    </p:cNvPr>
+          <p:cNvPr id="3" name="Image 0" descr="/work/_shared/assets/logo-candidate-2.png">    </p:cNvPr>
           <p:cNvPicPr>
             <a:picLocks noChangeAspect="1"/>
           </p:cNvPicPr>
@@ -15216,7 +15216,7 @@
       </p:sp>
       <p:pic>
         <p:nvPicPr>
-          <p:cNvPr id="6" name="Image 1" descr="/tmp/pcwork/api-patterns-and-practices-graphql/presentation/_shared/png/11-deprecation-lifecycle.png">    </p:cNvPr>
+          <p:cNvPr id="6" name="Image 1" descr="/work/_shared/png/11-deprecation-lifecycle.png">    </p:cNvPr>
           <p:cNvPicPr>
             <a:picLocks noChangeAspect="1"/>
           </p:cNvPicPr>
@@ -15270,7 +15270,7 @@
                 <a:ea typeface="Red Hat Text" pitchFamily="34" charset="-122"/>
                 <a:cs typeface="Red Hat Text" pitchFamily="34" charset="-120"/>
               </a:rPr>
-              <a:t>Figure 11.2 — Add, deprecate, observe, then remove with a recorded sign-off.</a:t>
+              <a:t>Figure 11.2: Add, deprecate, observe, then remove with a recorded sign-off.</a:t>
             </a:r>
             <a:endParaRPr lang="en-US" sz="1300" dirty="0"/>
           </a:p>
@@ -15420,7 +15420,7 @@
       </p:sp>
       <p:pic>
         <p:nvPicPr>
-          <p:cNvPr id="5" name="Image 0" descr="/tmp/pcwork/api-patterns-and-practices-graphql/presentation/_shared/assets/redhat-logo-white.png">    </p:cNvPr>
+          <p:cNvPr id="5" name="Image 0" descr="/work/_shared/assets/redhat-logo-white.png">    </p:cNvPr>
           <p:cNvPicPr>
             <a:picLocks noChangeAspect="1"/>
           </p:cNvPicPr>
@@ -15508,7 +15508,7 @@
       </p:sp>
       <p:pic>
         <p:nvPicPr>
-          <p:cNvPr id="3" name="Image 0" descr="/tmp/pcwork/api-patterns-and-practices-graphql/presentation/_shared/assets/logo-candidate-2.png">    </p:cNvPr>
+          <p:cNvPr id="3" name="Image 0" descr="/work/_shared/assets/logo-candidate-2.png">    </p:cNvPr>
           <p:cNvPicPr>
             <a:picLocks noChangeAspect="1"/>
           </p:cNvPicPr>
@@ -15610,7 +15610,7 @@
       </p:sp>
       <p:pic>
         <p:nvPicPr>
-          <p:cNvPr id="6" name="Image 1" descr="/tmp/pcwork/api-patterns-and-practices-graphql/presentation/_shared/png/12-connection-anatomy.png">    </p:cNvPr>
+          <p:cNvPr id="6" name="Image 1" descr="/work/_shared/png/12-connection-anatomy.png">    </p:cNvPr>
           <p:cNvPicPr>
             <a:picLocks noChangeAspect="1"/>
           </p:cNvPicPr>
@@ -15664,7 +15664,7 @@
                 <a:ea typeface="Red Hat Text" pitchFamily="34" charset="-122"/>
                 <a:cs typeface="Red Hat Text" pitchFamily="34" charset="-120"/>
               </a:rPr>
-              <a:t>Figure 12.2 — A connection has edges and pageInfo. The edge's node is the one nullable link in the chain.</a:t>
+              <a:t>Figure 12.2: A connection has edges and pageInfo. The edge's node is the one nullable link in the chain.</a:t>
             </a:r>
             <a:endParaRPr lang="en-US" sz="1300" dirty="0"/>
           </a:p>
@@ -15736,7 +15736,7 @@
       </p:sp>
       <p:pic>
         <p:nvPicPr>
-          <p:cNvPr id="3" name="Image 0" descr="/tmp/pcwork/api-patterns-and-practices-graphql/presentation/_shared/assets/logo-candidate-2.png">    </p:cNvPr>
+          <p:cNvPr id="3" name="Image 0" descr="/work/_shared/assets/logo-candidate-2.png">    </p:cNvPr>
           <p:cNvPicPr>
             <a:picLocks noChangeAspect="1"/>
           </p:cNvPicPr>
@@ -15838,7 +15838,7 @@
       </p:sp>
       <p:pic>
         <p:nvPicPr>
-          <p:cNvPr id="6" name="Image 1" descr="/tmp/pcwork/api-patterns-and-practices-graphql/presentation/_shared/png/12-offset-vs-keyset.png">    </p:cNvPr>
+          <p:cNvPr id="6" name="Image 1" descr="/work/_shared/png/12-offset-vs-keyset.png">    </p:cNvPr>
           <p:cNvPicPr>
             <a:picLocks noChangeAspect="1"/>
           </p:cNvPicPr>
@@ -15892,7 +15892,7 @@
                 <a:ea typeface="Red Hat Text" pitchFamily="34" charset="-122"/>
                 <a:cs typeface="Red Hat Text" pitchFamily="34" charset="-120"/>
               </a:rPr>
-              <a:t>Figure 12.1 — One insert, two designs. Offset repeats an item; the keyset cursor seeks past it.</a:t>
+              <a:t>Figure 12.1: One insert, two designs. Offset repeats an item; the keyset cursor seeks past it.</a:t>
             </a:r>
             <a:endParaRPr lang="en-US" sz="1300" dirty="0"/>
           </a:p>
@@ -15964,7 +15964,7 @@
       </p:sp>
       <p:pic>
         <p:nvPicPr>
-          <p:cNvPr id="3" name="Image 0" descr="/tmp/pcwork/api-patterns-and-practices-graphql/presentation/_shared/assets/logo-candidate-2.png">    </p:cNvPr>
+          <p:cNvPr id="3" name="Image 0" descr="/work/_shared/assets/logo-candidate-2.png">    </p:cNvPr>
           <p:cNvPicPr>
             <a:picLocks noChangeAspect="1"/>
           </p:cNvPicPr>
@@ -16402,7 +16402,7 @@
       </p:sp>
       <p:pic>
         <p:nvPicPr>
-          <p:cNvPr id="3" name="Image 0" descr="/tmp/pcwork/api-patterns-and-practices-graphql/presentation/_shared/assets/logo-candidate-2.png">    </p:cNvPr>
+          <p:cNvPr id="3" name="Image 0" descr="/work/_shared/assets/logo-candidate-2.png">    </p:cNvPr>
           <p:cNvPicPr>
             <a:picLocks noChangeAspect="1"/>
           </p:cNvPicPr>
@@ -16504,7 +16504,7 @@
       </p:sp>
       <p:pic>
         <p:nvPicPr>
-          <p:cNvPr id="6" name="Image 1" descr="/tmp/pcwork/api-patterns-and-practices-graphql/presentation/_shared/png/13-n-plus-one-fanout.png">    </p:cNvPr>
+          <p:cNvPr id="6" name="Image 1" descr="/work/_shared/png/13-n-plus-one-fanout.png">    </p:cNvPr>
           <p:cNvPicPr>
             <a:picLocks noChangeAspect="1"/>
           </p:cNvPicPr>
@@ -16558,7 +16558,7 @@
                 <a:ea typeface="Red Hat Text" pitchFamily="34" charset="-122"/>
                 <a:cs typeface="Red Hat Text" pitchFamily="34" charset="-120"/>
               </a:rPr>
-              <a:t>Figure 13.1 — Before batching: one call per field occurrence, 29 in all. Highlighted keys are fetched twice.</a:t>
+              <a:t>Figure 13.1: Before batching: one call per field occurrence, 29 in all. Highlighted keys are fetched twice.</a:t>
             </a:r>
             <a:endParaRPr lang="en-US" sz="1300" dirty="0"/>
           </a:p>
@@ -16630,7 +16630,7 @@
       </p:sp>
       <p:pic>
         <p:nvPicPr>
-          <p:cNvPr id="3" name="Image 0" descr="/tmp/pcwork/api-patterns-and-practices-graphql/presentation/_shared/assets/logo-candidate-2.png">    </p:cNvPr>
+          <p:cNvPr id="3" name="Image 0" descr="/work/_shared/assets/logo-candidate-2.png">    </p:cNvPr>
           <p:cNvPicPr>
             <a:picLocks noChangeAspect="1"/>
           </p:cNvPicPr>
@@ -16732,7 +16732,7 @@
       </p:sp>
       <p:pic>
         <p:nvPicPr>
-          <p:cNvPr id="6" name="Image 1" descr="/tmp/pcwork/api-patterns-and-practices-graphql/presentation/_shared/png/13-batched-load.png">    </p:cNvPr>
+          <p:cNvPr id="6" name="Image 1" descr="/work/_shared/png/13-batched-load.png">    </p:cNvPr>
           <p:cNvPicPr>
             <a:picLocks noChangeAspect="1"/>
           </p:cNvPicPr>
@@ -16786,7 +16786,7 @@
                 <a:ea typeface="Red Hat Text" pitchFamily="34" charset="-122"/>
                 <a:cs typeface="Red Hat Text" pitchFamily="34" charset="-120"/>
               </a:rPr>
-              <a:t>Figure 13.2 — The same query with one bulk call per level, without changing a field of the schema.</a:t>
+              <a:t>Figure 13.2: The same query with one bulk call per level, without changing a field of the schema.</a:t>
             </a:r>
             <a:endParaRPr lang="en-US" sz="1300" dirty="0"/>
           </a:p>
@@ -16858,7 +16858,7 @@
       </p:sp>
       <p:pic>
         <p:nvPicPr>
-          <p:cNvPr id="3" name="Image 0" descr="/tmp/pcwork/api-patterns-and-practices-graphql/presentation/_shared/assets/logo-candidate-2.png">    </p:cNvPr>
+          <p:cNvPr id="3" name="Image 0" descr="/work/_shared/assets/logo-candidate-2.png">    </p:cNvPr>
           <p:cNvPicPr>
             <a:picLocks noChangeAspect="1"/>
           </p:cNvPicPr>
@@ -16960,7 +16960,7 @@
       </p:sp>
       <p:pic>
         <p:nvPicPr>
-          <p:cNvPr id="6" name="Image 1" descr="/tmp/pcwork/api-patterns-and-practices-graphql/presentation/_shared/png/01-three-paradigms.png">    </p:cNvPr>
+          <p:cNvPr id="6" name="Image 1" descr="/work/_shared/png/01-three-paradigms.png">    </p:cNvPr>
           <p:cNvPicPr>
             <a:picLocks noChangeAspect="1"/>
           </p:cNvPicPr>
@@ -17014,7 +17014,7 @@
                 <a:ea typeface="Red Hat Text" pitchFamily="34" charset="-122"/>
                 <a:cs typeface="Red Hat Text" pitchFamily="34" charset="-120"/>
               </a:rPr>
-              <a:t>Figure 1.1 — Three paradigms, one intent: REST, gRPC and GraphQL answering one tracking question.</a:t>
+              <a:t>Figure 1.1: Three paradigms, one intent: REST, gRPC and GraphQL answering one tracking question.</a:t>
             </a:r>
             <a:endParaRPr lang="en-US" sz="1300" dirty="0"/>
           </a:p>
@@ -17086,7 +17086,7 @@
       </p:sp>
       <p:pic>
         <p:nvPicPr>
-          <p:cNvPr id="3" name="Image 0" descr="/tmp/pcwork/api-patterns-and-practices-graphql/presentation/_shared/assets/logo-candidate-2.png">    </p:cNvPr>
+          <p:cNvPr id="3" name="Image 0" descr="/work/_shared/assets/logo-candidate-2.png">    </p:cNvPr>
           <p:cNvPicPr>
             <a:picLocks noChangeAspect="1"/>
           </p:cNvPicPr>
@@ -17188,7 +17188,7 @@
       </p:sp>
       <p:pic>
         <p:nvPicPr>
-          <p:cNvPr id="6" name="Image 1" descr="/tmp/pcwork/api-patterns-and-practices-graphql/presentation/_shared/png/13-dataloader-tick.png">    </p:cNvPr>
+          <p:cNvPr id="6" name="Image 1" descr="/work/_shared/png/13-dataloader-tick.png">    </p:cNvPr>
           <p:cNvPicPr>
             <a:picLocks noChangeAspect="1"/>
           </p:cNvPicPr>
@@ -17242,7 +17242,7 @@
                 <a:ea typeface="Red Hat Text" pitchFamily="34" charset="-122"/>
                 <a:cs typeface="Red Hat Text" pitchFamily="34" charset="-120"/>
               </a:rPr>
-              <a:t>Figure 13.3 — Loads queue during a tick, one bulk call follows, and the next level starts when it returns.</a:t>
+              <a:t>Figure 13.3: Loads queue during a tick, one bulk call follows, and the next level starts when it returns.</a:t>
             </a:r>
             <a:endParaRPr lang="en-US" sz="1300" dirty="0"/>
           </a:p>
@@ -17392,7 +17392,7 @@
       </p:sp>
       <p:pic>
         <p:nvPicPr>
-          <p:cNvPr id="5" name="Image 0" descr="/tmp/pcwork/api-patterns-and-practices-graphql/presentation/_shared/assets/redhat-logo-white.png">    </p:cNvPr>
+          <p:cNvPr id="5" name="Image 0" descr="/work/_shared/assets/redhat-logo-white.png">    </p:cNvPr>
           <p:cNvPicPr>
             <a:picLocks noChangeAspect="1"/>
           </p:cNvPicPr>
@@ -17480,7 +17480,7 @@
       </p:sp>
       <p:pic>
         <p:nvPicPr>
-          <p:cNvPr id="3" name="Image 0" descr="/tmp/pcwork/api-patterns-and-practices-graphql/presentation/_shared/assets/logo-candidate-2.png">    </p:cNvPr>
+          <p:cNvPr id="3" name="Image 0" descr="/work/_shared/assets/logo-candidate-2.png">    </p:cNvPr>
           <p:cNvPicPr>
             <a:picLocks noChangeAspect="1"/>
           </p:cNvPicPr>
@@ -17582,7 +17582,7 @@
       </p:sp>
       <p:pic>
         <p:nvPicPr>
-          <p:cNvPr id="6" name="Image 1" descr="/tmp/pcwork/api-patterns-and-practices-graphql/presentation/_shared/png/14-limit-pipeline.png">    </p:cNvPr>
+          <p:cNvPr id="6" name="Image 1" descr="/work/_shared/png/14-limit-pipeline.png">    </p:cNvPr>
           <p:cNvPicPr>
             <a:picLocks noChangeAspect="1"/>
           </p:cNvPicPr>
@@ -17636,7 +17636,7 @@
                 <a:ea typeface="Red Hat Text" pitchFamily="34" charset="-122"/>
                 <a:cs typeface="Red Hat Text" pitchFamily="34" charset="-120"/>
               </a:rPr>
-              <a:t>Figure 14.2 — Where each limit fires. Every refusal ends before the sources are reached.</a:t>
+              <a:t>Figure 14.2: Where each limit fires. Every refusal ends before the sources are reached.</a:t>
             </a:r>
             <a:endParaRPr lang="en-US" sz="1300" dirty="0"/>
           </a:p>
@@ -17708,7 +17708,7 @@
       </p:sp>
       <p:pic>
         <p:nvPicPr>
-          <p:cNvPr id="3" name="Image 0" descr="/tmp/pcwork/api-patterns-and-practices-graphql/presentation/_shared/assets/logo-candidate-2.png">    </p:cNvPr>
+          <p:cNvPr id="3" name="Image 0" descr="/work/_shared/assets/logo-candidate-2.png">    </p:cNvPr>
           <p:cNvPicPr>
             <a:picLocks noChangeAspect="1"/>
           </p:cNvPicPr>
@@ -17810,7 +17810,7 @@
       </p:sp>
       <p:pic>
         <p:nvPicPr>
-          <p:cNvPr id="6" name="Image 1" descr="/tmp/pcwork/api-patterns-and-practices-graphql/presentation/_shared/png/14-cost-accumulation.png">    </p:cNvPr>
+          <p:cNvPr id="6" name="Image 1" descr="/work/_shared/png/14-cost-accumulation.png">    </p:cNvPr>
           <p:cNvPicPr>
             <a:picLocks noChangeAspect="1"/>
           </p:cNvPicPr>
@@ -17864,7 +17864,7 @@
                 <a:ea typeface="Red Hat Text" pitchFamily="34" charset="-122"/>
                 <a:cs typeface="Red Hat Text" pitchFamily="34" charset="-120"/>
               </a:rPr>
-              <a:t>Figure 14.3 — The nested query priced bottom-up: 385,151 units. The four-cargo query of Chapter 13 is 53.</a:t>
+              <a:t>Figure 14.3: The nested query priced bottom-up: 385,151 units. The four-cargo query of Chapter 13 is 53.</a:t>
             </a:r>
             <a:endParaRPr lang="en-US" sz="1300" dirty="0"/>
           </a:p>
@@ -17936,7 +17936,7 @@
       </p:sp>
       <p:pic>
         <p:nvPicPr>
-          <p:cNvPr id="3" name="Image 0" descr="/tmp/pcwork/api-patterns-and-practices-graphql/presentation/_shared/assets/logo-candidate-2.png">    </p:cNvPr>
+          <p:cNvPr id="3" name="Image 0" descr="/work/_shared/assets/logo-candidate-2.png">    </p:cNvPr>
           <p:cNvPicPr>
             <a:picLocks noChangeAspect="1"/>
           </p:cNvPicPr>
@@ -18038,7 +18038,7 @@
       </p:sp>
       <p:pic>
         <p:nvPicPr>
-          <p:cNvPr id="6" name="Image 1" descr="/tmp/pcwork/api-patterns-and-practices-graphql/presentation/_shared/png/15-apq-handshake.png">    </p:cNvPr>
+          <p:cNvPr id="6" name="Image 1" descr="/work/_shared/png/15-apq-handshake.png">    </p:cNvPr>
           <p:cNvPicPr>
             <a:picLocks noChangeAspect="1"/>
           </p:cNvPicPr>
@@ -18092,7 +18092,7 @@
                 <a:ea typeface="Red Hat Text" pitchFamily="34" charset="-122"/>
                 <a:cs typeface="Red Hat Text" pitchFamily="34" charset="-120"/>
               </a:rPr>
-              <a:t>Figure 15.1 — A miss, a registration, and a hit by GET, with request and response sizes in bytes.</a:t>
+              <a:t>Figure 15.1: A miss, a registration, and a hit by GET, with request and response sizes in bytes.</a:t>
             </a:r>
             <a:endParaRPr lang="en-US" sz="1300" dirty="0"/>
           </a:p>
@@ -18164,7 +18164,7 @@
       </p:sp>
       <p:pic>
         <p:nvPicPr>
-          <p:cNvPr id="3" name="Image 0" descr="/tmp/pcwork/api-patterns-and-practices-graphql/presentation/_shared/assets/logo-candidate-2.png">    </p:cNvPr>
+          <p:cNvPr id="3" name="Image 0" descr="/work/_shared/assets/logo-candidate-2.png">    </p:cNvPr>
           <p:cNvPicPr>
             <a:picLocks noChangeAspect="1"/>
           </p:cNvPicPr>
@@ -18266,7 +18266,7 @@
       </p:sp>
       <p:pic>
         <p:nvPicPr>
-          <p:cNvPr id="6" name="Image 1" descr="/tmp/pcwork/api-patterns-and-practices-graphql/presentation/_shared/png/15-apq-vs-trusted.png">    </p:cNvPr>
+          <p:cNvPr id="6" name="Image 1" descr="/work/_shared/png/15-apq-vs-trusted.png">    </p:cNvPr>
           <p:cNvPicPr>
             <a:picLocks noChangeAspect="1"/>
           </p:cNvPicPr>
@@ -18320,7 +18320,7 @@
                 <a:ea typeface="Red Hat Text" pitchFamily="34" charset="-122"/>
                 <a:cs typeface="Red Hat Text" pitchFamily="34" charset="-120"/>
               </a:rPr>
-              <a:t>Figure 15.2 — APQ and trusted documents compare on who registers and what the server accepts.</a:t>
+              <a:t>Figure 15.2: APQ and trusted documents compare on who registers and what the server accepts.</a:t>
             </a:r>
             <a:endParaRPr lang="en-US" sz="1300" dirty="0"/>
           </a:p>
@@ -18392,7 +18392,7 @@
       </p:sp>
       <p:pic>
         <p:nvPicPr>
-          <p:cNvPr id="3" name="Image 0" descr="/tmp/pcwork/api-patterns-and-practices-graphql/presentation/_shared/assets/logo-candidate-2.png">    </p:cNvPr>
+          <p:cNvPr id="3" name="Image 0" descr="/work/_shared/assets/logo-candidate-2.png">    </p:cNvPr>
           <p:cNvPicPr>
             <a:picLocks noChangeAspect="1"/>
           </p:cNvPicPr>
@@ -18494,7 +18494,7 @@
       </p:sp>
       <p:pic>
         <p:nvPicPr>
-          <p:cNvPr id="6" name="Image 1" descr="/tmp/pcwork/api-patterns-and-practices-graphql/presentation/_shared/png/16-cache-layers.png">    </p:cNvPr>
+          <p:cNvPr id="6" name="Image 1" descr="/work/_shared/png/16-cache-layers.png">    </p:cNvPr>
           <p:cNvPicPr>
             <a:picLocks noChangeAspect="1"/>
           </p:cNvPicPr>
@@ -18548,7 +18548,7 @@
                 <a:ea typeface="Red Hat Text" pitchFamily="34" charset="-122"/>
                 <a:cs typeface="Red Hat Text" pitchFamily="34" charset="-120"/>
               </a:rPr>
-              <a:t>Figure 16.1 — Four places to keep an answer, nearest the caller first, with the key and the eviction of each.</a:t>
+              <a:t>Figure 16.1: Four places to keep an answer, nearest the caller first, with the key and the eviction of each.</a:t>
             </a:r>
             <a:endParaRPr lang="en-US" sz="1300" dirty="0"/>
           </a:p>
@@ -18620,7 +18620,7 @@
       </p:sp>
       <p:pic>
         <p:nvPicPr>
-          <p:cNvPr id="3" name="Image 0" descr="/tmp/pcwork/api-patterns-and-practices-graphql/presentation/_shared/assets/logo-candidate-2.png">    </p:cNvPr>
+          <p:cNvPr id="3" name="Image 0" descr="/work/_shared/assets/logo-candidate-2.png">    </p:cNvPr>
           <p:cNvPicPr>
             <a:picLocks noChangeAspect="1"/>
           </p:cNvPicPr>
@@ -18722,7 +18722,7 @@
       </p:sp>
       <p:pic>
         <p:nvPicPr>
-          <p:cNvPr id="6" name="Image 1" descr="/tmp/pcwork/api-patterns-and-practices-graphql/presentation/_shared/png/16-cache-policy-decision.png">    </p:cNvPr>
+          <p:cNvPr id="6" name="Image 1" descr="/work/_shared/png/16-cache-policy-decision.png">    </p:cNvPr>
           <p:cNvPicPr>
             <a:picLocks noChangeAspect="1"/>
           </p:cNvPicPr>
@@ -18776,7 +18776,7 @@
                 <a:ea typeface="Red Hat Text" pitchFamily="34" charset="-122"/>
                 <a:cs typeface="Red Hat Text" pitchFamily="34" charset="-120"/>
               </a:rPr>
-              <a:t>Figure 16.3 — Four tests, and any no ends in no-store.</a:t>
+              <a:t>Figure 16.3: Four tests, and any no ends in no-store.</a:t>
             </a:r>
             <a:endParaRPr lang="en-US" sz="1300" dirty="0"/>
           </a:p>
@@ -18926,7 +18926,7 @@
       </p:sp>
       <p:pic>
         <p:nvPicPr>
-          <p:cNvPr id="5" name="Image 0" descr="/tmp/pcwork/api-patterns-and-practices-graphql/presentation/_shared/assets/redhat-logo-white.png">    </p:cNvPr>
+          <p:cNvPr id="5" name="Image 0" descr="/work/_shared/assets/redhat-logo-white.png">    </p:cNvPr>
           <p:cNvPicPr>
             <a:picLocks noChangeAspect="1"/>
           </p:cNvPicPr>
@@ -19014,7 +19014,7 @@
       </p:sp>
       <p:pic>
         <p:nvPicPr>
-          <p:cNvPr id="3" name="Image 0" descr="/tmp/pcwork/api-patterns-and-practices-graphql/presentation/_shared/assets/logo-candidate-2.png">    </p:cNvPr>
+          <p:cNvPr id="3" name="Image 0" descr="/work/_shared/assets/logo-candidate-2.png">    </p:cNvPr>
           <p:cNvPicPr>
             <a:picLocks noChangeAspect="1"/>
           </p:cNvPicPr>
@@ -19116,7 +19116,7 @@
       </p:sp>
       <p:pic>
         <p:nvPicPr>
-          <p:cNvPr id="6" name="Image 1" descr="/tmp/pcwork/api-patterns-and-practices-graphql/presentation/_shared/png/17-hardened-request-path.png">    </p:cNvPr>
+          <p:cNvPr id="6" name="Image 1" descr="/work/_shared/png/17-hardened-request-path.png">    </p:cNvPr>
           <p:cNvPicPr>
             <a:picLocks noChangeAspect="1"/>
           </p:cNvPicPr>
@@ -19170,7 +19170,7 @@
                 <a:ea typeface="Red Hat Text" pitchFamily="34" charset="-122"/>
                 <a:cs typeface="Red Hat Text" pitchFamily="34" charset="-120"/>
               </a:rPr>
-              <a:t>Figure 17.1 — The gates in front of a public instance. A refused request makes no source call.</a:t>
+              <a:t>Figure 17.1: The gates in front of a public instance. A refused request makes no source call.</a:t>
             </a:r>
             <a:endParaRPr lang="en-US" sz="1300" dirty="0"/>
           </a:p>
@@ -19242,7 +19242,7 @@
       </p:sp>
       <p:pic>
         <p:nvPicPr>
-          <p:cNvPr id="3" name="Image 0" descr="/tmp/pcwork/api-patterns-and-practices-graphql/presentation/_shared/assets/logo-candidate-2.png">    </p:cNvPr>
+          <p:cNvPr id="3" name="Image 0" descr="/work/_shared/assets/logo-candidate-2.png">    </p:cNvPr>
           <p:cNvPicPr>
             <a:picLocks noChangeAspect="1"/>
           </p:cNvPicPr>
@@ -19344,7 +19344,7 @@
       </p:sp>
       <p:pic>
         <p:nvPicPr>
-          <p:cNvPr id="6" name="Image 1" descr="/tmp/pcwork/api-patterns-and-practices-graphql/presentation/_shared/png/01-request-path.png">    </p:cNvPr>
+          <p:cNvPr id="6" name="Image 1" descr="/work/_shared/png/01-request-path.png">    </p:cNvPr>
           <p:cNvPicPr>
             <a:picLocks noChangeAspect="1"/>
           </p:cNvPicPr>
@@ -19398,7 +19398,7 @@
                 <a:ea typeface="Red Hat Text" pitchFamily="34" charset="-122"/>
                 <a:cs typeface="Red Hat Text" pitchFamily="34" charset="-120"/>
               </a:rPr>
-              <a:t>Figure 1.2 — One endpoint, one POST, four server stages and a fan-out to the services that own the data.</a:t>
+              <a:t>Figure 1.2: One endpoint, one POST, four server stages and a fan-out to the services that own the data.</a:t>
             </a:r>
             <a:endParaRPr lang="en-US" sz="1300" dirty="0"/>
           </a:p>
@@ -19470,7 +19470,7 @@
       </p:sp>
       <p:pic>
         <p:nvPicPr>
-          <p:cNvPr id="3" name="Image 0" descr="/tmp/pcwork/api-patterns-and-practices-graphql/presentation/_shared/assets/logo-candidate-2.png">    </p:cNvPr>
+          <p:cNvPr id="3" name="Image 0" descr="/work/_shared/assets/logo-candidate-2.png">    </p:cNvPr>
           <p:cNvPicPr>
             <a:picLocks noChangeAspect="1"/>
           </p:cNvPicPr>
@@ -19572,7 +19572,7 @@
       </p:sp>
       <p:pic>
         <p:nvPicPr>
-          <p:cNvPr id="6" name="Image 1" descr="/tmp/pcwork/api-patterns-and-practices-graphql/presentation/_shared/png/17-public-vs-internal-endpoints.png">    </p:cNvPr>
+          <p:cNvPr id="6" name="Image 1" descr="/work/_shared/png/17-public-vs-internal-endpoints.png">    </p:cNvPr>
           <p:cNvPicPr>
             <a:picLocks noChangeAspect="1"/>
           </p:cNvPicPr>
@@ -19626,7 +19626,7 @@
                 <a:ea typeface="Red Hat Text" pitchFamily="34" charset="-122"/>
                 <a:cs typeface="Red Hat Text" pitchFamily="34" charset="-120"/>
               </a:rPr>
-              <a:t>Figure 17.2 — One image, deployed twice. Only the internal instance answers a schema query.</a:t>
+              <a:t>Figure 17.2: One image, deployed twice. Only the internal instance answers a schema query.</a:t>
             </a:r>
             <a:endParaRPr lang="en-US" sz="1300" dirty="0"/>
           </a:p>
@@ -19698,7 +19698,7 @@
       </p:sp>
       <p:pic>
         <p:nvPicPr>
-          <p:cNvPr id="3" name="Image 0" descr="/tmp/pcwork/api-patterns-and-practices-graphql/presentation/_shared/assets/logo-candidate-2.png">    </p:cNvPr>
+          <p:cNvPr id="3" name="Image 0" descr="/work/_shared/assets/logo-candidate-2.png">    </p:cNvPr>
           <p:cNvPicPr>
             <a:picLocks noChangeAspect="1"/>
           </p:cNvPicPr>
@@ -19800,7 +19800,7 @@
       </p:sp>
       <p:pic>
         <p:nvPicPr>
-          <p:cNvPr id="6" name="Image 1" descr="/tmp/pcwork/api-patterns-and-practices-graphql/presentation/_shared/png/18-authorization-layers.png">    </p:cNvPr>
+          <p:cNvPr id="6" name="Image 1" descr="/work/_shared/png/18-authorization-layers.png">    </p:cNvPr>
           <p:cNvPicPr>
             <a:picLocks noChangeAspect="1"/>
           </p:cNvPicPr>
@@ -19854,7 +19854,7 @@
                 <a:ea typeface="Red Hat Text" pitchFamily="34" charset="-122"/>
                 <a:cs typeface="Red Hat Text" pitchFamily="34" charset="-120"/>
               </a:rPr>
-              <a:t>Figure 18.2 — Three layers. An operation or a field refuses with a coded error; an object refuses with a null.</a:t>
+              <a:t>Figure 18.2: Three layers. An operation or a field refuses with a coded error; an object refuses with a null.</a:t>
             </a:r>
             <a:endParaRPr lang="en-US" sz="1300" dirty="0"/>
           </a:p>
@@ -19926,7 +19926,7 @@
       </p:sp>
       <p:pic>
         <p:nvPicPr>
-          <p:cNvPr id="3" name="Image 0" descr="/tmp/pcwork/api-patterns-and-practices-graphql/presentation/_shared/assets/logo-candidate-2.png">    </p:cNvPr>
+          <p:cNvPr id="3" name="Image 0" descr="/work/_shared/assets/logo-candidate-2.png">    </p:cNvPr>
           <p:cNvPicPr>
             <a:picLocks noChangeAspect="1"/>
           </p:cNvPicPr>
@@ -20028,7 +20028,7 @@
       </p:sp>
       <p:pic>
         <p:nvPicPr>
-          <p:cNvPr id="6" name="Image 1" descr="/tmp/pcwork/api-patterns-and-practices-graphql/presentation/_shared/png/18-errors-vs-nulls.png">    </p:cNvPr>
+          <p:cNvPr id="6" name="Image 1" descr="/work/_shared/png/18-errors-vs-nulls.png">    </p:cNvPr>
           <p:cNvPicPr>
             <a:picLocks noChangeAspect="1"/>
           </p:cNvPicPr>
@@ -20082,7 +20082,7 @@
                 <a:ea typeface="Red Hat Text" pitchFamily="34" charset="-122"/>
                 <a:cs typeface="Red Hat Text" pitchFamily="34" charset="-120"/>
               </a:rPr>
-              <a:t>Figure 18.3 — Fields: error. Objects: null. A refused object looks like one that does not exist.</a:t>
+              <a:t>Figure 18.3: Fields: error. Objects: null. A refused object looks like one that does not exist.</a:t>
             </a:r>
             <a:endParaRPr lang="en-US" sz="1300" dirty="0"/>
           </a:p>
@@ -20232,7 +20232,7 @@
       </p:sp>
       <p:pic>
         <p:nvPicPr>
-          <p:cNvPr id="5" name="Image 0" descr="/tmp/pcwork/api-patterns-and-practices-graphql/presentation/_shared/assets/redhat-logo-white.png">    </p:cNvPr>
+          <p:cNvPr id="5" name="Image 0" descr="/work/_shared/assets/redhat-logo-white.png">    </p:cNvPr>
           <p:cNvPicPr>
             <a:picLocks noChangeAspect="1"/>
           </p:cNvPicPr>
@@ -20320,7 +20320,7 @@
       </p:sp>
       <p:pic>
         <p:nvPicPr>
-          <p:cNvPr id="3" name="Image 0" descr="/tmp/pcwork/api-patterns-and-practices-graphql/presentation/_shared/assets/logo-candidate-2.png">    </p:cNvPr>
+          <p:cNvPr id="3" name="Image 0" descr="/work/_shared/assets/logo-candidate-2.png">    </p:cNvPr>
           <p:cNvPicPr>
             <a:picLocks noChangeAspect="1"/>
           </p:cNvPicPr>
@@ -20422,7 +20422,7 @@
       </p:sp>
       <p:pic>
         <p:nvPicPr>
-          <p:cNvPr id="6" name="Image 1" descr="/tmp/pcwork/api-patterns-and-practices-graphql/presentation/_shared/png/19-one-endpoint-blind-spot.png">    </p:cNvPr>
+          <p:cNvPr id="6" name="Image 1" descr="/work/_shared/png/19-one-endpoint-blind-spot.png">    </p:cNvPr>
           <p:cNvPicPr>
             <a:picLocks noChangeAspect="1"/>
           </p:cNvPicPr>
@@ -20476,7 +20476,7 @@
                 <a:ea typeface="Red Hat Text" pitchFamily="34" charset="-122"/>
                 <a:cs typeface="Red Hat Text" pitchFamily="34" charset="-120"/>
               </a:rPr>
-              <a:t>Figure 19.1 — The same nine requests, keyed two ways. The operation name and error code separate them.</a:t>
+              <a:t>Figure 19.1: The same nine requests, keyed two ways. The operation name and error code separate them.</a:t>
             </a:r>
             <a:endParaRPr lang="en-US" sz="1300" dirty="0"/>
           </a:p>
@@ -20548,7 +20548,7 @@
       </p:sp>
       <p:pic>
         <p:nvPicPr>
-          <p:cNvPr id="3" name="Image 0" descr="/tmp/pcwork/api-patterns-and-practices-graphql/presentation/_shared/assets/logo-candidate-2.png">    </p:cNvPr>
+          <p:cNvPr id="3" name="Image 0" descr="/work/_shared/assets/logo-candidate-2.png">    </p:cNvPr>
           <p:cNvPicPr>
             <a:picLocks noChangeAspect="1"/>
           </p:cNvPicPr>
@@ -20650,7 +20650,7 @@
       </p:sp>
       <p:pic>
         <p:nvPicPr>
-          <p:cNvPr id="6" name="Image 1" descr="/tmp/pcwork/api-patterns-and-practices-graphql/presentation/_shared/png/19-span-per-resolver.png">    </p:cNvPr>
+          <p:cNvPr id="6" name="Image 1" descr="/work/_shared/png/19-span-per-resolver.png">    </p:cNvPr>
           <p:cNvPicPr>
             <a:picLocks noChangeAspect="1"/>
           </p:cNvPicPr>
@@ -20704,7 +20704,7 @@
                 <a:ea typeface="Red Hat Text" pitchFamily="34" charset="-122"/>
                 <a:cs typeface="Red Hat Text" pitchFamily="34" charset="-120"/>
               </a:rPr>
-              <a:t>Figure 19.3 — Twenty-five resolver spans in four levels, and one source call per batch.</a:t>
+              <a:t>Figure 19.3: Twenty-five resolver spans in four levels, and one source call per batch.</a:t>
             </a:r>
             <a:endParaRPr lang="en-US" sz="1300" dirty="0"/>
           </a:p>
@@ -20776,7 +20776,7 @@
       </p:sp>
       <p:pic>
         <p:nvPicPr>
-          <p:cNvPr id="3" name="Image 0" descr="/tmp/pcwork/api-patterns-and-practices-graphql/presentation/_shared/assets/logo-candidate-2.png">    </p:cNvPr>
+          <p:cNvPr id="3" name="Image 0" descr="/work/_shared/assets/logo-candidate-2.png">    </p:cNvPr>
           <p:cNvPicPr>
             <a:picLocks noChangeAspect="1"/>
           </p:cNvPicPr>
@@ -20878,7 +20878,7 @@
       </p:sp>
       <p:pic>
         <p:nvPicPr>
-          <p:cNvPr id="6" name="Image 1" descr="/tmp/pcwork/api-patterns-and-practices-graphql/presentation/_shared/png/20-subgraph-ownership.png">    </p:cNvPr>
+          <p:cNvPr id="6" name="Image 1" descr="/work/_shared/png/20-subgraph-ownership.png">    </p:cNvPr>
           <p:cNvPicPr>
             <a:picLocks noChangeAspect="1"/>
           </p:cNvPicPr>
@@ -20932,7 +20932,7 @@
                 <a:ea typeface="Red Hat Text" pitchFamily="34" charset="-122"/>
                 <a:cs typeface="Red Hat Text" pitchFamily="34" charset="-120"/>
               </a:rPr>
-              <a:t>Figure 20.1 — Each field has one owner. An entity is shared by its key; a reference names a place only.</a:t>
+              <a:t>Figure 20.1: Each field has one owner. An entity is shared by its key; a reference names a place only.</a:t>
             </a:r>
             <a:endParaRPr lang="en-US" sz="1300" dirty="0"/>
           </a:p>
@@ -21004,7 +21004,7 @@
       </p:sp>
       <p:pic>
         <p:nvPicPr>
-          <p:cNvPr id="3" name="Image 0" descr="/tmp/pcwork/api-patterns-and-practices-graphql/presentation/_shared/assets/logo-candidate-2.png">    </p:cNvPr>
+          <p:cNvPr id="3" name="Image 0" descr="/work/_shared/assets/logo-candidate-2.png">    </p:cNvPr>
           <p:cNvPicPr>
             <a:picLocks noChangeAspect="1"/>
           </p:cNvPicPr>
@@ -21106,7 +21106,7 @@
       </p:sp>
       <p:pic>
         <p:nvPicPr>
-          <p:cNvPr id="6" name="Image 1" descr="/tmp/pcwork/api-patterns-and-practices-graphql/presentation/_shared/png/20-query-plan.png">    </p:cNvPr>
+          <p:cNvPr id="6" name="Image 1" descr="/work/_shared/png/20-query-plan.png">    </p:cNvPr>
           <p:cNvPicPr>
             <a:picLocks noChangeAspect="1"/>
           </p:cNvPicPr>
@@ -21160,7 +21160,7 @@
                 <a:ea typeface="Red Hat Text" pitchFamily="34" charset="-122"/>
                 <a:cs typeface="Red Hat Text" pitchFamily="34" charset="-120"/>
               </a:rPr>
-              <a:t>Figure 20.3 — One client request, three subgraph fetches. The cargo subgraph is asked twice.</a:t>
+              <a:t>Figure 20.3: One client request, three subgraph fetches. The cargo subgraph is asked twice.</a:t>
             </a:r>
             <a:endParaRPr lang="en-US" sz="1300" dirty="0"/>
           </a:p>
@@ -21310,7 +21310,7 @@
       </p:sp>
       <p:pic>
         <p:nvPicPr>
-          <p:cNvPr id="5" name="Image 0" descr="/tmp/pcwork/api-patterns-and-practices-graphql/presentation/_shared/assets/redhat-logo-white.png">    </p:cNvPr>
+          <p:cNvPr id="5" name="Image 0" descr="/work/_shared/assets/redhat-logo-white.png">    </p:cNvPr>
           <p:cNvPicPr>
             <a:picLocks noChangeAspect="1"/>
           </p:cNvPicPr>
@@ -21398,7 +21398,7 @@
       </p:sp>
       <p:pic>
         <p:nvPicPr>
-          <p:cNvPr id="3" name="Image 0" descr="/tmp/pcwork/api-patterns-and-practices-graphql/presentation/_shared/assets/logo-candidate-2.png">    </p:cNvPr>
+          <p:cNvPr id="3" name="Image 0" descr="/work/_shared/assets/logo-candidate-2.png">    </p:cNvPr>
           <p:cNvPicPr>
             <a:picLocks noChangeAspect="1"/>
           </p:cNvPicPr>
@@ -21500,7 +21500,7 @@
       </p:sp>
       <p:pic>
         <p:nvPicPr>
-          <p:cNvPr id="6" name="Image 1" descr="/tmp/pcwork/api-patterns-and-practices-graphql/presentation/_shared/png/21-three-ways-to-push.png">    </p:cNvPr>
+          <p:cNvPr id="6" name="Image 1" descr="/work/_shared/png/21-three-ways-to-push.png">    </p:cNvPr>
           <p:cNvPicPr>
             <a:picLocks noChangeAspect="1"/>
           </p:cNvPicPr>
@@ -21554,7 +21554,7 @@
                 <a:ea typeface="Red Hat Text" pitchFamily="34" charset="-122"/>
                 <a:cs typeface="Red Hat Text" pitchFamily="34" charset="-120"/>
               </a:rPr>
-              <a:t>Figure 21.1 — GraphQL columns keep the selection set and schema; the plain feed trades them for resume.</a:t>
+              <a:t>Figure 21.1: GraphQL columns keep the selection set and schema; the plain feed trades them for resume.</a:t>
             </a:r>
             <a:endParaRPr lang="en-US" sz="1300" dirty="0"/>
           </a:p>
@@ -21626,7 +21626,7 @@
       </p:sp>
       <p:pic>
         <p:nvPicPr>
-          <p:cNvPr id="3" name="Image 0" descr="/tmp/pcwork/api-patterns-and-practices-graphql/presentation/_shared/assets/logo-candidate-2.png">    </p:cNvPr>
+          <p:cNvPr id="3" name="Image 0" descr="/work/_shared/assets/logo-candidate-2.png">    </p:cNvPr>
           <p:cNvPicPr>
             <a:picLocks noChangeAspect="1"/>
           </p:cNvPicPr>
@@ -21862,7 +21862,7 @@
                 <a:ea typeface="Red Hat Mono" pitchFamily="34" charset="-122"/>
                 <a:cs typeface="Red Hat Mono" pitchFamily="34" charset="-120"/>
               </a:rPr>
-              <a:t>The services behind the tracking view own the data and the rules. The cargo service decides what a booking is. The routing service decides which itinerary satisfies a route specification. The handling service records what physically happened. The delivery state is derived from those events and the itinerary, and Chapter 7 puts that derivation in the tracking view. Each of them may speak REST or gRPC, exactly as the sibling books describe, and none of them needs to know GraphQL exists. The tracking view owns no business data. It owns a schema, a set of resolvers that know which service to ask for which field, and the logic that stitches the answers into a graph and derives the delivery state.
+              <a:t>The services behind the tracking view own the data and the rules. The cargo service decides what a booking is. The routing service decides which itinerary satisfies a route specification. The handling service records what physically happened. The delivery state is derived from those events and the itinerary, and that derivation lives inside the tracking view itself. Each of them may speak REST or gRPC, exactly as the sibling books describe, and none of them needs to know GraphQL exists. The tracking view owns no business data. It owns a schema, a set of resolvers that know which service to ask for which field, and the logic that stitches the answers into a graph and derives the delivery state.
 </a:t>
             </a:r>
             <a:pPr algn="l" indent="0" marL="0">
@@ -21934,7 +21934,7 @@
                 <a:ea typeface="Red Hat Mono" pitchFamily="34" charset="-122"/>
                 <a:cs typeface="Red Hat Mono" pitchFamily="34" charset="-120"/>
               </a:rPr>
-              <a:t>The read-oriented emphasis is a design choice. The schema does contain one mutation, `registerHandlingEvent`, because recording a handling event is the one write a tracking client legitimately initiates, and Chapter 8 treats mutations in detail. Booking a cargo and assigning its route remain REST and gRPC operations in the owning services. Chapter 2 gives the criteria that put each interaction on its side of that line.
+              <a:t>The read-oriented emphasis is a design choice. The schema does contain one mutation, `registerHandlingEvent`, because recording a handling event is the one write a tracking client legitimately initiates, and mutation design gets full treatment later in the book. Booking a cargo and assigning its route remain REST and gRPC operations in the owning services. A decision framework gives the criteria that put each interaction on its side of that line.
 </a:t>
             </a:r>
             <a:pPr algn="l" indent="0" marL="0">
@@ -22204,7 +22204,7 @@
                 <a:ea typeface="Red Hat Mono" pitchFamily="34" charset="-122"/>
                 <a:cs typeface="Red Hat Mono" pitchFamily="34" charset="-120"/>
               </a:rPr>
-              <a:t>The operation takes one variable, `$id`, typed with the schema's `TrackingId` scalar and marked non-null with `!`. The root field `cargo` resolves one `Cargo` by tracking id. Inside it, `origin`, `destination` and `lastKnownLocation` are `Location` objects of which the client asks only for the UN/LOCODE and the name. `itinerary` is nullable in the schema because a cargo that has not been routed has none, and `handlingHistory(first: 2)` uses the Relay connection pattern that Chapter 12 covers: edges that wrap nodes, so the client can page through events newest first.
+              <a:t>The operation takes one variable, `$id`, typed with the schema's `TrackingId` scalar and marked non-null with `!`. The root field `cargo` resolves one `Cargo` by tracking id. Inside it, `origin`, `destination` and `lastKnownLocation` are `Location` objects of which the client asks only for the UN/LOCODE and the name. `itinerary` is nullable in the schema because a cargo that has not been routed has none, and `handlingHistory(first: 2)` uses the Relay connection pattern: edges that wrap nodes, so the client can page through events newest first.
 </a:t>
             </a:r>
             <a:pPr algn="l" indent="0" marL="0">
@@ -22370,7 +22370,7 @@
       </p:sp>
       <p:pic>
         <p:nvPicPr>
-          <p:cNvPr id="3" name="Image 0" descr="/tmp/pcwork/api-patterns-and-practices-graphql/presentation/_shared/assets/logo-candidate-2.png">    </p:cNvPr>
+          <p:cNvPr id="3" name="Image 0" descr="/work/_shared/assets/logo-candidate-2.png">    </p:cNvPr>
           <p:cNvPicPr>
             <a:picLocks noChangeAspect="1"/>
           </p:cNvPicPr>
@@ -23394,7 +23394,7 @@
       </p:sp>
       <p:pic>
         <p:nvPicPr>
-          <p:cNvPr id="3" name="Image 0" descr="/tmp/pcwork/api-patterns-and-practices-graphql/presentation/_shared/assets/logo-candidate-2.png">    </p:cNvPr>
+          <p:cNvPr id="3" name="Image 0" descr="/work/_shared/assets/logo-candidate-2.png">    </p:cNvPr>
           <p:cNvPicPr>
             <a:picLocks noChangeAspect="1"/>
           </p:cNvPicPr>
@@ -23496,7 +23496,7 @@
       </p:sp>
       <p:pic>
         <p:nvPicPr>
-          <p:cNvPr id="6" name="Image 1" descr="/tmp/pcwork/api-patterns-and-practices-graphql/presentation/_shared/png/22-normalized-cache-update.png">    </p:cNvPr>
+          <p:cNvPr id="6" name="Image 1" descr="/work/_shared/png/22-normalized-cache-update.png">    </p:cNvPr>
           <p:cNvPicPr>
             <a:picLocks noChangeAspect="1"/>
           </p:cNvPicPr>
@@ -23550,7 +23550,7 @@
                 <a:ea typeface="Red Hat Text" pitchFamily="34" charset="-122"/>
                 <a:cs typeface="Red Hat Text" pitchFamily="34" charset="-120"/>
               </a:rPr>
-              <a:t>Figure 22.2 — Two requests leave the client; the second query is answered from the first one's entry.</a:t>
+              <a:t>Figure 22.2: Two requests leave the client; the second query is answered from the first one's entry.</a:t>
             </a:r>
             <a:endParaRPr lang="en-US" sz="1300" dirty="0"/>
           </a:p>
@@ -23700,7 +23700,7 @@
       </p:sp>
       <p:pic>
         <p:nvPicPr>
-          <p:cNvPr id="5" name="Image 0" descr="/tmp/pcwork/api-patterns-and-practices-graphql/presentation/_shared/assets/redhat-logo-white.png">    </p:cNvPr>
+          <p:cNvPr id="5" name="Image 0" descr="/work/_shared/assets/redhat-logo-white.png">    </p:cNvPr>
           <p:cNvPicPr>
             <a:picLocks noChangeAspect="1"/>
           </p:cNvPicPr>
@@ -23788,7 +23788,7 @@
       </p:sp>
       <p:pic>
         <p:nvPicPr>
-          <p:cNvPr id="3" name="Image 0" descr="/tmp/pcwork/api-patterns-and-practices-graphql/presentation/_shared/assets/logo-candidate-2.png">    </p:cNvPr>
+          <p:cNvPr id="3" name="Image 0" descr="/work/_shared/assets/logo-candidate-2.png">    </p:cNvPr>
           <p:cNvPicPr>
             <a:picLocks noChangeAspect="1"/>
           </p:cNvPicPr>
@@ -23890,7 +23890,7 @@
       </p:sp>
       <p:pic>
         <p:nvPicPr>
-          <p:cNvPr id="6" name="Image 1" descr="/tmp/pcwork/api-patterns-and-practices-graphql/presentation/_shared/png/23-test-layers.png">    </p:cNvPr>
+          <p:cNvPr id="6" name="Image 1" descr="/work/_shared/png/23-test-layers.png">    </p:cNvPr>
           <p:cNvPicPr>
             <a:picLocks noChangeAspect="1"/>
           </p:cNvPicPr>
@@ -23944,7 +23944,7 @@
                 <a:ea typeface="Red Hat Text" pitchFamily="34" charset="-122"/>
                 <a:cs typeface="Red Hat Text" pitchFamily="34" charset="-120"/>
               </a:rPr>
-              <a:t>Figure 23.1 — Six layers: three run in each stack's test image, three against the live stacks.</a:t>
+              <a:t>Figure 23.1: Six layers: three run in each stack's test image, three against the live stacks.</a:t>
             </a:r>
             <a:endParaRPr lang="en-US" sz="1300" dirty="0"/>
           </a:p>
@@ -24016,7 +24016,7 @@
       </p:sp>
       <p:pic>
         <p:nvPicPr>
-          <p:cNvPr id="3" name="Image 0" descr="/tmp/pcwork/api-patterns-and-practices-graphql/presentation/_shared/assets/logo-candidate-2.png">    </p:cNvPr>
+          <p:cNvPr id="3" name="Image 0" descr="/work/_shared/assets/logo-candidate-2.png">    </p:cNvPr>
           <p:cNvPicPr>
             <a:picLocks noChangeAspect="1"/>
           </p:cNvPicPr>
@@ -24118,7 +24118,7 @@
       </p:sp>
       <p:pic>
         <p:nvPicPr>
-          <p:cNvPr id="6" name="Image 1" descr="/tmp/pcwork/api-patterns-and-practices-graphql/presentation/_shared/png/24-diagnosis-path.png">    </p:cNvPr>
+          <p:cNvPr id="6" name="Image 1" descr="/work/_shared/png/24-diagnosis-path.png">    </p:cNvPr>
           <p:cNvPicPr>
             <a:picLocks noChangeAspect="1"/>
           </p:cNvPicPr>
@@ -24172,7 +24172,7 @@
                 <a:ea typeface="Red Hat Text" pitchFamily="34" charset="-122"/>
                 <a:cs typeface="Red Hat Text" pitchFamily="34" charset="-120"/>
               </a:rPr>
-              <a:t>Figure 24.1 — One masked error followed to the data, through the trace id, the trace and the log.</a:t>
+              <a:t>Figure 24.1: One masked error followed to the data, through the trace id, the trace and the log.</a:t>
             </a:r>
             <a:endParaRPr lang="en-US" sz="1300" dirty="0"/>
           </a:p>
@@ -24322,7 +24322,7 @@
       </p:sp>
       <p:pic>
         <p:nvPicPr>
-          <p:cNvPr id="5" name="Image 0" descr="/tmp/pcwork/api-patterns-and-practices-graphql/presentation/_shared/assets/redhat-logo-white.png">    </p:cNvPr>
+          <p:cNvPr id="5" name="Image 0" descr="/work/_shared/assets/redhat-logo-white.png">    </p:cNvPr>
           <p:cNvPicPr>
             <a:picLocks noChangeAspect="1"/>
           </p:cNvPicPr>
@@ -24410,7 +24410,7 @@
       </p:sp>
       <p:pic>
         <p:nvPicPr>
-          <p:cNvPr id="3" name="Image 0" descr="/tmp/pcwork/api-patterns-and-practices-graphql/presentation/_shared/assets/logo-candidate-2.png">    </p:cNvPr>
+          <p:cNvPr id="3" name="Image 0" descr="/work/_shared/assets/logo-candidate-2.png">    </p:cNvPr>
           <p:cNvPicPr>
             <a:picLocks noChangeAspect="1"/>
           </p:cNvPicPr>
@@ -24512,7 +24512,7 @@
       </p:sp>
       <p:pic>
         <p:nvPicPr>
-          <p:cNvPr id="6" name="Image 1" descr="/tmp/pcwork/api-patterns-and-practices-graphql/presentation/_shared/png/26-compose-to-kubernetes.png">    </p:cNvPr>
+          <p:cNvPr id="6" name="Image 1" descr="/work/_shared/png/26-compose-to-kubernetes.png">    </p:cNvPr>
           <p:cNvPicPr>
             <a:picLocks noChangeAspect="1"/>
           </p:cNvPicPr>
@@ -24566,7 +24566,7 @@
                 <a:ea typeface="Red Hat Text" pitchFamily="34" charset="-122"/>
                 <a:cs typeface="Red Hat Text" pitchFamily="34" charset="-120"/>
               </a:rPr>
-              <a:t>Figure 26.1 — Compose concepts and the chart templates that carry them; images and environment match.</a:t>
+              <a:t>Figure 26.1: Compose concepts and the chart templates that carry them; images and environment match.</a:t>
             </a:r>
             <a:endParaRPr lang="en-US" sz="1300" dirty="0"/>
           </a:p>
@@ -24638,7 +24638,7 @@
       </p:sp>
       <p:pic>
         <p:nvPicPr>
-          <p:cNvPr id="3" name="Image 0" descr="/tmp/pcwork/api-patterns-and-practices-graphql/presentation/_shared/assets/logo-candidate-2.png">    </p:cNvPr>
+          <p:cNvPr id="3" name="Image 0" descr="/work/_shared/assets/logo-candidate-2.png">    </p:cNvPr>
           <p:cNvPicPr>
             <a:picLocks noChangeAspect="1"/>
           </p:cNvPicPr>
@@ -24740,7 +24740,7 @@
       </p:sp>
       <p:pic>
         <p:nvPicPr>
-          <p:cNvPr id="6" name="Image 1" descr="/tmp/pcwork/api-patterns-and-practices-graphql/presentation/_shared/png/27-final-architecture.png">    </p:cNvPr>
+          <p:cNvPr id="6" name="Image 1" descr="/work/_shared/png/27-final-architecture.png">    </p:cNvPr>
           <p:cNvPicPr>
             <a:picLocks noChangeAspect="1"/>
           </p:cNvPicPr>
@@ -24794,7 +24794,7 @@
                 <a:ea typeface="Red Hat Text" pitchFamily="34" charset="-122"/>
                 <a:cs typeface="Red Hat Text" pitchFamily="34" charset="-120"/>
               </a:rPr>
-              <a:t>Figure 27.1 — The final project's compose tier. Each component implements one pattern from the deck.</a:t>
+              <a:t>Figure 27.1: The final project's compose tier. Each component implements one pattern from the deck.</a:t>
             </a:r>
             <a:endParaRPr lang="en-US" sz="1300" dirty="0"/>
           </a:p>
@@ -24866,7 +24866,7 @@
       </p:sp>
       <p:pic>
         <p:nvPicPr>
-          <p:cNvPr id="3" name="Image 0" descr="/tmp/pcwork/api-patterns-and-practices-graphql/presentation/_shared/assets/logo-candidate-2.png">    </p:cNvPr>
+          <p:cNvPr id="3" name="Image 0" descr="/work/_shared/assets/logo-candidate-2.png">    </p:cNvPr>
           <p:cNvPicPr>
             <a:picLocks noChangeAspect="1"/>
           </p:cNvPicPr>
@@ -24968,7 +24968,7 @@
       </p:sp>
       <p:pic>
         <p:nvPicPr>
-          <p:cNvPr id="6" name="Image 1" descr="/tmp/pcwork/api-patterns-and-practices-graphql/presentation/_shared/png/27-request-defences.png">    </p:cNvPr>
+          <p:cNvPr id="6" name="Image 1" descr="/work/_shared/png/27-request-defences.png">    </p:cNvPr>
           <p:cNvPicPr>
             <a:picLocks noChangeAspect="1"/>
           </p:cNvPicPr>
@@ -25022,7 +25022,7 @@
                 <a:ea typeface="Red Hat Text" pitchFamily="34" charset="-122"/>
                 <a:cs typeface="Red Hat Text" pitchFamily="34" charset="-120"/>
               </a:rPr>
-              <a:t>Figure 27.2 — The defences in the order a request meets them, and the answer each gives.</a:t>
+              <a:t>Figure 27.2: The defences in the order a request meets them, and the answer each gives.</a:t>
             </a:r>
             <a:endParaRPr lang="en-US" sz="1300" dirty="0"/>
           </a:p>
@@ -25094,7 +25094,7 @@
       </p:sp>
       <p:pic>
         <p:nvPicPr>
-          <p:cNvPr id="3" name="Image 0" descr="/tmp/pcwork/api-patterns-and-practices-graphql/presentation/_shared/assets/logo-candidate-2.png">    </p:cNvPr>
+          <p:cNvPr id="3" name="Image 0" descr="/work/_shared/assets/logo-candidate-2.png">    </p:cNvPr>
           <p:cNvPicPr>
             <a:picLocks noChangeAspect="1"/>
           </p:cNvPicPr>
@@ -26709,7 +26709,7 @@
       </p:sp>
       <p:pic>
         <p:nvPicPr>
-          <p:cNvPr id="3" name="Image 0" descr="/tmp/pcwork/api-patterns-and-practices-graphql/presentation/_shared/assets/logo-candidate-2.png">    </p:cNvPr>
+          <p:cNvPr id="3" name="Image 0" descr="/work/_shared/assets/logo-candidate-2.png">    </p:cNvPr>
           <p:cNvPicPr>
             <a:picLocks noChangeAspect="1"/>
           </p:cNvPicPr>
@@ -28599,7 +28599,7 @@
       </p:sp>
       <p:pic>
         <p:nvPicPr>
-          <p:cNvPr id="5" name="Image 0" descr="/tmp/pcwork/api-patterns-and-practices-graphql/presentation/_shared/assets/redhat-logo-white.png">    </p:cNvPr>
+          <p:cNvPr id="5" name="Image 0" descr="/work/_shared/assets/redhat-logo-white.png">    </p:cNvPr>
           <p:cNvPicPr>
             <a:picLocks noChangeAspect="1"/>
           </p:cNvPicPr>
@@ -28687,7 +28687,7 @@
       </p:sp>
       <p:pic>
         <p:nvPicPr>
-          <p:cNvPr id="3" name="Image 0" descr="/tmp/pcwork/api-patterns-and-practices-graphql/presentation/_shared/assets/logo-candidate-2.png">    </p:cNvPr>
+          <p:cNvPr id="3" name="Image 0" descr="/work/_shared/assets/logo-candidate-2.png">    </p:cNvPr>
           <p:cNvPicPr>
             <a:picLocks noChangeAspect="1"/>
           </p:cNvPicPr>
@@ -29377,7 +29377,7 @@
       </p:sp>
       <p:pic>
         <p:nvPicPr>
-          <p:cNvPr id="3" name="Image 0" descr="/tmp/pcwork/api-patterns-and-practices-graphql/presentation/_shared/assets/logo-candidate-2.png">    </p:cNvPr>
+          <p:cNvPr id="3" name="Image 0" descr="/work/_shared/assets/logo-candidate-2.png">    </p:cNvPr>
           <p:cNvPicPr>
             <a:picLocks noChangeAspect="1"/>
           </p:cNvPicPr>
@@ -30067,7 +30067,7 @@
       </p:sp>
       <p:pic>
         <p:nvPicPr>
-          <p:cNvPr id="3" name="Image 0" descr="/tmp/pcwork/api-patterns-and-practices-graphql/presentation/_shared/assets/logo-candidate-2.png">    </p:cNvPr>
+          <p:cNvPr id="3" name="Image 0" descr="/work/_shared/assets/logo-candidate-2.png">    </p:cNvPr>
           <p:cNvPicPr>
             <a:picLocks noChangeAspect="1"/>
           </p:cNvPicPr>
@@ -30793,7 +30793,7 @@
       </p:sp>
       <p:pic>
         <p:nvPicPr>
-          <p:cNvPr id="3" name="Image 0" descr="/tmp/pcwork/api-patterns-and-practices-graphql/presentation/_shared/assets/logo-candidate-2.png">    </p:cNvPr>
+          <p:cNvPr id="3" name="Image 0" descr="/work/_shared/assets/logo-candidate-2.png">    </p:cNvPr>
           <p:cNvPicPr>
             <a:picLocks noChangeAspect="1"/>
           </p:cNvPicPr>
@@ -31393,7 +31393,7 @@
       </p:sp>
       <p:pic>
         <p:nvPicPr>
-          <p:cNvPr id="3" name="Image 0" descr="/tmp/pcwork/api-patterns-and-practices-graphql/presentation/_shared/assets/logo-candidate-2.png">    </p:cNvPr>
+          <p:cNvPr id="3" name="Image 0" descr="/work/_shared/assets/logo-candidate-2.png">    </p:cNvPr>
           <p:cNvPicPr>
             <a:picLocks noChangeAspect="1"/>
           </p:cNvPicPr>
@@ -33008,7 +33008,7 @@
       </p:sp>
       <p:pic>
         <p:nvPicPr>
-          <p:cNvPr id="3" name="Image 0" descr="/tmp/pcwork/api-patterns-and-practices-graphql/presentation/_shared/assets/logo-candidate-2.png">    </p:cNvPr>
+          <p:cNvPr id="3" name="Image 0" descr="/work/_shared/assets/logo-candidate-2.png">    </p:cNvPr>
           <p:cNvPicPr>
             <a:picLocks noChangeAspect="1"/>
           </p:cNvPicPr>
@@ -33782,7 +33782,7 @@
       </p:sp>
       <p:pic>
         <p:nvPicPr>
-          <p:cNvPr id="3" name="Image 0" descr="/tmp/pcwork/api-patterns-and-practices-graphql/presentation/_shared/assets/logo-candidate-2.png">    </p:cNvPr>
+          <p:cNvPr id="3" name="Image 0" descr="/work/_shared/assets/logo-candidate-2.png">    </p:cNvPr>
           <p:cNvPicPr>
             <a:picLocks noChangeAspect="1"/>
           </p:cNvPicPr>
@@ -34153,7 +34153,7 @@
       </p:sp>
       <p:pic>
         <p:nvPicPr>
-          <p:cNvPr id="3" name="Image 0" descr="/tmp/pcwork/api-patterns-and-practices-graphql/presentation/_shared/assets/logo-candidate-2.png">    </p:cNvPr>
+          <p:cNvPr id="3" name="Image 0" descr="/work/_shared/assets/logo-candidate-2.png">    </p:cNvPr>
           <p:cNvPicPr>
             <a:picLocks noChangeAspect="1"/>
           </p:cNvPicPr>
@@ -34428,7 +34428,7 @@
       </p:sp>
       <p:pic>
         <p:nvPicPr>
-          <p:cNvPr id="3" name="Image 0" descr="/tmp/pcwork/api-patterns-and-practices-graphql/presentation/_shared/assets/logo-candidate-2.png">    </p:cNvPr>
+          <p:cNvPr id="3" name="Image 0" descr="/work/_shared/assets/logo-candidate-2.png">    </p:cNvPr>
           <p:cNvPicPr>
             <a:picLocks noChangeAspect="1"/>
           </p:cNvPicPr>
@@ -34530,7 +34530,7 @@
       </p:sp>
       <p:pic>
         <p:nvPicPr>
-          <p:cNvPr id="6" name="Image 1" descr="/tmp/pcwork/api-patterns-and-practices-graphql/presentation/_shared/assets/qr-graphql-site.png">    </p:cNvPr>
+          <p:cNvPr id="6" name="Image 1" descr="/work/_shared/assets/qr-graphql-site.png">    </p:cNvPr>
           <p:cNvPicPr>
             <a:picLocks noChangeAspect="1"/>
           </p:cNvPicPr>
@@ -34671,7 +34671,7 @@
       </p:sp>
       <p:pic>
         <p:nvPicPr>
-          <p:cNvPr id="10" name="Image 2" descr="/tmp/pcwork/api-patterns-and-practices-graphql/presentation/_shared/assets/qr-hub.png">    </p:cNvPr>
+          <p:cNvPr id="10" name="Image 2" descr="/work/_shared/assets/qr-hub.png">    </p:cNvPr>
           <p:cNvPicPr>
             <a:picLocks noChangeAspect="1"/>
           </p:cNvPicPr>
@@ -34876,7 +34876,7 @@
       </p:sp>
       <p:pic>
         <p:nvPicPr>
-          <p:cNvPr id="3" name="Image 0" descr="/tmp/pcwork/api-patterns-and-practices-graphql/presentation/_shared/assets/logo-candidate-2.png">    </p:cNvPr>
+          <p:cNvPr id="3" name="Image 0" descr="/work/_shared/assets/logo-candidate-2.png">    </p:cNvPr>
           <p:cNvPicPr>
             <a:picLocks noChangeAspect="1"/>
           </p:cNvPicPr>
@@ -34978,7 +34978,7 @@
       </p:sp>
       <p:pic>
         <p:nvPicPr>
-          <p:cNvPr id="6" name="Image 1" descr="/tmp/pcwork/api-patterns-and-practices-graphql/presentation/_shared/png/02-decision-framework.png">    </p:cNvPr>
+          <p:cNvPr id="6" name="Image 1" descr="/work/_shared/png/02-decision-framework.png">    </p:cNvPr>
           <p:cNvPicPr>
             <a:picLocks noChangeAspect="1"/>
           </p:cNvPicPr>
@@ -35032,7 +35032,7 @@
                 <a:ea typeface="Red Hat Text" pitchFamily="34" charset="-122"/>
                 <a:cs typeface="Red Hat Text" pitchFamily="34" charset="-120"/>
               </a:rPr>
-              <a:t>Figure 2.1 — Seven axes feed one decision per interaction; the shipping domain lands on four answers.</a:t>
+              <a:t>Figure 2.1: Seven axes feed one decision per interaction; the shipping domain lands on four answers.</a:t>
             </a:r>
             <a:endParaRPr lang="en-US" sz="1300" dirty="0"/>
           </a:p>
@@ -35104,7 +35104,7 @@
       </p:sp>
       <p:pic>
         <p:nvPicPr>
-          <p:cNvPr id="3" name="Image 0" descr="/tmp/pcwork/api-patterns-and-practices-graphql/presentation/_shared/assets/logo-candidate-2.png">    </p:cNvPr>
+          <p:cNvPr id="3" name="Image 0" descr="/work/_shared/assets/logo-candidate-2.png">    </p:cNvPr>
           <p:cNvPicPr>
             <a:picLocks noChangeAspect="1"/>
           </p:cNvPicPr>
@@ -35206,7 +35206,7 @@
       </p:sp>
       <p:pic>
         <p:nvPicPr>
-          <p:cNvPr id="6" name="Image 1" descr="/tmp/pcwork/api-patterns-and-practices-graphql/presentation/_shared/png/02-tracking-view-topology.png">    </p:cNvPr>
+          <p:cNvPr id="6" name="Image 1" descr="/work/_shared/png/02-tracking-view-topology.png">    </p:cNvPr>
           <p:cNvPicPr>
             <a:picLocks noChangeAspect="1"/>
           </p:cNvPicPr>
@@ -35260,7 +35260,7 @@
                 <a:ea typeface="Red Hat Text" pitchFamily="34" charset="-122"/>
                 <a:cs typeface="Red Hat Text" pitchFamily="34" charset="-120"/>
               </a:rPr>
-              <a:t>Figure 2.2 — The tracking view fronts three sources for reads; writes and bulk feeds take their own paths.</a:t>
+              <a:t>Figure 2.2: The tracking view fronts three sources for reads; writes and bulk feeds take their own paths.</a:t>
             </a:r>
             <a:endParaRPr lang="en-US" sz="1300" dirty="0"/>
           </a:p>

</xml_diff>